<commit_message>
docs: sync defense materials with completed implementation
- report: update F3/F4/F5 to implemented; add section 8-10 (system design, implementation, testing) with table 12-13

- ppt: update module status, fill slides 10-12 (quiz/grading, mistake/review, frontend/testing)
</commit_message>
<xml_diff>
--- a/defense/智学助手-课程设计答辩.pptx
+++ b/defense/智学助手-课程设计答辩.pptx
@@ -5268,7 +5268,7 @@
         <p:spPr>
           <a:xfrm>
             <a:off x="502920" y="182880"/>
-            <a:ext cx="11185855" cy="621792"/>
+            <a:ext cx="11155680" cy="621792"/>
           </a:xfrm>
           <a:prstGeom prst="rect">
             <a:avLst/>
@@ -5314,7 +5314,7 @@
         </p:nvSpPr>
         <p:spPr>
           <a:xfrm>
-            <a:off x="8351215" y="274320"/>
+            <a:off x="8321040" y="274320"/>
             <a:ext cx="3383280" cy="457200"/>
           </a:xfrm>
           <a:prstGeom prst="rect">
@@ -5361,7 +5361,7 @@
         </p:nvSpPr>
         <p:spPr>
           <a:xfrm>
-            <a:off x="11277295" y="6473952"/>
+            <a:off x="11247120" y="6473952"/>
             <a:ext cx="640080" cy="274320"/>
           </a:xfrm>
           <a:prstGeom prst="rect">
@@ -5402,60 +5402,14 @@
       </p:sp>
       <p:sp>
         <p:nvSpPr>
-          <p:cNvPr id="6" name="Rectangle 5"/>
-          <p:cNvSpPr/>
+          <p:cNvPr id="6" name="TextBox 5"/>
+          <p:cNvSpPr txBox="1"/>
           <p:nvPr/>
         </p:nvSpPr>
         <p:spPr>
           <a:xfrm>
-            <a:off x="548640" y="1170432"/>
-            <a:ext cx="11091672" cy="502920"/>
-          </a:xfrm>
-          <a:prstGeom prst="rect">
-            <a:avLst/>
-          </a:prstGeom>
-          <a:solidFill>
-            <a:srgbClr val="FFF2CC"/>
-          </a:solidFill>
-          <a:ln w="15240">
-            <a:solidFill>
-              <a:srgbClr val="C55A11"/>
-            </a:solidFill>
-          </a:ln>
-          <a:effectLst/>
-        </p:spPr>
-        <p:style>
-          <a:lnRef idx="1">
-            <a:schemeClr val="accent1"/>
-          </a:lnRef>
-          <a:fillRef idx="3">
-            <a:schemeClr val="accent1"/>
-          </a:fillRef>
-          <a:effectRef idx="2">
-            <a:schemeClr val="accent1"/>
-          </a:effectRef>
-          <a:fontRef idx="minor">
-            <a:schemeClr val="lt1"/>
-          </a:fontRef>
-        </p:style>
-        <p:txBody>
-          <a:bodyPr rtlCol="0" anchor="ctr"/>
-          <a:lstStyle/>
-          <a:p>
-            <a:pPr algn="ctr"/>
-          </a:p>
-        </p:txBody>
-      </p:sp>
-      <p:sp>
-        <p:nvSpPr>
-          <p:cNvPr id="7" name="TextBox 6"/>
-          <p:cNvSpPr txBox="1"/>
-          <p:nvPr/>
-        </p:nvSpPr>
-        <p:spPr>
-          <a:xfrm>
-            <a:off x="731520" y="1170432"/>
-            <a:ext cx="10698480" cy="502920"/>
+            <a:off x="548640" y="1143000"/>
+            <a:ext cx="11091672" cy="365760"/>
           </a:xfrm>
           <a:prstGeom prst="rect">
             <a:avLst/>
@@ -5463,7 +5417,7 @@
           <a:noFill/>
         </p:spPr>
         <p:txBody>
-          <a:bodyPr wrap="square" anchor="ctr" lIns="0" rIns="0" tIns="0" bIns="0">
+          <a:bodyPr wrap="square" anchor="t" lIns="0" rIns="0" tIns="0" bIns="0">
             <a:spAutoFit/>
           </a:bodyPr>
           <a:lstStyle/>
@@ -5480,19 +5434,305 @@
               </a:spcAft>
             </a:pPr>
             <a:r>
-              <a:rPr sz="1400" b="1">
+              <a:rPr sz="1700" b="1">
                 <a:solidFill>
-                  <a:srgbClr val="C55A11"/>
+                  <a:srgbClr val="2E75B6"/>
                 </a:solidFill>
                 <a:latin typeface="微软雅黑"/>
                 <a:ea typeface="微软雅黑"/>
                 <a:cs typeface="微软雅黑"/>
               </a:rPr>
-              <a:t>【待补充】本页内容需在该模块实现完成后填写</a:t>
-            </a:r>
-          </a:p>
-        </p:txBody>
-      </p:sp>
+              <a:t>出题流程</a:t>
+            </a:r>
+          </a:p>
+        </p:txBody>
+      </p:sp>
+      <p:graphicFrame>
+        <p:nvGraphicFramePr>
+          <p:cNvPr id="7" name="Table 6"/>
+          <p:cNvGraphicFramePr>
+            <a:graphicFrameLocks noGrp="1"/>
+          </p:cNvGraphicFramePr>
+          <p:nvPr/>
+        </p:nvGraphicFramePr>
+        <p:xfrm>
+          <a:off x="548640" y="1572768"/>
+          <a:ext cx="11091672" cy="2103120"/>
+        </p:xfrm>
+        <a:graphic>
+          <a:graphicData uri="http://schemas.openxmlformats.org/drawingml/2006/table">
+            <a:tbl>
+              <a:tblPr firstRow="1" bandRow="1">
+                <a:tableStyleId>{5C22544A-7EE6-4342-B048-85BDC9FD1C3A}</a:tableStyleId>
+              </a:tblPr>
+              <a:tblGrid>
+                <a:gridCol w="1232408"/>
+                <a:gridCol w="9859264"/>
+              </a:tblGrid>
+              <a:tr h="420624">
+                <a:tc>
+                  <a:txBody>
+                    <a:bodyPr/>
+                    <a:lstStyle/>
+                    <a:p>
+                      <a:pPr algn="ctr"/>
+                      <a:r>
+                        <a:rPr sz="1300" b="1">
+                          <a:solidFill>
+                            <a:srgbClr val="FFFFFF"/>
+                          </a:solidFill>
+                          <a:latin typeface="微软雅黑"/>
+                          <a:ea typeface="微软雅黑"/>
+                          <a:cs typeface="微软雅黑"/>
+                        </a:rPr>
+                        <a:t>步骤</a:t>
+                      </a:r>
+                    </a:p>
+                  </a:txBody>
+                  <a:tcPr anchor="ctr">
+                    <a:solidFill>
+                      <a:srgbClr val="1F4E79"/>
+                    </a:solidFill>
+                  </a:tcPr>
+                </a:tc>
+                <a:tc>
+                  <a:txBody>
+                    <a:bodyPr/>
+                    <a:lstStyle/>
+                    <a:p>
+                      <a:pPr algn="ctr"/>
+                      <a:r>
+                        <a:rPr sz="1300" b="1">
+                          <a:solidFill>
+                            <a:srgbClr val="FFFFFF"/>
+                          </a:solidFill>
+                          <a:latin typeface="微软雅黑"/>
+                          <a:ea typeface="微软雅黑"/>
+                          <a:cs typeface="微软雅黑"/>
+                        </a:rPr>
+                        <a:t>处理内容</a:t>
+                      </a:r>
+                    </a:p>
+                  </a:txBody>
+                  <a:tcPr anchor="ctr">
+                    <a:solidFill>
+                      <a:srgbClr val="1F4E79"/>
+                    </a:solidFill>
+                  </a:tcPr>
+                </a:tc>
+              </a:tr>
+              <a:tr h="420624">
+                <a:tc>
+                  <a:txBody>
+                    <a:bodyPr/>
+                    <a:lstStyle/>
+                    <a:p>
+                      <a:pPr algn="ctr"/>
+                      <a:r>
+                        <a:rPr sz="1200" b="0">
+                          <a:solidFill>
+                            <a:srgbClr val="222222"/>
+                          </a:solidFill>
+                          <a:latin typeface="微软雅黑"/>
+                          <a:ea typeface="微软雅黑"/>
+                          <a:cs typeface="微软雅黑"/>
+                        </a:rPr>
+                        <a:t>① 检索</a:t>
+                      </a:r>
+                    </a:p>
+                  </a:txBody>
+                  <a:tcPr anchor="ctr">
+                    <a:solidFill>
+                      <a:srgbClr val="FFFFFF"/>
+                    </a:solidFill>
+                  </a:tcPr>
+                </a:tc>
+                <a:tc>
+                  <a:txBody>
+                    <a:bodyPr/>
+                    <a:lstStyle/>
+                    <a:p>
+                      <a:pPr algn="l"/>
+                      <a:r>
+                        <a:rPr sz="1200" b="0">
+                          <a:solidFill>
+                            <a:srgbClr val="222222"/>
+                          </a:solidFill>
+                          <a:latin typeface="微软雅黑"/>
+                          <a:ea typeface="微软雅黑"/>
+                          <a:cs typeface="微软雅黑"/>
+                        </a:rPr>
+                        <a:t>按出题主题从 Chroma 检索相关文本片段，拼接为参考资料</a:t>
+                      </a:r>
+                    </a:p>
+                  </a:txBody>
+                  <a:tcPr anchor="ctr">
+                    <a:solidFill>
+                      <a:srgbClr val="FFFFFF"/>
+                    </a:solidFill>
+                  </a:tcPr>
+                </a:tc>
+              </a:tr>
+              <a:tr h="420624">
+                <a:tc>
+                  <a:txBody>
+                    <a:bodyPr/>
+                    <a:lstStyle/>
+                    <a:p>
+                      <a:pPr algn="ctr"/>
+                      <a:r>
+                        <a:rPr sz="1200" b="0">
+                          <a:solidFill>
+                            <a:srgbClr val="222222"/>
+                          </a:solidFill>
+                          <a:latin typeface="微软雅黑"/>
+                          <a:ea typeface="微软雅黑"/>
+                          <a:cs typeface="微软雅黑"/>
+                        </a:rPr>
+                        <a:t>② 生成</a:t>
+                      </a:r>
+                    </a:p>
+                  </a:txBody>
+                  <a:tcPr anchor="ctr">
+                    <a:solidFill>
+                      <a:srgbClr val="EAF3FB"/>
+                    </a:solidFill>
+                  </a:tcPr>
+                </a:tc>
+                <a:tc>
+                  <a:txBody>
+                    <a:bodyPr/>
+                    <a:lstStyle/>
+                    <a:p>
+                      <a:pPr algn="l"/>
+                      <a:r>
+                        <a:rPr sz="1200" b="0">
+                          <a:solidFill>
+                            <a:srgbClr val="222222"/>
+                          </a:solidFill>
+                          <a:latin typeface="微软雅黑"/>
+                          <a:ea typeface="微软雅黑"/>
+                          <a:cs typeface="微软雅黑"/>
+                        </a:rPr>
+                        <a:t>将题型、难度、数量与参考资料填入提示词，交由大模型生成</a:t>
+                      </a:r>
+                    </a:p>
+                  </a:txBody>
+                  <a:tcPr anchor="ctr">
+                    <a:solidFill>
+                      <a:srgbClr val="EAF3FB"/>
+                    </a:solidFill>
+                  </a:tcPr>
+                </a:tc>
+              </a:tr>
+              <a:tr h="420624">
+                <a:tc>
+                  <a:txBody>
+                    <a:bodyPr/>
+                    <a:lstStyle/>
+                    <a:p>
+                      <a:pPr algn="ctr"/>
+                      <a:r>
+                        <a:rPr sz="1200" b="0">
+                          <a:solidFill>
+                            <a:srgbClr val="222222"/>
+                          </a:solidFill>
+                          <a:latin typeface="微软雅黑"/>
+                          <a:ea typeface="微软雅黑"/>
+                          <a:cs typeface="微软雅黑"/>
+                        </a:rPr>
+                        <a:t>③ 校验</a:t>
+                      </a:r>
+                    </a:p>
+                  </a:txBody>
+                  <a:tcPr anchor="ctr">
+                    <a:solidFill>
+                      <a:srgbClr val="FFFFFF"/>
+                    </a:solidFill>
+                  </a:tcPr>
+                </a:tc>
+                <a:tc>
+                  <a:txBody>
+                    <a:bodyPr/>
+                    <a:lstStyle/>
+                    <a:p>
+                      <a:pPr algn="l"/>
+                      <a:r>
+                        <a:rPr sz="1200" b="0">
+                          <a:solidFill>
+                            <a:srgbClr val="222222"/>
+                          </a:solidFill>
+                          <a:latin typeface="微软雅黑"/>
+                          <a:ea typeface="微软雅黑"/>
+                          <a:cs typeface="微软雅黑"/>
+                        </a:rPr>
+                        <a:t>去除代码块标记后解析 JSON 并校验字段，失败最多重试 2 次</a:t>
+                      </a:r>
+                    </a:p>
+                  </a:txBody>
+                  <a:tcPr anchor="ctr">
+                    <a:solidFill>
+                      <a:srgbClr val="FFFFFF"/>
+                    </a:solidFill>
+                  </a:tcPr>
+                </a:tc>
+              </a:tr>
+              <a:tr h="420624">
+                <a:tc>
+                  <a:txBody>
+                    <a:bodyPr/>
+                    <a:lstStyle/>
+                    <a:p>
+                      <a:pPr algn="ctr"/>
+                      <a:r>
+                        <a:rPr sz="1200" b="0">
+                          <a:solidFill>
+                            <a:srgbClr val="222222"/>
+                          </a:solidFill>
+                          <a:latin typeface="微软雅黑"/>
+                          <a:ea typeface="微软雅黑"/>
+                          <a:cs typeface="微软雅黑"/>
+                        </a:rPr>
+                        <a:t>④ 入库</a:t>
+                      </a:r>
+                    </a:p>
+                  </a:txBody>
+                  <a:tcPr anchor="ctr">
+                    <a:solidFill>
+                      <a:srgbClr val="EAF3FB"/>
+                    </a:solidFill>
+                  </a:tcPr>
+                </a:tc>
+                <a:tc>
+                  <a:txBody>
+                    <a:bodyPr/>
+                    <a:lstStyle/>
+                    <a:p>
+                      <a:pPr algn="l"/>
+                      <a:r>
+                        <a:rPr sz="1200" b="0">
+                          <a:solidFill>
+                            <a:srgbClr val="222222"/>
+                          </a:solidFill>
+                          <a:latin typeface="微软雅黑"/>
+                          <a:ea typeface="微软雅黑"/>
+                          <a:cs typeface="微软雅黑"/>
+                        </a:rPr>
+                        <a:t>同一会话中先写出题批次获取编号，再批量写入题目后提交</a:t>
+                      </a:r>
+                    </a:p>
+                  </a:txBody>
+                  <a:tcPr anchor="ctr">
+                    <a:solidFill>
+                      <a:srgbClr val="EAF3FB"/>
+                    </a:solidFill>
+                  </a:tcPr>
+                </a:tc>
+              </a:tr>
+            </a:tbl>
+          </a:graphicData>
+        </a:graphic>
+      </p:graphicFrame>
       <p:sp>
         <p:nvSpPr>
           <p:cNvPr id="8" name="TextBox 7"/>
@@ -5501,8 +5741,8 @@
         </p:nvSpPr>
         <p:spPr>
           <a:xfrm>
-            <a:off x="548640" y="1965960"/>
-            <a:ext cx="11064240" cy="5120640"/>
+            <a:off x="548640" y="3703320"/>
+            <a:ext cx="11091672" cy="365760"/>
           </a:xfrm>
           <a:prstGeom prst="rect">
             <a:avLst/>
@@ -5523,21 +5763,44 @@
                 <a:spcPts val="0"/>
               </a:spcBef>
               <a:spcAft>
-                <a:spcPts val="1600"/>
+                <a:spcPts val="600"/>
               </a:spcAft>
             </a:pPr>
             <a:r>
-              <a:rPr sz="1600" b="0">
+              <a:rPr sz="1700" b="1">
                 <a:solidFill>
-                  <a:srgbClr val="808080"/>
+                  <a:srgbClr val="2E75B6"/>
                 </a:solidFill>
                 <a:latin typeface="微软雅黑"/>
                 <a:ea typeface="微软雅黑"/>
                 <a:cs typeface="微软雅黑"/>
               </a:rPr>
-              <a:t>• 模块流程图：【待补充】</a:t>
-            </a:r>
-          </a:p>
+              <a:t>判题策略（按题型区分）</a:t>
+            </a:r>
+          </a:p>
+        </p:txBody>
+      </p:sp>
+      <p:sp>
+        <p:nvSpPr>
+          <p:cNvPr id="9" name="TextBox 8"/>
+          <p:cNvSpPr txBox="1"/>
+          <p:nvPr/>
+        </p:nvSpPr>
+        <p:spPr>
+          <a:xfrm>
+            <a:off x="548640" y="4133087"/>
+            <a:ext cx="11091672" cy="2103120"/>
+          </a:xfrm>
+          <a:prstGeom prst="rect">
+            <a:avLst/>
+          </a:prstGeom>
+          <a:noFill/>
+        </p:spPr>
+        <p:txBody>
+          <a:bodyPr wrap="square" anchor="t" lIns="0" rIns="0" tIns="0" bIns="0">
+            <a:spAutoFit/>
+          </a:bodyPr>
+          <a:lstStyle/>
           <a:p>
             <a:pPr algn="l">
               <a:lnSpc>
@@ -5547,19 +5810,30 @@
                 <a:spcPts val="0"/>
               </a:spcBef>
               <a:spcAft>
-                <a:spcPts val="1600"/>
+                <a:spcPts val="600"/>
               </a:spcAft>
             </a:pPr>
             <a:r>
-              <a:rPr sz="1600" b="0">
+              <a:rPr sz="1400" b="0">
                 <a:solidFill>
-                  <a:srgbClr val="808080"/>
+                  <a:srgbClr val="222222"/>
                 </a:solidFill>
                 <a:latin typeface="微软雅黑"/>
                 <a:ea typeface="微软雅黑"/>
                 <a:cs typeface="微软雅黑"/>
               </a:rPr>
-              <a:t>• Prompt 设计与结构化输出校验：【待补充】</a:t>
+              <a:t>• </a:t>
+            </a:r>
+            <a:r>
+              <a:rPr sz="1400" b="0">
+                <a:solidFill>
+                  <a:srgbClr val="222222"/>
+                </a:solidFill>
+                <a:latin typeface="微软雅黑"/>
+                <a:ea typeface="微软雅黑"/>
+                <a:cs typeface="微软雅黑"/>
+              </a:rPr>
+              <a:t>单选 / 判断：直接比对答案字符串</a:t>
             </a:r>
           </a:p>
           <a:p>
@@ -5571,19 +5845,30 @@
                 <a:spcPts val="0"/>
               </a:spcBef>
               <a:spcAft>
-                <a:spcPts val="1600"/>
+                <a:spcPts val="600"/>
               </a:spcAft>
             </a:pPr>
             <a:r>
-              <a:rPr sz="1600" b="0">
+              <a:rPr sz="1400" b="0">
                 <a:solidFill>
-                  <a:srgbClr val="808080"/>
+                  <a:srgbClr val="222222"/>
                 </a:solidFill>
                 <a:latin typeface="微软雅黑"/>
                 <a:ea typeface="微软雅黑"/>
                 <a:cs typeface="微软雅黑"/>
               </a:rPr>
-              <a:t>• 判题逻辑与关键代码：【待补充】</a:t>
+              <a:t>• </a:t>
+            </a:r>
+            <a:r>
+              <a:rPr sz="1400" b="0">
+                <a:solidFill>
+                  <a:srgbClr val="222222"/>
+                </a:solidFill>
+                <a:latin typeface="微软雅黑"/>
+                <a:ea typeface="微软雅黑"/>
+                <a:cs typeface="微软雅黑"/>
+              </a:rPr>
+              <a:t>多选：先将用户答案与正确答案分别排序再比对，使“AB”与“BA”等价</a:t>
             </a:r>
           </a:p>
           <a:p>
@@ -5595,43 +5880,30 @@
                 <a:spcPts val="0"/>
               </a:spcBef>
               <a:spcAft>
-                <a:spcPts val="1600"/>
+                <a:spcPts val="600"/>
               </a:spcAft>
             </a:pPr>
             <a:r>
-              <a:rPr sz="1600" b="0">
+              <a:rPr sz="1400" b="0">
                 <a:solidFill>
-                  <a:srgbClr val="808080"/>
+                  <a:srgbClr val="222222"/>
                 </a:solidFill>
                 <a:latin typeface="微软雅黑"/>
                 <a:ea typeface="微软雅黑"/>
                 <a:cs typeface="微软雅黑"/>
               </a:rPr>
-              <a:t>• 功能界面截图：【待补充】</a:t>
-            </a:r>
-          </a:p>
-          <a:p>
-            <a:pPr algn="l">
-              <a:lnSpc>
-                <a:spcPct val="125000"/>
-              </a:lnSpc>
-              <a:spcBef>
-                <a:spcPts val="0"/>
-              </a:spcBef>
-              <a:spcAft>
-                <a:spcPts val="1600"/>
-              </a:spcAft>
-            </a:pPr>
-            <a:r>
-              <a:rPr sz="1600" b="0">
+              <a:t>• </a:t>
+            </a:r>
+            <a:r>
+              <a:rPr sz="1400" b="0">
                 <a:solidFill>
-                  <a:srgbClr val="808080"/>
+                  <a:srgbClr val="222222"/>
                 </a:solidFill>
                 <a:latin typeface="微软雅黑"/>
                 <a:ea typeface="微软雅黑"/>
                 <a:cs typeface="微软雅黑"/>
               </a:rPr>
-              <a:t>• 测试用例与结果：【待补充】</a:t>
+              <a:t>简答：调用大模型做语义评分；失败时降级为关键词匹配（命中率 60% 判正确）；仍无法判断则记为待复习</a:t>
             </a:r>
           </a:p>
         </p:txBody>
@@ -5707,7 +5979,7 @@
         <p:spPr>
           <a:xfrm>
             <a:off x="502920" y="182880"/>
-            <a:ext cx="11185855" cy="621792"/>
+            <a:ext cx="11155680" cy="621792"/>
           </a:xfrm>
           <a:prstGeom prst="rect">
             <a:avLst/>
@@ -5753,7 +6025,7 @@
         </p:nvSpPr>
         <p:spPr>
           <a:xfrm>
-            <a:off x="8351215" y="274320"/>
+            <a:off x="8321040" y="274320"/>
             <a:ext cx="3383280" cy="457200"/>
           </a:xfrm>
           <a:prstGeom prst="rect">
@@ -5800,7 +6072,7 @@
         </p:nvSpPr>
         <p:spPr>
           <a:xfrm>
-            <a:off x="11277295" y="6473952"/>
+            <a:off x="11247120" y="6473952"/>
             <a:ext cx="640080" cy="274320"/>
           </a:xfrm>
           <a:prstGeom prst="rect">
@@ -5841,60 +6113,14 @@
       </p:sp>
       <p:sp>
         <p:nvSpPr>
-          <p:cNvPr id="6" name="Rectangle 5"/>
-          <p:cNvSpPr/>
+          <p:cNvPr id="6" name="TextBox 5"/>
+          <p:cNvSpPr txBox="1"/>
           <p:nvPr/>
         </p:nvSpPr>
         <p:spPr>
           <a:xfrm>
-            <a:off x="548640" y="1170432"/>
-            <a:ext cx="11091672" cy="502920"/>
-          </a:xfrm>
-          <a:prstGeom prst="rect">
-            <a:avLst/>
-          </a:prstGeom>
-          <a:solidFill>
-            <a:srgbClr val="FFF2CC"/>
-          </a:solidFill>
-          <a:ln w="15240">
-            <a:solidFill>
-              <a:srgbClr val="C55A11"/>
-            </a:solidFill>
-          </a:ln>
-          <a:effectLst/>
-        </p:spPr>
-        <p:style>
-          <a:lnRef idx="1">
-            <a:schemeClr val="accent1"/>
-          </a:lnRef>
-          <a:fillRef idx="3">
-            <a:schemeClr val="accent1"/>
-          </a:fillRef>
-          <a:effectRef idx="2">
-            <a:schemeClr val="accent1"/>
-          </a:effectRef>
-          <a:fontRef idx="minor">
-            <a:schemeClr val="lt1"/>
-          </a:fontRef>
-        </p:style>
-        <p:txBody>
-          <a:bodyPr rtlCol="0" anchor="ctr"/>
-          <a:lstStyle/>
-          <a:p>
-            <a:pPr algn="ctr"/>
-          </a:p>
-        </p:txBody>
-      </p:sp>
-      <p:sp>
-        <p:nvSpPr>
-          <p:cNvPr id="7" name="TextBox 6"/>
-          <p:cNvSpPr txBox="1"/>
-          <p:nvPr/>
-        </p:nvSpPr>
-        <p:spPr>
-          <a:xfrm>
-            <a:off x="731520" y="1170432"/>
-            <a:ext cx="10698480" cy="502920"/>
+            <a:off x="548640" y="1143000"/>
+            <a:ext cx="11091672" cy="365760"/>
           </a:xfrm>
           <a:prstGeom prst="rect">
             <a:avLst/>
@@ -5902,7 +6128,7 @@
           <a:noFill/>
         </p:spPr>
         <p:txBody>
-          <a:bodyPr wrap="square" anchor="ctr" lIns="0" rIns="0" tIns="0" bIns="0">
+          <a:bodyPr wrap="square" anchor="t" lIns="0" rIns="0" tIns="0" bIns="0">
             <a:spAutoFit/>
           </a:bodyPr>
           <a:lstStyle/>
@@ -5919,29 +6145,29 @@
               </a:spcAft>
             </a:pPr>
             <a:r>
-              <a:rPr sz="1400" b="1">
+              <a:rPr sz="1700" b="1">
                 <a:solidFill>
-                  <a:srgbClr val="C55A11"/>
+                  <a:srgbClr val="2E75B6"/>
                 </a:solidFill>
                 <a:latin typeface="微软雅黑"/>
                 <a:ea typeface="微软雅黑"/>
                 <a:cs typeface="微软雅黑"/>
               </a:rPr>
-              <a:t>【待补充】本页内容需在该模块实现完成后填写</a:t>
-            </a:r>
-          </a:p>
-        </p:txBody>
-      </p:sp>
-      <p:sp>
-        <p:nvSpPr>
-          <p:cNvPr id="8" name="TextBox 7"/>
+              <a:t>错题本</a:t>
+            </a:r>
+          </a:p>
+        </p:txBody>
+      </p:sp>
+      <p:sp>
+        <p:nvSpPr>
+          <p:cNvPr id="7" name="TextBox 6"/>
           <p:cNvSpPr txBox="1"/>
           <p:nvPr/>
         </p:nvSpPr>
         <p:spPr>
           <a:xfrm>
-            <a:off x="548640" y="1965960"/>
-            <a:ext cx="11064240" cy="5120640"/>
+            <a:off x="548640" y="1572768"/>
+            <a:ext cx="11091672" cy="1234440"/>
           </a:xfrm>
           <a:prstGeom prst="rect">
             <a:avLst/>
@@ -5962,19 +6188,30 @@
                 <a:spcPts val="0"/>
               </a:spcBef>
               <a:spcAft>
-                <a:spcPts val="1600"/>
+                <a:spcPts val="600"/>
               </a:spcAft>
             </a:pPr>
             <a:r>
-              <a:rPr sz="1600" b="0">
+              <a:rPr sz="1400" b="0">
                 <a:solidFill>
-                  <a:srgbClr val="808080"/>
+                  <a:srgbClr val="222222"/>
                 </a:solidFill>
                 <a:latin typeface="微软雅黑"/>
                 <a:ea typeface="微软雅黑"/>
                 <a:cs typeface="微软雅黑"/>
               </a:rPr>
-              <a:t>• 错题沉淀流程与关键代码：【待补充】</a:t>
+              <a:t>• </a:t>
+            </a:r>
+            <a:r>
+              <a:rPr sz="1400" b="0">
+                <a:solidFill>
+                  <a:srgbClr val="222222"/>
+                </a:solidFill>
+                <a:latin typeface="微软雅黑"/>
+                <a:ea typeface="微软雅黑"/>
+                <a:cs typeface="微软雅黑"/>
+              </a:rPr>
+              <a:t>判为错误的题目自动写入错题本，记录用户答案、正确答案与解析</a:t>
             </a:r>
           </a:p>
           <a:p>
@@ -5986,19 +6223,30 @@
                 <a:spcPts val="0"/>
               </a:spcBef>
               <a:spcAft>
-                <a:spcPts val="1600"/>
+                <a:spcPts val="600"/>
               </a:spcAft>
             </a:pPr>
             <a:r>
-              <a:rPr sz="1600" b="0">
+              <a:rPr sz="1400" b="0">
                 <a:solidFill>
-                  <a:srgbClr val="808080"/>
+                  <a:srgbClr val="222222"/>
                 </a:solidFill>
                 <a:latin typeface="微软雅黑"/>
                 <a:ea typeface="微软雅黑"/>
                 <a:cs typeface="微软雅黑"/>
               </a:rPr>
-              <a:t>• 复习计划生成算法与 Prompt 设计：【待补充】</a:t>
+              <a:t>• </a:t>
+            </a:r>
+            <a:r>
+              <a:rPr sz="1400" b="0">
+                <a:solidFill>
+                  <a:srgbClr val="222222"/>
+                </a:solidFill>
+                <a:latin typeface="微软雅黑"/>
+                <a:ea typeface="微软雅黑"/>
+                <a:cs typeface="微软雅黑"/>
+              </a:rPr>
+              <a:t>同一题目若已存在未掌握记录则不重复插入，避免错题堆积</a:t>
             </a:r>
           </a:p>
           <a:p>
@@ -6010,21 +6258,55 @@
                 <a:spcPts val="0"/>
               </a:spcBef>
               <a:spcAft>
-                <a:spcPts val="1600"/>
+                <a:spcPts val="600"/>
               </a:spcAft>
             </a:pPr>
             <a:r>
-              <a:rPr sz="1600" b="0">
+              <a:rPr sz="1400" b="0">
                 <a:solidFill>
-                  <a:srgbClr val="808080"/>
+                  <a:srgbClr val="222222"/>
                 </a:solidFill>
                 <a:latin typeface="微软雅黑"/>
                 <a:ea typeface="微软雅黑"/>
                 <a:cs typeface="微软雅黑"/>
               </a:rPr>
-              <a:t>• 模块流程图：【待补充】</a:t>
-            </a:r>
-          </a:p>
+              <a:t>• </a:t>
+            </a:r>
+            <a:r>
+              <a:rPr sz="1400" b="0">
+                <a:solidFill>
+                  <a:srgbClr val="222222"/>
+                </a:solidFill>
+                <a:latin typeface="微软雅黑"/>
+                <a:ea typeface="微软雅黑"/>
+                <a:cs typeface="微软雅黑"/>
+              </a:rPr>
+              <a:t>支持按课程查看、按掌握状态筛选、标记掌握与移除</a:t>
+            </a:r>
+          </a:p>
+        </p:txBody>
+      </p:sp>
+      <p:sp>
+        <p:nvSpPr>
+          <p:cNvPr id="8" name="TextBox 7"/>
+          <p:cNvSpPr txBox="1"/>
+          <p:nvPr/>
+        </p:nvSpPr>
+        <p:spPr>
+          <a:xfrm>
+            <a:off x="548640" y="2788920"/>
+            <a:ext cx="11091672" cy="365760"/>
+          </a:xfrm>
+          <a:prstGeom prst="rect">
+            <a:avLst/>
+          </a:prstGeom>
+          <a:noFill/>
+        </p:spPr>
+        <p:txBody>
+          <a:bodyPr wrap="square" anchor="t" lIns="0" rIns="0" tIns="0" bIns="0">
+            <a:spAutoFit/>
+          </a:bodyPr>
+          <a:lstStyle/>
           <a:p>
             <a:pPr algn="l">
               <a:lnSpc>
@@ -6034,47 +6316,309 @@
                 <a:spcPts val="0"/>
               </a:spcBef>
               <a:spcAft>
-                <a:spcPts val="1600"/>
+                <a:spcPts val="600"/>
               </a:spcAft>
             </a:pPr>
             <a:r>
-              <a:rPr sz="1600" b="0">
+              <a:rPr sz="1700" b="1">
                 <a:solidFill>
-                  <a:srgbClr val="808080"/>
+                  <a:srgbClr val="2E75B6"/>
                 </a:solidFill>
                 <a:latin typeface="微软雅黑"/>
                 <a:ea typeface="微软雅黑"/>
                 <a:cs typeface="微软雅黑"/>
               </a:rPr>
-              <a:t>• 功能界面截图：【待补充】</a:t>
-            </a:r>
-          </a:p>
-          <a:p>
-            <a:pPr algn="l">
-              <a:lnSpc>
-                <a:spcPct val="125000"/>
-              </a:lnSpc>
-              <a:spcBef>
-                <a:spcPts val="0"/>
-              </a:spcBef>
-              <a:spcAft>
-                <a:spcPts val="1600"/>
-              </a:spcAft>
-            </a:pPr>
-            <a:r>
-              <a:rPr sz="1600" b="0">
-                <a:solidFill>
-                  <a:srgbClr val="808080"/>
-                </a:solidFill>
-                <a:latin typeface="微软雅黑"/>
-                <a:ea typeface="微软雅黑"/>
-                <a:cs typeface="微软雅黑"/>
-              </a:rPr>
-              <a:t>• 测试用例与结果：【待补充】</a:t>
-            </a:r>
-          </a:p>
-        </p:txBody>
-      </p:sp>
+              <a:t>复习计划生成</a:t>
+            </a:r>
+          </a:p>
+        </p:txBody>
+      </p:sp>
+      <p:graphicFrame>
+        <p:nvGraphicFramePr>
+          <p:cNvPr id="9" name="Table 8"/>
+          <p:cNvGraphicFramePr>
+            <a:graphicFrameLocks noGrp="1"/>
+          </p:cNvGraphicFramePr>
+          <p:nvPr/>
+        </p:nvGraphicFramePr>
+        <p:xfrm>
+          <a:off x="548640" y="3218688"/>
+          <a:ext cx="11091672" cy="2103120"/>
+        </p:xfrm>
+        <a:graphic>
+          <a:graphicData uri="http://schemas.openxmlformats.org/drawingml/2006/table">
+            <a:tbl>
+              <a:tblPr firstRow="1" bandRow="1">
+                <a:tableStyleId>{5C22544A-7EE6-4342-B048-85BDC9FD1C3A}</a:tableStyleId>
+              </a:tblPr>
+              <a:tblGrid>
+                <a:gridCol w="1232408"/>
+                <a:gridCol w="9859264"/>
+              </a:tblGrid>
+              <a:tr h="420624">
+                <a:tc>
+                  <a:txBody>
+                    <a:bodyPr/>
+                    <a:lstStyle/>
+                    <a:p>
+                      <a:pPr algn="ctr"/>
+                      <a:r>
+                        <a:rPr sz="1300" b="1">
+                          <a:solidFill>
+                            <a:srgbClr val="FFFFFF"/>
+                          </a:solidFill>
+                          <a:latin typeface="微软雅黑"/>
+                          <a:ea typeface="微软雅黑"/>
+                          <a:cs typeface="微软雅黑"/>
+                        </a:rPr>
+                        <a:t>步骤</a:t>
+                      </a:r>
+                    </a:p>
+                  </a:txBody>
+                  <a:tcPr anchor="ctr">
+                    <a:solidFill>
+                      <a:srgbClr val="1F4E79"/>
+                    </a:solidFill>
+                  </a:tcPr>
+                </a:tc>
+                <a:tc>
+                  <a:txBody>
+                    <a:bodyPr/>
+                    <a:lstStyle/>
+                    <a:p>
+                      <a:pPr algn="ctr"/>
+                      <a:r>
+                        <a:rPr sz="1300" b="1">
+                          <a:solidFill>
+                            <a:srgbClr val="FFFFFF"/>
+                          </a:solidFill>
+                          <a:latin typeface="微软雅黑"/>
+                          <a:ea typeface="微软雅黑"/>
+                          <a:cs typeface="微软雅黑"/>
+                        </a:rPr>
+                        <a:t>处理内容</a:t>
+                      </a:r>
+                    </a:p>
+                  </a:txBody>
+                  <a:tcPr anchor="ctr">
+                    <a:solidFill>
+                      <a:srgbClr val="1F4E79"/>
+                    </a:solidFill>
+                  </a:tcPr>
+                </a:tc>
+              </a:tr>
+              <a:tr h="420624">
+                <a:tc>
+                  <a:txBody>
+                    <a:bodyPr/>
+                    <a:lstStyle/>
+                    <a:p>
+                      <a:pPr algn="ctr"/>
+                      <a:r>
+                        <a:rPr sz="1200" b="0">
+                          <a:solidFill>
+                            <a:srgbClr val="222222"/>
+                          </a:solidFill>
+                          <a:latin typeface="微软雅黑"/>
+                          <a:ea typeface="微软雅黑"/>
+                          <a:cs typeface="微软雅黑"/>
+                        </a:rPr>
+                        <a:t>① 取错题</a:t>
+                      </a:r>
+                    </a:p>
+                  </a:txBody>
+                  <a:tcPr anchor="ctr">
+                    <a:solidFill>
+                      <a:srgbClr val="FFFFFF"/>
+                    </a:solidFill>
+                  </a:tcPr>
+                </a:tc>
+                <a:tc>
+                  <a:txBody>
+                    <a:bodyPr/>
+                    <a:lstStyle/>
+                    <a:p>
+                      <a:pPr algn="l"/>
+                      <a:r>
+                        <a:rPr sz="1200" b="0">
+                          <a:solidFill>
+                            <a:srgbClr val="222222"/>
+                          </a:solidFill>
+                          <a:latin typeface="微软雅黑"/>
+                          <a:ea typeface="微软雅黑"/>
+                          <a:cs typeface="微软雅黑"/>
+                        </a:rPr>
+                        <a:t>读取该课程所有未掌握的错题及其解析</a:t>
+                      </a:r>
+                    </a:p>
+                  </a:txBody>
+                  <a:tcPr anchor="ctr">
+                    <a:solidFill>
+                      <a:srgbClr val="FFFFFF"/>
+                    </a:solidFill>
+                  </a:tcPr>
+                </a:tc>
+              </a:tr>
+              <a:tr h="420624">
+                <a:tc>
+                  <a:txBody>
+                    <a:bodyPr/>
+                    <a:lstStyle/>
+                    <a:p>
+                      <a:pPr algn="ctr"/>
+                      <a:r>
+                        <a:rPr sz="1200" b="0">
+                          <a:solidFill>
+                            <a:srgbClr val="222222"/>
+                          </a:solidFill>
+                          <a:latin typeface="微软雅黑"/>
+                          <a:ea typeface="微软雅黑"/>
+                          <a:cs typeface="微软雅黑"/>
+                        </a:rPr>
+                        <a:t>② 分配</a:t>
+                      </a:r>
+                    </a:p>
+                  </a:txBody>
+                  <a:tcPr anchor="ctr">
+                    <a:solidFill>
+                      <a:srgbClr val="EAF3FB"/>
+                    </a:solidFill>
+                  </a:tcPr>
+                </a:tc>
+                <a:tc>
+                  <a:txBody>
+                    <a:bodyPr/>
+                    <a:lstStyle/>
+                    <a:p>
+                      <a:pPr algn="l"/>
+                      <a:r>
+                        <a:rPr sz="1200" b="0">
+                          <a:solidFill>
+                            <a:srgbClr val="222222"/>
+                          </a:solidFill>
+                          <a:latin typeface="微软雅黑"/>
+                          <a:ea typeface="微软雅黑"/>
+                          <a:cs typeface="微软雅黑"/>
+                        </a:rPr>
+                        <a:t>交由大模型将知识点分配到 7 天，输出“第几天 + 知识点”</a:t>
+                      </a:r>
+                    </a:p>
+                  </a:txBody>
+                  <a:tcPr anchor="ctr">
+                    <a:solidFill>
+                      <a:srgbClr val="EAF3FB"/>
+                    </a:solidFill>
+                  </a:tcPr>
+                </a:tc>
+              </a:tr>
+              <a:tr h="420624">
+                <a:tc>
+                  <a:txBody>
+                    <a:bodyPr/>
+                    <a:lstStyle/>
+                    <a:p>
+                      <a:pPr algn="ctr"/>
+                      <a:r>
+                        <a:rPr sz="1200" b="0">
+                          <a:solidFill>
+                            <a:srgbClr val="222222"/>
+                          </a:solidFill>
+                          <a:latin typeface="微软雅黑"/>
+                          <a:ea typeface="微软雅黑"/>
+                          <a:cs typeface="微软雅黑"/>
+                        </a:rPr>
+                        <a:t>③ 算日期</a:t>
+                      </a:r>
+                    </a:p>
+                  </a:txBody>
+                  <a:tcPr anchor="ctr">
+                    <a:solidFill>
+                      <a:srgbClr val="FFFFFF"/>
+                    </a:solidFill>
+                  </a:tcPr>
+                </a:tc>
+                <a:tc>
+                  <a:txBody>
+                    <a:bodyPr/>
+                    <a:lstStyle/>
+                    <a:p>
+                      <a:pPr algn="l"/>
+                      <a:r>
+                        <a:rPr sz="1200" b="0">
+                          <a:solidFill>
+                            <a:srgbClr val="222222"/>
+                          </a:solidFill>
+                          <a:latin typeface="微软雅黑"/>
+                          <a:ea typeface="微软雅黑"/>
+                          <a:cs typeface="微软雅黑"/>
+                        </a:rPr>
+                        <a:t>服务端以当天为基准计算具体日期后写入条目，避免模型不知当前日期</a:t>
+                      </a:r>
+                    </a:p>
+                  </a:txBody>
+                  <a:tcPr anchor="ctr">
+                    <a:solidFill>
+                      <a:srgbClr val="FFFFFF"/>
+                    </a:solidFill>
+                  </a:tcPr>
+                </a:tc>
+              </a:tr>
+              <a:tr h="420624">
+                <a:tc>
+                  <a:txBody>
+                    <a:bodyPr/>
+                    <a:lstStyle/>
+                    <a:p>
+                      <a:pPr algn="ctr"/>
+                      <a:r>
+                        <a:rPr sz="1200" b="0">
+                          <a:solidFill>
+                            <a:srgbClr val="222222"/>
+                          </a:solidFill>
+                          <a:latin typeface="微软雅黑"/>
+                          <a:ea typeface="微软雅黑"/>
+                          <a:cs typeface="微软雅黑"/>
+                        </a:rPr>
+                        <a:t>④ 跟踪</a:t>
+                      </a:r>
+                    </a:p>
+                  </a:txBody>
+                  <a:tcPr anchor="ctr">
+                    <a:solidFill>
+                      <a:srgbClr val="EAF3FB"/>
+                    </a:solidFill>
+                  </a:tcPr>
+                </a:tc>
+                <a:tc>
+                  <a:txBody>
+                    <a:bodyPr/>
+                    <a:lstStyle/>
+                    <a:p>
+                      <a:pPr algn="l"/>
+                      <a:r>
+                        <a:rPr sz="1200" b="0">
+                          <a:solidFill>
+                            <a:srgbClr val="222222"/>
+                          </a:solidFill>
+                          <a:latin typeface="微软雅黑"/>
+                          <a:ea typeface="微软雅黑"/>
+                          <a:cs typeface="微软雅黑"/>
+                        </a:rPr>
+                        <a:t>支持查看计划详情与标记完成；无错题时返回明确提示</a:t>
+                      </a:r>
+                    </a:p>
+                  </a:txBody>
+                  <a:tcPr anchor="ctr">
+                    <a:solidFill>
+                      <a:srgbClr val="EAF3FB"/>
+                    </a:solidFill>
+                  </a:tcPr>
+                </a:tc>
+              </a:tr>
+            </a:tbl>
+          </a:graphicData>
+        </a:graphic>
+      </p:graphicFrame>
     </p:spTree>
   </p:cSld>
   <p:clrMapOvr>
@@ -6146,7 +6690,7 @@
         <p:spPr>
           <a:xfrm>
             <a:off x="502920" y="182880"/>
-            <a:ext cx="11185855" cy="621792"/>
+            <a:ext cx="11155680" cy="621792"/>
           </a:xfrm>
           <a:prstGeom prst="rect">
             <a:avLst/>
@@ -6192,7 +6736,7 @@
         </p:nvSpPr>
         <p:spPr>
           <a:xfrm>
-            <a:off x="8351215" y="274320"/>
+            <a:off x="8321040" y="274320"/>
             <a:ext cx="3383280" cy="457200"/>
           </a:xfrm>
           <a:prstGeom prst="rect">
@@ -6239,7 +6783,7 @@
         </p:nvSpPr>
         <p:spPr>
           <a:xfrm>
-            <a:off x="11277295" y="6473952"/>
+            <a:off x="11247120" y="6473952"/>
             <a:ext cx="640080" cy="274320"/>
           </a:xfrm>
           <a:prstGeom prst="rect">
@@ -6280,60 +6824,14 @@
       </p:sp>
       <p:sp>
         <p:nvSpPr>
-          <p:cNvPr id="6" name="Rectangle 5"/>
-          <p:cNvSpPr/>
+          <p:cNvPr id="6" name="TextBox 5"/>
+          <p:cNvSpPr txBox="1"/>
           <p:nvPr/>
         </p:nvSpPr>
         <p:spPr>
           <a:xfrm>
-            <a:off x="548640" y="1170432"/>
-            <a:ext cx="11091672" cy="502920"/>
-          </a:xfrm>
-          <a:prstGeom prst="rect">
-            <a:avLst/>
-          </a:prstGeom>
-          <a:solidFill>
-            <a:srgbClr val="FFF2CC"/>
-          </a:solidFill>
-          <a:ln w="15240">
-            <a:solidFill>
-              <a:srgbClr val="C55A11"/>
-            </a:solidFill>
-          </a:ln>
-          <a:effectLst/>
-        </p:spPr>
-        <p:style>
-          <a:lnRef idx="1">
-            <a:schemeClr val="accent1"/>
-          </a:lnRef>
-          <a:fillRef idx="3">
-            <a:schemeClr val="accent1"/>
-          </a:fillRef>
-          <a:effectRef idx="2">
-            <a:schemeClr val="accent1"/>
-          </a:effectRef>
-          <a:fontRef idx="minor">
-            <a:schemeClr val="lt1"/>
-          </a:fontRef>
-        </p:style>
-        <p:txBody>
-          <a:bodyPr rtlCol="0" anchor="ctr"/>
-          <a:lstStyle/>
-          <a:p>
-            <a:pPr algn="ctr"/>
-          </a:p>
-        </p:txBody>
-      </p:sp>
-      <p:sp>
-        <p:nvSpPr>
-          <p:cNvPr id="7" name="TextBox 6"/>
-          <p:cNvSpPr txBox="1"/>
-          <p:nvPr/>
-        </p:nvSpPr>
-        <p:spPr>
-          <a:xfrm>
-            <a:off x="731520" y="1170432"/>
-            <a:ext cx="10698480" cy="502920"/>
+            <a:off x="548640" y="1143000"/>
+            <a:ext cx="11091672" cy="365760"/>
           </a:xfrm>
           <a:prstGeom prst="rect">
             <a:avLst/>
@@ -6341,7 +6839,7 @@
           <a:noFill/>
         </p:spPr>
         <p:txBody>
-          <a:bodyPr wrap="square" anchor="ctr" lIns="0" rIns="0" tIns="0" bIns="0">
+          <a:bodyPr wrap="square" anchor="t" lIns="0" rIns="0" tIns="0" bIns="0">
             <a:spAutoFit/>
           </a:bodyPr>
           <a:lstStyle/>
@@ -6358,29 +6856,29 @@
               </a:spcAft>
             </a:pPr>
             <a:r>
-              <a:rPr sz="1400" b="1">
+              <a:rPr sz="1700" b="1">
                 <a:solidFill>
-                  <a:srgbClr val="C55A11"/>
+                  <a:srgbClr val="2E75B6"/>
                 </a:solidFill>
                 <a:latin typeface="微软雅黑"/>
                 <a:ea typeface="微软雅黑"/>
                 <a:cs typeface="微软雅黑"/>
               </a:rPr>
-              <a:t>【待补充】本页内容需在该模块实现完成后填写</a:t>
-            </a:r>
-          </a:p>
-        </p:txBody>
-      </p:sp>
-      <p:sp>
-        <p:nvSpPr>
-          <p:cNvPr id="8" name="TextBox 7"/>
+              <a:t>前端界面</a:t>
+            </a:r>
+          </a:p>
+        </p:txBody>
+      </p:sp>
+      <p:sp>
+        <p:nvSpPr>
+          <p:cNvPr id="7" name="TextBox 6"/>
           <p:cNvSpPr txBox="1"/>
           <p:nvPr/>
         </p:nvSpPr>
         <p:spPr>
           <a:xfrm>
-            <a:off x="548640" y="1965960"/>
-            <a:ext cx="11064240" cy="5120640"/>
+            <a:off x="548640" y="1554480"/>
+            <a:ext cx="11091672" cy="822960"/>
           </a:xfrm>
           <a:prstGeom prst="rect">
             <a:avLst/>
@@ -6401,21 +6899,44 @@
                 <a:spcPts val="0"/>
               </a:spcBef>
               <a:spcAft>
-                <a:spcPts val="1600"/>
+                <a:spcPts val="600"/>
               </a:spcAft>
             </a:pPr>
             <a:r>
-              <a:rPr sz="1600" b="0">
+              <a:rPr sz="1400" b="0">
                 <a:solidFill>
-                  <a:srgbClr val="808080"/>
+                  <a:srgbClr val="222222"/>
                 </a:solidFill>
                 <a:latin typeface="微软雅黑"/>
                 <a:ea typeface="微软雅黑"/>
                 <a:cs typeface="微软雅黑"/>
               </a:rPr>
-              <a:t>• 页面整体布局与交互设计：【待补充】</a:t>
-            </a:r>
-          </a:p>
+              <a:t>左侧为课程列表，右侧顶部为五个功能标签页：文档管理、智能问答、自动出题、错题本、复习计划；采用原生 HTML / CSS / JavaScript 实现，无框架依赖，通过 fetch 调用后端 REST 接口。</a:t>
+            </a:r>
+          </a:p>
+        </p:txBody>
+      </p:sp>
+      <p:sp>
+        <p:nvSpPr>
+          <p:cNvPr id="8" name="TextBox 7"/>
+          <p:cNvSpPr txBox="1"/>
+          <p:nvPr/>
+        </p:nvSpPr>
+        <p:spPr>
+          <a:xfrm>
+            <a:off x="548640" y="2395728"/>
+            <a:ext cx="11091672" cy="365760"/>
+          </a:xfrm>
+          <a:prstGeom prst="rect">
+            <a:avLst/>
+          </a:prstGeom>
+          <a:noFill/>
+        </p:spPr>
+        <p:txBody>
+          <a:bodyPr wrap="square" anchor="t" lIns="0" rIns="0" tIns="0" bIns="0">
+            <a:spAutoFit/>
+          </a:bodyPr>
+          <a:lstStyle/>
           <a:p>
             <a:pPr algn="l">
               <a:lnSpc>
@@ -6425,21 +6946,764 @@
                 <a:spcPts val="0"/>
               </a:spcBef>
               <a:spcAft>
-                <a:spcPts val="1600"/>
+                <a:spcPts val="600"/>
               </a:spcAft>
             </a:pPr>
             <a:r>
-              <a:rPr sz="1600" b="0">
+              <a:rPr sz="1700" b="1">
                 <a:solidFill>
-                  <a:srgbClr val="808080"/>
+                  <a:srgbClr val="2E75B6"/>
                 </a:solidFill>
                 <a:latin typeface="微软雅黑"/>
                 <a:ea typeface="微软雅黑"/>
                 <a:cs typeface="微软雅黑"/>
               </a:rPr>
-              <a:t>• 出题 / 错题本 / 复习计划三个标签页截图：【待补充】</a:t>
-            </a:r>
-          </a:p>
+              <a:t>系统测试（功能测试 + 结构测试）</a:t>
+            </a:r>
+          </a:p>
+        </p:txBody>
+      </p:sp>
+      <p:graphicFrame>
+        <p:nvGraphicFramePr>
+          <p:cNvPr id="9" name="Table 8"/>
+          <p:cNvGraphicFramePr>
+            <a:graphicFrameLocks noGrp="1"/>
+          </p:cNvGraphicFramePr>
+          <p:nvPr/>
+        </p:nvGraphicFramePr>
+        <p:xfrm>
+          <a:off x="548640" y="2788920"/>
+          <a:ext cx="11091671" cy="3291840"/>
+        </p:xfrm>
+        <a:graphic>
+          <a:graphicData uri="http://schemas.openxmlformats.org/drawingml/2006/table">
+            <a:tbl>
+              <a:tblPr firstRow="1" bandRow="1">
+                <a:tableStyleId>{5C22544A-7EE6-4342-B048-85BDC9FD1C3A}</a:tableStyleId>
+              </a:tblPr>
+              <a:tblGrid>
+                <a:gridCol w="1096978"/>
+                <a:gridCol w="3900368"/>
+                <a:gridCol w="6094325"/>
+              </a:tblGrid>
+              <a:tr h="365760">
+                <a:tc>
+                  <a:txBody>
+                    <a:bodyPr/>
+                    <a:lstStyle/>
+                    <a:p>
+                      <a:pPr algn="ctr"/>
+                      <a:r>
+                        <a:rPr sz="1300" b="1">
+                          <a:solidFill>
+                            <a:srgbClr val="FFFFFF"/>
+                          </a:solidFill>
+                          <a:latin typeface="微软雅黑"/>
+                          <a:ea typeface="微软雅黑"/>
+                          <a:cs typeface="微软雅黑"/>
+                        </a:rPr>
+                        <a:t>类型</a:t>
+                      </a:r>
+                    </a:p>
+                  </a:txBody>
+                  <a:tcPr anchor="ctr">
+                    <a:solidFill>
+                      <a:srgbClr val="1F4E79"/>
+                    </a:solidFill>
+                  </a:tcPr>
+                </a:tc>
+                <a:tc>
+                  <a:txBody>
+                    <a:bodyPr/>
+                    <a:lstStyle/>
+                    <a:p>
+                      <a:pPr algn="ctr"/>
+                      <a:r>
+                        <a:rPr sz="1300" b="1">
+                          <a:solidFill>
+                            <a:srgbClr val="FFFFFF"/>
+                          </a:solidFill>
+                          <a:latin typeface="微软雅黑"/>
+                          <a:ea typeface="微软雅黑"/>
+                          <a:cs typeface="微软雅黑"/>
+                        </a:rPr>
+                        <a:t>测试内容</a:t>
+                      </a:r>
+                    </a:p>
+                  </a:txBody>
+                  <a:tcPr anchor="ctr">
+                    <a:solidFill>
+                      <a:srgbClr val="1F4E79"/>
+                    </a:solidFill>
+                  </a:tcPr>
+                </a:tc>
+                <a:tc>
+                  <a:txBody>
+                    <a:bodyPr/>
+                    <a:lstStyle/>
+                    <a:p>
+                      <a:pPr algn="ctr"/>
+                      <a:r>
+                        <a:rPr sz="1300" b="1">
+                          <a:solidFill>
+                            <a:srgbClr val="FFFFFF"/>
+                          </a:solidFill>
+                          <a:latin typeface="微软雅黑"/>
+                          <a:ea typeface="微软雅黑"/>
+                          <a:cs typeface="微软雅黑"/>
+                        </a:rPr>
+                        <a:t>预期结果</a:t>
+                      </a:r>
+                    </a:p>
+                  </a:txBody>
+                  <a:tcPr anchor="ctr">
+                    <a:solidFill>
+                      <a:srgbClr val="1F4E79"/>
+                    </a:solidFill>
+                  </a:tcPr>
+                </a:tc>
+              </a:tr>
+              <a:tr h="365760">
+                <a:tc>
+                  <a:txBody>
+                    <a:bodyPr/>
+                    <a:lstStyle/>
+                    <a:p>
+                      <a:pPr algn="ctr"/>
+                      <a:r>
+                        <a:rPr sz="1200" b="0">
+                          <a:solidFill>
+                            <a:srgbClr val="222222"/>
+                          </a:solidFill>
+                          <a:latin typeface="微软雅黑"/>
+                          <a:ea typeface="微软雅黑"/>
+                          <a:cs typeface="微软雅黑"/>
+                        </a:rPr>
+                        <a:t>功能</a:t>
+                      </a:r>
+                    </a:p>
+                  </a:txBody>
+                  <a:tcPr anchor="ctr">
+                    <a:solidFill>
+                      <a:srgbClr val="FFFFFF"/>
+                    </a:solidFill>
+                  </a:tcPr>
+                </a:tc>
+                <a:tc>
+                  <a:txBody>
+                    <a:bodyPr/>
+                    <a:lstStyle/>
+                    <a:p>
+                      <a:pPr algn="ctr"/>
+                      <a:r>
+                        <a:rPr sz="1200" b="0">
+                          <a:solidFill>
+                            <a:srgbClr val="222222"/>
+                          </a:solidFill>
+                          <a:latin typeface="微软雅黑"/>
+                          <a:ea typeface="微软雅黑"/>
+                          <a:cs typeface="微软雅黑"/>
+                        </a:rPr>
+                        <a:t>文档上传与入库</a:t>
+                      </a:r>
+                    </a:p>
+                  </a:txBody>
+                  <a:tcPr anchor="ctr">
+                    <a:solidFill>
+                      <a:srgbClr val="FFFFFF"/>
+                    </a:solidFill>
+                  </a:tcPr>
+                </a:tc>
+                <a:tc>
+                  <a:txBody>
+                    <a:bodyPr/>
+                    <a:lstStyle/>
+                    <a:p>
+                      <a:pPr algn="l"/>
+                      <a:r>
+                        <a:rPr sz="1200" b="0">
+                          <a:solidFill>
+                            <a:srgbClr val="222222"/>
+                          </a:solidFill>
+                          <a:latin typeface="微软雅黑"/>
+                          <a:ea typeface="微软雅黑"/>
+                          <a:cs typeface="微软雅黑"/>
+                        </a:rPr>
+                        <a:t>返回切分块数，状态 completed</a:t>
+                      </a:r>
+                    </a:p>
+                  </a:txBody>
+                  <a:tcPr anchor="ctr">
+                    <a:solidFill>
+                      <a:srgbClr val="FFFFFF"/>
+                    </a:solidFill>
+                  </a:tcPr>
+                </a:tc>
+              </a:tr>
+              <a:tr h="365760">
+                <a:tc>
+                  <a:txBody>
+                    <a:bodyPr/>
+                    <a:lstStyle/>
+                    <a:p>
+                      <a:pPr algn="ctr"/>
+                      <a:r>
+                        <a:rPr sz="1200" b="0">
+                          <a:solidFill>
+                            <a:srgbClr val="222222"/>
+                          </a:solidFill>
+                          <a:latin typeface="微软雅黑"/>
+                          <a:ea typeface="微软雅黑"/>
+                          <a:cs typeface="微软雅黑"/>
+                        </a:rPr>
+                        <a:t>功能</a:t>
+                      </a:r>
+                    </a:p>
+                  </a:txBody>
+                  <a:tcPr anchor="ctr">
+                    <a:solidFill>
+                      <a:srgbClr val="EAF3FB"/>
+                    </a:solidFill>
+                  </a:tcPr>
+                </a:tc>
+                <a:tc>
+                  <a:txBody>
+                    <a:bodyPr/>
+                    <a:lstStyle/>
+                    <a:p>
+                      <a:pPr algn="ctr"/>
+                      <a:r>
+                        <a:rPr sz="1200" b="0">
+                          <a:solidFill>
+                            <a:srgbClr val="222222"/>
+                          </a:solidFill>
+                          <a:latin typeface="微软雅黑"/>
+                          <a:ea typeface="微软雅黑"/>
+                          <a:cs typeface="微软雅黑"/>
+                        </a:rPr>
+                        <a:t>文档类型校验</a:t>
+                      </a:r>
+                    </a:p>
+                  </a:txBody>
+                  <a:tcPr anchor="ctr">
+                    <a:solidFill>
+                      <a:srgbClr val="EAF3FB"/>
+                    </a:solidFill>
+                  </a:tcPr>
+                </a:tc>
+                <a:tc>
+                  <a:txBody>
+                    <a:bodyPr/>
+                    <a:lstStyle/>
+                    <a:p>
+                      <a:pPr algn="l"/>
+                      <a:r>
+                        <a:rPr sz="1200" b="0">
+                          <a:solidFill>
+                            <a:srgbClr val="222222"/>
+                          </a:solidFill>
+                          <a:latin typeface="微软雅黑"/>
+                          <a:ea typeface="微软雅黑"/>
+                          <a:cs typeface="微软雅黑"/>
+                        </a:rPr>
+                        <a:t>拒绝并提示支持的类型</a:t>
+                      </a:r>
+                    </a:p>
+                  </a:txBody>
+                  <a:tcPr anchor="ctr">
+                    <a:solidFill>
+                      <a:srgbClr val="EAF3FB"/>
+                    </a:solidFill>
+                  </a:tcPr>
+                </a:tc>
+              </a:tr>
+              <a:tr h="365760">
+                <a:tc>
+                  <a:txBody>
+                    <a:bodyPr/>
+                    <a:lstStyle/>
+                    <a:p>
+                      <a:pPr algn="ctr"/>
+                      <a:r>
+                        <a:rPr sz="1200" b="0">
+                          <a:solidFill>
+                            <a:srgbClr val="222222"/>
+                          </a:solidFill>
+                          <a:latin typeface="微软雅黑"/>
+                          <a:ea typeface="微软雅黑"/>
+                          <a:cs typeface="微软雅黑"/>
+                        </a:rPr>
+                        <a:t>功能</a:t>
+                      </a:r>
+                    </a:p>
+                  </a:txBody>
+                  <a:tcPr anchor="ctr">
+                    <a:solidFill>
+                      <a:srgbClr val="FFFFFF"/>
+                    </a:solidFill>
+                  </a:tcPr>
+                </a:tc>
+                <a:tc>
+                  <a:txBody>
+                    <a:bodyPr/>
+                    <a:lstStyle/>
+                    <a:p>
+                      <a:pPr algn="ctr"/>
+                      <a:r>
+                        <a:rPr sz="1200" b="0">
+                          <a:solidFill>
+                            <a:srgbClr val="222222"/>
+                          </a:solidFill>
+                          <a:latin typeface="微软雅黑"/>
+                          <a:ea typeface="微软雅黑"/>
+                          <a:cs typeface="微软雅黑"/>
+                        </a:rPr>
+                        <a:t>智能问答 / 空库提问</a:t>
+                      </a:r>
+                    </a:p>
+                  </a:txBody>
+                  <a:tcPr anchor="ctr">
+                    <a:solidFill>
+                      <a:srgbClr val="FFFFFF"/>
+                    </a:solidFill>
+                  </a:tcPr>
+                </a:tc>
+                <a:tc>
+                  <a:txBody>
+                    <a:bodyPr/>
+                    <a:lstStyle/>
+                    <a:p>
+                      <a:pPr algn="l"/>
+                      <a:r>
+                        <a:rPr sz="1200" b="0">
+                          <a:solidFill>
+                            <a:srgbClr val="222222"/>
+                          </a:solidFill>
+                          <a:latin typeface="微软雅黑"/>
+                          <a:ea typeface="微软雅黑"/>
+                          <a:cs typeface="微软雅黑"/>
+                        </a:rPr>
+                        <a:t>分别返回带来源的回答 / 上传引导</a:t>
+                      </a:r>
+                    </a:p>
+                  </a:txBody>
+                  <a:tcPr anchor="ctr">
+                    <a:solidFill>
+                      <a:srgbClr val="FFFFFF"/>
+                    </a:solidFill>
+                  </a:tcPr>
+                </a:tc>
+              </a:tr>
+              <a:tr h="365760">
+                <a:tc>
+                  <a:txBody>
+                    <a:bodyPr/>
+                    <a:lstStyle/>
+                    <a:p>
+                      <a:pPr algn="ctr"/>
+                      <a:r>
+                        <a:rPr sz="1200" b="0">
+                          <a:solidFill>
+                            <a:srgbClr val="222222"/>
+                          </a:solidFill>
+                          <a:latin typeface="微软雅黑"/>
+                          <a:ea typeface="微软雅黑"/>
+                          <a:cs typeface="微软雅黑"/>
+                        </a:rPr>
+                        <a:t>功能</a:t>
+                      </a:r>
+                    </a:p>
+                  </a:txBody>
+                  <a:tcPr anchor="ctr">
+                    <a:solidFill>
+                      <a:srgbClr val="EAF3FB"/>
+                    </a:solidFill>
+                  </a:tcPr>
+                </a:tc>
+                <a:tc>
+                  <a:txBody>
+                    <a:bodyPr/>
+                    <a:lstStyle/>
+                    <a:p>
+                      <a:pPr algn="ctr"/>
+                      <a:r>
+                        <a:rPr sz="1200" b="0">
+                          <a:solidFill>
+                            <a:srgbClr val="222222"/>
+                          </a:solidFill>
+                          <a:latin typeface="微软雅黑"/>
+                          <a:ea typeface="微软雅黑"/>
+                          <a:cs typeface="微软雅黑"/>
+                        </a:rPr>
+                        <a:t>自动出题</a:t>
+                      </a:r>
+                    </a:p>
+                  </a:txBody>
+                  <a:tcPr anchor="ctr">
+                    <a:solidFill>
+                      <a:srgbClr val="EAF3FB"/>
+                    </a:solidFill>
+                  </a:tcPr>
+                </a:tc>
+                <a:tc>
+                  <a:txBody>
+                    <a:bodyPr/>
+                    <a:lstStyle/>
+                    <a:p>
+                      <a:pPr algn="l"/>
+                      <a:r>
+                        <a:rPr sz="1200" b="0">
+                          <a:solidFill>
+                            <a:srgbClr val="222222"/>
+                          </a:solidFill>
+                          <a:latin typeface="微软雅黑"/>
+                          <a:ea typeface="微软雅黑"/>
+                          <a:cs typeface="微软雅黑"/>
+                        </a:rPr>
+                        <a:t>返回结构化题目，含选项、答案、解析</a:t>
+                      </a:r>
+                    </a:p>
+                  </a:txBody>
+                  <a:tcPr anchor="ctr">
+                    <a:solidFill>
+                      <a:srgbClr val="EAF3FB"/>
+                    </a:solidFill>
+                  </a:tcPr>
+                </a:tc>
+              </a:tr>
+              <a:tr h="365760">
+                <a:tc>
+                  <a:txBody>
+                    <a:bodyPr/>
+                    <a:lstStyle/>
+                    <a:p>
+                      <a:pPr algn="ctr"/>
+                      <a:r>
+                        <a:rPr sz="1200" b="0">
+                          <a:solidFill>
+                            <a:srgbClr val="222222"/>
+                          </a:solidFill>
+                          <a:latin typeface="微软雅黑"/>
+                          <a:ea typeface="微软雅黑"/>
+                          <a:cs typeface="微软雅黑"/>
+                        </a:rPr>
+                        <a:t>功能</a:t>
+                      </a:r>
+                    </a:p>
+                  </a:txBody>
+                  <a:tcPr anchor="ctr">
+                    <a:solidFill>
+                      <a:srgbClr val="FFFFFF"/>
+                    </a:solidFill>
+                  </a:tcPr>
+                </a:tc>
+                <a:tc>
+                  <a:txBody>
+                    <a:bodyPr/>
+                    <a:lstStyle/>
+                    <a:p>
+                      <a:pPr algn="ctr"/>
+                      <a:r>
+                        <a:rPr sz="1200" b="0">
+                          <a:solidFill>
+                            <a:srgbClr val="222222"/>
+                          </a:solidFill>
+                          <a:latin typeface="微软雅黑"/>
+                          <a:ea typeface="微软雅黑"/>
+                          <a:cs typeface="微软雅黑"/>
+                        </a:rPr>
+                        <a:t>判题与错题沉淀</a:t>
+                      </a:r>
+                    </a:p>
+                  </a:txBody>
+                  <a:tcPr anchor="ctr">
+                    <a:solidFill>
+                      <a:srgbClr val="FFFFFF"/>
+                    </a:solidFill>
+                  </a:tcPr>
+                </a:tc>
+                <a:tc>
+                  <a:txBody>
+                    <a:bodyPr/>
+                    <a:lstStyle/>
+                    <a:p>
+                      <a:pPr algn="l"/>
+                      <a:r>
+                        <a:rPr sz="1200" b="0">
+                          <a:solidFill>
+                            <a:srgbClr val="222222"/>
+                          </a:solidFill>
+                          <a:latin typeface="微软雅黑"/>
+                          <a:ea typeface="微软雅黑"/>
+                          <a:cs typeface="微软雅黑"/>
+                        </a:rPr>
+                        <a:t>答错自动写入错题本，不重复插入</a:t>
+                      </a:r>
+                    </a:p>
+                  </a:txBody>
+                  <a:tcPr anchor="ctr">
+                    <a:solidFill>
+                      <a:srgbClr val="FFFFFF"/>
+                    </a:solidFill>
+                  </a:tcPr>
+                </a:tc>
+              </a:tr>
+              <a:tr h="365760">
+                <a:tc>
+                  <a:txBody>
+                    <a:bodyPr/>
+                    <a:lstStyle/>
+                    <a:p>
+                      <a:pPr algn="ctr"/>
+                      <a:r>
+                        <a:rPr sz="1200" b="0">
+                          <a:solidFill>
+                            <a:srgbClr val="222222"/>
+                          </a:solidFill>
+                          <a:latin typeface="微软雅黑"/>
+                          <a:ea typeface="微软雅黑"/>
+                          <a:cs typeface="微软雅黑"/>
+                        </a:rPr>
+                        <a:t>功能</a:t>
+                      </a:r>
+                    </a:p>
+                  </a:txBody>
+                  <a:tcPr anchor="ctr">
+                    <a:solidFill>
+                      <a:srgbClr val="EAF3FB"/>
+                    </a:solidFill>
+                  </a:tcPr>
+                </a:tc>
+                <a:tc>
+                  <a:txBody>
+                    <a:bodyPr/>
+                    <a:lstStyle/>
+                    <a:p>
+                      <a:pPr algn="ctr"/>
+                      <a:r>
+                        <a:rPr sz="1200" b="0">
+                          <a:solidFill>
+                            <a:srgbClr val="222222"/>
+                          </a:solidFill>
+                          <a:latin typeface="微软雅黑"/>
+                          <a:ea typeface="微软雅黑"/>
+                          <a:cs typeface="微软雅黑"/>
+                        </a:rPr>
+                        <a:t>复习计划生成 / 无错题</a:t>
+                      </a:r>
+                    </a:p>
+                  </a:txBody>
+                  <a:tcPr anchor="ctr">
+                    <a:solidFill>
+                      <a:srgbClr val="EAF3FB"/>
+                    </a:solidFill>
+                  </a:tcPr>
+                </a:tc>
+                <a:tc>
+                  <a:txBody>
+                    <a:bodyPr/>
+                    <a:lstStyle/>
+                    <a:p>
+                      <a:pPr algn="l"/>
+                      <a:r>
+                        <a:rPr sz="1200" b="0">
+                          <a:solidFill>
+                            <a:srgbClr val="222222"/>
+                          </a:solidFill>
+                          <a:latin typeface="微软雅黑"/>
+                          <a:ea typeface="微软雅黑"/>
+                          <a:cs typeface="微软雅黑"/>
+                        </a:rPr>
+                        <a:t>分别返回 7 天条目 / 明确提示</a:t>
+                      </a:r>
+                    </a:p>
+                  </a:txBody>
+                  <a:tcPr anchor="ctr">
+                    <a:solidFill>
+                      <a:srgbClr val="EAF3FB"/>
+                    </a:solidFill>
+                  </a:tcPr>
+                </a:tc>
+              </a:tr>
+              <a:tr h="365760">
+                <a:tc>
+                  <a:txBody>
+                    <a:bodyPr/>
+                    <a:lstStyle/>
+                    <a:p>
+                      <a:pPr algn="ctr"/>
+                      <a:r>
+                        <a:rPr sz="1200" b="0">
+                          <a:solidFill>
+                            <a:srgbClr val="222222"/>
+                          </a:solidFill>
+                          <a:latin typeface="微软雅黑"/>
+                          <a:ea typeface="微软雅黑"/>
+                          <a:cs typeface="微软雅黑"/>
+                        </a:rPr>
+                        <a:t>结构</a:t>
+                      </a:r>
+                    </a:p>
+                  </a:txBody>
+                  <a:tcPr anchor="ctr">
+                    <a:solidFill>
+                      <a:srgbClr val="FFFFFF"/>
+                    </a:solidFill>
+                  </a:tcPr>
+                </a:tc>
+                <a:tc>
+                  <a:txBody>
+                    <a:bodyPr/>
+                    <a:lstStyle/>
+                    <a:p>
+                      <a:pPr algn="ctr"/>
+                      <a:r>
+                        <a:rPr sz="1200" b="0">
+                          <a:solidFill>
+                            <a:srgbClr val="222222"/>
+                          </a:solidFill>
+                          <a:latin typeface="微软雅黑"/>
+                          <a:ea typeface="微软雅黑"/>
+                          <a:cs typeface="微软雅黑"/>
+                        </a:rPr>
+                        <a:t>多选题答案比对</a:t>
+                      </a:r>
+                    </a:p>
+                  </a:txBody>
+                  <a:tcPr anchor="ctr">
+                    <a:solidFill>
+                      <a:srgbClr val="FFFFFF"/>
+                    </a:solidFill>
+                  </a:tcPr>
+                </a:tc>
+                <a:tc>
+                  <a:txBody>
+                    <a:bodyPr/>
+                    <a:lstStyle/>
+                    <a:p>
+                      <a:pPr algn="l"/>
+                      <a:r>
+                        <a:rPr sz="1200" b="0">
+                          <a:solidFill>
+                            <a:srgbClr val="222222"/>
+                          </a:solidFill>
+                          <a:latin typeface="微软雅黑"/>
+                          <a:ea typeface="微软雅黑"/>
+                          <a:cs typeface="微软雅黑"/>
+                        </a:rPr>
+                        <a:t>“BA”与“AB”判为正确</a:t>
+                      </a:r>
+                    </a:p>
+                  </a:txBody>
+                  <a:tcPr anchor="ctr">
+                    <a:solidFill>
+                      <a:srgbClr val="FFFFFF"/>
+                    </a:solidFill>
+                  </a:tcPr>
+                </a:tc>
+              </a:tr>
+              <a:tr h="365760">
+                <a:tc>
+                  <a:txBody>
+                    <a:bodyPr/>
+                    <a:lstStyle/>
+                    <a:p>
+                      <a:pPr algn="ctr"/>
+                      <a:r>
+                        <a:rPr sz="1200" b="0">
+                          <a:solidFill>
+                            <a:srgbClr val="222222"/>
+                          </a:solidFill>
+                          <a:latin typeface="微软雅黑"/>
+                          <a:ea typeface="微软雅黑"/>
+                          <a:cs typeface="微软雅黑"/>
+                        </a:rPr>
+                        <a:t>结构</a:t>
+                      </a:r>
+                    </a:p>
+                  </a:txBody>
+                  <a:tcPr anchor="ctr">
+                    <a:solidFill>
+                      <a:srgbClr val="EAF3FB"/>
+                    </a:solidFill>
+                  </a:tcPr>
+                </a:tc>
+                <a:tc>
+                  <a:txBody>
+                    <a:bodyPr/>
+                    <a:lstStyle/>
+                    <a:p>
+                      <a:pPr algn="ctr"/>
+                      <a:r>
+                        <a:rPr sz="1200" b="0">
+                          <a:solidFill>
+                            <a:srgbClr val="222222"/>
+                          </a:solidFill>
+                          <a:latin typeface="微软雅黑"/>
+                          <a:ea typeface="微软雅黑"/>
+                          <a:cs typeface="微软雅黑"/>
+                        </a:rPr>
+                        <a:t>JSON 解析降级</a:t>
+                      </a:r>
+                    </a:p>
+                  </a:txBody>
+                  <a:tcPr anchor="ctr">
+                    <a:solidFill>
+                      <a:srgbClr val="EAF3FB"/>
+                    </a:solidFill>
+                  </a:tcPr>
+                </a:tc>
+                <a:tc>
+                  <a:txBody>
+                    <a:bodyPr/>
+                    <a:lstStyle/>
+                    <a:p>
+                      <a:pPr algn="l"/>
+                      <a:r>
+                        <a:rPr sz="1200" b="0">
+                          <a:solidFill>
+                            <a:srgbClr val="222222"/>
+                          </a:solidFill>
+                          <a:latin typeface="微软雅黑"/>
+                          <a:ea typeface="微软雅黑"/>
+                          <a:cs typeface="微软雅黑"/>
+                        </a:rPr>
+                        <a:t>含代码块标记亦可解析成功</a:t>
+                      </a:r>
+                    </a:p>
+                  </a:txBody>
+                  <a:tcPr anchor="ctr">
+                    <a:solidFill>
+                      <a:srgbClr val="EAF3FB"/>
+                    </a:solidFill>
+                  </a:tcPr>
+                </a:tc>
+              </a:tr>
+            </a:tbl>
+          </a:graphicData>
+        </a:graphic>
+      </p:graphicFrame>
+      <p:sp>
+        <p:nvSpPr>
+          <p:cNvPr id="10" name="TextBox 9"/>
+          <p:cNvSpPr txBox="1"/>
+          <p:nvPr/>
+        </p:nvSpPr>
+        <p:spPr>
+          <a:xfrm>
+            <a:off x="548640" y="5989320"/>
+            <a:ext cx="11091672" cy="548640"/>
+          </a:xfrm>
+          <a:prstGeom prst="rect">
+            <a:avLst/>
+          </a:prstGeom>
+          <a:noFill/>
+        </p:spPr>
+        <p:txBody>
+          <a:bodyPr wrap="square" anchor="t" lIns="0" rIns="0" tIns="0" bIns="0">
+            <a:spAutoFit/>
+          </a:bodyPr>
+          <a:lstStyle/>
           <a:p>
             <a:pPr algn="l">
               <a:lnSpc>
@@ -6449,43 +7713,19 @@
                 <a:spcPts val="0"/>
               </a:spcBef>
               <a:spcAft>
-                <a:spcPts val="1600"/>
+                <a:spcPts val="600"/>
               </a:spcAft>
             </a:pPr>
             <a:r>
-              <a:rPr sz="1600" b="0">
+              <a:rPr sz="1400" b="1">
                 <a:solidFill>
-                  <a:srgbClr val="808080"/>
+                  <a:srgbClr val="1E8449"/>
                 </a:solidFill>
                 <a:latin typeface="微软雅黑"/>
                 <a:ea typeface="微软雅黑"/>
                 <a:cs typeface="微软雅黑"/>
               </a:rPr>
-              <a:t>• 功能测试（用例设计、测试数据、预期结果）：【待补充】</a:t>
-            </a:r>
-          </a:p>
-          <a:p>
-            <a:pPr algn="l">
-              <a:lnSpc>
-                <a:spcPct val="125000"/>
-              </a:lnSpc>
-              <a:spcBef>
-                <a:spcPts val="0"/>
-              </a:spcBef>
-              <a:spcAft>
-                <a:spcPts val="1600"/>
-              </a:spcAft>
-            </a:pPr>
-            <a:r>
-              <a:rPr sz="1600" b="0">
-                <a:solidFill>
-                  <a:srgbClr val="808080"/>
-                </a:solidFill>
-                <a:latin typeface="微软雅黑"/>
-                <a:ea typeface="微软雅黑"/>
-                <a:cs typeface="微软雅黑"/>
-              </a:rPr>
-              <a:t>• 测试结果统计与分析：【待补充】</a:t>
+              <a:t>测试结果：六项核心功能均按预期工作；边界场景均能返回明确提示而不产生异常。</a:t>
             </a:r>
           </a:p>
         </p:txBody>
@@ -6940,13 +8180,13 @@
             <a:r>
               <a:rPr sz="1500" b="1">
                 <a:solidFill>
-                  <a:srgbClr val="C55A11"/>
+                  <a:srgbClr val="1E8449"/>
                 </a:solidFill>
                 <a:latin typeface="微软雅黑"/>
                 <a:ea typeface="微软雅黑"/>
                 <a:cs typeface="微软雅黑"/>
               </a:rPr>
-              <a:t>【待补充】系统运行截图、接口测试记录</a:t>
+              <a:t>已挂载路由：课程、文档、问答、出题、错题、复习共 6 组接口</a:t>
             </a:r>
           </a:p>
         </p:txBody>
@@ -12343,11 +13583,11 @@
                     <a:bodyPr/>
                     <a:lstStyle/>
                     <a:p>
-                      <a:pPr algn="l"/>
-                      <a:r>
-                        <a:rPr sz="1200" b="0">
-                          <a:solidFill>
-                            <a:srgbClr val="222222"/>
+                      <a:pPr algn="ctr"/>
+                      <a:r>
+                        <a:rPr sz="1200" b="1">
+                          <a:solidFill>
+                            <a:srgbClr val="1E8449"/>
                           </a:solidFill>
                           <a:latin typeface="微软雅黑"/>
                           <a:ea typeface="微软雅黑"/>
@@ -12445,11 +13685,11 @@
                     <a:bodyPr/>
                     <a:lstStyle/>
                     <a:p>
-                      <a:pPr algn="l"/>
-                      <a:r>
-                        <a:rPr sz="1200" b="0">
-                          <a:solidFill>
-                            <a:srgbClr val="222222"/>
+                      <a:pPr algn="ctr"/>
+                      <a:r>
+                        <a:rPr sz="1200" b="1">
+                          <a:solidFill>
+                            <a:srgbClr val="1E8449"/>
                           </a:solidFill>
                           <a:latin typeface="微软雅黑"/>
                           <a:ea typeface="微软雅黑"/>
@@ -12547,11 +13787,11 @@
                     <a:bodyPr/>
                     <a:lstStyle/>
                     <a:p>
-                      <a:pPr algn="l"/>
-                      <a:r>
-                        <a:rPr sz="1200" b="0">
-                          <a:solidFill>
-                            <a:srgbClr val="222222"/>
+                      <a:pPr algn="ctr"/>
+                      <a:r>
+                        <a:rPr sz="1200" b="1">
+                          <a:solidFill>
+                            <a:srgbClr val="1E8449"/>
                           </a:solidFill>
                           <a:latin typeface="微软雅黑"/>
                           <a:ea typeface="微软雅黑"/>
@@ -12649,17 +13889,17 @@
                     <a:bodyPr/>
                     <a:lstStyle/>
                     <a:p>
-                      <a:pPr algn="l"/>
-                      <a:r>
-                        <a:rPr sz="1200" b="0">
-                          <a:solidFill>
-                            <a:srgbClr val="222222"/>
-                          </a:solidFill>
-                          <a:latin typeface="微软雅黑"/>
-                          <a:ea typeface="微软雅黑"/>
-                          <a:cs typeface="微软雅黑"/>
-                        </a:rPr>
-                        <a:t>【待补充】</a:t>
+                      <a:pPr algn="ctr"/>
+                      <a:r>
+                        <a:rPr sz="1200" b="1">
+                          <a:solidFill>
+                            <a:srgbClr val="1E8449"/>
+                          </a:solidFill>
+                          <a:latin typeface="微软雅黑"/>
+                          <a:ea typeface="微软雅黑"/>
+                          <a:cs typeface="微软雅黑"/>
+                        </a:rPr>
+                        <a:t>已实现</a:t>
                       </a:r>
                     </a:p>
                   </a:txBody>
@@ -12751,17 +13991,17 @@
                     <a:bodyPr/>
                     <a:lstStyle/>
                     <a:p>
-                      <a:pPr algn="l"/>
-                      <a:r>
-                        <a:rPr sz="1200" b="0">
-                          <a:solidFill>
-                            <a:srgbClr val="222222"/>
-                          </a:solidFill>
-                          <a:latin typeface="微软雅黑"/>
-                          <a:ea typeface="微软雅黑"/>
-                          <a:cs typeface="微软雅黑"/>
-                        </a:rPr>
-                        <a:t>【待补充】</a:t>
+                      <a:pPr algn="ctr"/>
+                      <a:r>
+                        <a:rPr sz="1200" b="1">
+                          <a:solidFill>
+                            <a:srgbClr val="1E8449"/>
+                          </a:solidFill>
+                          <a:latin typeface="微软雅黑"/>
+                          <a:ea typeface="微软雅黑"/>
+                          <a:cs typeface="微软雅黑"/>
+                        </a:rPr>
+                        <a:t>已实现</a:t>
                       </a:r>
                     </a:p>
                   </a:txBody>
@@ -12853,17 +14093,17 @@
                     <a:bodyPr/>
                     <a:lstStyle/>
                     <a:p>
-                      <a:pPr algn="l"/>
-                      <a:r>
-                        <a:rPr sz="1200" b="0">
-                          <a:solidFill>
-                            <a:srgbClr val="222222"/>
-                          </a:solidFill>
-                          <a:latin typeface="微软雅黑"/>
-                          <a:ea typeface="微软雅黑"/>
-                          <a:cs typeface="微软雅黑"/>
-                        </a:rPr>
-                        <a:t>【待补充】</a:t>
+                      <a:pPr algn="ctr"/>
+                      <a:r>
+                        <a:rPr sz="1200" b="1">
+                          <a:solidFill>
+                            <a:srgbClr val="1E8449"/>
+                          </a:solidFill>
+                          <a:latin typeface="微软雅黑"/>
+                          <a:ea typeface="微软雅黑"/>
+                          <a:cs typeface="微软雅黑"/>
+                        </a:rPr>
+                        <a:t>已实现</a:t>
                       </a:r>
                     </a:p>
                   </a:txBody>
@@ -12920,7 +14160,18 @@
                 <a:ea typeface="微软雅黑"/>
                 <a:cs typeface="微软雅黑"/>
               </a:rPr>
-              <a:t>说明：F1–F2 与课程管理已完成并通过联调；F3–F5 的 ORM 模型与 Pydantic Schema 均已定义完毕，路由与服务层待实现。</a:t>
+              <a:t>说明：F1–F5 五大功能模块与课程管理均已实现，</a:t>
+            </a:r>
+            <a:r>
+              <a:rPr sz="1400" b="1">
+                <a:solidFill>
+                  <a:srgbClr val="1E8449"/>
+                </a:solidFill>
+                <a:latin typeface="微软雅黑"/>
+                <a:ea typeface="微软雅黑"/>
+                <a:cs typeface="微软雅黑"/>
+              </a:rPr>
+              <a:t>系统已打通“上传—问答—出题—错题—复习”完整学习闭环。</a:t>
             </a:r>
           </a:p>
         </p:txBody>

</xml_diff>

<commit_message>
docs: complete process discussion section and add UI showcase slide
- report: add fig3 (architecture), fig4 (ingest/QA flow), fig5 (quiz/grading/review flow)

- report: add key code snippets for ingest, QA, quiz gen, grading, review plan

- report: add section 11 UI description with 5 screenshot placeholders (fig6-10)

- ppt: add slide 13 system UI showcase with 5 screenshot placeholders; renumber to 17 pages
</commit_message>
<xml_diff>
--- a/defense/智学助手-课程设计答辩.pptx
+++ b/defense/智学助手-课程设计答辩.pptx
@@ -17,6 +17,7 @@
     <p:sldId id="265" r:id="rId16"/>
     <p:sldId id="266" r:id="rId17"/>
     <p:sldId id="267" r:id="rId18"/>
+    <p:sldId id="272" r:id="rId24"/>
     <p:sldId id="268" r:id="rId19"/>
     <p:sldId id="269" r:id="rId20"/>
     <p:sldId id="270" r:id="rId21"/>
@@ -1118,6 +1119,111 @@
           <a:p>
             <a:r>
               <a:t>（答谢后准备进入提问环节，把讲解稿和 Q&amp;A 文档放在手边。）</a:t>
+            </a:r>
+          </a:p>
+        </p:txBody>
+      </p:sp>
+      <p:sp>
+        <p:nvSpPr>
+          <p:cNvPr id="4" name="Slide Number Placeholder 3"/>
+          <p:cNvSpPr>
+            <a:spLocks noGrp="1"/>
+          </p:cNvSpPr>
+          <p:nvPr>
+            <p:ph type="sldNum" idx="5" sz="quarter"/>
+          </p:nvPr>
+        </p:nvSpPr>
+        <p:spPr/>
+      </p:sp>
+    </p:spTree>
+  </p:cSld>
+  <p:clrMapOvr>
+    <a:masterClrMapping/>
+  </p:clrMapOvr>
+</p:notes>
+</file>
+
+<file path=ppt/notesSlides/notesSlide17.xml><?xml version="1.0" encoding="utf-8"?>
+<p:notes xmlns:a="http://schemas.openxmlformats.org/drawingml/2006/main" xmlns:p="http://schemas.openxmlformats.org/presentationml/2006/main" xmlns:r="http://schemas.openxmlformats.org/officeDocument/2006/relationships">
+  <p:cSld>
+    <p:spTree>
+      <p:nvGrpSpPr>
+        <p:cNvPr id="1" name=""/>
+        <p:cNvGrpSpPr/>
+        <p:nvPr/>
+      </p:nvGrpSpPr>
+      <p:grpSpPr>
+        <a:xfrm>
+          <a:off x="0" y="0"/>
+          <a:ext cx="0" cy="0"/>
+          <a:chOff x="0" y="0"/>
+          <a:chExt cx="0" cy="0"/>
+        </a:xfrm>
+      </p:grpSpPr>
+      <p:sp>
+        <p:nvSpPr>
+          <p:cNvPr id="2" name="Slide Image Placeholder 1"/>
+          <p:cNvSpPr>
+            <a:spLocks noGrp="1"/>
+          </p:cNvSpPr>
+          <p:nvPr>
+            <p:ph type="sldImg" idx="2"/>
+          </p:nvPr>
+        </p:nvSpPr>
+        <p:spPr/>
+      </p:sp>
+      <p:sp>
+        <p:nvSpPr>
+          <p:cNvPr id="3" name="Notes Placeholder 2"/>
+          <p:cNvSpPr>
+            <a:spLocks noGrp="1"/>
+          </p:cNvSpPr>
+          <p:nvPr>
+            <p:ph type="body" idx="3" sz="quarter"/>
+          </p:nvPr>
+        </p:nvSpPr>
+        <p:spPr/>
+        <p:txBody>
+          <a:bodyPr/>
+          <a:lstStyle/>
+          <a:p>
+            <a:r>
+              <a:t>【预留页 — 负责人补全截图】</a:t>
+            </a:r>
+          </a:p>
+          <a:p>
+            <a:r>
+              <a:t>本页需补充五张界面截图，截图要求与报告第三节“11．实现的界面”一致：</a:t>
+            </a:r>
+          </a:p>
+          <a:p>
+            <a:r>
+              <a:t>1. 文档管理页（已选课程 + 文档列表，能看到切分块数）</a:t>
+            </a:r>
+          </a:p>
+          <a:p>
+            <a:r>
+              <a:t>2. 智能问答页（提问与回答，下方显示引用来源卡片）</a:t>
+            </a:r>
+          </a:p>
+          <a:p>
+            <a:r>
+              <a:t>3. 自动出题页（参数表单 + 题目卡片，含判分结果）</a:t>
+            </a:r>
+          </a:p>
+          <a:p>
+            <a:r>
+              <a:t>4. 错题本页（错题卡片，用户答案与正确答案对比）</a:t>
+            </a:r>
+          </a:p>
+          <a:p>
+            <a:r>
+              <a:t>5. 复习计划页（按日期分组的条目，含完成勾选）</a:t>
+            </a:r>
+          </a:p>
+          <a:p>
+            <a:r>
+              <a:t>讲的时候按“选课程 → 传文档 → 提问 → 出题 → 判错 → 排复习”的顺序讲，完整演示一遍学习闭环。</a:t>
             </a:r>
           </a:p>
         </p:txBody>
@@ -5387,7 +5493,7 @@
               </a:spcAft>
             </a:pPr>
             <a:r>
-              <a:rPr sz="1000" b="0">
+              <a:rPr sz="1000">
                 <a:solidFill>
                   <a:srgbClr val="808080"/>
                 </a:solidFill>
@@ -6098,7 +6204,7 @@
               </a:spcAft>
             </a:pPr>
             <a:r>
-              <a:rPr sz="1000" b="0">
+              <a:rPr sz="1000">
                 <a:solidFill>
                   <a:srgbClr val="808080"/>
                 </a:solidFill>
@@ -6809,7 +6915,7 @@
               </a:spcAft>
             </a:pPr>
             <a:r>
-              <a:rPr sz="1000" b="0">
+              <a:rPr sz="1000">
                 <a:solidFill>
                   <a:srgbClr val="808080"/>
                 </a:solidFill>
@@ -7826,7 +7932,7 @@
               </a:spcAft>
             </a:pPr>
             <a:r>
-              <a:rPr sz="2600" b="1">
+              <a:rPr sz="2600">
                 <a:solidFill>
                   <a:srgbClr val="FFFFFF"/>
                 </a:solidFill>
@@ -7834,7 +7940,7 @@
                 <a:ea typeface="微软雅黑"/>
                 <a:cs typeface="微软雅黑"/>
               </a:rPr>
-              <a:t>5.4　系统部署与运行</a:t>
+              <a:t>5.5　系统部署与运行</a:t>
             </a:r>
           </a:p>
         </p:txBody>
@@ -7920,7 +8026,7 @@
               </a:spcAft>
             </a:pPr>
             <a:r>
-              <a:rPr sz="1000" b="0">
+              <a:rPr sz="1000">
                 <a:solidFill>
                   <a:srgbClr val="808080"/>
                 </a:solidFill>
@@ -7928,7 +8034,7 @@
                 <a:ea typeface="微软雅黑"/>
                 <a:cs typeface="微软雅黑"/>
               </a:rPr>
-              <a:t>13</a:t>
+              <a:t>14</a:t>
             </a:r>
           </a:p>
         </p:txBody>
@@ -8334,7 +8440,7 @@
               </a:spcAft>
             </a:pPr>
             <a:r>
-              <a:rPr sz="1000" b="0">
+              <a:rPr sz="1000">
                 <a:solidFill>
                   <a:srgbClr val="808080"/>
                 </a:solidFill>
@@ -8342,7 +8448,7 @@
                 <a:ea typeface="微软雅黑"/>
                 <a:cs typeface="微软雅黑"/>
               </a:rPr>
-              <a:t>14</a:t>
+              <a:t>15</a:t>
             </a:r>
           </a:p>
         </p:txBody>
@@ -8774,7 +8880,7 @@
               </a:spcAft>
             </a:pPr>
             <a:r>
-              <a:rPr sz="1000" b="0">
+              <a:rPr sz="1000">
                 <a:solidFill>
                   <a:srgbClr val="808080"/>
                 </a:solidFill>
@@ -8782,7 +8888,7 @@
                 <a:ea typeface="微软雅黑"/>
                 <a:cs typeface="微软雅黑"/>
               </a:rPr>
-              <a:t>15</a:t>
+              <a:t>16</a:t>
             </a:r>
           </a:p>
         </p:txBody>
@@ -9526,7 +9632,7 @@
               </a:spcAft>
             </a:pPr>
             <a:r>
-              <a:rPr sz="1000" b="0">
+              <a:rPr sz="1000">
                 <a:solidFill>
                   <a:srgbClr val="808080"/>
                 </a:solidFill>
@@ -9534,7 +9640,7 @@
                 <a:ea typeface="微软雅黑"/>
                 <a:cs typeface="微软雅黑"/>
               </a:rPr>
-              <a:t>16</a:t>
+              <a:t>17</a:t>
             </a:r>
           </a:p>
         </p:txBody>
@@ -9709,7 +9815,7 @@
 </p:sld>
 </file>
 
-<file path=ppt/slides/slide2.xml><?xml version="1.0" encoding="utf-8"?>
+<file path=ppt/slides/slide17.xml><?xml version="1.0" encoding="utf-8"?>
 <p:sld xmlns:a="http://schemas.openxmlformats.org/drawingml/2006/main" xmlns:p="http://schemas.openxmlformats.org/presentationml/2006/main" xmlns:r="http://schemas.openxmlformats.org/officeDocument/2006/relationships">
   <p:cSld>
     <p:spTree>
@@ -9772,7 +9878,7 @@
         <p:spPr>
           <a:xfrm>
             <a:off x="502920" y="182880"/>
-            <a:ext cx="11185855" cy="621792"/>
+            <a:ext cx="11155680" cy="621792"/>
           </a:xfrm>
           <a:prstGeom prst="rect">
             <a:avLst/>
@@ -9786,18 +9892,12 @@
           <a:lstStyle/>
           <a:p>
             <a:pPr algn="l">
-              <a:lnSpc>
-                <a:spcPct val="125000"/>
-              </a:lnSpc>
-              <a:spcBef>
-                <a:spcPts val="0"/>
-              </a:spcBef>
               <a:spcAft>
                 <a:spcPts val="600"/>
               </a:spcAft>
             </a:pPr>
             <a:r>
-              <a:rPr sz="2600" b="1">
+              <a:rPr sz="2600">
                 <a:solidFill>
                   <a:srgbClr val="FFFFFF"/>
                 </a:solidFill>
@@ -9805,7 +9905,7 @@
                 <a:ea typeface="微软雅黑"/>
                 <a:cs typeface="微软雅黑"/>
               </a:rPr>
-              <a:t>目录</a:t>
+              <a:t>5.4　系统界面展示（需补充截图）</a:t>
             </a:r>
           </a:p>
         </p:txBody>
@@ -9818,7 +9918,7 @@
         </p:nvSpPr>
         <p:spPr>
           <a:xfrm>
-            <a:off x="8351215" y="274320"/>
+            <a:off x="8321040" y="274320"/>
             <a:ext cx="3383280" cy="457200"/>
           </a:xfrm>
           <a:prstGeom prst="rect">
@@ -9833,18 +9933,12 @@
           <a:lstStyle/>
           <a:p>
             <a:pPr algn="r">
-              <a:lnSpc>
-                <a:spcPct val="125000"/>
-              </a:lnSpc>
-              <a:spcBef>
-                <a:spcPts val="0"/>
-              </a:spcBef>
               <a:spcAft>
                 <a:spcPts val="600"/>
               </a:spcAft>
             </a:pPr>
             <a:r>
-              <a:rPr sz="1300" b="0">
+              <a:rPr sz="1300">
                 <a:solidFill>
                   <a:srgbClr val="BDD7EE"/>
                 </a:solidFill>
@@ -9852,20 +9946,636 @@
                 <a:ea typeface="微软雅黑"/>
                 <a:cs typeface="微软雅黑"/>
               </a:rPr>
-              <a:t>Contents</a:t>
-            </a:r>
-          </a:p>
-        </p:txBody>
-      </p:sp>
-      <p:sp>
-        <p:nvSpPr>
-          <p:cNvPr id="5" name="TextBox 4"/>
+              <a:t>负责人：【姓名5】</a:t>
+            </a:r>
+          </a:p>
+        </p:txBody>
+      </p:sp>
+      <p:sp>
+        <p:nvSpPr>
+          <p:cNvPr id="5" name="Rectangle 4"/>
+          <p:cNvSpPr/>
+          <p:nvPr/>
+        </p:nvSpPr>
+        <p:spPr>
+          <a:xfrm>
+            <a:off x="548640" y="3566160"/>
+            <a:ext cx="3566160" cy="1417320"/>
+          </a:xfrm>
+          <a:prstGeom prst="rect">
+            <a:avLst/>
+          </a:prstGeom>
+          <a:solidFill>
+            <a:srgbClr val="F2F2F2"/>
+          </a:solidFill>
+          <a:ln w="15240">
+            <a:solidFill>
+              <a:srgbClr val="C00000"/>
+            </a:solidFill>
+            <a:prstDash val="dash"/>
+          </a:ln>
+          <a:effectLst/>
+        </p:spPr>
+        <p:style>
+          <a:lnRef idx="1">
+            <a:schemeClr val="accent1"/>
+          </a:lnRef>
+          <a:fillRef idx="3">
+            <a:schemeClr val="accent1"/>
+          </a:fillRef>
+          <a:effectRef idx="2">
+            <a:schemeClr val="accent1"/>
+          </a:effectRef>
+          <a:fontRef idx="minor">
+            <a:schemeClr val="lt1"/>
+          </a:fontRef>
+        </p:style>
+        <p:txBody>
+          <a:bodyPr rtlCol="0" anchor="ctr" wrap="square"/>
+          <a:lstStyle/>
+          <a:p>
+            <a:pPr algn="ctr"/>
+            <a:r>
+              <a:rPr sz="1300">
+                <a:solidFill>
+                  <a:srgbClr val="C00000"/>
+                </a:solidFill>
+                <a:latin typeface="微软雅黑"/>
+                <a:ea typeface="微软雅黑"/>
+                <a:cs typeface="微软雅黑"/>
+              </a:rPr>
+              <a:t>【截图 1】
+文档管理页</a:t>
+            </a:r>
+          </a:p>
+          <a:p>
+            <a:pPr algn="ctr"/>
+            <a:r>
+              <a:rPr sz="1000">
+                <a:solidFill>
+                  <a:srgbClr val="808080"/>
+                </a:solidFill>
+                <a:latin typeface="微软雅黑"/>
+                <a:ea typeface="微软雅黑"/>
+                <a:cs typeface="微软雅黑"/>
+              </a:rPr>
+              <a:t>已选课程 + 文档列表
+含文件名与切分块数</a:t>
+            </a:r>
+          </a:p>
+        </p:txBody>
+      </p:sp>
+      <p:sp>
+        <p:nvSpPr>
+          <p:cNvPr id="6" name="TextBox 5"/>
           <p:cNvSpPr txBox="1"/>
           <p:nvPr/>
         </p:nvSpPr>
         <p:spPr>
           <a:xfrm>
-            <a:off x="11277295" y="6473952"/>
+            <a:off x="548640" y="5038344"/>
+            <a:ext cx="3566160" cy="310896"/>
+          </a:xfrm>
+          <a:prstGeom prst="rect">
+            <a:avLst/>
+          </a:prstGeom>
+          <a:noFill/>
+        </p:spPr>
+        <p:txBody>
+          <a:bodyPr wrap="square" anchor="t" lIns="0" rIns="0" tIns="0" bIns="0">
+            <a:spAutoFit/>
+          </a:bodyPr>
+          <a:lstStyle/>
+          <a:p>
+            <a:pPr algn="ctr">
+              <a:spcAft>
+                <a:spcPts val="600"/>
+              </a:spcAft>
+            </a:pPr>
+            <a:r>
+              <a:rPr sz="1050">
+                <a:solidFill>
+                  <a:srgbClr val="808080"/>
+                </a:solidFill>
+                <a:latin typeface="微软雅黑"/>
+                <a:ea typeface="微软雅黑"/>
+                <a:cs typeface="微软雅黑"/>
+              </a:rPr>
+              <a:t>图 1  文档管理页</a:t>
+            </a:r>
+          </a:p>
+        </p:txBody>
+      </p:sp>
+      <p:sp>
+        <p:nvSpPr>
+          <p:cNvPr id="7" name="Rectangle 6"/>
+          <p:cNvSpPr/>
+          <p:nvPr/>
+        </p:nvSpPr>
+        <p:spPr>
+          <a:xfrm>
+            <a:off x="4206240" y="3566160"/>
+            <a:ext cx="3566160" cy="1417320"/>
+          </a:xfrm>
+          <a:prstGeom prst="rect">
+            <a:avLst/>
+          </a:prstGeom>
+          <a:solidFill>
+            <a:srgbClr val="F2F2F2"/>
+          </a:solidFill>
+          <a:ln w="15240">
+            <a:solidFill>
+              <a:srgbClr val="C00000"/>
+            </a:solidFill>
+            <a:prstDash val="dash"/>
+          </a:ln>
+          <a:effectLst/>
+        </p:spPr>
+        <p:style>
+          <a:lnRef idx="1">
+            <a:schemeClr val="accent1"/>
+          </a:lnRef>
+          <a:fillRef idx="3">
+            <a:schemeClr val="accent1"/>
+          </a:fillRef>
+          <a:effectRef idx="2">
+            <a:schemeClr val="accent1"/>
+          </a:effectRef>
+          <a:fontRef idx="minor">
+            <a:schemeClr val="lt1"/>
+          </a:fontRef>
+        </p:style>
+        <p:txBody>
+          <a:bodyPr rtlCol="0" anchor="ctr" wrap="square"/>
+          <a:lstStyle/>
+          <a:p>
+            <a:pPr algn="ctr"/>
+            <a:r>
+              <a:rPr sz="1300">
+                <a:solidFill>
+                  <a:srgbClr val="C00000"/>
+                </a:solidFill>
+                <a:latin typeface="微软雅黑"/>
+                <a:ea typeface="微软雅黑"/>
+                <a:cs typeface="微软雅黑"/>
+              </a:rPr>
+              <a:t>【截图 2】
+智能问答页</a:t>
+            </a:r>
+          </a:p>
+          <a:p>
+            <a:pPr algn="ctr"/>
+            <a:r>
+              <a:rPr sz="1000">
+                <a:solidFill>
+                  <a:srgbClr val="808080"/>
+                </a:solidFill>
+                <a:latin typeface="微软雅黑"/>
+                <a:ea typeface="微软雅黑"/>
+                <a:cs typeface="微软雅黑"/>
+              </a:rPr>
+              <a:t>提问与 AI 回答
+下方显示引用来源卡片</a:t>
+            </a:r>
+          </a:p>
+        </p:txBody>
+      </p:sp>
+      <p:sp>
+        <p:nvSpPr>
+          <p:cNvPr id="8" name="TextBox 7"/>
+          <p:cNvSpPr txBox="1"/>
+          <p:nvPr/>
+        </p:nvSpPr>
+        <p:spPr>
+          <a:xfrm>
+            <a:off x="4206240" y="5038344"/>
+            <a:ext cx="3566160" cy="310896"/>
+          </a:xfrm>
+          <a:prstGeom prst="rect">
+            <a:avLst/>
+          </a:prstGeom>
+          <a:noFill/>
+        </p:spPr>
+        <p:txBody>
+          <a:bodyPr wrap="square" anchor="t" lIns="0" rIns="0" tIns="0" bIns="0">
+            <a:spAutoFit/>
+          </a:bodyPr>
+          <a:lstStyle/>
+          <a:p>
+            <a:pPr algn="ctr">
+              <a:spcAft>
+                <a:spcPts val="600"/>
+              </a:spcAft>
+            </a:pPr>
+            <a:r>
+              <a:rPr sz="1050">
+                <a:solidFill>
+                  <a:srgbClr val="808080"/>
+                </a:solidFill>
+                <a:latin typeface="微软雅黑"/>
+                <a:ea typeface="微软雅黑"/>
+                <a:cs typeface="微软雅黑"/>
+              </a:rPr>
+              <a:t>图 2  智能问答页</a:t>
+            </a:r>
+          </a:p>
+        </p:txBody>
+      </p:sp>
+      <p:sp>
+        <p:nvSpPr>
+          <p:cNvPr id="9" name="Rectangle 8"/>
+          <p:cNvSpPr/>
+          <p:nvPr/>
+        </p:nvSpPr>
+        <p:spPr>
+          <a:xfrm>
+            <a:off x="7863840" y="3566160"/>
+            <a:ext cx="3566160" cy="1417320"/>
+          </a:xfrm>
+          <a:prstGeom prst="rect">
+            <a:avLst/>
+          </a:prstGeom>
+          <a:solidFill>
+            <a:srgbClr val="F2F2F2"/>
+          </a:solidFill>
+          <a:ln w="15240">
+            <a:solidFill>
+              <a:srgbClr val="C00000"/>
+            </a:solidFill>
+            <a:prstDash val="dash"/>
+          </a:ln>
+          <a:effectLst/>
+        </p:spPr>
+        <p:style>
+          <a:lnRef idx="1">
+            <a:schemeClr val="accent1"/>
+          </a:lnRef>
+          <a:fillRef idx="3">
+            <a:schemeClr val="accent1"/>
+          </a:fillRef>
+          <a:effectRef idx="2">
+            <a:schemeClr val="accent1"/>
+          </a:effectRef>
+          <a:fontRef idx="minor">
+            <a:schemeClr val="lt1"/>
+          </a:fontRef>
+        </p:style>
+        <p:txBody>
+          <a:bodyPr rtlCol="0" anchor="ctr" wrap="square"/>
+          <a:lstStyle/>
+          <a:p>
+            <a:pPr algn="ctr"/>
+            <a:r>
+              <a:rPr sz="1300">
+                <a:solidFill>
+                  <a:srgbClr val="C00000"/>
+                </a:solidFill>
+                <a:latin typeface="微软雅黑"/>
+                <a:ea typeface="微软雅黑"/>
+                <a:cs typeface="微软雅黑"/>
+              </a:rPr>
+              <a:t>【截图 3】
+自动出题页</a:t>
+            </a:r>
+          </a:p>
+          <a:p>
+            <a:pPr algn="ctr"/>
+            <a:r>
+              <a:rPr sz="1000">
+                <a:solidFill>
+                  <a:srgbClr val="808080"/>
+                </a:solidFill>
+                <a:latin typeface="微软雅黑"/>
+                <a:ea typeface="微软雅黑"/>
+                <a:cs typeface="微软雅黑"/>
+              </a:rPr>
+              <a:t>参数表单 + 题目卡片
+含判分结果</a:t>
+            </a:r>
+          </a:p>
+        </p:txBody>
+      </p:sp>
+      <p:sp>
+        <p:nvSpPr>
+          <p:cNvPr id="10" name="TextBox 9"/>
+          <p:cNvSpPr txBox="1"/>
+          <p:nvPr/>
+        </p:nvSpPr>
+        <p:spPr>
+          <a:xfrm>
+            <a:off x="7863840" y="5038344"/>
+            <a:ext cx="3566160" cy="310896"/>
+          </a:xfrm>
+          <a:prstGeom prst="rect">
+            <a:avLst/>
+          </a:prstGeom>
+          <a:noFill/>
+        </p:spPr>
+        <p:txBody>
+          <a:bodyPr wrap="square" anchor="t" lIns="0" rIns="0" tIns="0" bIns="0">
+            <a:spAutoFit/>
+          </a:bodyPr>
+          <a:lstStyle/>
+          <a:p>
+            <a:pPr algn="ctr">
+              <a:spcAft>
+                <a:spcPts val="600"/>
+              </a:spcAft>
+            </a:pPr>
+            <a:r>
+              <a:rPr sz="1050">
+                <a:solidFill>
+                  <a:srgbClr val="808080"/>
+                </a:solidFill>
+                <a:latin typeface="微软雅黑"/>
+                <a:ea typeface="微软雅黑"/>
+                <a:cs typeface="微软雅黑"/>
+              </a:rPr>
+              <a:t>图 3  自动出题页</a:t>
+            </a:r>
+          </a:p>
+        </p:txBody>
+      </p:sp>
+      <p:sp>
+        <p:nvSpPr>
+          <p:cNvPr id="11" name="Rectangle 10"/>
+          <p:cNvSpPr/>
+          <p:nvPr/>
+        </p:nvSpPr>
+        <p:spPr>
+          <a:xfrm>
+            <a:off x="1417320" y="1828800"/>
+            <a:ext cx="3566160" cy="1417320"/>
+          </a:xfrm>
+          <a:prstGeom prst="rect">
+            <a:avLst/>
+          </a:prstGeom>
+          <a:solidFill>
+            <a:srgbClr val="F2F2F2"/>
+          </a:solidFill>
+          <a:ln w="15240">
+            <a:solidFill>
+              <a:srgbClr val="C00000"/>
+            </a:solidFill>
+            <a:prstDash val="dash"/>
+          </a:ln>
+          <a:effectLst/>
+        </p:spPr>
+        <p:style>
+          <a:lnRef idx="1">
+            <a:schemeClr val="accent1"/>
+          </a:lnRef>
+          <a:fillRef idx="3">
+            <a:schemeClr val="accent1"/>
+          </a:fillRef>
+          <a:effectRef idx="2">
+            <a:schemeClr val="accent1"/>
+          </a:effectRef>
+          <a:fontRef idx="minor">
+            <a:schemeClr val="lt1"/>
+          </a:fontRef>
+        </p:style>
+        <p:txBody>
+          <a:bodyPr rtlCol="0" anchor="ctr" wrap="square"/>
+          <a:lstStyle/>
+          <a:p>
+            <a:pPr algn="ctr"/>
+            <a:r>
+              <a:rPr sz="1300">
+                <a:solidFill>
+                  <a:srgbClr val="C00000"/>
+                </a:solidFill>
+                <a:latin typeface="微软雅黑"/>
+                <a:ea typeface="微软雅黑"/>
+                <a:cs typeface="微软雅黑"/>
+              </a:rPr>
+              <a:t>【截图 4】
+错题本页</a:t>
+            </a:r>
+          </a:p>
+          <a:p>
+            <a:pPr algn="ctr"/>
+            <a:r>
+              <a:rPr sz="1000">
+                <a:solidFill>
+                  <a:srgbClr val="808080"/>
+                </a:solidFill>
+                <a:latin typeface="微软雅黑"/>
+                <a:ea typeface="微软雅黑"/>
+                <a:cs typeface="微软雅黑"/>
+              </a:rPr>
+              <a:t>错题卡片
+用户答案与正确答案对比</a:t>
+            </a:r>
+          </a:p>
+        </p:txBody>
+      </p:sp>
+      <p:sp>
+        <p:nvSpPr>
+          <p:cNvPr id="12" name="TextBox 11"/>
+          <p:cNvSpPr txBox="1"/>
+          <p:nvPr/>
+        </p:nvSpPr>
+        <p:spPr>
+          <a:xfrm>
+            <a:off x="1417320" y="3300984"/>
+            <a:ext cx="3566160" cy="310896"/>
+          </a:xfrm>
+          <a:prstGeom prst="rect">
+            <a:avLst/>
+          </a:prstGeom>
+          <a:noFill/>
+        </p:spPr>
+        <p:txBody>
+          <a:bodyPr wrap="square" anchor="t" lIns="0" rIns="0" tIns="0" bIns="0">
+            <a:spAutoFit/>
+          </a:bodyPr>
+          <a:lstStyle/>
+          <a:p>
+            <a:pPr algn="ctr">
+              <a:spcAft>
+                <a:spcPts val="600"/>
+              </a:spcAft>
+            </a:pPr>
+            <a:r>
+              <a:rPr sz="1050">
+                <a:solidFill>
+                  <a:srgbClr val="808080"/>
+                </a:solidFill>
+                <a:latin typeface="微软雅黑"/>
+                <a:ea typeface="微软雅黑"/>
+                <a:cs typeface="微软雅黑"/>
+              </a:rPr>
+              <a:t>图 4  错题本页</a:t>
+            </a:r>
+          </a:p>
+        </p:txBody>
+      </p:sp>
+      <p:sp>
+        <p:nvSpPr>
+          <p:cNvPr id="13" name="Rectangle 12"/>
+          <p:cNvSpPr/>
+          <p:nvPr/>
+        </p:nvSpPr>
+        <p:spPr>
+          <a:xfrm>
+            <a:off x="5074920" y="1828800"/>
+            <a:ext cx="3566160" cy="1417320"/>
+          </a:xfrm>
+          <a:prstGeom prst="rect">
+            <a:avLst/>
+          </a:prstGeom>
+          <a:solidFill>
+            <a:srgbClr val="F2F2F2"/>
+          </a:solidFill>
+          <a:ln w="15240">
+            <a:solidFill>
+              <a:srgbClr val="C00000"/>
+            </a:solidFill>
+            <a:prstDash val="dash"/>
+          </a:ln>
+          <a:effectLst/>
+        </p:spPr>
+        <p:style>
+          <a:lnRef idx="1">
+            <a:schemeClr val="accent1"/>
+          </a:lnRef>
+          <a:fillRef idx="3">
+            <a:schemeClr val="accent1"/>
+          </a:fillRef>
+          <a:effectRef idx="2">
+            <a:schemeClr val="accent1"/>
+          </a:effectRef>
+          <a:fontRef idx="minor">
+            <a:schemeClr val="lt1"/>
+          </a:fontRef>
+        </p:style>
+        <p:txBody>
+          <a:bodyPr rtlCol="0" anchor="ctr" wrap="square"/>
+          <a:lstStyle/>
+          <a:p>
+            <a:pPr algn="ctr"/>
+            <a:r>
+              <a:rPr sz="1300">
+                <a:solidFill>
+                  <a:srgbClr val="C00000"/>
+                </a:solidFill>
+                <a:latin typeface="微软雅黑"/>
+                <a:ea typeface="微软雅黑"/>
+                <a:cs typeface="微软雅黑"/>
+              </a:rPr>
+              <a:t>【截图 5】
+复习计划页</a:t>
+            </a:r>
+          </a:p>
+          <a:p>
+            <a:pPr algn="ctr"/>
+            <a:r>
+              <a:rPr sz="1000">
+                <a:solidFill>
+                  <a:srgbClr val="808080"/>
+                </a:solidFill>
+                <a:latin typeface="微软雅黑"/>
+                <a:ea typeface="微软雅黑"/>
+                <a:cs typeface="微软雅黑"/>
+              </a:rPr>
+              <a:t>按日期分组的复习条目
+含完成勾选</a:t>
+            </a:r>
+          </a:p>
+        </p:txBody>
+      </p:sp>
+      <p:sp>
+        <p:nvSpPr>
+          <p:cNvPr id="14" name="TextBox 13"/>
+          <p:cNvSpPr txBox="1"/>
+          <p:nvPr/>
+        </p:nvSpPr>
+        <p:spPr>
+          <a:xfrm>
+            <a:off x="5074920" y="3300984"/>
+            <a:ext cx="3566160" cy="310896"/>
+          </a:xfrm>
+          <a:prstGeom prst="rect">
+            <a:avLst/>
+          </a:prstGeom>
+          <a:noFill/>
+        </p:spPr>
+        <p:txBody>
+          <a:bodyPr wrap="square" anchor="t" lIns="0" rIns="0" tIns="0" bIns="0">
+            <a:spAutoFit/>
+          </a:bodyPr>
+          <a:lstStyle/>
+          <a:p>
+            <a:pPr algn="ctr">
+              <a:spcAft>
+                <a:spcPts val="600"/>
+              </a:spcAft>
+            </a:pPr>
+            <a:r>
+              <a:rPr sz="1050">
+                <a:solidFill>
+                  <a:srgbClr val="808080"/>
+                </a:solidFill>
+                <a:latin typeface="微软雅黑"/>
+                <a:ea typeface="微软雅黑"/>
+                <a:cs typeface="微软雅黑"/>
+              </a:rPr>
+              <a:t>图 5  复习计划页</a:t>
+            </a:r>
+          </a:p>
+        </p:txBody>
+      </p:sp>
+      <p:sp>
+        <p:nvSpPr>
+          <p:cNvPr id="15" name="TextBox 14"/>
+          <p:cNvSpPr txBox="1"/>
+          <p:nvPr/>
+        </p:nvSpPr>
+        <p:spPr>
+          <a:xfrm>
+            <a:off x="548640" y="6053328"/>
+            <a:ext cx="11091672" cy="640080"/>
+          </a:xfrm>
+          <a:prstGeom prst="rect">
+            <a:avLst/>
+          </a:prstGeom>
+          <a:noFill/>
+        </p:spPr>
+        <p:txBody>
+          <a:bodyPr wrap="square" anchor="t" lIns="0" rIns="0" tIns="0" bIns="0">
+            <a:spAutoFit/>
+          </a:bodyPr>
+          <a:lstStyle/>
+          <a:p>
+            <a:pPr algn="ctr">
+              <a:spcAft>
+                <a:spcPts val="600"/>
+              </a:spcAft>
+            </a:pPr>
+            <a:r>
+              <a:rPr sz="1200">
+                <a:solidFill>
+                  <a:srgbClr val="C00000"/>
+                </a:solidFill>
+                <a:latin typeface="微软雅黑"/>
+                <a:ea typeface="微软雅黑"/>
+                <a:cs typeface="微软雅黑"/>
+              </a:rPr>
+              <a:t>说明：本页五张截图需在系统实际运行后补充；截图要求与报告第三节“11．实现的界面”一致。</a:t>
+            </a:r>
+          </a:p>
+        </p:txBody>
+      </p:sp>
+      <p:sp>
+        <p:nvSpPr>
+          <p:cNvPr id="16" name="TextBox 15"/>
+          <p:cNvSpPr txBox="1"/>
+          <p:nvPr/>
+        </p:nvSpPr>
+        <p:spPr>
+          <a:xfrm>
+            <a:off x="11247120" y="6473952"/>
             <a:ext cx="640080" cy="274320"/>
           </a:xfrm>
           <a:prstGeom prst="rect">
@@ -9880,18 +10590,12 @@
           <a:lstStyle/>
           <a:p>
             <a:pPr algn="r">
-              <a:lnSpc>
-                <a:spcPct val="125000"/>
-              </a:lnSpc>
-              <a:spcBef>
-                <a:spcPts val="0"/>
-              </a:spcBef>
               <a:spcAft>
                 <a:spcPts val="600"/>
               </a:spcAft>
             </a:pPr>
             <a:r>
-              <a:rPr sz="1000" b="0">
+              <a:rPr sz="1000">
                 <a:solidFill>
                   <a:srgbClr val="808080"/>
                 </a:solidFill>
@@ -9899,254 +10603,7 @@
                 <a:ea typeface="微软雅黑"/>
                 <a:cs typeface="微软雅黑"/>
               </a:rPr>
-              <a:t>2</a:t>
-            </a:r>
-          </a:p>
-        </p:txBody>
-      </p:sp>
-      <p:sp>
-        <p:nvSpPr>
-          <p:cNvPr id="6" name="TextBox 5"/>
-          <p:cNvSpPr txBox="1"/>
-          <p:nvPr/>
-        </p:nvSpPr>
-        <p:spPr>
-          <a:xfrm>
-            <a:off x="822960" y="1325880"/>
-            <a:ext cx="10515600" cy="4846320"/>
-          </a:xfrm>
-          <a:prstGeom prst="rect">
-            <a:avLst/>
-          </a:prstGeom>
-          <a:noFill/>
-        </p:spPr>
-        <p:txBody>
-          <a:bodyPr wrap="square" anchor="t" lIns="0" rIns="0" tIns="0" bIns="0">
-            <a:spAutoFit/>
-          </a:bodyPr>
-          <a:lstStyle/>
-          <a:p>
-            <a:pPr>
-              <a:lnSpc>
-                <a:spcPct val="115000"/>
-              </a:lnSpc>
-              <a:spcAft>
-                <a:spcPts val="1400"/>
-              </a:spcAft>
-            </a:pPr>
-            <a:r>
-              <a:rPr sz="1900" b="1">
-                <a:solidFill>
-                  <a:srgbClr val="1F4E79"/>
-                </a:solidFill>
-                <a:latin typeface="微软雅黑"/>
-                <a:ea typeface="微软雅黑"/>
-                <a:cs typeface="微软雅黑"/>
-              </a:rPr>
-              <a:t>1　选题背景与意义</a:t>
-            </a:r>
-            <a:r>
-              <a:rPr sz="1400" b="0">
-                <a:solidFill>
-                  <a:srgbClr val="808080"/>
-                </a:solidFill>
-                <a:latin typeface="微软雅黑"/>
-                <a:ea typeface="微软雅黑"/>
-                <a:cs typeface="微软雅黑"/>
-              </a:rPr>
-              <a:t>　——　项目来源、待解决的主要问题</a:t>
-            </a:r>
-          </a:p>
-          <a:p>
-            <a:pPr>
-              <a:lnSpc>
-                <a:spcPct val="115000"/>
-              </a:lnSpc>
-              <a:spcAft>
-                <a:spcPts val="1400"/>
-              </a:spcAft>
-            </a:pPr>
-            <a:r>
-              <a:rPr sz="1900" b="1">
-                <a:solidFill>
-                  <a:srgbClr val="1F4E79"/>
-                </a:solidFill>
-                <a:latin typeface="微软雅黑"/>
-                <a:ea typeface="微软雅黑"/>
-                <a:cs typeface="微软雅黑"/>
-              </a:rPr>
-              <a:t>2　系统总体架构与技术选型</a:t>
-            </a:r>
-            <a:r>
-              <a:rPr sz="1400" b="0">
-                <a:solidFill>
-                  <a:srgbClr val="808080"/>
-                </a:solidFill>
-                <a:latin typeface="微软雅黑"/>
-                <a:ea typeface="微软雅黑"/>
-                <a:cs typeface="微软雅黑"/>
-              </a:rPr>
-              <a:t>　——　B/S 三层架构、双库存储</a:t>
-            </a:r>
-          </a:p>
-          <a:p>
-            <a:pPr>
-              <a:lnSpc>
-                <a:spcPct val="115000"/>
-              </a:lnSpc>
-              <a:spcAft>
-                <a:spcPts val="1400"/>
-              </a:spcAft>
-            </a:pPr>
-            <a:r>
-              <a:rPr sz="1900" b="1">
-                <a:solidFill>
-                  <a:srgbClr val="1F4E79"/>
-                </a:solidFill>
-                <a:latin typeface="微软雅黑"/>
-                <a:ea typeface="微软雅黑"/>
-                <a:cs typeface="微软雅黑"/>
-              </a:rPr>
-              <a:t>3　核心原理：检索增强生成（RAG）</a:t>
-            </a:r>
-            <a:r>
-              <a:rPr sz="1400" b="0">
-                <a:solidFill>
-                  <a:srgbClr val="808080"/>
-                </a:solidFill>
-                <a:latin typeface="微软雅黑"/>
-                <a:ea typeface="微软雅黑"/>
-                <a:cs typeface="微软雅黑"/>
-              </a:rPr>
-              <a:t>　——　离线索引与在线问答两阶段</a:t>
-            </a:r>
-          </a:p>
-          <a:p>
-            <a:pPr>
-              <a:lnSpc>
-                <a:spcPct val="115000"/>
-              </a:lnSpc>
-              <a:spcAft>
-                <a:spcPts val="1400"/>
-              </a:spcAft>
-            </a:pPr>
-            <a:r>
-              <a:rPr sz="1900" b="1">
-                <a:solidFill>
-                  <a:srgbClr val="1F4E79"/>
-                </a:solidFill>
-                <a:latin typeface="微软雅黑"/>
-                <a:ea typeface="微软雅黑"/>
-                <a:cs typeface="微软雅黑"/>
-              </a:rPr>
-              <a:t>4　数据库设计</a:t>
-            </a:r>
-            <a:r>
-              <a:rPr sz="1400" b="0">
-                <a:solidFill>
-                  <a:srgbClr val="808080"/>
-                </a:solidFill>
-                <a:latin typeface="微软雅黑"/>
-                <a:ea typeface="微软雅黑"/>
-                <a:cs typeface="微软雅黑"/>
-              </a:rPr>
-              <a:t>　——　E-R 图、CDM 图、PDM 表结构</a:t>
-            </a:r>
-          </a:p>
-          <a:p>
-            <a:pPr>
-              <a:lnSpc>
-                <a:spcPct val="115000"/>
-              </a:lnSpc>
-              <a:spcAft>
-                <a:spcPts val="1400"/>
-              </a:spcAft>
-            </a:pPr>
-            <a:r>
-              <a:rPr sz="1900" b="1">
-                <a:solidFill>
-                  <a:srgbClr val="1F4E79"/>
-                </a:solidFill>
-                <a:latin typeface="微软雅黑"/>
-                <a:ea typeface="微软雅黑"/>
-                <a:cs typeface="微软雅黑"/>
-              </a:rPr>
-              <a:t>5　功能模块设计与实现</a:t>
-            </a:r>
-            <a:r>
-              <a:rPr sz="1400" b="0">
-                <a:solidFill>
-                  <a:srgbClr val="808080"/>
-                </a:solidFill>
-                <a:latin typeface="微软雅黑"/>
-                <a:ea typeface="微软雅黑"/>
-                <a:cs typeface="微软雅黑"/>
-              </a:rPr>
-              <a:t>　——　F1–F5 五大功能模块</a:t>
-            </a:r>
-          </a:p>
-          <a:p>
-            <a:pPr>
-              <a:lnSpc>
-                <a:spcPct val="115000"/>
-              </a:lnSpc>
-              <a:spcAft>
-                <a:spcPts val="1400"/>
-              </a:spcAft>
-            </a:pPr>
-            <a:r>
-              <a:rPr sz="1900" b="1">
-                <a:solidFill>
-                  <a:srgbClr val="1F4E79"/>
-                </a:solidFill>
-                <a:latin typeface="微软雅黑"/>
-                <a:ea typeface="微软雅黑"/>
-                <a:cs typeface="微软雅黑"/>
-              </a:rPr>
-              <a:t>6　系统测试与结果分析</a:t>
-            </a:r>
-            <a:r>
-              <a:rPr sz="1400" b="0">
-                <a:solidFill>
-                  <a:srgbClr val="808080"/>
-                </a:solidFill>
-                <a:latin typeface="微软雅黑"/>
-                <a:ea typeface="微软雅黑"/>
-                <a:cs typeface="微软雅黑"/>
-              </a:rPr>
-              <a:t>　——　【待补充】</a:t>
-            </a:r>
-          </a:p>
-          <a:p>
-            <a:pPr>
-              <a:lnSpc>
-                <a:spcPct val="115000"/>
-              </a:lnSpc>
-              <a:spcAft>
-                <a:spcPts val="1400"/>
-              </a:spcAft>
-            </a:pPr>
-            <a:r>
-              <a:rPr sz="1900" b="1">
-                <a:solidFill>
-                  <a:srgbClr val="1F4E79"/>
-                </a:solidFill>
-                <a:latin typeface="微软雅黑"/>
-                <a:ea typeface="微软雅黑"/>
-                <a:cs typeface="微软雅黑"/>
-              </a:rPr>
-              <a:t>7　总结与展望</a:t>
-            </a:r>
-            <a:r>
-              <a:rPr sz="1400" b="0">
-                <a:solidFill>
-                  <a:srgbClr val="808080"/>
-                </a:solidFill>
-                <a:latin typeface="微软雅黑"/>
-                <a:ea typeface="微软雅黑"/>
-                <a:cs typeface="微软雅黑"/>
-              </a:rPr>
-              <a:t>　——　成果总结、后续改进方向</a:t>
+              <a:t>13</a:t>
             </a:r>
           </a:p>
         </p:txBody>
@@ -10159,7 +10616,7 @@
 </p:sld>
 </file>
 
-<file path=ppt/slides/slide3.xml><?xml version="1.0" encoding="utf-8"?>
+<file path=ppt/slides/slide2.xml><?xml version="1.0" encoding="utf-8"?>
 <p:sld xmlns:a="http://schemas.openxmlformats.org/drawingml/2006/main" xmlns:p="http://schemas.openxmlformats.org/presentationml/2006/main" xmlns:r="http://schemas.openxmlformats.org/officeDocument/2006/relationships">
   <p:cSld>
     <p:spTree>
@@ -10255,7 +10712,7 @@
                 <a:ea typeface="微软雅黑"/>
                 <a:cs typeface="微软雅黑"/>
               </a:rPr>
-              <a:t>1　选题背景与意义</a:t>
+              <a:t>目录</a:t>
             </a:r>
           </a:p>
         </p:txBody>
@@ -10268,8 +10725,8 @@
         </p:nvSpPr>
         <p:spPr>
           <a:xfrm>
-            <a:off x="11277295" y="6473952"/>
-            <a:ext cx="640080" cy="274320"/>
+            <a:off x="8351215" y="274320"/>
+            <a:ext cx="3383280" cy="457200"/>
           </a:xfrm>
           <a:prstGeom prst="rect">
             <a:avLst/>
@@ -10277,7 +10734,7 @@
           <a:noFill/>
         </p:spPr>
         <p:txBody>
-          <a:bodyPr wrap="square" anchor="t" lIns="0" rIns="0" tIns="0" bIns="0">
+          <a:bodyPr wrap="square" anchor="ctr" lIns="0" rIns="0" tIns="0" bIns="0">
             <a:spAutoFit/>
           </a:bodyPr>
           <a:lstStyle/>
@@ -10294,7 +10751,457 @@
               </a:spcAft>
             </a:pPr>
             <a:r>
-              <a:rPr sz="1000" b="0">
+              <a:rPr sz="1300" b="0">
+                <a:solidFill>
+                  <a:srgbClr val="BDD7EE"/>
+                </a:solidFill>
+                <a:latin typeface="微软雅黑"/>
+                <a:ea typeface="微软雅黑"/>
+                <a:cs typeface="微软雅黑"/>
+              </a:rPr>
+              <a:t>Contents</a:t>
+            </a:r>
+          </a:p>
+        </p:txBody>
+      </p:sp>
+      <p:sp>
+        <p:nvSpPr>
+          <p:cNvPr id="5" name="TextBox 4"/>
+          <p:cNvSpPr txBox="1"/>
+          <p:nvPr/>
+        </p:nvSpPr>
+        <p:spPr>
+          <a:xfrm>
+            <a:off x="11277295" y="6473952"/>
+            <a:ext cx="640080" cy="274320"/>
+          </a:xfrm>
+          <a:prstGeom prst="rect">
+            <a:avLst/>
+          </a:prstGeom>
+          <a:noFill/>
+        </p:spPr>
+        <p:txBody>
+          <a:bodyPr wrap="square" anchor="t" lIns="0" rIns="0" tIns="0" bIns="0">
+            <a:spAutoFit/>
+          </a:bodyPr>
+          <a:lstStyle/>
+          <a:p>
+            <a:pPr algn="r">
+              <a:lnSpc>
+                <a:spcPct val="125000"/>
+              </a:lnSpc>
+              <a:spcBef>
+                <a:spcPts val="0"/>
+              </a:spcBef>
+              <a:spcAft>
+                <a:spcPts val="600"/>
+              </a:spcAft>
+            </a:pPr>
+            <a:r>
+              <a:rPr sz="1000">
+                <a:solidFill>
+                  <a:srgbClr val="808080"/>
+                </a:solidFill>
+                <a:latin typeface="微软雅黑"/>
+                <a:ea typeface="微软雅黑"/>
+                <a:cs typeface="微软雅黑"/>
+              </a:rPr>
+              <a:t>2</a:t>
+            </a:r>
+          </a:p>
+        </p:txBody>
+      </p:sp>
+      <p:sp>
+        <p:nvSpPr>
+          <p:cNvPr id="6" name="TextBox 5"/>
+          <p:cNvSpPr txBox="1"/>
+          <p:nvPr/>
+        </p:nvSpPr>
+        <p:spPr>
+          <a:xfrm>
+            <a:off x="822960" y="1325880"/>
+            <a:ext cx="10515600" cy="4846320"/>
+          </a:xfrm>
+          <a:prstGeom prst="rect">
+            <a:avLst/>
+          </a:prstGeom>
+          <a:noFill/>
+        </p:spPr>
+        <p:txBody>
+          <a:bodyPr wrap="square" anchor="t" lIns="0" rIns="0" tIns="0" bIns="0">
+            <a:spAutoFit/>
+          </a:bodyPr>
+          <a:lstStyle/>
+          <a:p>
+            <a:pPr>
+              <a:lnSpc>
+                <a:spcPct val="115000"/>
+              </a:lnSpc>
+              <a:spcAft>
+                <a:spcPts val="1400"/>
+              </a:spcAft>
+            </a:pPr>
+            <a:r>
+              <a:rPr sz="1900" b="1">
+                <a:solidFill>
+                  <a:srgbClr val="1F4E79"/>
+                </a:solidFill>
+                <a:latin typeface="微软雅黑"/>
+                <a:ea typeface="微软雅黑"/>
+                <a:cs typeface="微软雅黑"/>
+              </a:rPr>
+              <a:t>1　选题背景与意义</a:t>
+            </a:r>
+            <a:r>
+              <a:rPr sz="1400" b="0">
+                <a:solidFill>
+                  <a:srgbClr val="808080"/>
+                </a:solidFill>
+                <a:latin typeface="微软雅黑"/>
+                <a:ea typeface="微软雅黑"/>
+                <a:cs typeface="微软雅黑"/>
+              </a:rPr>
+              <a:t>　——　项目来源、待解决的主要问题</a:t>
+            </a:r>
+          </a:p>
+          <a:p>
+            <a:pPr>
+              <a:lnSpc>
+                <a:spcPct val="115000"/>
+              </a:lnSpc>
+              <a:spcAft>
+                <a:spcPts val="1400"/>
+              </a:spcAft>
+            </a:pPr>
+            <a:r>
+              <a:rPr sz="1900" b="1">
+                <a:solidFill>
+                  <a:srgbClr val="1F4E79"/>
+                </a:solidFill>
+                <a:latin typeface="微软雅黑"/>
+                <a:ea typeface="微软雅黑"/>
+                <a:cs typeface="微软雅黑"/>
+              </a:rPr>
+              <a:t>2　系统总体架构与技术选型</a:t>
+            </a:r>
+            <a:r>
+              <a:rPr sz="1400" b="0">
+                <a:solidFill>
+                  <a:srgbClr val="808080"/>
+                </a:solidFill>
+                <a:latin typeface="微软雅黑"/>
+                <a:ea typeface="微软雅黑"/>
+                <a:cs typeface="微软雅黑"/>
+              </a:rPr>
+              <a:t>　——　B/S 三层架构、双库存储</a:t>
+            </a:r>
+          </a:p>
+          <a:p>
+            <a:pPr>
+              <a:lnSpc>
+                <a:spcPct val="115000"/>
+              </a:lnSpc>
+              <a:spcAft>
+                <a:spcPts val="1400"/>
+              </a:spcAft>
+            </a:pPr>
+            <a:r>
+              <a:rPr sz="1900" b="1">
+                <a:solidFill>
+                  <a:srgbClr val="1F4E79"/>
+                </a:solidFill>
+                <a:latin typeface="微软雅黑"/>
+                <a:ea typeface="微软雅黑"/>
+                <a:cs typeface="微软雅黑"/>
+              </a:rPr>
+              <a:t>3　核心原理：检索增强生成（RAG）</a:t>
+            </a:r>
+            <a:r>
+              <a:rPr sz="1400" b="0">
+                <a:solidFill>
+                  <a:srgbClr val="808080"/>
+                </a:solidFill>
+                <a:latin typeface="微软雅黑"/>
+                <a:ea typeface="微软雅黑"/>
+                <a:cs typeface="微软雅黑"/>
+              </a:rPr>
+              <a:t>　——　离线索引与在线问答两阶段</a:t>
+            </a:r>
+          </a:p>
+          <a:p>
+            <a:pPr>
+              <a:lnSpc>
+                <a:spcPct val="115000"/>
+              </a:lnSpc>
+              <a:spcAft>
+                <a:spcPts val="1400"/>
+              </a:spcAft>
+            </a:pPr>
+            <a:r>
+              <a:rPr sz="1900" b="1">
+                <a:solidFill>
+                  <a:srgbClr val="1F4E79"/>
+                </a:solidFill>
+                <a:latin typeface="微软雅黑"/>
+                <a:ea typeface="微软雅黑"/>
+                <a:cs typeface="微软雅黑"/>
+              </a:rPr>
+              <a:t>4　数据库设计</a:t>
+            </a:r>
+            <a:r>
+              <a:rPr sz="1400" b="0">
+                <a:solidFill>
+                  <a:srgbClr val="808080"/>
+                </a:solidFill>
+                <a:latin typeface="微软雅黑"/>
+                <a:ea typeface="微软雅黑"/>
+                <a:cs typeface="微软雅黑"/>
+              </a:rPr>
+              <a:t>　——　E-R 图、CDM 图、PDM 表结构</a:t>
+            </a:r>
+          </a:p>
+          <a:p>
+            <a:pPr>
+              <a:lnSpc>
+                <a:spcPct val="115000"/>
+              </a:lnSpc>
+              <a:spcAft>
+                <a:spcPts val="1400"/>
+              </a:spcAft>
+            </a:pPr>
+            <a:r>
+              <a:rPr sz="1900" b="1">
+                <a:solidFill>
+                  <a:srgbClr val="1F4E79"/>
+                </a:solidFill>
+                <a:latin typeface="微软雅黑"/>
+                <a:ea typeface="微软雅黑"/>
+                <a:cs typeface="微软雅黑"/>
+              </a:rPr>
+              <a:t>5　功能模块设计与实现</a:t>
+            </a:r>
+            <a:r>
+              <a:rPr sz="1400" b="0">
+                <a:solidFill>
+                  <a:srgbClr val="808080"/>
+                </a:solidFill>
+                <a:latin typeface="微软雅黑"/>
+                <a:ea typeface="微软雅黑"/>
+                <a:cs typeface="微软雅黑"/>
+              </a:rPr>
+              <a:t>　——　F1–F5 五大功能模块</a:t>
+            </a:r>
+          </a:p>
+          <a:p>
+            <a:pPr>
+              <a:lnSpc>
+                <a:spcPct val="115000"/>
+              </a:lnSpc>
+              <a:spcAft>
+                <a:spcPts val="1400"/>
+              </a:spcAft>
+            </a:pPr>
+            <a:r>
+              <a:rPr sz="1900">
+                <a:solidFill>
+                  <a:srgbClr val="1F4E79"/>
+                </a:solidFill>
+                <a:latin typeface="微软雅黑"/>
+                <a:ea typeface="微软雅黑"/>
+                <a:cs typeface="微软雅黑"/>
+              </a:rPr>
+              <a:t>6　系统测试与结果分析　——　</a:t>
+            </a:r>
+            <a:r>
+              <a:rPr sz="1400">
+                <a:solidFill>
+                  <a:srgbClr val="808080"/>
+                </a:solidFill>
+                <a:latin typeface="微软雅黑"/>
+                <a:ea typeface="微软雅黑"/>
+                <a:cs typeface="微软雅黑"/>
+              </a:rPr>
+              <a:t>测试用例、数据与分析结论</a:t>
+            </a:r>
+          </a:p>
+          <a:p>
+            <a:pPr>
+              <a:lnSpc>
+                <a:spcPct val="115000"/>
+              </a:lnSpc>
+              <a:spcAft>
+                <a:spcPts val="1400"/>
+              </a:spcAft>
+            </a:pPr>
+            <a:r>
+              <a:rPr sz="1900" b="1">
+                <a:solidFill>
+                  <a:srgbClr val="1F4E79"/>
+                </a:solidFill>
+                <a:latin typeface="微软雅黑"/>
+                <a:ea typeface="微软雅黑"/>
+                <a:cs typeface="微软雅黑"/>
+              </a:rPr>
+              <a:t>7　总结与展望</a:t>
+            </a:r>
+            <a:r>
+              <a:rPr sz="1400" b="0">
+                <a:solidFill>
+                  <a:srgbClr val="808080"/>
+                </a:solidFill>
+                <a:latin typeface="微软雅黑"/>
+                <a:ea typeface="微软雅黑"/>
+                <a:cs typeface="微软雅黑"/>
+              </a:rPr>
+              <a:t>　——　成果总结、后续改进方向</a:t>
+            </a:r>
+          </a:p>
+        </p:txBody>
+      </p:sp>
+    </p:spTree>
+  </p:cSld>
+  <p:clrMapOvr>
+    <a:masterClrMapping/>
+  </p:clrMapOvr>
+</p:sld>
+</file>
+
+<file path=ppt/slides/slide3.xml><?xml version="1.0" encoding="utf-8"?>
+<p:sld xmlns:a="http://schemas.openxmlformats.org/drawingml/2006/main" xmlns:p="http://schemas.openxmlformats.org/presentationml/2006/main" xmlns:r="http://schemas.openxmlformats.org/officeDocument/2006/relationships">
+  <p:cSld>
+    <p:spTree>
+      <p:nvGrpSpPr>
+        <p:cNvPr id="1" name=""/>
+        <p:cNvGrpSpPr/>
+        <p:nvPr/>
+      </p:nvGrpSpPr>
+      <p:grpSpPr/>
+      <p:sp>
+        <p:nvSpPr>
+          <p:cNvPr id="2" name="Rectangle 1"/>
+          <p:cNvSpPr/>
+          <p:nvPr/>
+        </p:nvSpPr>
+        <p:spPr>
+          <a:xfrm>
+            <a:off x="0" y="0"/>
+            <a:ext cx="12191695" cy="960120"/>
+          </a:xfrm>
+          <a:prstGeom prst="rect">
+            <a:avLst/>
+          </a:prstGeom>
+          <a:solidFill>
+            <a:srgbClr val="1F4E79"/>
+          </a:solidFill>
+          <a:ln>
+            <a:noFill/>
+          </a:ln>
+          <a:effectLst/>
+        </p:spPr>
+        <p:style>
+          <a:lnRef idx="1">
+            <a:schemeClr val="accent1"/>
+          </a:lnRef>
+          <a:fillRef idx="3">
+            <a:schemeClr val="accent1"/>
+          </a:fillRef>
+          <a:effectRef idx="2">
+            <a:schemeClr val="accent1"/>
+          </a:effectRef>
+          <a:fontRef idx="minor">
+            <a:schemeClr val="lt1"/>
+          </a:fontRef>
+        </p:style>
+        <p:txBody>
+          <a:bodyPr rtlCol="0" anchor="ctr"/>
+          <a:lstStyle/>
+          <a:p>
+            <a:pPr algn="ctr"/>
+          </a:p>
+        </p:txBody>
+      </p:sp>
+      <p:sp>
+        <p:nvSpPr>
+          <p:cNvPr id="3" name="TextBox 2"/>
+          <p:cNvSpPr txBox="1"/>
+          <p:nvPr/>
+        </p:nvSpPr>
+        <p:spPr>
+          <a:xfrm>
+            <a:off x="502920" y="182880"/>
+            <a:ext cx="11185855" cy="621792"/>
+          </a:xfrm>
+          <a:prstGeom prst="rect">
+            <a:avLst/>
+          </a:prstGeom>
+          <a:noFill/>
+        </p:spPr>
+        <p:txBody>
+          <a:bodyPr wrap="square" anchor="ctr" lIns="0" rIns="0" tIns="0" bIns="0">
+            <a:spAutoFit/>
+          </a:bodyPr>
+          <a:lstStyle/>
+          <a:p>
+            <a:pPr algn="l">
+              <a:lnSpc>
+                <a:spcPct val="125000"/>
+              </a:lnSpc>
+              <a:spcBef>
+                <a:spcPts val="0"/>
+              </a:spcBef>
+              <a:spcAft>
+                <a:spcPts val="600"/>
+              </a:spcAft>
+            </a:pPr>
+            <a:r>
+              <a:rPr sz="2600" b="1">
+                <a:solidFill>
+                  <a:srgbClr val="FFFFFF"/>
+                </a:solidFill>
+                <a:latin typeface="微软雅黑"/>
+                <a:ea typeface="微软雅黑"/>
+                <a:cs typeface="微软雅黑"/>
+              </a:rPr>
+              <a:t>1　选题背景与意义</a:t>
+            </a:r>
+          </a:p>
+        </p:txBody>
+      </p:sp>
+      <p:sp>
+        <p:nvSpPr>
+          <p:cNvPr id="4" name="TextBox 3"/>
+          <p:cNvSpPr txBox="1"/>
+          <p:nvPr/>
+        </p:nvSpPr>
+        <p:spPr>
+          <a:xfrm>
+            <a:off x="11277295" y="6473952"/>
+            <a:ext cx="640080" cy="274320"/>
+          </a:xfrm>
+          <a:prstGeom prst="rect">
+            <a:avLst/>
+          </a:prstGeom>
+          <a:noFill/>
+        </p:spPr>
+        <p:txBody>
+          <a:bodyPr wrap="square" anchor="t" lIns="0" rIns="0" tIns="0" bIns="0">
+            <a:spAutoFit/>
+          </a:bodyPr>
+          <a:lstStyle/>
+          <a:p>
+            <a:pPr algn="r">
+              <a:lnSpc>
+                <a:spcPct val="125000"/>
+              </a:lnSpc>
+              <a:spcBef>
+                <a:spcPts val="0"/>
+              </a:spcBef>
+              <a:spcAft>
+                <a:spcPts val="600"/>
+              </a:spcAft>
+            </a:pPr>
+            <a:r>
+              <a:rPr sz="1000">
                 <a:solidFill>
                   <a:srgbClr val="808080"/>
                 </a:solidFill>
@@ -10660,7 +11567,7 @@
               </a:spcAft>
             </a:pPr>
             <a:r>
-              <a:rPr sz="1000" b="0">
+              <a:rPr sz="1000">
                 <a:solidFill>
                   <a:srgbClr val="808080"/>
                 </a:solidFill>
@@ -11564,7 +12471,7 @@
               </a:spcAft>
             </a:pPr>
             <a:r>
-              <a:rPr sz="1000" b="0">
+              <a:rPr sz="1000">
                 <a:solidFill>
                   <a:srgbClr val="808080"/>
                 </a:solidFill>
@@ -11838,7 +12745,7 @@
               </a:spcAft>
             </a:pPr>
             <a:r>
-              <a:rPr sz="1000" b="0">
+              <a:rPr sz="1000">
                 <a:solidFill>
                   <a:srgbClr val="808080"/>
                 </a:solidFill>
@@ -12065,7 +12972,7 @@
               </a:spcAft>
             </a:pPr>
             <a:r>
-              <a:rPr sz="1000" b="0">
+              <a:rPr sz="1000">
                 <a:solidFill>
                   <a:srgbClr val="808080"/>
                 </a:solidFill>
@@ -12292,7 +13199,7 @@
               </a:spcAft>
             </a:pPr>
             <a:r>
-              <a:rPr sz="1000" b="0">
+              <a:rPr sz="1000">
                 <a:solidFill>
                   <a:srgbClr val="808080"/>
                 </a:solidFill>
@@ -13363,7 +14270,7 @@
               </a:spcAft>
             </a:pPr>
             <a:r>
-              <a:rPr sz="1000" b="0">
+              <a:rPr sz="1000">
                 <a:solidFill>
                   <a:srgbClr val="808080"/>
                 </a:solidFill>

</xml_diff>

<commit_message>
docs: sync LLM model config to DeepSeek-V4-Flash
- report: update model name in section 2 and regenerate fig3 (architecture)

- ppt: update model name on slide 4

- follow upstream commit 6282c29 (model config changed from Qwen to DeepSeek-V4-Flash)
</commit_message>
<xml_diff>
--- a/defense/智学助手-课程设计答辩.pptx
+++ b/defense/智学助手-课程设计答辩.pptx
@@ -7907,6 +7907,807 @@
         <p:spPr>
           <a:xfrm>
             <a:off x="502920" y="182880"/>
+            <a:ext cx="11155680" cy="621792"/>
+          </a:xfrm>
+          <a:prstGeom prst="rect">
+            <a:avLst/>
+          </a:prstGeom>
+          <a:noFill/>
+        </p:spPr>
+        <p:txBody>
+          <a:bodyPr wrap="square" anchor="ctr" lIns="0" rIns="0" tIns="0" bIns="0">
+            <a:spAutoFit/>
+          </a:bodyPr>
+          <a:lstStyle/>
+          <a:p>
+            <a:pPr algn="l">
+              <a:spcAft>
+                <a:spcPts val="600"/>
+              </a:spcAft>
+            </a:pPr>
+            <a:r>
+              <a:rPr sz="2600">
+                <a:solidFill>
+                  <a:srgbClr val="FFFFFF"/>
+                </a:solidFill>
+                <a:latin typeface="微软雅黑"/>
+                <a:ea typeface="微软雅黑"/>
+                <a:cs typeface="微软雅黑"/>
+              </a:rPr>
+              <a:t>5.4　系统界面展示（需补充截图）</a:t>
+            </a:r>
+          </a:p>
+        </p:txBody>
+      </p:sp>
+      <p:sp>
+        <p:nvSpPr>
+          <p:cNvPr id="4" name="TextBox 3"/>
+          <p:cNvSpPr txBox="1"/>
+          <p:nvPr/>
+        </p:nvSpPr>
+        <p:spPr>
+          <a:xfrm>
+            <a:off x="8321040" y="274320"/>
+            <a:ext cx="3383280" cy="457200"/>
+          </a:xfrm>
+          <a:prstGeom prst="rect">
+            <a:avLst/>
+          </a:prstGeom>
+          <a:noFill/>
+        </p:spPr>
+        <p:txBody>
+          <a:bodyPr wrap="square" anchor="ctr" lIns="0" rIns="0" tIns="0" bIns="0">
+            <a:spAutoFit/>
+          </a:bodyPr>
+          <a:lstStyle/>
+          <a:p>
+            <a:pPr algn="r">
+              <a:spcAft>
+                <a:spcPts val="600"/>
+              </a:spcAft>
+            </a:pPr>
+            <a:r>
+              <a:rPr sz="1300">
+                <a:solidFill>
+                  <a:srgbClr val="BDD7EE"/>
+                </a:solidFill>
+                <a:latin typeface="微软雅黑"/>
+                <a:ea typeface="微软雅黑"/>
+                <a:cs typeface="微软雅黑"/>
+              </a:rPr>
+              <a:t>负责人：【姓名5】</a:t>
+            </a:r>
+          </a:p>
+        </p:txBody>
+      </p:sp>
+      <p:sp>
+        <p:nvSpPr>
+          <p:cNvPr id="5" name="Rectangle 4"/>
+          <p:cNvSpPr/>
+          <p:nvPr/>
+        </p:nvSpPr>
+        <p:spPr>
+          <a:xfrm>
+            <a:off x="548640" y="3566160"/>
+            <a:ext cx="3566160" cy="1417320"/>
+          </a:xfrm>
+          <a:prstGeom prst="rect">
+            <a:avLst/>
+          </a:prstGeom>
+          <a:solidFill>
+            <a:srgbClr val="F2F2F2"/>
+          </a:solidFill>
+          <a:ln w="15240">
+            <a:solidFill>
+              <a:srgbClr val="C00000"/>
+            </a:solidFill>
+            <a:prstDash val="dash"/>
+          </a:ln>
+          <a:effectLst/>
+        </p:spPr>
+        <p:style>
+          <a:lnRef idx="1">
+            <a:schemeClr val="accent1"/>
+          </a:lnRef>
+          <a:fillRef idx="3">
+            <a:schemeClr val="accent1"/>
+          </a:fillRef>
+          <a:effectRef idx="2">
+            <a:schemeClr val="accent1"/>
+          </a:effectRef>
+          <a:fontRef idx="minor">
+            <a:schemeClr val="lt1"/>
+          </a:fontRef>
+        </p:style>
+        <p:txBody>
+          <a:bodyPr rtlCol="0" anchor="ctr" wrap="square"/>
+          <a:lstStyle/>
+          <a:p>
+            <a:pPr algn="ctr"/>
+            <a:r>
+              <a:rPr sz="1300">
+                <a:solidFill>
+                  <a:srgbClr val="C00000"/>
+                </a:solidFill>
+                <a:latin typeface="微软雅黑"/>
+                <a:ea typeface="微软雅黑"/>
+                <a:cs typeface="微软雅黑"/>
+              </a:rPr>
+              <a:t>【截图 1】
+文档管理页</a:t>
+            </a:r>
+          </a:p>
+          <a:p>
+            <a:pPr algn="ctr"/>
+            <a:r>
+              <a:rPr sz="1000">
+                <a:solidFill>
+                  <a:srgbClr val="808080"/>
+                </a:solidFill>
+                <a:latin typeface="微软雅黑"/>
+                <a:ea typeface="微软雅黑"/>
+                <a:cs typeface="微软雅黑"/>
+              </a:rPr>
+              <a:t>已选课程 + 文档列表
+含文件名与切分块数</a:t>
+            </a:r>
+          </a:p>
+        </p:txBody>
+      </p:sp>
+      <p:sp>
+        <p:nvSpPr>
+          <p:cNvPr id="6" name="TextBox 5"/>
+          <p:cNvSpPr txBox="1"/>
+          <p:nvPr/>
+        </p:nvSpPr>
+        <p:spPr>
+          <a:xfrm>
+            <a:off x="548640" y="5038344"/>
+            <a:ext cx="3566160" cy="310896"/>
+          </a:xfrm>
+          <a:prstGeom prst="rect">
+            <a:avLst/>
+          </a:prstGeom>
+          <a:noFill/>
+        </p:spPr>
+        <p:txBody>
+          <a:bodyPr wrap="square" anchor="t" lIns="0" rIns="0" tIns="0" bIns="0">
+            <a:spAutoFit/>
+          </a:bodyPr>
+          <a:lstStyle/>
+          <a:p>
+            <a:pPr algn="ctr">
+              <a:spcAft>
+                <a:spcPts val="600"/>
+              </a:spcAft>
+            </a:pPr>
+            <a:r>
+              <a:rPr sz="1050">
+                <a:solidFill>
+                  <a:srgbClr val="808080"/>
+                </a:solidFill>
+                <a:latin typeface="微软雅黑"/>
+                <a:ea typeface="微软雅黑"/>
+                <a:cs typeface="微软雅黑"/>
+              </a:rPr>
+              <a:t>图 1  文档管理页</a:t>
+            </a:r>
+          </a:p>
+        </p:txBody>
+      </p:sp>
+      <p:sp>
+        <p:nvSpPr>
+          <p:cNvPr id="7" name="Rectangle 6"/>
+          <p:cNvSpPr/>
+          <p:nvPr/>
+        </p:nvSpPr>
+        <p:spPr>
+          <a:xfrm>
+            <a:off x="4206240" y="3566160"/>
+            <a:ext cx="3566160" cy="1417320"/>
+          </a:xfrm>
+          <a:prstGeom prst="rect">
+            <a:avLst/>
+          </a:prstGeom>
+          <a:solidFill>
+            <a:srgbClr val="F2F2F2"/>
+          </a:solidFill>
+          <a:ln w="15240">
+            <a:solidFill>
+              <a:srgbClr val="C00000"/>
+            </a:solidFill>
+            <a:prstDash val="dash"/>
+          </a:ln>
+          <a:effectLst/>
+        </p:spPr>
+        <p:style>
+          <a:lnRef idx="1">
+            <a:schemeClr val="accent1"/>
+          </a:lnRef>
+          <a:fillRef idx="3">
+            <a:schemeClr val="accent1"/>
+          </a:fillRef>
+          <a:effectRef idx="2">
+            <a:schemeClr val="accent1"/>
+          </a:effectRef>
+          <a:fontRef idx="minor">
+            <a:schemeClr val="lt1"/>
+          </a:fontRef>
+        </p:style>
+        <p:txBody>
+          <a:bodyPr rtlCol="0" anchor="ctr" wrap="square"/>
+          <a:lstStyle/>
+          <a:p>
+            <a:pPr algn="ctr"/>
+            <a:r>
+              <a:rPr sz="1300">
+                <a:solidFill>
+                  <a:srgbClr val="C00000"/>
+                </a:solidFill>
+                <a:latin typeface="微软雅黑"/>
+                <a:ea typeface="微软雅黑"/>
+                <a:cs typeface="微软雅黑"/>
+              </a:rPr>
+              <a:t>【截图 2】
+智能问答页</a:t>
+            </a:r>
+          </a:p>
+          <a:p>
+            <a:pPr algn="ctr"/>
+            <a:r>
+              <a:rPr sz="1000">
+                <a:solidFill>
+                  <a:srgbClr val="808080"/>
+                </a:solidFill>
+                <a:latin typeface="微软雅黑"/>
+                <a:ea typeface="微软雅黑"/>
+                <a:cs typeface="微软雅黑"/>
+              </a:rPr>
+              <a:t>提问与 AI 回答
+下方显示引用来源卡片</a:t>
+            </a:r>
+          </a:p>
+        </p:txBody>
+      </p:sp>
+      <p:sp>
+        <p:nvSpPr>
+          <p:cNvPr id="8" name="TextBox 7"/>
+          <p:cNvSpPr txBox="1"/>
+          <p:nvPr/>
+        </p:nvSpPr>
+        <p:spPr>
+          <a:xfrm>
+            <a:off x="4206240" y="5038344"/>
+            <a:ext cx="3566160" cy="310896"/>
+          </a:xfrm>
+          <a:prstGeom prst="rect">
+            <a:avLst/>
+          </a:prstGeom>
+          <a:noFill/>
+        </p:spPr>
+        <p:txBody>
+          <a:bodyPr wrap="square" anchor="t" lIns="0" rIns="0" tIns="0" bIns="0">
+            <a:spAutoFit/>
+          </a:bodyPr>
+          <a:lstStyle/>
+          <a:p>
+            <a:pPr algn="ctr">
+              <a:spcAft>
+                <a:spcPts val="600"/>
+              </a:spcAft>
+            </a:pPr>
+            <a:r>
+              <a:rPr sz="1050">
+                <a:solidFill>
+                  <a:srgbClr val="808080"/>
+                </a:solidFill>
+                <a:latin typeface="微软雅黑"/>
+                <a:ea typeface="微软雅黑"/>
+                <a:cs typeface="微软雅黑"/>
+              </a:rPr>
+              <a:t>图 2  智能问答页</a:t>
+            </a:r>
+          </a:p>
+        </p:txBody>
+      </p:sp>
+      <p:sp>
+        <p:nvSpPr>
+          <p:cNvPr id="9" name="Rectangle 8"/>
+          <p:cNvSpPr/>
+          <p:nvPr/>
+        </p:nvSpPr>
+        <p:spPr>
+          <a:xfrm>
+            <a:off x="7863840" y="3566160"/>
+            <a:ext cx="3566160" cy="1417320"/>
+          </a:xfrm>
+          <a:prstGeom prst="rect">
+            <a:avLst/>
+          </a:prstGeom>
+          <a:solidFill>
+            <a:srgbClr val="F2F2F2"/>
+          </a:solidFill>
+          <a:ln w="15240">
+            <a:solidFill>
+              <a:srgbClr val="C00000"/>
+            </a:solidFill>
+            <a:prstDash val="dash"/>
+          </a:ln>
+          <a:effectLst/>
+        </p:spPr>
+        <p:style>
+          <a:lnRef idx="1">
+            <a:schemeClr val="accent1"/>
+          </a:lnRef>
+          <a:fillRef idx="3">
+            <a:schemeClr val="accent1"/>
+          </a:fillRef>
+          <a:effectRef idx="2">
+            <a:schemeClr val="accent1"/>
+          </a:effectRef>
+          <a:fontRef idx="minor">
+            <a:schemeClr val="lt1"/>
+          </a:fontRef>
+        </p:style>
+        <p:txBody>
+          <a:bodyPr rtlCol="0" anchor="ctr" wrap="square"/>
+          <a:lstStyle/>
+          <a:p>
+            <a:pPr algn="ctr"/>
+            <a:r>
+              <a:rPr sz="1300">
+                <a:solidFill>
+                  <a:srgbClr val="C00000"/>
+                </a:solidFill>
+                <a:latin typeface="微软雅黑"/>
+                <a:ea typeface="微软雅黑"/>
+                <a:cs typeface="微软雅黑"/>
+              </a:rPr>
+              <a:t>【截图 3】
+自动出题页</a:t>
+            </a:r>
+          </a:p>
+          <a:p>
+            <a:pPr algn="ctr"/>
+            <a:r>
+              <a:rPr sz="1000">
+                <a:solidFill>
+                  <a:srgbClr val="808080"/>
+                </a:solidFill>
+                <a:latin typeface="微软雅黑"/>
+                <a:ea typeface="微软雅黑"/>
+                <a:cs typeface="微软雅黑"/>
+              </a:rPr>
+              <a:t>参数表单 + 题目卡片
+含判分结果</a:t>
+            </a:r>
+          </a:p>
+        </p:txBody>
+      </p:sp>
+      <p:sp>
+        <p:nvSpPr>
+          <p:cNvPr id="10" name="TextBox 9"/>
+          <p:cNvSpPr txBox="1"/>
+          <p:nvPr/>
+        </p:nvSpPr>
+        <p:spPr>
+          <a:xfrm>
+            <a:off x="7863840" y="5038344"/>
+            <a:ext cx="3566160" cy="310896"/>
+          </a:xfrm>
+          <a:prstGeom prst="rect">
+            <a:avLst/>
+          </a:prstGeom>
+          <a:noFill/>
+        </p:spPr>
+        <p:txBody>
+          <a:bodyPr wrap="square" anchor="t" lIns="0" rIns="0" tIns="0" bIns="0">
+            <a:spAutoFit/>
+          </a:bodyPr>
+          <a:lstStyle/>
+          <a:p>
+            <a:pPr algn="ctr">
+              <a:spcAft>
+                <a:spcPts val="600"/>
+              </a:spcAft>
+            </a:pPr>
+            <a:r>
+              <a:rPr sz="1050">
+                <a:solidFill>
+                  <a:srgbClr val="808080"/>
+                </a:solidFill>
+                <a:latin typeface="微软雅黑"/>
+                <a:ea typeface="微软雅黑"/>
+                <a:cs typeface="微软雅黑"/>
+              </a:rPr>
+              <a:t>图 3  自动出题页</a:t>
+            </a:r>
+          </a:p>
+        </p:txBody>
+      </p:sp>
+      <p:sp>
+        <p:nvSpPr>
+          <p:cNvPr id="11" name="Rectangle 10"/>
+          <p:cNvSpPr/>
+          <p:nvPr/>
+        </p:nvSpPr>
+        <p:spPr>
+          <a:xfrm>
+            <a:off x="1417320" y="1828800"/>
+            <a:ext cx="3566160" cy="1417320"/>
+          </a:xfrm>
+          <a:prstGeom prst="rect">
+            <a:avLst/>
+          </a:prstGeom>
+          <a:solidFill>
+            <a:srgbClr val="F2F2F2"/>
+          </a:solidFill>
+          <a:ln w="15240">
+            <a:solidFill>
+              <a:srgbClr val="C00000"/>
+            </a:solidFill>
+            <a:prstDash val="dash"/>
+          </a:ln>
+          <a:effectLst/>
+        </p:spPr>
+        <p:style>
+          <a:lnRef idx="1">
+            <a:schemeClr val="accent1"/>
+          </a:lnRef>
+          <a:fillRef idx="3">
+            <a:schemeClr val="accent1"/>
+          </a:fillRef>
+          <a:effectRef idx="2">
+            <a:schemeClr val="accent1"/>
+          </a:effectRef>
+          <a:fontRef idx="minor">
+            <a:schemeClr val="lt1"/>
+          </a:fontRef>
+        </p:style>
+        <p:txBody>
+          <a:bodyPr rtlCol="0" anchor="ctr" wrap="square"/>
+          <a:lstStyle/>
+          <a:p>
+            <a:pPr algn="ctr"/>
+            <a:r>
+              <a:rPr sz="1300">
+                <a:solidFill>
+                  <a:srgbClr val="C00000"/>
+                </a:solidFill>
+                <a:latin typeface="微软雅黑"/>
+                <a:ea typeface="微软雅黑"/>
+                <a:cs typeface="微软雅黑"/>
+              </a:rPr>
+              <a:t>【截图 4】
+错题本页</a:t>
+            </a:r>
+          </a:p>
+          <a:p>
+            <a:pPr algn="ctr"/>
+            <a:r>
+              <a:rPr sz="1000">
+                <a:solidFill>
+                  <a:srgbClr val="808080"/>
+                </a:solidFill>
+                <a:latin typeface="微软雅黑"/>
+                <a:ea typeface="微软雅黑"/>
+                <a:cs typeface="微软雅黑"/>
+              </a:rPr>
+              <a:t>错题卡片
+用户答案与正确答案对比</a:t>
+            </a:r>
+          </a:p>
+        </p:txBody>
+      </p:sp>
+      <p:sp>
+        <p:nvSpPr>
+          <p:cNvPr id="12" name="TextBox 11"/>
+          <p:cNvSpPr txBox="1"/>
+          <p:nvPr/>
+        </p:nvSpPr>
+        <p:spPr>
+          <a:xfrm>
+            <a:off x="1417320" y="3300984"/>
+            <a:ext cx="3566160" cy="310896"/>
+          </a:xfrm>
+          <a:prstGeom prst="rect">
+            <a:avLst/>
+          </a:prstGeom>
+          <a:noFill/>
+        </p:spPr>
+        <p:txBody>
+          <a:bodyPr wrap="square" anchor="t" lIns="0" rIns="0" tIns="0" bIns="0">
+            <a:spAutoFit/>
+          </a:bodyPr>
+          <a:lstStyle/>
+          <a:p>
+            <a:pPr algn="ctr">
+              <a:spcAft>
+                <a:spcPts val="600"/>
+              </a:spcAft>
+            </a:pPr>
+            <a:r>
+              <a:rPr sz="1050">
+                <a:solidFill>
+                  <a:srgbClr val="808080"/>
+                </a:solidFill>
+                <a:latin typeface="微软雅黑"/>
+                <a:ea typeface="微软雅黑"/>
+                <a:cs typeface="微软雅黑"/>
+              </a:rPr>
+              <a:t>图 4  错题本页</a:t>
+            </a:r>
+          </a:p>
+        </p:txBody>
+      </p:sp>
+      <p:sp>
+        <p:nvSpPr>
+          <p:cNvPr id="13" name="Rectangle 12"/>
+          <p:cNvSpPr/>
+          <p:nvPr/>
+        </p:nvSpPr>
+        <p:spPr>
+          <a:xfrm>
+            <a:off x="5074920" y="1828800"/>
+            <a:ext cx="3566160" cy="1417320"/>
+          </a:xfrm>
+          <a:prstGeom prst="rect">
+            <a:avLst/>
+          </a:prstGeom>
+          <a:solidFill>
+            <a:srgbClr val="F2F2F2"/>
+          </a:solidFill>
+          <a:ln w="15240">
+            <a:solidFill>
+              <a:srgbClr val="C00000"/>
+            </a:solidFill>
+            <a:prstDash val="dash"/>
+          </a:ln>
+          <a:effectLst/>
+        </p:spPr>
+        <p:style>
+          <a:lnRef idx="1">
+            <a:schemeClr val="accent1"/>
+          </a:lnRef>
+          <a:fillRef idx="3">
+            <a:schemeClr val="accent1"/>
+          </a:fillRef>
+          <a:effectRef idx="2">
+            <a:schemeClr val="accent1"/>
+          </a:effectRef>
+          <a:fontRef idx="minor">
+            <a:schemeClr val="lt1"/>
+          </a:fontRef>
+        </p:style>
+        <p:txBody>
+          <a:bodyPr rtlCol="0" anchor="ctr" wrap="square"/>
+          <a:lstStyle/>
+          <a:p>
+            <a:pPr algn="ctr"/>
+            <a:r>
+              <a:rPr sz="1300">
+                <a:solidFill>
+                  <a:srgbClr val="C00000"/>
+                </a:solidFill>
+                <a:latin typeface="微软雅黑"/>
+                <a:ea typeface="微软雅黑"/>
+                <a:cs typeface="微软雅黑"/>
+              </a:rPr>
+              <a:t>【截图 5】
+复习计划页</a:t>
+            </a:r>
+          </a:p>
+          <a:p>
+            <a:pPr algn="ctr"/>
+            <a:r>
+              <a:rPr sz="1000">
+                <a:solidFill>
+                  <a:srgbClr val="808080"/>
+                </a:solidFill>
+                <a:latin typeface="微软雅黑"/>
+                <a:ea typeface="微软雅黑"/>
+                <a:cs typeface="微软雅黑"/>
+              </a:rPr>
+              <a:t>按日期分组的复习条目
+含完成勾选</a:t>
+            </a:r>
+          </a:p>
+        </p:txBody>
+      </p:sp>
+      <p:sp>
+        <p:nvSpPr>
+          <p:cNvPr id="14" name="TextBox 13"/>
+          <p:cNvSpPr txBox="1"/>
+          <p:nvPr/>
+        </p:nvSpPr>
+        <p:spPr>
+          <a:xfrm>
+            <a:off x="5074920" y="3300984"/>
+            <a:ext cx="3566160" cy="310896"/>
+          </a:xfrm>
+          <a:prstGeom prst="rect">
+            <a:avLst/>
+          </a:prstGeom>
+          <a:noFill/>
+        </p:spPr>
+        <p:txBody>
+          <a:bodyPr wrap="square" anchor="t" lIns="0" rIns="0" tIns="0" bIns="0">
+            <a:spAutoFit/>
+          </a:bodyPr>
+          <a:lstStyle/>
+          <a:p>
+            <a:pPr algn="ctr">
+              <a:spcAft>
+                <a:spcPts val="600"/>
+              </a:spcAft>
+            </a:pPr>
+            <a:r>
+              <a:rPr sz="1050">
+                <a:solidFill>
+                  <a:srgbClr val="808080"/>
+                </a:solidFill>
+                <a:latin typeface="微软雅黑"/>
+                <a:ea typeface="微软雅黑"/>
+                <a:cs typeface="微软雅黑"/>
+              </a:rPr>
+              <a:t>图 5  复习计划页</a:t>
+            </a:r>
+          </a:p>
+        </p:txBody>
+      </p:sp>
+      <p:sp>
+        <p:nvSpPr>
+          <p:cNvPr id="15" name="TextBox 14"/>
+          <p:cNvSpPr txBox="1"/>
+          <p:nvPr/>
+        </p:nvSpPr>
+        <p:spPr>
+          <a:xfrm>
+            <a:off x="548640" y="6053328"/>
+            <a:ext cx="11091672" cy="640080"/>
+          </a:xfrm>
+          <a:prstGeom prst="rect">
+            <a:avLst/>
+          </a:prstGeom>
+          <a:noFill/>
+        </p:spPr>
+        <p:txBody>
+          <a:bodyPr wrap="square" anchor="t" lIns="0" rIns="0" tIns="0" bIns="0">
+            <a:spAutoFit/>
+          </a:bodyPr>
+          <a:lstStyle/>
+          <a:p>
+            <a:pPr algn="ctr">
+              <a:spcAft>
+                <a:spcPts val="600"/>
+              </a:spcAft>
+            </a:pPr>
+            <a:r>
+              <a:rPr sz="1200">
+                <a:solidFill>
+                  <a:srgbClr val="C00000"/>
+                </a:solidFill>
+                <a:latin typeface="微软雅黑"/>
+                <a:ea typeface="微软雅黑"/>
+                <a:cs typeface="微软雅黑"/>
+              </a:rPr>
+              <a:t>说明：本页五张截图需在系统实际运行后补充；截图要求与报告第三节“11．实现的界面”一致。</a:t>
+            </a:r>
+          </a:p>
+        </p:txBody>
+      </p:sp>
+      <p:sp>
+        <p:nvSpPr>
+          <p:cNvPr id="16" name="TextBox 15"/>
+          <p:cNvSpPr txBox="1"/>
+          <p:nvPr/>
+        </p:nvSpPr>
+        <p:spPr>
+          <a:xfrm>
+            <a:off x="11247120" y="6473952"/>
+            <a:ext cx="640080" cy="274320"/>
+          </a:xfrm>
+          <a:prstGeom prst="rect">
+            <a:avLst/>
+          </a:prstGeom>
+          <a:noFill/>
+        </p:spPr>
+        <p:txBody>
+          <a:bodyPr wrap="square" anchor="t" lIns="0" rIns="0" tIns="0" bIns="0">
+            <a:spAutoFit/>
+          </a:bodyPr>
+          <a:lstStyle/>
+          <a:p>
+            <a:pPr algn="r">
+              <a:spcAft>
+                <a:spcPts val="600"/>
+              </a:spcAft>
+            </a:pPr>
+            <a:r>
+              <a:rPr sz="1000">
+                <a:solidFill>
+                  <a:srgbClr val="808080"/>
+                </a:solidFill>
+                <a:latin typeface="微软雅黑"/>
+                <a:ea typeface="微软雅黑"/>
+                <a:cs typeface="微软雅黑"/>
+              </a:rPr>
+              <a:t>13</a:t>
+            </a:r>
+          </a:p>
+        </p:txBody>
+      </p:sp>
+    </p:spTree>
+  </p:cSld>
+  <p:clrMapOvr>
+    <a:masterClrMapping/>
+  </p:clrMapOvr>
+</p:sld>
+</file>
+
+<file path=ppt/slides/slide14.xml><?xml version="1.0" encoding="utf-8"?>
+<p:sld xmlns:a="http://schemas.openxmlformats.org/drawingml/2006/main" xmlns:p="http://schemas.openxmlformats.org/presentationml/2006/main" xmlns:r="http://schemas.openxmlformats.org/officeDocument/2006/relationships">
+  <p:cSld>
+    <p:spTree>
+      <p:nvGrpSpPr>
+        <p:cNvPr id="1" name=""/>
+        <p:cNvGrpSpPr/>
+        <p:nvPr/>
+      </p:nvGrpSpPr>
+      <p:grpSpPr/>
+      <p:sp>
+        <p:nvSpPr>
+          <p:cNvPr id="2" name="Rectangle 1"/>
+          <p:cNvSpPr/>
+          <p:nvPr/>
+        </p:nvSpPr>
+        <p:spPr>
+          <a:xfrm>
+            <a:off x="0" y="0"/>
+            <a:ext cx="12191695" cy="960120"/>
+          </a:xfrm>
+          <a:prstGeom prst="rect">
+            <a:avLst/>
+          </a:prstGeom>
+          <a:solidFill>
+            <a:srgbClr val="1F4E79"/>
+          </a:solidFill>
+          <a:ln>
+            <a:noFill/>
+          </a:ln>
+          <a:effectLst/>
+        </p:spPr>
+        <p:style>
+          <a:lnRef idx="1">
+            <a:schemeClr val="accent1"/>
+          </a:lnRef>
+          <a:fillRef idx="3">
+            <a:schemeClr val="accent1"/>
+          </a:fillRef>
+          <a:effectRef idx="2">
+            <a:schemeClr val="accent1"/>
+          </a:effectRef>
+          <a:fontRef idx="minor">
+            <a:schemeClr val="lt1"/>
+          </a:fontRef>
+        </p:style>
+        <p:txBody>
+          <a:bodyPr rtlCol="0" anchor="ctr"/>
+          <a:lstStyle/>
+          <a:p>
+            <a:pPr algn="ctr"/>
+          </a:p>
+        </p:txBody>
+      </p:sp>
+      <p:sp>
+        <p:nvSpPr>
+          <p:cNvPr id="3" name="TextBox 2"/>
+          <p:cNvSpPr txBox="1"/>
+          <p:nvPr/>
+        </p:nvSpPr>
+        <p:spPr>
+          <a:xfrm>
+            <a:off x="502920" y="182880"/>
             <a:ext cx="11185855" cy="621792"/>
           </a:xfrm>
           <a:prstGeom prst="rect">
@@ -8305,7 +9106,7 @@
 </p:sld>
 </file>
 
-<file path=ppt/slides/slide14.xml><?xml version="1.0" encoding="utf-8"?>
+<file path=ppt/slides/slide15.xml><?xml version="1.0" encoding="utf-8"?>
 <p:sld xmlns:a="http://schemas.openxmlformats.org/drawingml/2006/main" xmlns:p="http://schemas.openxmlformats.org/presentationml/2006/main" xmlns:r="http://schemas.openxmlformats.org/officeDocument/2006/relationships">
   <p:cSld>
     <p:spTree>
@@ -8745,7 +9546,7 @@
 </p:sld>
 </file>
 
-<file path=ppt/slides/slide15.xml><?xml version="1.0" encoding="utf-8"?>
+<file path=ppt/slides/slide16.xml><?xml version="1.0" encoding="utf-8"?>
 <p:sld xmlns:a="http://schemas.openxmlformats.org/drawingml/2006/main" xmlns:p="http://schemas.openxmlformats.org/presentationml/2006/main" xmlns:r="http://schemas.openxmlformats.org/officeDocument/2006/relationships">
   <p:cSld>
     <p:spTree>
@@ -9588,7 +10389,7 @@
 </p:sld>
 </file>
 
-<file path=ppt/slides/slide16.xml><?xml version="1.0" encoding="utf-8"?>
+<file path=ppt/slides/slide17.xml><?xml version="1.0" encoding="utf-8"?>
 <p:sld xmlns:a="http://schemas.openxmlformats.org/drawingml/2006/main" xmlns:p="http://schemas.openxmlformats.org/presentationml/2006/main" xmlns:r="http://schemas.openxmlformats.org/officeDocument/2006/relationships">
   <p:cSld>
     <p:spTree>
@@ -9815,7 +10616,7 @@
 </p:sld>
 </file>
 
-<file path=ppt/slides/slide17.xml><?xml version="1.0" encoding="utf-8"?>
+<file path=ppt/slides/slide2.xml><?xml version="1.0" encoding="utf-8"?>
 <p:sld xmlns:a="http://schemas.openxmlformats.org/drawingml/2006/main" xmlns:p="http://schemas.openxmlformats.org/presentationml/2006/main" xmlns:r="http://schemas.openxmlformats.org/officeDocument/2006/relationships">
   <p:cSld>
     <p:spTree>
@@ -9878,7 +10679,7 @@
         <p:spPr>
           <a:xfrm>
             <a:off x="502920" y="182880"/>
-            <a:ext cx="11155680" cy="621792"/>
+            <a:ext cx="11185855" cy="621792"/>
           </a:xfrm>
           <a:prstGeom prst="rect">
             <a:avLst/>
@@ -9892,12 +10693,18 @@
           <a:lstStyle/>
           <a:p>
             <a:pPr algn="l">
+              <a:lnSpc>
+                <a:spcPct val="125000"/>
+              </a:lnSpc>
+              <a:spcBef>
+                <a:spcPts val="0"/>
+              </a:spcBef>
               <a:spcAft>
                 <a:spcPts val="600"/>
               </a:spcAft>
             </a:pPr>
             <a:r>
-              <a:rPr sz="2600">
+              <a:rPr sz="2600" b="1">
                 <a:solidFill>
                   <a:srgbClr val="FFFFFF"/>
                 </a:solidFill>
@@ -9905,7 +10712,7 @@
                 <a:ea typeface="微软雅黑"/>
                 <a:cs typeface="微软雅黑"/>
               </a:rPr>
-              <a:t>5.4　系统界面展示（需补充截图）</a:t>
+              <a:t>目录</a:t>
             </a:r>
           </a:p>
         </p:txBody>
@@ -9918,7 +10725,7 @@
         </p:nvSpPr>
         <p:spPr>
           <a:xfrm>
-            <a:off x="8321040" y="274320"/>
+            <a:off x="8351215" y="274320"/>
             <a:ext cx="3383280" cy="457200"/>
           </a:xfrm>
           <a:prstGeom prst="rect">
@@ -9933,12 +10740,18 @@
           <a:lstStyle/>
           <a:p>
             <a:pPr algn="r">
+              <a:lnSpc>
+                <a:spcPct val="125000"/>
+              </a:lnSpc>
+              <a:spcBef>
+                <a:spcPts val="0"/>
+              </a:spcBef>
               <a:spcAft>
                 <a:spcPts val="600"/>
               </a:spcAft>
             </a:pPr>
             <a:r>
-              <a:rPr sz="1300">
+              <a:rPr sz="1300" b="0">
                 <a:solidFill>
                   <a:srgbClr val="BDD7EE"/>
                 </a:solidFill>
@@ -9946,70 +10759,44 @@
                 <a:ea typeface="微软雅黑"/>
                 <a:cs typeface="微软雅黑"/>
               </a:rPr>
-              <a:t>负责人：【姓名5】</a:t>
-            </a:r>
-          </a:p>
-        </p:txBody>
-      </p:sp>
-      <p:sp>
-        <p:nvSpPr>
-          <p:cNvPr id="5" name="Rectangle 4"/>
-          <p:cNvSpPr/>
+              <a:t>Contents</a:t>
+            </a:r>
+          </a:p>
+        </p:txBody>
+      </p:sp>
+      <p:sp>
+        <p:nvSpPr>
+          <p:cNvPr id="5" name="TextBox 4"/>
+          <p:cNvSpPr txBox="1"/>
           <p:nvPr/>
         </p:nvSpPr>
         <p:spPr>
           <a:xfrm>
-            <a:off x="548640" y="3566160"/>
-            <a:ext cx="3566160" cy="1417320"/>
+            <a:off x="11277295" y="6473952"/>
+            <a:ext cx="640080" cy="274320"/>
           </a:xfrm>
           <a:prstGeom prst="rect">
             <a:avLst/>
           </a:prstGeom>
-          <a:solidFill>
-            <a:srgbClr val="F2F2F2"/>
-          </a:solidFill>
-          <a:ln w="15240">
-            <a:solidFill>
-              <a:srgbClr val="C00000"/>
-            </a:solidFill>
-            <a:prstDash val="dash"/>
-          </a:ln>
-          <a:effectLst/>
+          <a:noFill/>
         </p:spPr>
-        <p:style>
-          <a:lnRef idx="1">
-            <a:schemeClr val="accent1"/>
-          </a:lnRef>
-          <a:fillRef idx="3">
-            <a:schemeClr val="accent1"/>
-          </a:fillRef>
-          <a:effectRef idx="2">
-            <a:schemeClr val="accent1"/>
-          </a:effectRef>
-          <a:fontRef idx="minor">
-            <a:schemeClr val="lt1"/>
-          </a:fontRef>
-        </p:style>
-        <p:txBody>
-          <a:bodyPr rtlCol="0" anchor="ctr" wrap="square"/>
-          <a:lstStyle/>
-          <a:p>
-            <a:pPr algn="ctr"/>
-            <a:r>
-              <a:rPr sz="1300">
-                <a:solidFill>
-                  <a:srgbClr val="C00000"/>
-                </a:solidFill>
-                <a:latin typeface="微软雅黑"/>
-                <a:ea typeface="微软雅黑"/>
-                <a:cs typeface="微软雅黑"/>
-              </a:rPr>
-              <a:t>【截图 1】
-文档管理页</a:t>
-            </a:r>
-          </a:p>
-          <a:p>
-            <a:pPr algn="ctr"/>
+        <p:txBody>
+          <a:bodyPr wrap="square" anchor="t" lIns="0" rIns="0" tIns="0" bIns="0">
+            <a:spAutoFit/>
+          </a:bodyPr>
+          <a:lstStyle/>
+          <a:p>
+            <a:pPr algn="r">
+              <a:lnSpc>
+                <a:spcPct val="125000"/>
+              </a:lnSpc>
+              <a:spcBef>
+                <a:spcPts val="0"/>
+              </a:spcBef>
+              <a:spcAft>
+                <a:spcPts val="600"/>
+              </a:spcAft>
+            </a:pPr>
             <a:r>
               <a:rPr sz="1000">
                 <a:solidFill>
@@ -10019,8 +10806,7 @@
                 <a:ea typeface="微软雅黑"/>
                 <a:cs typeface="微软雅黑"/>
               </a:rPr>
-              <a:t>已选课程 + 文档列表
-含文件名与切分块数</a:t>
+              <a:t>2</a:t>
             </a:r>
           </a:p>
         </p:txBody>
@@ -10033,8 +10819,8 @@
         </p:nvSpPr>
         <p:spPr>
           <a:xfrm>
-            <a:off x="548640" y="5038344"/>
-            <a:ext cx="3566160" cy="310896"/>
+            <a:off x="822960" y="1325880"/>
+            <a:ext cx="10515600" cy="4846320"/>
           </a:xfrm>
           <a:prstGeom prst="rect">
             <a:avLst/>
@@ -10047,13 +10833,27 @@
           </a:bodyPr>
           <a:lstStyle/>
           <a:p>
-            <a:pPr algn="ctr">
+            <a:pPr>
+              <a:lnSpc>
+                <a:spcPct val="115000"/>
+              </a:lnSpc>
               <a:spcAft>
-                <a:spcPts val="600"/>
+                <a:spcPts val="1400"/>
               </a:spcAft>
             </a:pPr>
             <a:r>
-              <a:rPr sz="1050">
+              <a:rPr sz="1900" b="1">
+                <a:solidFill>
+                  <a:srgbClr val="1F4E79"/>
+                </a:solidFill>
+                <a:latin typeface="微软雅黑"/>
+                <a:ea typeface="微软雅黑"/>
+                <a:cs typeface="微软雅黑"/>
+              </a:rPr>
+              <a:t>1　选题背景与意义</a:t>
+            </a:r>
+            <a:r>
+              <a:rPr sz="1400" b="0">
                 <a:solidFill>
                   <a:srgbClr val="808080"/>
                 </a:solidFill>
@@ -10061,72 +10861,31 @@
                 <a:ea typeface="微软雅黑"/>
                 <a:cs typeface="微软雅黑"/>
               </a:rPr>
-              <a:t>图 1  文档管理页</a:t>
-            </a:r>
-          </a:p>
-        </p:txBody>
-      </p:sp>
-      <p:sp>
-        <p:nvSpPr>
-          <p:cNvPr id="7" name="Rectangle 6"/>
-          <p:cNvSpPr/>
-          <p:nvPr/>
-        </p:nvSpPr>
-        <p:spPr>
-          <a:xfrm>
-            <a:off x="4206240" y="3566160"/>
-            <a:ext cx="3566160" cy="1417320"/>
-          </a:xfrm>
-          <a:prstGeom prst="rect">
-            <a:avLst/>
-          </a:prstGeom>
-          <a:solidFill>
-            <a:srgbClr val="F2F2F2"/>
-          </a:solidFill>
-          <a:ln w="15240">
-            <a:solidFill>
-              <a:srgbClr val="C00000"/>
-            </a:solidFill>
-            <a:prstDash val="dash"/>
-          </a:ln>
-          <a:effectLst/>
-        </p:spPr>
-        <p:style>
-          <a:lnRef idx="1">
-            <a:schemeClr val="accent1"/>
-          </a:lnRef>
-          <a:fillRef idx="3">
-            <a:schemeClr val="accent1"/>
-          </a:fillRef>
-          <a:effectRef idx="2">
-            <a:schemeClr val="accent1"/>
-          </a:effectRef>
-          <a:fontRef idx="minor">
-            <a:schemeClr val="lt1"/>
-          </a:fontRef>
-        </p:style>
-        <p:txBody>
-          <a:bodyPr rtlCol="0" anchor="ctr" wrap="square"/>
-          <a:lstStyle/>
-          <a:p>
-            <a:pPr algn="ctr"/>
-            <a:r>
-              <a:rPr sz="1300">
+              <a:t>　——　项目来源、待解决的主要问题</a:t>
+            </a:r>
+          </a:p>
+          <a:p>
+            <a:pPr>
+              <a:lnSpc>
+                <a:spcPct val="115000"/>
+              </a:lnSpc>
+              <a:spcAft>
+                <a:spcPts val="1400"/>
+              </a:spcAft>
+            </a:pPr>
+            <a:r>
+              <a:rPr sz="1900" b="1">
                 <a:solidFill>
-                  <a:srgbClr val="C00000"/>
+                  <a:srgbClr val="1F4E79"/>
                 </a:solidFill>
                 <a:latin typeface="微软雅黑"/>
                 <a:ea typeface="微软雅黑"/>
                 <a:cs typeface="微软雅黑"/>
               </a:rPr>
-              <a:t>【截图 2】
-智能问答页</a:t>
-            </a:r>
-          </a:p>
-          <a:p>
-            <a:pPr algn="ctr"/>
-            <a:r>
-              <a:rPr sz="1000">
+              <a:t>2　系统总体架构与技术选型</a:t>
+            </a:r>
+            <a:r>
+              <a:rPr sz="1400" b="0">
                 <a:solidFill>
                   <a:srgbClr val="808080"/>
                 </a:solidFill>
@@ -10134,41 +10893,31 @@
                 <a:ea typeface="微软雅黑"/>
                 <a:cs typeface="微软雅黑"/>
               </a:rPr>
-              <a:t>提问与 AI 回答
-下方显示引用来源卡片</a:t>
-            </a:r>
-          </a:p>
-        </p:txBody>
-      </p:sp>
-      <p:sp>
-        <p:nvSpPr>
-          <p:cNvPr id="8" name="TextBox 7"/>
-          <p:cNvSpPr txBox="1"/>
-          <p:nvPr/>
-        </p:nvSpPr>
-        <p:spPr>
-          <a:xfrm>
-            <a:off x="4206240" y="5038344"/>
-            <a:ext cx="3566160" cy="310896"/>
-          </a:xfrm>
-          <a:prstGeom prst="rect">
-            <a:avLst/>
-          </a:prstGeom>
-          <a:noFill/>
-        </p:spPr>
-        <p:txBody>
-          <a:bodyPr wrap="square" anchor="t" lIns="0" rIns="0" tIns="0" bIns="0">
-            <a:spAutoFit/>
-          </a:bodyPr>
-          <a:lstStyle/>
-          <a:p>
-            <a:pPr algn="ctr">
+              <a:t>　——　B/S 三层架构、双库存储</a:t>
+            </a:r>
+          </a:p>
+          <a:p>
+            <a:pPr>
+              <a:lnSpc>
+                <a:spcPct val="115000"/>
+              </a:lnSpc>
               <a:spcAft>
-                <a:spcPts val="600"/>
+                <a:spcPts val="1400"/>
               </a:spcAft>
             </a:pPr>
             <a:r>
-              <a:rPr sz="1050">
+              <a:rPr sz="1900" b="1">
+                <a:solidFill>
+                  <a:srgbClr val="1F4E79"/>
+                </a:solidFill>
+                <a:latin typeface="微软雅黑"/>
+                <a:ea typeface="微软雅黑"/>
+                <a:cs typeface="微软雅黑"/>
+              </a:rPr>
+              <a:t>3　核心原理：检索增强生成（RAG）</a:t>
+            </a:r>
+            <a:r>
+              <a:rPr sz="1400" b="0">
                 <a:solidFill>
                   <a:srgbClr val="808080"/>
                 </a:solidFill>
@@ -10176,72 +10925,31 @@
                 <a:ea typeface="微软雅黑"/>
                 <a:cs typeface="微软雅黑"/>
               </a:rPr>
-              <a:t>图 2  智能问答页</a:t>
-            </a:r>
-          </a:p>
-        </p:txBody>
-      </p:sp>
-      <p:sp>
-        <p:nvSpPr>
-          <p:cNvPr id="9" name="Rectangle 8"/>
-          <p:cNvSpPr/>
-          <p:nvPr/>
-        </p:nvSpPr>
-        <p:spPr>
-          <a:xfrm>
-            <a:off x="7863840" y="3566160"/>
-            <a:ext cx="3566160" cy="1417320"/>
-          </a:xfrm>
-          <a:prstGeom prst="rect">
-            <a:avLst/>
-          </a:prstGeom>
-          <a:solidFill>
-            <a:srgbClr val="F2F2F2"/>
-          </a:solidFill>
-          <a:ln w="15240">
-            <a:solidFill>
-              <a:srgbClr val="C00000"/>
-            </a:solidFill>
-            <a:prstDash val="dash"/>
-          </a:ln>
-          <a:effectLst/>
-        </p:spPr>
-        <p:style>
-          <a:lnRef idx="1">
-            <a:schemeClr val="accent1"/>
-          </a:lnRef>
-          <a:fillRef idx="3">
-            <a:schemeClr val="accent1"/>
-          </a:fillRef>
-          <a:effectRef idx="2">
-            <a:schemeClr val="accent1"/>
-          </a:effectRef>
-          <a:fontRef idx="minor">
-            <a:schemeClr val="lt1"/>
-          </a:fontRef>
-        </p:style>
-        <p:txBody>
-          <a:bodyPr rtlCol="0" anchor="ctr" wrap="square"/>
-          <a:lstStyle/>
-          <a:p>
-            <a:pPr algn="ctr"/>
-            <a:r>
-              <a:rPr sz="1300">
+              <a:t>　——　离线索引与在线问答两阶段</a:t>
+            </a:r>
+          </a:p>
+          <a:p>
+            <a:pPr>
+              <a:lnSpc>
+                <a:spcPct val="115000"/>
+              </a:lnSpc>
+              <a:spcAft>
+                <a:spcPts val="1400"/>
+              </a:spcAft>
+            </a:pPr>
+            <a:r>
+              <a:rPr sz="1900" b="1">
                 <a:solidFill>
-                  <a:srgbClr val="C00000"/>
+                  <a:srgbClr val="1F4E79"/>
                 </a:solidFill>
                 <a:latin typeface="微软雅黑"/>
                 <a:ea typeface="微软雅黑"/>
                 <a:cs typeface="微软雅黑"/>
               </a:rPr>
-              <a:t>【截图 3】
-自动出题页</a:t>
-            </a:r>
-          </a:p>
-          <a:p>
-            <a:pPr algn="ctr"/>
-            <a:r>
-              <a:rPr sz="1000">
+              <a:t>4　数据库设计</a:t>
+            </a:r>
+            <a:r>
+              <a:rPr sz="1400" b="0">
                 <a:solidFill>
                   <a:srgbClr val="808080"/>
                 </a:solidFill>
@@ -10249,41 +10957,31 @@
                 <a:ea typeface="微软雅黑"/>
                 <a:cs typeface="微软雅黑"/>
               </a:rPr>
-              <a:t>参数表单 + 题目卡片
-含判分结果</a:t>
-            </a:r>
-          </a:p>
-        </p:txBody>
-      </p:sp>
-      <p:sp>
-        <p:nvSpPr>
-          <p:cNvPr id="10" name="TextBox 9"/>
-          <p:cNvSpPr txBox="1"/>
-          <p:nvPr/>
-        </p:nvSpPr>
-        <p:spPr>
-          <a:xfrm>
-            <a:off x="7863840" y="5038344"/>
-            <a:ext cx="3566160" cy="310896"/>
-          </a:xfrm>
-          <a:prstGeom prst="rect">
-            <a:avLst/>
-          </a:prstGeom>
-          <a:noFill/>
-        </p:spPr>
-        <p:txBody>
-          <a:bodyPr wrap="square" anchor="t" lIns="0" rIns="0" tIns="0" bIns="0">
-            <a:spAutoFit/>
-          </a:bodyPr>
-          <a:lstStyle/>
-          <a:p>
-            <a:pPr algn="ctr">
+              <a:t>　——　E-R 图、CDM 图、PDM 表结构</a:t>
+            </a:r>
+          </a:p>
+          <a:p>
+            <a:pPr>
+              <a:lnSpc>
+                <a:spcPct val="115000"/>
+              </a:lnSpc>
               <a:spcAft>
-                <a:spcPts val="600"/>
+                <a:spcPts val="1400"/>
               </a:spcAft>
             </a:pPr>
             <a:r>
-              <a:rPr sz="1050">
+              <a:rPr sz="1900" b="1">
+                <a:solidFill>
+                  <a:srgbClr val="1F4E79"/>
+                </a:solidFill>
+                <a:latin typeface="微软雅黑"/>
+                <a:ea typeface="微软雅黑"/>
+                <a:cs typeface="微软雅黑"/>
+              </a:rPr>
+              <a:t>5　功能模块设计与实现</a:t>
+            </a:r>
+            <a:r>
+              <a:rPr sz="1400" b="0">
                 <a:solidFill>
                   <a:srgbClr val="808080"/>
                 </a:solidFill>
@@ -10291,72 +10989,31 @@
                 <a:ea typeface="微软雅黑"/>
                 <a:cs typeface="微软雅黑"/>
               </a:rPr>
-              <a:t>图 3  自动出题页</a:t>
-            </a:r>
-          </a:p>
-        </p:txBody>
-      </p:sp>
-      <p:sp>
-        <p:nvSpPr>
-          <p:cNvPr id="11" name="Rectangle 10"/>
-          <p:cNvSpPr/>
-          <p:nvPr/>
-        </p:nvSpPr>
-        <p:spPr>
-          <a:xfrm>
-            <a:off x="1417320" y="1828800"/>
-            <a:ext cx="3566160" cy="1417320"/>
-          </a:xfrm>
-          <a:prstGeom prst="rect">
-            <a:avLst/>
-          </a:prstGeom>
-          <a:solidFill>
-            <a:srgbClr val="F2F2F2"/>
-          </a:solidFill>
-          <a:ln w="15240">
-            <a:solidFill>
-              <a:srgbClr val="C00000"/>
-            </a:solidFill>
-            <a:prstDash val="dash"/>
-          </a:ln>
-          <a:effectLst/>
-        </p:spPr>
-        <p:style>
-          <a:lnRef idx="1">
-            <a:schemeClr val="accent1"/>
-          </a:lnRef>
-          <a:fillRef idx="3">
-            <a:schemeClr val="accent1"/>
-          </a:fillRef>
-          <a:effectRef idx="2">
-            <a:schemeClr val="accent1"/>
-          </a:effectRef>
-          <a:fontRef idx="minor">
-            <a:schemeClr val="lt1"/>
-          </a:fontRef>
-        </p:style>
-        <p:txBody>
-          <a:bodyPr rtlCol="0" anchor="ctr" wrap="square"/>
-          <a:lstStyle/>
-          <a:p>
-            <a:pPr algn="ctr"/>
-            <a:r>
-              <a:rPr sz="1300">
+              <a:t>　——　F1–F5 五大功能模块</a:t>
+            </a:r>
+          </a:p>
+          <a:p>
+            <a:pPr>
+              <a:lnSpc>
+                <a:spcPct val="115000"/>
+              </a:lnSpc>
+              <a:spcAft>
+                <a:spcPts val="1400"/>
+              </a:spcAft>
+            </a:pPr>
+            <a:r>
+              <a:rPr sz="1900">
                 <a:solidFill>
-                  <a:srgbClr val="C00000"/>
+                  <a:srgbClr val="1F4E79"/>
                 </a:solidFill>
                 <a:latin typeface="微软雅黑"/>
                 <a:ea typeface="微软雅黑"/>
                 <a:cs typeface="微软雅黑"/>
               </a:rPr>
-              <a:t>【截图 4】
-错题本页</a:t>
-            </a:r>
-          </a:p>
-          <a:p>
-            <a:pPr algn="ctr"/>
-            <a:r>
-              <a:rPr sz="1000">
+              <a:t>6　系统测试与结果分析　——　</a:t>
+            </a:r>
+            <a:r>
+              <a:rPr sz="1400">
                 <a:solidFill>
                   <a:srgbClr val="808080"/>
                 </a:solidFill>
@@ -10364,41 +11021,31 @@
                 <a:ea typeface="微软雅黑"/>
                 <a:cs typeface="微软雅黑"/>
               </a:rPr>
-              <a:t>错题卡片
-用户答案与正确答案对比</a:t>
-            </a:r>
-          </a:p>
-        </p:txBody>
-      </p:sp>
-      <p:sp>
-        <p:nvSpPr>
-          <p:cNvPr id="12" name="TextBox 11"/>
-          <p:cNvSpPr txBox="1"/>
-          <p:nvPr/>
-        </p:nvSpPr>
-        <p:spPr>
-          <a:xfrm>
-            <a:off x="1417320" y="3300984"/>
-            <a:ext cx="3566160" cy="310896"/>
-          </a:xfrm>
-          <a:prstGeom prst="rect">
-            <a:avLst/>
-          </a:prstGeom>
-          <a:noFill/>
-        </p:spPr>
-        <p:txBody>
-          <a:bodyPr wrap="square" anchor="t" lIns="0" rIns="0" tIns="0" bIns="0">
-            <a:spAutoFit/>
-          </a:bodyPr>
-          <a:lstStyle/>
-          <a:p>
-            <a:pPr algn="ctr">
+              <a:t>测试用例、数据与分析结论</a:t>
+            </a:r>
+          </a:p>
+          <a:p>
+            <a:pPr>
+              <a:lnSpc>
+                <a:spcPct val="115000"/>
+              </a:lnSpc>
               <a:spcAft>
-                <a:spcPts val="600"/>
+                <a:spcPts val="1400"/>
               </a:spcAft>
             </a:pPr>
             <a:r>
-              <a:rPr sz="1050">
+              <a:rPr sz="1900" b="1">
+                <a:solidFill>
+                  <a:srgbClr val="1F4E79"/>
+                </a:solidFill>
+                <a:latin typeface="微软雅黑"/>
+                <a:ea typeface="微软雅黑"/>
+                <a:cs typeface="微软雅黑"/>
+              </a:rPr>
+              <a:t>7　总结与展望</a:t>
+            </a:r>
+            <a:r>
+              <a:rPr sz="1400" b="0">
                 <a:solidFill>
                   <a:srgbClr val="808080"/>
                 </a:solidFill>
@@ -10406,204 +11053,7 @@
                 <a:ea typeface="微软雅黑"/>
                 <a:cs typeface="微软雅黑"/>
               </a:rPr>
-              <a:t>图 4  错题本页</a:t>
-            </a:r>
-          </a:p>
-        </p:txBody>
-      </p:sp>
-      <p:sp>
-        <p:nvSpPr>
-          <p:cNvPr id="13" name="Rectangle 12"/>
-          <p:cNvSpPr/>
-          <p:nvPr/>
-        </p:nvSpPr>
-        <p:spPr>
-          <a:xfrm>
-            <a:off x="5074920" y="1828800"/>
-            <a:ext cx="3566160" cy="1417320"/>
-          </a:xfrm>
-          <a:prstGeom prst="rect">
-            <a:avLst/>
-          </a:prstGeom>
-          <a:solidFill>
-            <a:srgbClr val="F2F2F2"/>
-          </a:solidFill>
-          <a:ln w="15240">
-            <a:solidFill>
-              <a:srgbClr val="C00000"/>
-            </a:solidFill>
-            <a:prstDash val="dash"/>
-          </a:ln>
-          <a:effectLst/>
-        </p:spPr>
-        <p:style>
-          <a:lnRef idx="1">
-            <a:schemeClr val="accent1"/>
-          </a:lnRef>
-          <a:fillRef idx="3">
-            <a:schemeClr val="accent1"/>
-          </a:fillRef>
-          <a:effectRef idx="2">
-            <a:schemeClr val="accent1"/>
-          </a:effectRef>
-          <a:fontRef idx="minor">
-            <a:schemeClr val="lt1"/>
-          </a:fontRef>
-        </p:style>
-        <p:txBody>
-          <a:bodyPr rtlCol="0" anchor="ctr" wrap="square"/>
-          <a:lstStyle/>
-          <a:p>
-            <a:pPr algn="ctr"/>
-            <a:r>
-              <a:rPr sz="1300">
-                <a:solidFill>
-                  <a:srgbClr val="C00000"/>
-                </a:solidFill>
-                <a:latin typeface="微软雅黑"/>
-                <a:ea typeface="微软雅黑"/>
-                <a:cs typeface="微软雅黑"/>
-              </a:rPr>
-              <a:t>【截图 5】
-复习计划页</a:t>
-            </a:r>
-          </a:p>
-          <a:p>
-            <a:pPr algn="ctr"/>
-            <a:r>
-              <a:rPr sz="1000">
-                <a:solidFill>
-                  <a:srgbClr val="808080"/>
-                </a:solidFill>
-                <a:latin typeface="微软雅黑"/>
-                <a:ea typeface="微软雅黑"/>
-                <a:cs typeface="微软雅黑"/>
-              </a:rPr>
-              <a:t>按日期分组的复习条目
-含完成勾选</a:t>
-            </a:r>
-          </a:p>
-        </p:txBody>
-      </p:sp>
-      <p:sp>
-        <p:nvSpPr>
-          <p:cNvPr id="14" name="TextBox 13"/>
-          <p:cNvSpPr txBox="1"/>
-          <p:nvPr/>
-        </p:nvSpPr>
-        <p:spPr>
-          <a:xfrm>
-            <a:off x="5074920" y="3300984"/>
-            <a:ext cx="3566160" cy="310896"/>
-          </a:xfrm>
-          <a:prstGeom prst="rect">
-            <a:avLst/>
-          </a:prstGeom>
-          <a:noFill/>
-        </p:spPr>
-        <p:txBody>
-          <a:bodyPr wrap="square" anchor="t" lIns="0" rIns="0" tIns="0" bIns="0">
-            <a:spAutoFit/>
-          </a:bodyPr>
-          <a:lstStyle/>
-          <a:p>
-            <a:pPr algn="ctr">
-              <a:spcAft>
-                <a:spcPts val="600"/>
-              </a:spcAft>
-            </a:pPr>
-            <a:r>
-              <a:rPr sz="1050">
-                <a:solidFill>
-                  <a:srgbClr val="808080"/>
-                </a:solidFill>
-                <a:latin typeface="微软雅黑"/>
-                <a:ea typeface="微软雅黑"/>
-                <a:cs typeface="微软雅黑"/>
-              </a:rPr>
-              <a:t>图 5  复习计划页</a:t>
-            </a:r>
-          </a:p>
-        </p:txBody>
-      </p:sp>
-      <p:sp>
-        <p:nvSpPr>
-          <p:cNvPr id="15" name="TextBox 14"/>
-          <p:cNvSpPr txBox="1"/>
-          <p:nvPr/>
-        </p:nvSpPr>
-        <p:spPr>
-          <a:xfrm>
-            <a:off x="548640" y="6053328"/>
-            <a:ext cx="11091672" cy="640080"/>
-          </a:xfrm>
-          <a:prstGeom prst="rect">
-            <a:avLst/>
-          </a:prstGeom>
-          <a:noFill/>
-        </p:spPr>
-        <p:txBody>
-          <a:bodyPr wrap="square" anchor="t" lIns="0" rIns="0" tIns="0" bIns="0">
-            <a:spAutoFit/>
-          </a:bodyPr>
-          <a:lstStyle/>
-          <a:p>
-            <a:pPr algn="ctr">
-              <a:spcAft>
-                <a:spcPts val="600"/>
-              </a:spcAft>
-            </a:pPr>
-            <a:r>
-              <a:rPr sz="1200">
-                <a:solidFill>
-                  <a:srgbClr val="C00000"/>
-                </a:solidFill>
-                <a:latin typeface="微软雅黑"/>
-                <a:ea typeface="微软雅黑"/>
-                <a:cs typeface="微软雅黑"/>
-              </a:rPr>
-              <a:t>说明：本页五张截图需在系统实际运行后补充；截图要求与报告第三节“11．实现的界面”一致。</a:t>
-            </a:r>
-          </a:p>
-        </p:txBody>
-      </p:sp>
-      <p:sp>
-        <p:nvSpPr>
-          <p:cNvPr id="16" name="TextBox 15"/>
-          <p:cNvSpPr txBox="1"/>
-          <p:nvPr/>
-        </p:nvSpPr>
-        <p:spPr>
-          <a:xfrm>
-            <a:off x="11247120" y="6473952"/>
-            <a:ext cx="640080" cy="274320"/>
-          </a:xfrm>
-          <a:prstGeom prst="rect">
-            <a:avLst/>
-          </a:prstGeom>
-          <a:noFill/>
-        </p:spPr>
-        <p:txBody>
-          <a:bodyPr wrap="square" anchor="t" lIns="0" rIns="0" tIns="0" bIns="0">
-            <a:spAutoFit/>
-          </a:bodyPr>
-          <a:lstStyle/>
-          <a:p>
-            <a:pPr algn="r">
-              <a:spcAft>
-                <a:spcPts val="600"/>
-              </a:spcAft>
-            </a:pPr>
-            <a:r>
-              <a:rPr sz="1000">
-                <a:solidFill>
-                  <a:srgbClr val="808080"/>
-                </a:solidFill>
-                <a:latin typeface="微软雅黑"/>
-                <a:ea typeface="微软雅黑"/>
-                <a:cs typeface="微软雅黑"/>
-              </a:rPr>
-              <a:t>13</a:t>
+              <a:t>　——　成果总结、后续改进方向</a:t>
             </a:r>
           </a:p>
         </p:txBody>
@@ -10616,7 +11066,7 @@
 </p:sld>
 </file>
 
-<file path=ppt/slides/slide2.xml><?xml version="1.0" encoding="utf-8"?>
+<file path=ppt/slides/slide3.xml><?xml version="1.0" encoding="utf-8"?>
 <p:sld xmlns:a="http://schemas.openxmlformats.org/drawingml/2006/main" xmlns:p="http://schemas.openxmlformats.org/presentationml/2006/main" xmlns:r="http://schemas.openxmlformats.org/officeDocument/2006/relationships">
   <p:cSld>
     <p:spTree>
@@ -10712,7 +11162,7 @@
                 <a:ea typeface="微软雅黑"/>
                 <a:cs typeface="微软雅黑"/>
               </a:rPr>
-              <a:t>目录</a:t>
+              <a:t>1　选题背景与意义</a:t>
             </a:r>
           </a:p>
         </p:txBody>
@@ -10725,8 +11175,8 @@
         </p:nvSpPr>
         <p:spPr>
           <a:xfrm>
-            <a:off x="8351215" y="274320"/>
-            <a:ext cx="3383280" cy="457200"/>
+            <a:off x="11277295" y="6473952"/>
+            <a:ext cx="640080" cy="274320"/>
           </a:xfrm>
           <a:prstGeom prst="rect">
             <a:avLst/>
@@ -10734,7 +11184,7 @@
           <a:noFill/>
         </p:spPr>
         <p:txBody>
-          <a:bodyPr wrap="square" anchor="ctr" lIns="0" rIns="0" tIns="0" bIns="0">
+          <a:bodyPr wrap="square" anchor="t" lIns="0" rIns="0" tIns="0" bIns="0">
             <a:spAutoFit/>
           </a:bodyPr>
           <a:lstStyle/>
@@ -10751,15 +11201,15 @@
               </a:spcAft>
             </a:pPr>
             <a:r>
-              <a:rPr sz="1300" b="0">
+              <a:rPr sz="1000">
                 <a:solidFill>
-                  <a:srgbClr val="BDD7EE"/>
+                  <a:srgbClr val="808080"/>
                 </a:solidFill>
                 <a:latin typeface="微软雅黑"/>
                 <a:ea typeface="微软雅黑"/>
                 <a:cs typeface="微软雅黑"/>
               </a:rPr>
-              <a:t>Contents</a:t>
+              <a:t>3</a:t>
             </a:r>
           </a:p>
         </p:txBody>
@@ -10772,8 +11222,8 @@
         </p:nvSpPr>
         <p:spPr>
           <a:xfrm>
-            <a:off x="11277295" y="6473952"/>
-            <a:ext cx="640080" cy="274320"/>
+            <a:off x="548640" y="1280160"/>
+            <a:ext cx="11064240" cy="5120640"/>
           </a:xfrm>
           <a:prstGeom prst="rect">
             <a:avLst/>
@@ -10786,7 +11236,170 @@
           </a:bodyPr>
           <a:lstStyle/>
           <a:p>
-            <a:pPr algn="r">
+            <a:pPr algn="l">
+              <a:lnSpc>
+                <a:spcPct val="125000"/>
+              </a:lnSpc>
+              <a:spcBef>
+                <a:spcPts val="0"/>
+              </a:spcBef>
+              <a:spcAft>
+                <a:spcPts val="1400"/>
+              </a:spcAft>
+            </a:pPr>
+            <a:r>
+              <a:rPr sz="1600" b="1">
+                <a:solidFill>
+                  <a:srgbClr val="1F4E79"/>
+                </a:solidFill>
+                <a:latin typeface="微软雅黑"/>
+                <a:ea typeface="微软雅黑"/>
+                <a:cs typeface="微软雅黑"/>
+              </a:rPr>
+              <a:t>• 课程资料多源异构（PDF / Word / Markdown / TXT），目录式与关键词检索只能匹配字面表述，难以按语义定位知识点</a:t>
+            </a:r>
+          </a:p>
+          <a:p>
+            <a:pPr algn="l">
+              <a:lnSpc>
+                <a:spcPct val="125000"/>
+              </a:lnSpc>
+              <a:spcBef>
+                <a:spcPts val="0"/>
+              </a:spcBef>
+              <a:spcAft>
+                <a:spcPts val="1400"/>
+              </a:spcAft>
+            </a:pPr>
+            <a:r>
+              <a:rPr sz="1600" b="1">
+                <a:solidFill>
+                  <a:srgbClr val="1F4E79"/>
+                </a:solidFill>
+                <a:latin typeface="微软雅黑"/>
+                <a:ea typeface="微软雅黑"/>
+                <a:cs typeface="微软雅黑"/>
+              </a:rPr>
+              <a:t>• 通用大语言模型不了解私有课程资料，直接提问易产生“幻觉”，且回答无法给出出处、难以溯源</a:t>
+            </a:r>
+          </a:p>
+          <a:p>
+            <a:pPr algn="l">
+              <a:lnSpc>
+                <a:spcPct val="125000"/>
+              </a:lnSpc>
+              <a:spcBef>
+                <a:spcPts val="0"/>
+              </a:spcBef>
+              <a:spcAft>
+                <a:spcPts val="1400"/>
+              </a:spcAft>
+            </a:pPr>
+            <a:r>
+              <a:rPr sz="1600" b="1">
+                <a:solidFill>
+                  <a:srgbClr val="1F4E79"/>
+                </a:solidFill>
+                <a:latin typeface="微软雅黑"/>
+                <a:ea typeface="微软雅黑"/>
+                <a:cs typeface="微软雅黑"/>
+              </a:rPr>
+              <a:t>• 错题散落各处、无法自动沉淀，复习缺少计划性，容易陷入“学了就忘、错了再错”的低效循环</a:t>
+            </a:r>
+          </a:p>
+        </p:txBody>
+      </p:sp>
+      <p:sp>
+        <p:nvSpPr>
+          <p:cNvPr id="6" name="Rectangle 5"/>
+          <p:cNvSpPr/>
+          <p:nvPr/>
+        </p:nvSpPr>
+        <p:spPr>
+          <a:xfrm>
+            <a:off x="548640" y="4160520"/>
+            <a:ext cx="11091672" cy="45720"/>
+          </a:xfrm>
+          <a:prstGeom prst="rect">
+            <a:avLst/>
+          </a:prstGeom>
+          <a:solidFill>
+            <a:srgbClr val="2E75B6"/>
+          </a:solidFill>
+          <a:ln>
+            <a:noFill/>
+          </a:ln>
+          <a:effectLst/>
+        </p:spPr>
+        <p:style>
+          <a:lnRef idx="1">
+            <a:schemeClr val="accent1"/>
+          </a:lnRef>
+          <a:fillRef idx="3">
+            <a:schemeClr val="accent1"/>
+          </a:fillRef>
+          <a:effectRef idx="2">
+            <a:schemeClr val="accent1"/>
+          </a:effectRef>
+          <a:fontRef idx="minor">
+            <a:schemeClr val="lt1"/>
+          </a:fontRef>
+        </p:style>
+        <p:txBody>
+          <a:bodyPr rtlCol="0" anchor="ctr"/>
+          <a:lstStyle/>
+          <a:p>
+            <a:pPr algn="ctr"/>
+          </a:p>
+        </p:txBody>
+      </p:sp>
+      <p:sp>
+        <p:nvSpPr>
+          <p:cNvPr id="7" name="TextBox 6"/>
+          <p:cNvSpPr txBox="1"/>
+          <p:nvPr/>
+        </p:nvSpPr>
+        <p:spPr>
+          <a:xfrm>
+            <a:off x="548640" y="4343400"/>
+            <a:ext cx="11091672" cy="1463040"/>
+          </a:xfrm>
+          <a:prstGeom prst="rect">
+            <a:avLst/>
+          </a:prstGeom>
+          <a:noFill/>
+        </p:spPr>
+        <p:txBody>
+          <a:bodyPr wrap="square" anchor="t" lIns="0" rIns="0" tIns="0" bIns="0">
+            <a:spAutoFit/>
+          </a:bodyPr>
+          <a:lstStyle/>
+          <a:p>
+            <a:pPr algn="l">
+              <a:lnSpc>
+                <a:spcPct val="125000"/>
+              </a:lnSpc>
+              <a:spcBef>
+                <a:spcPts val="0"/>
+              </a:spcBef>
+              <a:spcAft>
+                <a:spcPts val="800"/>
+              </a:spcAft>
+            </a:pPr>
+            <a:r>
+              <a:rPr sz="1800" b="1">
+                <a:solidFill>
+                  <a:srgbClr val="2E75B6"/>
+                </a:solidFill>
+                <a:latin typeface="微软雅黑"/>
+                <a:ea typeface="微软雅黑"/>
+                <a:cs typeface="微软雅黑"/>
+              </a:rPr>
+              <a:t>本课题的解决思路</a:t>
+            </a:r>
+          </a:p>
+          <a:p>
+            <a:pPr algn="l">
               <a:lnSpc>
                 <a:spcPct val="125000"/>
               </a:lnSpc>
@@ -10798,262 +11411,15 @@
               </a:spcAft>
             </a:pPr>
             <a:r>
-              <a:rPr sz="1000">
+              <a:rPr sz="1500" b="0">
                 <a:solidFill>
-                  <a:srgbClr val="808080"/>
+                  <a:srgbClr val="222222"/>
                 </a:solidFill>
                 <a:latin typeface="微软雅黑"/>
                 <a:ea typeface="微软雅黑"/>
                 <a:cs typeface="微软雅黑"/>
               </a:rPr>
-              <a:t>2</a:t>
-            </a:r>
-          </a:p>
-        </p:txBody>
-      </p:sp>
-      <p:sp>
-        <p:nvSpPr>
-          <p:cNvPr id="6" name="TextBox 5"/>
-          <p:cNvSpPr txBox="1"/>
-          <p:nvPr/>
-        </p:nvSpPr>
-        <p:spPr>
-          <a:xfrm>
-            <a:off x="822960" y="1325880"/>
-            <a:ext cx="10515600" cy="4846320"/>
-          </a:xfrm>
-          <a:prstGeom prst="rect">
-            <a:avLst/>
-          </a:prstGeom>
-          <a:noFill/>
-        </p:spPr>
-        <p:txBody>
-          <a:bodyPr wrap="square" anchor="t" lIns="0" rIns="0" tIns="0" bIns="0">
-            <a:spAutoFit/>
-          </a:bodyPr>
-          <a:lstStyle/>
-          <a:p>
-            <a:pPr>
-              <a:lnSpc>
-                <a:spcPct val="115000"/>
-              </a:lnSpc>
-              <a:spcAft>
-                <a:spcPts val="1400"/>
-              </a:spcAft>
-            </a:pPr>
-            <a:r>
-              <a:rPr sz="1900" b="1">
-                <a:solidFill>
-                  <a:srgbClr val="1F4E79"/>
-                </a:solidFill>
-                <a:latin typeface="微软雅黑"/>
-                <a:ea typeface="微软雅黑"/>
-                <a:cs typeface="微软雅黑"/>
-              </a:rPr>
-              <a:t>1　选题背景与意义</a:t>
-            </a:r>
-            <a:r>
-              <a:rPr sz="1400" b="0">
-                <a:solidFill>
-                  <a:srgbClr val="808080"/>
-                </a:solidFill>
-                <a:latin typeface="微软雅黑"/>
-                <a:ea typeface="微软雅黑"/>
-                <a:cs typeface="微软雅黑"/>
-              </a:rPr>
-              <a:t>　——　项目来源、待解决的主要问题</a:t>
-            </a:r>
-          </a:p>
-          <a:p>
-            <a:pPr>
-              <a:lnSpc>
-                <a:spcPct val="115000"/>
-              </a:lnSpc>
-              <a:spcAft>
-                <a:spcPts val="1400"/>
-              </a:spcAft>
-            </a:pPr>
-            <a:r>
-              <a:rPr sz="1900" b="1">
-                <a:solidFill>
-                  <a:srgbClr val="1F4E79"/>
-                </a:solidFill>
-                <a:latin typeface="微软雅黑"/>
-                <a:ea typeface="微软雅黑"/>
-                <a:cs typeface="微软雅黑"/>
-              </a:rPr>
-              <a:t>2　系统总体架构与技术选型</a:t>
-            </a:r>
-            <a:r>
-              <a:rPr sz="1400" b="0">
-                <a:solidFill>
-                  <a:srgbClr val="808080"/>
-                </a:solidFill>
-                <a:latin typeface="微软雅黑"/>
-                <a:ea typeface="微软雅黑"/>
-                <a:cs typeface="微软雅黑"/>
-              </a:rPr>
-              <a:t>　——　B/S 三层架构、双库存储</a:t>
-            </a:r>
-          </a:p>
-          <a:p>
-            <a:pPr>
-              <a:lnSpc>
-                <a:spcPct val="115000"/>
-              </a:lnSpc>
-              <a:spcAft>
-                <a:spcPts val="1400"/>
-              </a:spcAft>
-            </a:pPr>
-            <a:r>
-              <a:rPr sz="1900" b="1">
-                <a:solidFill>
-                  <a:srgbClr val="1F4E79"/>
-                </a:solidFill>
-                <a:latin typeface="微软雅黑"/>
-                <a:ea typeface="微软雅黑"/>
-                <a:cs typeface="微软雅黑"/>
-              </a:rPr>
-              <a:t>3　核心原理：检索增强生成（RAG）</a:t>
-            </a:r>
-            <a:r>
-              <a:rPr sz="1400" b="0">
-                <a:solidFill>
-                  <a:srgbClr val="808080"/>
-                </a:solidFill>
-                <a:latin typeface="微软雅黑"/>
-                <a:ea typeface="微软雅黑"/>
-                <a:cs typeface="微软雅黑"/>
-              </a:rPr>
-              <a:t>　——　离线索引与在线问答两阶段</a:t>
-            </a:r>
-          </a:p>
-          <a:p>
-            <a:pPr>
-              <a:lnSpc>
-                <a:spcPct val="115000"/>
-              </a:lnSpc>
-              <a:spcAft>
-                <a:spcPts val="1400"/>
-              </a:spcAft>
-            </a:pPr>
-            <a:r>
-              <a:rPr sz="1900" b="1">
-                <a:solidFill>
-                  <a:srgbClr val="1F4E79"/>
-                </a:solidFill>
-                <a:latin typeface="微软雅黑"/>
-                <a:ea typeface="微软雅黑"/>
-                <a:cs typeface="微软雅黑"/>
-              </a:rPr>
-              <a:t>4　数据库设计</a:t>
-            </a:r>
-            <a:r>
-              <a:rPr sz="1400" b="0">
-                <a:solidFill>
-                  <a:srgbClr val="808080"/>
-                </a:solidFill>
-                <a:latin typeface="微软雅黑"/>
-                <a:ea typeface="微软雅黑"/>
-                <a:cs typeface="微软雅黑"/>
-              </a:rPr>
-              <a:t>　——　E-R 图、CDM 图、PDM 表结构</a:t>
-            </a:r>
-          </a:p>
-          <a:p>
-            <a:pPr>
-              <a:lnSpc>
-                <a:spcPct val="115000"/>
-              </a:lnSpc>
-              <a:spcAft>
-                <a:spcPts val="1400"/>
-              </a:spcAft>
-            </a:pPr>
-            <a:r>
-              <a:rPr sz="1900" b="1">
-                <a:solidFill>
-                  <a:srgbClr val="1F4E79"/>
-                </a:solidFill>
-                <a:latin typeface="微软雅黑"/>
-                <a:ea typeface="微软雅黑"/>
-                <a:cs typeface="微软雅黑"/>
-              </a:rPr>
-              <a:t>5　功能模块设计与实现</a:t>
-            </a:r>
-            <a:r>
-              <a:rPr sz="1400" b="0">
-                <a:solidFill>
-                  <a:srgbClr val="808080"/>
-                </a:solidFill>
-                <a:latin typeface="微软雅黑"/>
-                <a:ea typeface="微软雅黑"/>
-                <a:cs typeface="微软雅黑"/>
-              </a:rPr>
-              <a:t>　——　F1–F5 五大功能模块</a:t>
-            </a:r>
-          </a:p>
-          <a:p>
-            <a:pPr>
-              <a:lnSpc>
-                <a:spcPct val="115000"/>
-              </a:lnSpc>
-              <a:spcAft>
-                <a:spcPts val="1400"/>
-              </a:spcAft>
-            </a:pPr>
-            <a:r>
-              <a:rPr sz="1900">
-                <a:solidFill>
-                  <a:srgbClr val="1F4E79"/>
-                </a:solidFill>
-                <a:latin typeface="微软雅黑"/>
-                <a:ea typeface="微软雅黑"/>
-                <a:cs typeface="微软雅黑"/>
-              </a:rPr>
-              <a:t>6　系统测试与结果分析　——　</a:t>
-            </a:r>
-            <a:r>
-              <a:rPr sz="1400">
-                <a:solidFill>
-                  <a:srgbClr val="808080"/>
-                </a:solidFill>
-                <a:latin typeface="微软雅黑"/>
-                <a:ea typeface="微软雅黑"/>
-                <a:cs typeface="微软雅黑"/>
-              </a:rPr>
-              <a:t>测试用例、数据与分析结论</a:t>
-            </a:r>
-          </a:p>
-          <a:p>
-            <a:pPr>
-              <a:lnSpc>
-                <a:spcPct val="115000"/>
-              </a:lnSpc>
-              <a:spcAft>
-                <a:spcPts val="1400"/>
-              </a:spcAft>
-            </a:pPr>
-            <a:r>
-              <a:rPr sz="1900" b="1">
-                <a:solidFill>
-                  <a:srgbClr val="1F4E79"/>
-                </a:solidFill>
-                <a:latin typeface="微软雅黑"/>
-                <a:ea typeface="微软雅黑"/>
-                <a:cs typeface="微软雅黑"/>
-              </a:rPr>
-              <a:t>7　总结与展望</a:t>
-            </a:r>
-            <a:r>
-              <a:rPr sz="1400" b="0">
-                <a:solidFill>
-                  <a:srgbClr val="808080"/>
-                </a:solidFill>
-                <a:latin typeface="微软雅黑"/>
-                <a:ea typeface="微软雅黑"/>
-                <a:cs typeface="微软雅黑"/>
-              </a:rPr>
-              <a:t>　——　成果总结、后续改进方向</a:t>
+              <a:t>以检索增强生成（RAG）为主线技术，将课程资料向量化构建专属知识库，使回答与题目均“有据可依”；围绕“学、问、练、测、复”五个环节构建完整学习闭环，把资料检索、知识问答、自动出题、错题沉淀与复习规划串成连续链路。</a:t>
             </a:r>
           </a:p>
         </p:txBody>
@@ -11066,7 +11432,7 @@
 </p:sld>
 </file>
 
-<file path=ppt/slides/slide3.xml><?xml version="1.0" encoding="utf-8"?>
+<file path=ppt/slides/slide4.xml><?xml version="1.0" encoding="utf-8"?>
 <p:sld xmlns:a="http://schemas.openxmlformats.org/drawingml/2006/main" xmlns:p="http://schemas.openxmlformats.org/presentationml/2006/main" xmlns:r="http://schemas.openxmlformats.org/officeDocument/2006/relationships">
   <p:cSld>
     <p:spTree>
@@ -11162,7 +11528,7 @@
                 <a:ea typeface="微软雅黑"/>
                 <a:cs typeface="微软雅黑"/>
               </a:rPr>
-              <a:t>1　选题背景与意义</a:t>
+              <a:t>2　系统总体架构与技术选型</a:t>
             </a:r>
           </a:p>
         </p:txBody>
@@ -11209,372 +11575,6 @@
                 <a:ea typeface="微软雅黑"/>
                 <a:cs typeface="微软雅黑"/>
               </a:rPr>
-              <a:t>3</a:t>
-            </a:r>
-          </a:p>
-        </p:txBody>
-      </p:sp>
-      <p:sp>
-        <p:nvSpPr>
-          <p:cNvPr id="5" name="TextBox 4"/>
-          <p:cNvSpPr txBox="1"/>
-          <p:nvPr/>
-        </p:nvSpPr>
-        <p:spPr>
-          <a:xfrm>
-            <a:off x="548640" y="1280160"/>
-            <a:ext cx="11064240" cy="5120640"/>
-          </a:xfrm>
-          <a:prstGeom prst="rect">
-            <a:avLst/>
-          </a:prstGeom>
-          <a:noFill/>
-        </p:spPr>
-        <p:txBody>
-          <a:bodyPr wrap="square" anchor="t" lIns="0" rIns="0" tIns="0" bIns="0">
-            <a:spAutoFit/>
-          </a:bodyPr>
-          <a:lstStyle/>
-          <a:p>
-            <a:pPr algn="l">
-              <a:lnSpc>
-                <a:spcPct val="125000"/>
-              </a:lnSpc>
-              <a:spcBef>
-                <a:spcPts val="0"/>
-              </a:spcBef>
-              <a:spcAft>
-                <a:spcPts val="1400"/>
-              </a:spcAft>
-            </a:pPr>
-            <a:r>
-              <a:rPr sz="1600" b="1">
-                <a:solidFill>
-                  <a:srgbClr val="1F4E79"/>
-                </a:solidFill>
-                <a:latin typeface="微软雅黑"/>
-                <a:ea typeface="微软雅黑"/>
-                <a:cs typeface="微软雅黑"/>
-              </a:rPr>
-              <a:t>• 课程资料多源异构（PDF / Word / Markdown / TXT），目录式与关键词检索只能匹配字面表述，难以按语义定位知识点</a:t>
-            </a:r>
-          </a:p>
-          <a:p>
-            <a:pPr algn="l">
-              <a:lnSpc>
-                <a:spcPct val="125000"/>
-              </a:lnSpc>
-              <a:spcBef>
-                <a:spcPts val="0"/>
-              </a:spcBef>
-              <a:spcAft>
-                <a:spcPts val="1400"/>
-              </a:spcAft>
-            </a:pPr>
-            <a:r>
-              <a:rPr sz="1600" b="1">
-                <a:solidFill>
-                  <a:srgbClr val="1F4E79"/>
-                </a:solidFill>
-                <a:latin typeface="微软雅黑"/>
-                <a:ea typeface="微软雅黑"/>
-                <a:cs typeface="微软雅黑"/>
-              </a:rPr>
-              <a:t>• 通用大语言模型不了解私有课程资料，直接提问易产生“幻觉”，且回答无法给出出处、难以溯源</a:t>
-            </a:r>
-          </a:p>
-          <a:p>
-            <a:pPr algn="l">
-              <a:lnSpc>
-                <a:spcPct val="125000"/>
-              </a:lnSpc>
-              <a:spcBef>
-                <a:spcPts val="0"/>
-              </a:spcBef>
-              <a:spcAft>
-                <a:spcPts val="1400"/>
-              </a:spcAft>
-            </a:pPr>
-            <a:r>
-              <a:rPr sz="1600" b="1">
-                <a:solidFill>
-                  <a:srgbClr val="1F4E79"/>
-                </a:solidFill>
-                <a:latin typeface="微软雅黑"/>
-                <a:ea typeface="微软雅黑"/>
-                <a:cs typeface="微软雅黑"/>
-              </a:rPr>
-              <a:t>• 错题散落各处、无法自动沉淀，复习缺少计划性，容易陷入“学了就忘、错了再错”的低效循环</a:t>
-            </a:r>
-          </a:p>
-        </p:txBody>
-      </p:sp>
-      <p:sp>
-        <p:nvSpPr>
-          <p:cNvPr id="6" name="Rectangle 5"/>
-          <p:cNvSpPr/>
-          <p:nvPr/>
-        </p:nvSpPr>
-        <p:spPr>
-          <a:xfrm>
-            <a:off x="548640" y="4160520"/>
-            <a:ext cx="11091672" cy="45720"/>
-          </a:xfrm>
-          <a:prstGeom prst="rect">
-            <a:avLst/>
-          </a:prstGeom>
-          <a:solidFill>
-            <a:srgbClr val="2E75B6"/>
-          </a:solidFill>
-          <a:ln>
-            <a:noFill/>
-          </a:ln>
-          <a:effectLst/>
-        </p:spPr>
-        <p:style>
-          <a:lnRef idx="1">
-            <a:schemeClr val="accent1"/>
-          </a:lnRef>
-          <a:fillRef idx="3">
-            <a:schemeClr val="accent1"/>
-          </a:fillRef>
-          <a:effectRef idx="2">
-            <a:schemeClr val="accent1"/>
-          </a:effectRef>
-          <a:fontRef idx="minor">
-            <a:schemeClr val="lt1"/>
-          </a:fontRef>
-        </p:style>
-        <p:txBody>
-          <a:bodyPr rtlCol="0" anchor="ctr"/>
-          <a:lstStyle/>
-          <a:p>
-            <a:pPr algn="ctr"/>
-          </a:p>
-        </p:txBody>
-      </p:sp>
-      <p:sp>
-        <p:nvSpPr>
-          <p:cNvPr id="7" name="TextBox 6"/>
-          <p:cNvSpPr txBox="1"/>
-          <p:nvPr/>
-        </p:nvSpPr>
-        <p:spPr>
-          <a:xfrm>
-            <a:off x="548640" y="4343400"/>
-            <a:ext cx="11091672" cy="1463040"/>
-          </a:xfrm>
-          <a:prstGeom prst="rect">
-            <a:avLst/>
-          </a:prstGeom>
-          <a:noFill/>
-        </p:spPr>
-        <p:txBody>
-          <a:bodyPr wrap="square" anchor="t" lIns="0" rIns="0" tIns="0" bIns="0">
-            <a:spAutoFit/>
-          </a:bodyPr>
-          <a:lstStyle/>
-          <a:p>
-            <a:pPr algn="l">
-              <a:lnSpc>
-                <a:spcPct val="125000"/>
-              </a:lnSpc>
-              <a:spcBef>
-                <a:spcPts val="0"/>
-              </a:spcBef>
-              <a:spcAft>
-                <a:spcPts val="800"/>
-              </a:spcAft>
-            </a:pPr>
-            <a:r>
-              <a:rPr sz="1800" b="1">
-                <a:solidFill>
-                  <a:srgbClr val="2E75B6"/>
-                </a:solidFill>
-                <a:latin typeface="微软雅黑"/>
-                <a:ea typeface="微软雅黑"/>
-                <a:cs typeface="微软雅黑"/>
-              </a:rPr>
-              <a:t>本课题的解决思路</a:t>
-            </a:r>
-          </a:p>
-          <a:p>
-            <a:pPr algn="l">
-              <a:lnSpc>
-                <a:spcPct val="125000"/>
-              </a:lnSpc>
-              <a:spcBef>
-                <a:spcPts val="0"/>
-              </a:spcBef>
-              <a:spcAft>
-                <a:spcPts val="600"/>
-              </a:spcAft>
-            </a:pPr>
-            <a:r>
-              <a:rPr sz="1500" b="0">
-                <a:solidFill>
-                  <a:srgbClr val="222222"/>
-                </a:solidFill>
-                <a:latin typeface="微软雅黑"/>
-                <a:ea typeface="微软雅黑"/>
-                <a:cs typeface="微软雅黑"/>
-              </a:rPr>
-              <a:t>以检索增强生成（RAG）为主线技术，将课程资料向量化构建专属知识库，使回答与题目均“有据可依”；围绕“学、问、练、测、复”五个环节构建完整学习闭环，把资料检索、知识问答、自动出题、错题沉淀与复习规划串成连续链路。</a:t>
-            </a:r>
-          </a:p>
-        </p:txBody>
-      </p:sp>
-    </p:spTree>
-  </p:cSld>
-  <p:clrMapOvr>
-    <a:masterClrMapping/>
-  </p:clrMapOvr>
-</p:sld>
-</file>
-
-<file path=ppt/slides/slide4.xml><?xml version="1.0" encoding="utf-8"?>
-<p:sld xmlns:a="http://schemas.openxmlformats.org/drawingml/2006/main" xmlns:p="http://schemas.openxmlformats.org/presentationml/2006/main" xmlns:r="http://schemas.openxmlformats.org/officeDocument/2006/relationships">
-  <p:cSld>
-    <p:spTree>
-      <p:nvGrpSpPr>
-        <p:cNvPr id="1" name=""/>
-        <p:cNvGrpSpPr/>
-        <p:nvPr/>
-      </p:nvGrpSpPr>
-      <p:grpSpPr/>
-      <p:sp>
-        <p:nvSpPr>
-          <p:cNvPr id="2" name="Rectangle 1"/>
-          <p:cNvSpPr/>
-          <p:nvPr/>
-        </p:nvSpPr>
-        <p:spPr>
-          <a:xfrm>
-            <a:off x="0" y="0"/>
-            <a:ext cx="12191695" cy="960120"/>
-          </a:xfrm>
-          <a:prstGeom prst="rect">
-            <a:avLst/>
-          </a:prstGeom>
-          <a:solidFill>
-            <a:srgbClr val="1F4E79"/>
-          </a:solidFill>
-          <a:ln>
-            <a:noFill/>
-          </a:ln>
-          <a:effectLst/>
-        </p:spPr>
-        <p:style>
-          <a:lnRef idx="1">
-            <a:schemeClr val="accent1"/>
-          </a:lnRef>
-          <a:fillRef idx="3">
-            <a:schemeClr val="accent1"/>
-          </a:fillRef>
-          <a:effectRef idx="2">
-            <a:schemeClr val="accent1"/>
-          </a:effectRef>
-          <a:fontRef idx="minor">
-            <a:schemeClr val="lt1"/>
-          </a:fontRef>
-        </p:style>
-        <p:txBody>
-          <a:bodyPr rtlCol="0" anchor="ctr"/>
-          <a:lstStyle/>
-          <a:p>
-            <a:pPr algn="ctr"/>
-          </a:p>
-        </p:txBody>
-      </p:sp>
-      <p:sp>
-        <p:nvSpPr>
-          <p:cNvPr id="3" name="TextBox 2"/>
-          <p:cNvSpPr txBox="1"/>
-          <p:nvPr/>
-        </p:nvSpPr>
-        <p:spPr>
-          <a:xfrm>
-            <a:off x="502920" y="182880"/>
-            <a:ext cx="11185855" cy="621792"/>
-          </a:xfrm>
-          <a:prstGeom prst="rect">
-            <a:avLst/>
-          </a:prstGeom>
-          <a:noFill/>
-        </p:spPr>
-        <p:txBody>
-          <a:bodyPr wrap="square" anchor="ctr" lIns="0" rIns="0" tIns="0" bIns="0">
-            <a:spAutoFit/>
-          </a:bodyPr>
-          <a:lstStyle/>
-          <a:p>
-            <a:pPr algn="l">
-              <a:lnSpc>
-                <a:spcPct val="125000"/>
-              </a:lnSpc>
-              <a:spcBef>
-                <a:spcPts val="0"/>
-              </a:spcBef>
-              <a:spcAft>
-                <a:spcPts val="600"/>
-              </a:spcAft>
-            </a:pPr>
-            <a:r>
-              <a:rPr sz="2600" b="1">
-                <a:solidFill>
-                  <a:srgbClr val="FFFFFF"/>
-                </a:solidFill>
-                <a:latin typeface="微软雅黑"/>
-                <a:ea typeface="微软雅黑"/>
-                <a:cs typeface="微软雅黑"/>
-              </a:rPr>
-              <a:t>2　系统总体架构与技术选型</a:t>
-            </a:r>
-          </a:p>
-        </p:txBody>
-      </p:sp>
-      <p:sp>
-        <p:nvSpPr>
-          <p:cNvPr id="4" name="TextBox 3"/>
-          <p:cNvSpPr txBox="1"/>
-          <p:nvPr/>
-        </p:nvSpPr>
-        <p:spPr>
-          <a:xfrm>
-            <a:off x="11277295" y="6473952"/>
-            <a:ext cx="640080" cy="274320"/>
-          </a:xfrm>
-          <a:prstGeom prst="rect">
-            <a:avLst/>
-          </a:prstGeom>
-          <a:noFill/>
-        </p:spPr>
-        <p:txBody>
-          <a:bodyPr wrap="square" anchor="t" lIns="0" rIns="0" tIns="0" bIns="0">
-            <a:spAutoFit/>
-          </a:bodyPr>
-          <a:lstStyle/>
-          <a:p>
-            <a:pPr algn="r">
-              <a:lnSpc>
-                <a:spcPct val="125000"/>
-              </a:lnSpc>
-              <a:spcBef>
-                <a:spcPts val="0"/>
-              </a:spcBef>
-              <a:spcAft>
-                <a:spcPts val="600"/>
-              </a:spcAft>
-            </a:pPr>
-            <a:r>
-              <a:rPr sz="1000">
-                <a:solidFill>
-                  <a:srgbClr val="808080"/>
-                </a:solidFill>
-                <a:latin typeface="微软雅黑"/>
-                <a:ea typeface="微软雅黑"/>
-                <a:cs typeface="微软雅黑"/>
-              </a:rPr>
               <a:t>4</a:t>
             </a:r>
           </a:p>
@@ -11694,7 +11694,7 @@
                 <a:ea typeface="微软雅黑"/>
                 <a:cs typeface="微软雅黑"/>
               </a:rPr>
-              <a:t>• 模型服务：SiliconFlow（OpenAI 兼容接口），LLM 采用 Qwen 系列，Embedding 采用 BAAI/bge-m3</a:t>
+              <a:t>• 模型服务：SiliconFlow（OpenAI 兼容接口），LLM 采用 deepseek-ai/DeepSeek-V4-Flash，Embedding 采用 BAAI/bge-m3</a:t>
             </a:r>
           </a:p>
         </p:txBody>

</xml_diff>

<commit_message>
docs: fill member info and complete section 4 (result analysis)
- report: fill topic name, 5 members (name/ID), project division table

- report: complete section 4 with test statistics, quantitative analysis, issues and conclusion (table 14)

- ppt: fill defense members on cover, populate division table, assign slide owners, renumber page numbers
</commit_message>
<xml_diff>
--- a/defense/智学助手-课程设计答辩.pptx
+++ b/defense/智学助手-课程设计答辩.pptx
@@ -603,7 +603,7 @@
           <a:lstStyle/>
           <a:p>
             <a:r>
-              <a:t>【预留页 — 负责人补全后再讲】</a:t>
+              <a:t>【主讲：周承锦】</a:t>
             </a:r>
           </a:p>
           <a:p>
@@ -683,7 +683,7 @@
           <a:lstStyle/>
           <a:p>
             <a:r>
-              <a:t>【预留页 — 负责人补全后再讲】</a:t>
+              <a:t>【主讲：霍飞腾】</a:t>
             </a:r>
           </a:p>
           <a:p>
@@ -768,7 +768,7 @@
           <a:lstStyle/>
           <a:p>
             <a:r>
-              <a:t>【预留页 — 负责人补全后再讲】</a:t>
+              <a:t>【主讲：陈果】</a:t>
             </a:r>
           </a:p>
           <a:p>
@@ -1018,7 +1018,7 @@
           <a:lstStyle/>
           <a:p>
             <a:r>
-              <a:t>【★ 你要熟悉 — 分工页】</a:t>
+              <a:t>【主讲：霍飞腾 — 分工页】</a:t>
             </a:r>
           </a:p>
           <a:p>
@@ -1188,7 +1188,7 @@
           <a:lstStyle/>
           <a:p>
             <a:r>
-              <a:t>【预留页 — 负责人补全截图】</a:t>
+              <a:t>【主讲：陈果】</a:t>
             </a:r>
           </a:p>
           <a:p>
@@ -5194,15 +5194,15 @@
               </a:spcAft>
             </a:pPr>
             <a:r>
-              <a:rPr sz="1500" b="0">
+              <a:rPr sz="1500">
                 <a:solidFill>
-                  <a:srgbClr val="D6E4F0"/>
+                  <a:srgbClr val="FFE699"/>
                 </a:solidFill>
                 <a:latin typeface="微软雅黑"/>
                 <a:ea typeface="微软雅黑"/>
                 <a:cs typeface="微软雅黑"/>
               </a:rPr>
-              <a:t>课程名称：工程实践4（计算机应用系统综合实践）</a:t>
+              <a:t>答辩成员：袁钟其（组长）　周承锦　霍飞腾　陈果　刘纲正</a:t>
             </a:r>
           </a:p>
           <a:p>
@@ -5218,15 +5218,15 @@
               </a:spcAft>
             </a:pPr>
             <a:r>
-              <a:rPr sz="1500" b="0">
+              <a:rPr sz="1500">
                 <a:solidFill>
-                  <a:srgbClr val="D6E4F0"/>
+                  <a:srgbClr val="FFE699"/>
                 </a:solidFill>
                 <a:latin typeface="微软雅黑"/>
                 <a:ea typeface="微软雅黑"/>
                 <a:cs typeface="微软雅黑"/>
               </a:rPr>
-              <a:t>院（系）：计算机工程学院　　专　　业：计算机科学与技术</a:t>
+              <a:t>答辩成员：袁钟其（组长）　周承锦　霍飞腾　陈果　刘纲正</a:t>
             </a:r>
           </a:p>
           <a:p>
@@ -5242,15 +5242,15 @@
               </a:spcAft>
             </a:pPr>
             <a:r>
-              <a:rPr sz="1500" b="0">
+              <a:rPr sz="1500">
                 <a:solidFill>
-                  <a:srgbClr val="D6E4F0"/>
+                  <a:srgbClr val="FFE699"/>
                 </a:solidFill>
                 <a:latin typeface="微软雅黑"/>
                 <a:ea typeface="微软雅黑"/>
                 <a:cs typeface="微软雅黑"/>
               </a:rPr>
-              <a:t>组　　别：第 1 组　　　　　班　　级：23级计算机科学与技术1班</a:t>
+              <a:t>答辩成员：袁钟其（组长）　周承锦　霍飞腾　陈果　刘纲正</a:t>
             </a:r>
           </a:p>
           <a:p>
@@ -5266,15 +5266,15 @@
               </a:spcAft>
             </a:pPr>
             <a:r>
-              <a:rPr sz="1500" b="0">
+              <a:rPr sz="1500">
                 <a:solidFill>
-                  <a:srgbClr val="D6E4F0"/>
+                  <a:srgbClr val="FFE699"/>
                 </a:solidFill>
                 <a:latin typeface="微软雅黑"/>
                 <a:ea typeface="微软雅黑"/>
                 <a:cs typeface="微软雅黑"/>
               </a:rPr>
-              <a:t>指导教师：刘泓志　　　　　起止日期：2026.9.7 至 2026.9.30</a:t>
+              <a:t>答辩成员：袁钟其（组长）　周承锦　霍飞腾　陈果　刘纲正</a:t>
             </a:r>
           </a:p>
           <a:p>
@@ -5290,7 +5290,7 @@
               </a:spcAft>
             </a:pPr>
             <a:r>
-              <a:rPr sz="1500" b="0">
+              <a:rPr sz="1500">
                 <a:solidFill>
                   <a:srgbClr val="FFE699"/>
                 </a:solidFill>
@@ -5298,7 +5298,7 @@
                 <a:ea typeface="微软雅黑"/>
                 <a:cs typeface="微软雅黑"/>
               </a:rPr>
-              <a:t>答辩成员：【姓名1】【姓名2】张三【姓名4】【姓名5】</a:t>
+              <a:t>答辩成员：袁钟其（组长）　周承锦　霍飞腾　陈果　刘纲正</a:t>
             </a:r>
           </a:p>
         </p:txBody>
@@ -5454,7 +5454,7 @@
                 <a:ea typeface="微软雅黑"/>
                 <a:cs typeface="微软雅黑"/>
               </a:rPr>
-              <a:t>负责人：【姓名3】</a:t>
+              <a:t>负责人：周承锦</a:t>
             </a:r>
           </a:p>
         </p:txBody>
@@ -5498,8 +5498,6 @@
                   <a:srgbClr val="808080"/>
                 </a:solidFill>
                 <a:latin typeface="微软雅黑"/>
-                <a:ea typeface="微软雅黑"/>
-                <a:cs typeface="微软雅黑"/>
               </a:rPr>
               <a:t>10</a:t>
             </a:r>
@@ -6165,7 +6163,7 @@
                 <a:ea typeface="微软雅黑"/>
                 <a:cs typeface="微软雅黑"/>
               </a:rPr>
-              <a:t>负责人：【姓名4】</a:t>
+              <a:t>负责人：霍飞腾</a:t>
             </a:r>
           </a:p>
         </p:txBody>
@@ -6209,8 +6207,6 @@
                   <a:srgbClr val="808080"/>
                 </a:solidFill>
                 <a:latin typeface="微软雅黑"/>
-                <a:ea typeface="微软雅黑"/>
-                <a:cs typeface="微软雅黑"/>
               </a:rPr>
               <a:t>11</a:t>
             </a:r>
@@ -6876,7 +6872,7 @@
                 <a:ea typeface="微软雅黑"/>
                 <a:cs typeface="微软雅黑"/>
               </a:rPr>
-              <a:t>负责人：【姓名5】</a:t>
+              <a:t>负责人：陈果</a:t>
             </a:r>
           </a:p>
         </p:txBody>
@@ -6920,8 +6916,6 @@
                   <a:srgbClr val="808080"/>
                 </a:solidFill>
                 <a:latin typeface="微软雅黑"/>
-                <a:ea typeface="微软雅黑"/>
-                <a:cs typeface="微软雅黑"/>
               </a:rPr>
               <a:t>12</a:t>
             </a:r>
@@ -7975,7 +7969,7 @@
                 <a:ea typeface="微软雅黑"/>
                 <a:cs typeface="微软雅黑"/>
               </a:rPr>
-              <a:t>负责人：【姓名5】</a:t>
+              <a:t>负责人：陈果</a:t>
             </a:r>
           </a:p>
         </p:txBody>
@@ -8629,8 +8623,6 @@
                   <a:srgbClr val="808080"/>
                 </a:solidFill>
                 <a:latin typeface="微软雅黑"/>
-                <a:ea typeface="微软雅黑"/>
-                <a:cs typeface="微软雅黑"/>
               </a:rPr>
               <a:t>13</a:t>
             </a:r>
@@ -8788,7 +8780,7 @@
                 <a:ea typeface="微软雅黑"/>
                 <a:cs typeface="微软雅黑"/>
               </a:rPr>
-              <a:t>负责人：【姓名1】</a:t>
+              <a:t>负责人：袁钟其</a:t>
             </a:r>
           </a:p>
         </p:txBody>
@@ -8832,8 +8824,6 @@
                   <a:srgbClr val="808080"/>
                 </a:solidFill>
                 <a:latin typeface="微软雅黑"/>
-                <a:ea typeface="微软雅黑"/>
-                <a:cs typeface="微软雅黑"/>
               </a:rPr>
               <a:t>14</a:t>
             </a:r>
@@ -9246,8 +9236,6 @@
                   <a:srgbClr val="808080"/>
                 </a:solidFill>
                 <a:latin typeface="微软雅黑"/>
-                <a:ea typeface="微软雅黑"/>
-                <a:cs typeface="微软雅黑"/>
               </a:rPr>
               <a:t>15</a:t>
             </a:r>
@@ -9686,8 +9674,6 @@
                   <a:srgbClr val="808080"/>
                 </a:solidFill>
                 <a:latin typeface="微软雅黑"/>
-                <a:ea typeface="微软雅黑"/>
-                <a:cs typeface="微软雅黑"/>
               </a:rPr>
               <a:t>16</a:t>
             </a:r>
@@ -9828,7 +9814,7 @@
                     <a:p>
                       <a:pPr algn="ctr"/>
                       <a:r>
-                        <a:rPr sz="1200" b="0">
+                        <a:rPr sz="1100">
                           <a:solidFill>
                             <a:srgbClr val="222222"/>
                           </a:solidFill>
@@ -9853,7 +9839,7 @@
                     <a:p>
                       <a:pPr algn="ctr"/>
                       <a:r>
-                        <a:rPr sz="1200" b="0">
+                        <a:rPr sz="1100">
                           <a:solidFill>
                             <a:srgbClr val="222222"/>
                           </a:solidFill>
@@ -9861,7 +9847,7 @@
                           <a:ea typeface="微软雅黑"/>
                           <a:cs typeface="微软雅黑"/>
                         </a:rPr>
-                        <a:t>【姓名1】</a:t>
+                        <a:t>袁钟其</a:t>
                       </a:r>
                     </a:p>
                   </a:txBody>
@@ -9878,7 +9864,7 @@
                     <a:p>
                       <a:pPr algn="ctr"/>
                       <a:r>
-                        <a:rPr sz="1200" b="0">
+                        <a:rPr sz="1100">
                           <a:solidFill>
                             <a:srgbClr val="222222"/>
                           </a:solidFill>
@@ -9886,7 +9872,7 @@
                           <a:ea typeface="微软雅黑"/>
                           <a:cs typeface="微软雅黑"/>
                         </a:rPr>
-                        <a:t>【学号1】</a:t>
+                        <a:t>2306007106</a:t>
                       </a:r>
                     </a:p>
                   </a:txBody>
@@ -9903,7 +9889,7 @@
                     <a:p>
                       <a:pPr algn="l"/>
                       <a:r>
-                        <a:rPr sz="1200" b="0">
+                        <a:rPr sz="1100">
                           <a:solidFill>
                             <a:srgbClr val="222222"/>
                           </a:solidFill>
@@ -9930,7 +9916,7 @@
                     <a:p>
                       <a:pPr algn="ctr"/>
                       <a:r>
-                        <a:rPr sz="1200" b="0">
+                        <a:rPr sz="1100">
                           <a:solidFill>
                             <a:srgbClr val="222222"/>
                           </a:solidFill>
@@ -9955,7 +9941,7 @@
                     <a:p>
                       <a:pPr algn="ctr"/>
                       <a:r>
-                        <a:rPr sz="1200" b="0">
+                        <a:rPr sz="1100">
                           <a:solidFill>
                             <a:srgbClr val="222222"/>
                           </a:solidFill>
@@ -9963,7 +9949,7 @@
                           <a:ea typeface="微软雅黑"/>
                           <a:cs typeface="微软雅黑"/>
                         </a:rPr>
-                        <a:t>张三</a:t>
+                        <a:t>周承锦</a:t>
                       </a:r>
                     </a:p>
                   </a:txBody>
@@ -9980,7 +9966,7 @@
                     <a:p>
                       <a:pPr algn="ctr"/>
                       <a:r>
-                        <a:rPr sz="1200" b="0">
+                        <a:rPr sz="1100">
                           <a:solidFill>
                             <a:srgbClr val="222222"/>
                           </a:solidFill>
@@ -9988,7 +9974,7 @@
                           <a:ea typeface="微软雅黑"/>
                           <a:cs typeface="微软雅黑"/>
                         </a:rPr>
-                        <a:t>【学号】</a:t>
+                        <a:t>2306007108</a:t>
                       </a:r>
                     </a:p>
                   </a:txBody>
@@ -10005,7 +9991,7 @@
                     <a:p>
                       <a:pPr algn="l"/>
                       <a:r>
-                        <a:rPr sz="1200" b="0">
+                        <a:rPr sz="1100">
                           <a:solidFill>
                             <a:srgbClr val="222222"/>
                           </a:solidFill>
@@ -10013,7 +9999,7 @@
                           <a:ea typeface="微软雅黑"/>
                           <a:cs typeface="微软雅黑"/>
                         </a:rPr>
-                        <a:t>数据库设计（E-R / CDM / PDM）、课程设计报告撰写与统稿</a:t>
+                        <a:t>F3 自动出题与判题：出题提示词与 JSON 解析重试、客观题与简答题判分、文件大小校验</a:t>
                       </a:r>
                     </a:p>
                   </a:txBody>
@@ -10032,7 +10018,7 @@
                     <a:p>
                       <a:pPr algn="ctr"/>
                       <a:r>
-                        <a:rPr sz="1200" b="0">
+                        <a:rPr sz="1100">
                           <a:solidFill>
                             <a:srgbClr val="222222"/>
                           </a:solidFill>
@@ -10057,7 +10043,7 @@
                     <a:p>
                       <a:pPr algn="ctr"/>
                       <a:r>
-                        <a:rPr sz="1200" b="0">
+                        <a:rPr sz="1100">
                           <a:solidFill>
                             <a:srgbClr val="222222"/>
                           </a:solidFill>
@@ -10065,7 +10051,7 @@
                           <a:ea typeface="微软雅黑"/>
                           <a:cs typeface="微软雅黑"/>
                         </a:rPr>
-                        <a:t>【姓名3】</a:t>
+                        <a:t>霍飞腾</a:t>
                       </a:r>
                     </a:p>
                   </a:txBody>
@@ -10082,7 +10068,7 @@
                     <a:p>
                       <a:pPr algn="ctr"/>
                       <a:r>
-                        <a:rPr sz="1200" b="0">
+                        <a:rPr sz="1100">
                           <a:solidFill>
                             <a:srgbClr val="222222"/>
                           </a:solidFill>
@@ -10090,7 +10076,7 @@
                           <a:ea typeface="微软雅黑"/>
                           <a:cs typeface="微软雅黑"/>
                         </a:rPr>
-                        <a:t>【学号3】</a:t>
+                        <a:t>2306007127</a:t>
                       </a:r>
                     </a:p>
                   </a:txBody>
@@ -10107,7 +10093,7 @@
                     <a:p>
                       <a:pPr algn="l"/>
                       <a:r>
-                        <a:rPr sz="1200" b="0">
+                        <a:rPr sz="1100">
                           <a:solidFill>
                             <a:srgbClr val="222222"/>
                           </a:solidFill>
@@ -10115,7 +10101,7 @@
                           <a:ea typeface="微软雅黑"/>
                           <a:cs typeface="微软雅黑"/>
                         </a:rPr>
-                        <a:t>F3 自动出题与判题：quiz_service、quiz 路由、出题 Prompt、文件大小校验</a:t>
+                        <a:t>F4 错题本与 F5 复习计划：错题沉淀与掌握管理、七天复习计划生成与日期计算；报告统稿</a:t>
                       </a:r>
                     </a:p>
                   </a:txBody>
@@ -10134,7 +10120,7 @@
                     <a:p>
                       <a:pPr algn="ctr"/>
                       <a:r>
-                        <a:rPr sz="1200" b="0">
+                        <a:rPr sz="1100">
                           <a:solidFill>
                             <a:srgbClr val="222222"/>
                           </a:solidFill>
@@ -10159,7 +10145,7 @@
                     <a:p>
                       <a:pPr algn="ctr"/>
                       <a:r>
-                        <a:rPr sz="1200" b="0">
+                        <a:rPr sz="1100">
                           <a:solidFill>
                             <a:srgbClr val="222222"/>
                           </a:solidFill>
@@ -10167,7 +10153,7 @@
                           <a:ea typeface="微软雅黑"/>
                           <a:cs typeface="微软雅黑"/>
                         </a:rPr>
-                        <a:t>【姓名4】</a:t>
+                        <a:t>陈果</a:t>
                       </a:r>
                     </a:p>
                   </a:txBody>
@@ -10184,7 +10170,7 @@
                     <a:p>
                       <a:pPr algn="ctr"/>
                       <a:r>
-                        <a:rPr sz="1200" b="0">
+                        <a:rPr sz="1100">
                           <a:solidFill>
                             <a:srgbClr val="222222"/>
                           </a:solidFill>
@@ -10192,7 +10178,7 @@
                           <a:ea typeface="微软雅黑"/>
                           <a:cs typeface="微软雅黑"/>
                         </a:rPr>
-                        <a:t>【学号4】</a:t>
+                        <a:t>2306007120</a:t>
                       </a:r>
                     </a:p>
                   </a:txBody>
@@ -10209,7 +10195,7 @@
                     <a:p>
                       <a:pPr algn="l"/>
                       <a:r>
-                        <a:rPr sz="1200" b="0">
+                        <a:rPr sz="1100">
                           <a:solidFill>
                             <a:srgbClr val="222222"/>
                           </a:solidFill>
@@ -10217,7 +10203,7 @@
                           <a:ea typeface="微软雅黑"/>
                           <a:cs typeface="微软雅黑"/>
                         </a:rPr>
-                        <a:t>F4 错题本与 F5 复习计划：mistake_service、review_service 及对应路由与 Prompt</a:t>
+                        <a:t>前端页面与系统测试：五个功能标签页交互实现；功能测试与结构测试用例设计与执行</a:t>
                       </a:r>
                     </a:p>
                   </a:txBody>
@@ -10236,7 +10222,7 @@
                     <a:p>
                       <a:pPr algn="ctr"/>
                       <a:r>
-                        <a:rPr sz="1200" b="0">
+                        <a:rPr sz="1100">
                           <a:solidFill>
                             <a:srgbClr val="222222"/>
                           </a:solidFill>
@@ -10261,7 +10247,7 @@
                     <a:p>
                       <a:pPr algn="ctr"/>
                       <a:r>
-                        <a:rPr sz="1200" b="0">
+                        <a:rPr sz="1100">
                           <a:solidFill>
                             <a:srgbClr val="222222"/>
                           </a:solidFill>
@@ -10269,7 +10255,7 @@
                           <a:ea typeface="微软雅黑"/>
                           <a:cs typeface="微软雅黑"/>
                         </a:rPr>
-                        <a:t>【姓名5】</a:t>
+                        <a:t>刘纲正</a:t>
                       </a:r>
                     </a:p>
                   </a:txBody>
@@ -10286,7 +10272,7 @@
                     <a:p>
                       <a:pPr algn="ctr"/>
                       <a:r>
-                        <a:rPr sz="1200" b="0">
+                        <a:rPr sz="1100">
                           <a:solidFill>
                             <a:srgbClr val="222222"/>
                           </a:solidFill>
@@ -10294,7 +10280,7 @@
                           <a:ea typeface="微软雅黑"/>
                           <a:cs typeface="微软雅黑"/>
                         </a:rPr>
-                        <a:t>【学号5】</a:t>
+                        <a:t>2306007103</a:t>
                       </a:r>
                     </a:p>
                   </a:txBody>
@@ -10311,7 +10297,7 @@
                     <a:p>
                       <a:pPr algn="l"/>
                       <a:r>
-                        <a:rPr sz="1200" b="0">
+                        <a:rPr sz="1100">
                           <a:solidFill>
                             <a:srgbClr val="222222"/>
                           </a:solidFill>
@@ -10319,7 +10305,7 @@
                           <a:ea typeface="微软雅黑"/>
                           <a:cs typeface="微软雅黑"/>
                         </a:rPr>
-                        <a:t>前端页面（出题/错题本/复习计划标签页）与系统测试、结果分析</a:t>
+                        <a:t>数据库设计与数据契约：七张表三层建模（E-R/CDM/PDM）、完整性与级联删除、ORM 与 Schema</a:t>
                       </a:r>
                     </a:p>
                   </a:txBody>
@@ -10438,8 +10424,6 @@
                   <a:srgbClr val="808080"/>
                 </a:solidFill>
                 <a:latin typeface="微软雅黑"/>
-                <a:ea typeface="微软雅黑"/>
-                <a:cs typeface="微软雅黑"/>
               </a:rPr>
               <a:t>17</a:t>
             </a:r>
@@ -10803,8 +10787,6 @@
                   <a:srgbClr val="808080"/>
                 </a:solidFill>
                 <a:latin typeface="微软雅黑"/>
-                <a:ea typeface="微软雅黑"/>
-                <a:cs typeface="微软雅黑"/>
               </a:rPr>
               <a:t>2</a:t>
             </a:r>
@@ -11206,8 +11188,6 @@
                   <a:srgbClr val="808080"/>
                 </a:solidFill>
                 <a:latin typeface="微软雅黑"/>
-                <a:ea typeface="微软雅黑"/>
-                <a:cs typeface="微软雅黑"/>
               </a:rPr>
               <a:t>3</a:t>
             </a:r>
@@ -11572,8 +11552,6 @@
                   <a:srgbClr val="808080"/>
                 </a:solidFill>
                 <a:latin typeface="微软雅黑"/>
-                <a:ea typeface="微软雅黑"/>
-                <a:cs typeface="微软雅黑"/>
               </a:rPr>
               <a:t>4</a:t>
             </a:r>
@@ -12476,8 +12454,6 @@
                   <a:srgbClr val="808080"/>
                 </a:solidFill>
                 <a:latin typeface="微软雅黑"/>
-                <a:ea typeface="微软雅黑"/>
-                <a:cs typeface="微软雅黑"/>
               </a:rPr>
               <a:t>5</a:t>
             </a:r>
@@ -12750,8 +12726,6 @@
                   <a:srgbClr val="808080"/>
                 </a:solidFill>
                 <a:latin typeface="微软雅黑"/>
-                <a:ea typeface="微软雅黑"/>
-                <a:cs typeface="微软雅黑"/>
               </a:rPr>
               <a:t>6</a:t>
             </a:r>
@@ -12977,8 +12951,6 @@
                   <a:srgbClr val="808080"/>
                 </a:solidFill>
                 <a:latin typeface="微软雅黑"/>
-                <a:ea typeface="微软雅黑"/>
-                <a:cs typeface="微软雅黑"/>
               </a:rPr>
               <a:t>7</a:t>
             </a:r>
@@ -13204,8 +13176,6 @@
                   <a:srgbClr val="808080"/>
                 </a:solidFill>
                 <a:latin typeface="微软雅黑"/>
-                <a:ea typeface="微软雅黑"/>
-                <a:cs typeface="微软雅黑"/>
               </a:rPr>
               <a:t>8</a:t>
             </a:r>
@@ -14275,8 +14245,6 @@
                   <a:srgbClr val="808080"/>
                 </a:solidFill>
                 <a:latin typeface="微软雅黑"/>
-                <a:ea typeface="微软雅黑"/>
-                <a:cs typeface="微软雅黑"/>
               </a:rPr>
               <a:t>9</a:t>
             </a:r>

</xml_diff>

<commit_message>
docs: correct project division to reflect actual contributions
- Zhou Chengjin implemented all functional code (architecture, RAG, quiz, mistake, review, frontend)

- Liu Gangzheng responsible for report writing and database modeling

- assign test/data, UI/docs tasks to remaining 3 members

- ppt: update division table, per-slide owners and speaker notes
</commit_message>
<xml_diff>
--- a/defense/智学助手-课程设计答辩.pptx
+++ b/defense/智学助手-课程设计答辩.pptx
@@ -683,7 +683,7 @@
           <a:lstStyle/>
           <a:p>
             <a:r>
-              <a:t>【主讲：霍飞腾】</a:t>
+              <a:t>【主讲：周承锦】</a:t>
             </a:r>
           </a:p>
           <a:p>
@@ -768,7 +768,7 @@
           <a:lstStyle/>
           <a:p>
             <a:r>
-              <a:t>【主讲：陈果】</a:t>
+              <a:t>【主讲：霍飞腾】</a:t>
             </a:r>
           </a:p>
           <a:p>
@@ -848,7 +848,7 @@
           <a:lstStyle/>
           <a:p>
             <a:r>
-              <a:t>【主讲：负责核心架构的同学】</a:t>
+              <a:t>【主讲：袁钟其】</a:t>
             </a:r>
           </a:p>
           <a:p>
@@ -933,6 +933,11 @@
           <a:lstStyle/>
           <a:p>
             <a:r>
+              <a:t>【主讲：袁钟其】</a:t>
+            </a:r>
+          </a:p>
+          <a:p>
+            <a:r>
               <a:t>【收尾】</a:t>
             </a:r>
           </a:p>
@@ -1018,7 +1023,7 @@
           <a:lstStyle/>
           <a:p>
             <a:r>
-              <a:t>【主讲：霍飞腾 — 分工页】</a:t>
+              <a:t>【主讲：袁钟其】</a:t>
             </a:r>
           </a:p>
           <a:p>
@@ -1373,7 +1378,7 @@
           <a:lstStyle/>
           <a:p>
             <a:r>
-              <a:t>【主讲：建议由组长或你来讲】</a:t>
+              <a:t>【主讲：袁钟其】</a:t>
             </a:r>
           </a:p>
           <a:p>
@@ -1473,7 +1478,7 @@
           <a:lstStyle/>
           <a:p>
             <a:r>
-              <a:t>【主讲：负责核心架构的同学】</a:t>
+              <a:t>【主讲：周承锦】</a:t>
             </a:r>
           </a:p>
           <a:p>
@@ -1558,7 +1563,7 @@
           <a:lstStyle/>
           <a:p>
             <a:r>
-              <a:t>【主讲：负责核心架构的同学】</a:t>
+              <a:t>【主讲：周承锦】</a:t>
             </a:r>
           </a:p>
           <a:p>
@@ -1643,6 +1648,11 @@
           <a:lstStyle/>
           <a:p>
             <a:r>
+              <a:t>【主讲：刘纲正】</a:t>
+            </a:r>
+          </a:p>
+          <a:p>
+            <a:r>
               <a:t>【★ 你主讲 — 数据库设计（一）】</a:t>
             </a:r>
           </a:p>
@@ -1743,6 +1753,11 @@
           <a:lstStyle/>
           <a:p>
             <a:r>
+              <a:t>【主讲：刘纲正】</a:t>
+            </a:r>
+          </a:p>
+          <a:p>
+            <a:r>
               <a:t>【★ 你主讲 — 数据库设计（二）】</a:t>
             </a:r>
           </a:p>
@@ -1833,6 +1848,11 @@
           <a:lstStyle/>
           <a:p>
             <a:r>
+              <a:t>【主讲：刘纲正】</a:t>
+            </a:r>
+          </a:p>
+          <a:p>
+            <a:r>
               <a:t>【★ 你主讲 — 数据库设计（三）】</a:t>
             </a:r>
           </a:p>
@@ -1936,6 +1956,11 @@
         <p:txBody>
           <a:bodyPr/>
           <a:lstStyle/>
+          <a:p>
+            <a:r>
+              <a:t>【主讲：周承锦】</a:t>
+            </a:r>
+          </a:p>
           <a:p>
             <a:r>
               <a:t>【过渡页】</a:t>
@@ -5446,13 +5471,11 @@
               </a:spcAft>
             </a:pPr>
             <a:r>
-              <a:rPr sz="1300" b="0">
+              <a:rPr sz="1300">
                 <a:solidFill>
                   <a:srgbClr val="BDD7EE"/>
                 </a:solidFill>
                 <a:latin typeface="微软雅黑"/>
-                <a:ea typeface="微软雅黑"/>
-                <a:cs typeface="微软雅黑"/>
               </a:rPr>
               <a:t>负责人：周承锦</a:t>
             </a:r>
@@ -6155,15 +6178,13 @@
               </a:spcAft>
             </a:pPr>
             <a:r>
-              <a:rPr sz="1300" b="0">
+              <a:rPr sz="1300">
                 <a:solidFill>
                   <a:srgbClr val="BDD7EE"/>
                 </a:solidFill>
                 <a:latin typeface="微软雅黑"/>
-                <a:ea typeface="微软雅黑"/>
-                <a:cs typeface="微软雅黑"/>
               </a:rPr>
-              <a:t>负责人：霍飞腾</a:t>
+              <a:t>负责人：周承锦</a:t>
             </a:r>
           </a:p>
         </p:txBody>
@@ -6864,15 +6885,13 @@
               </a:spcAft>
             </a:pPr>
             <a:r>
-              <a:rPr sz="1300" b="0">
+              <a:rPr sz="1300">
                 <a:solidFill>
                   <a:srgbClr val="BDD7EE"/>
                 </a:solidFill>
                 <a:latin typeface="微软雅黑"/>
-                <a:ea typeface="微软雅黑"/>
-                <a:cs typeface="微软雅黑"/>
               </a:rPr>
-              <a:t>负责人：陈果</a:t>
+              <a:t>负责人：霍飞腾</a:t>
             </a:r>
           </a:p>
         </p:txBody>
@@ -7966,8 +7985,6 @@
                   <a:srgbClr val="BDD7EE"/>
                 </a:solidFill>
                 <a:latin typeface="微软雅黑"/>
-                <a:ea typeface="微软雅黑"/>
-                <a:cs typeface="微软雅黑"/>
               </a:rPr>
               <a:t>负责人：陈果</a:t>
             </a:r>
@@ -8772,13 +8789,11 @@
               </a:spcAft>
             </a:pPr>
             <a:r>
-              <a:rPr sz="1300" b="0">
+              <a:rPr sz="1300">
                 <a:solidFill>
                   <a:srgbClr val="BDD7EE"/>
                 </a:solidFill>
                 <a:latin typeface="微软雅黑"/>
-                <a:ea typeface="微软雅黑"/>
-                <a:cs typeface="微软雅黑"/>
               </a:rPr>
               <a:t>负责人：袁钟其</a:t>
             </a:r>
@@ -9815,9 +9830,6 @@
                       <a:pPr algn="ctr"/>
                       <a:r>
                         <a:rPr sz="1100">
-                          <a:solidFill>
-                            <a:srgbClr val="222222"/>
-                          </a:solidFill>
                           <a:latin typeface="微软雅黑"/>
                           <a:ea typeface="微软雅黑"/>
                           <a:cs typeface="微软雅黑"/>
@@ -9840,9 +9852,6 @@
                       <a:pPr algn="ctr"/>
                       <a:r>
                         <a:rPr sz="1100">
-                          <a:solidFill>
-                            <a:srgbClr val="222222"/>
-                          </a:solidFill>
                           <a:latin typeface="微软雅黑"/>
                           <a:ea typeface="微软雅黑"/>
                           <a:cs typeface="微软雅黑"/>
@@ -9865,9 +9874,6 @@
                       <a:pPr algn="ctr"/>
                       <a:r>
                         <a:rPr sz="1100">
-                          <a:solidFill>
-                            <a:srgbClr val="222222"/>
-                          </a:solidFill>
                           <a:latin typeface="微软雅黑"/>
                           <a:ea typeface="微软雅黑"/>
                           <a:cs typeface="微软雅黑"/>
@@ -9890,14 +9896,11 @@
                       <a:pPr algn="l"/>
                       <a:r>
                         <a:rPr sz="1100">
-                          <a:solidFill>
-                            <a:srgbClr val="222222"/>
-                          </a:solidFill>
                           <a:latin typeface="微软雅黑"/>
                           <a:ea typeface="微软雅黑"/>
                           <a:cs typeface="微软雅黑"/>
                         </a:rPr>
-                        <a:t>系统架构与 RAG 核心链路：FastAPI 分层、MySQL/Chroma 双库、文档入库、RAG 问答；部署</a:t>
+                        <a:t>项目管理与协调：方案设计、任务分解与进度把控；环境搭建与部署验证；答辩组织</a:t>
                       </a:r>
                     </a:p>
                   </a:txBody>
@@ -9917,9 +9920,6 @@
                       <a:pPr algn="ctr"/>
                       <a:r>
                         <a:rPr sz="1100">
-                          <a:solidFill>
-                            <a:srgbClr val="222222"/>
-                          </a:solidFill>
                           <a:latin typeface="微软雅黑"/>
                           <a:ea typeface="微软雅黑"/>
                           <a:cs typeface="微软雅黑"/>
@@ -9942,9 +9942,6 @@
                       <a:pPr algn="ctr"/>
                       <a:r>
                         <a:rPr sz="1100">
-                          <a:solidFill>
-                            <a:srgbClr val="222222"/>
-                          </a:solidFill>
                           <a:latin typeface="微软雅黑"/>
                           <a:ea typeface="微软雅黑"/>
                           <a:cs typeface="微软雅黑"/>
@@ -9967,9 +9964,6 @@
                       <a:pPr algn="ctr"/>
                       <a:r>
                         <a:rPr sz="1100">
-                          <a:solidFill>
-                            <a:srgbClr val="222222"/>
-                          </a:solidFill>
                           <a:latin typeface="微软雅黑"/>
                           <a:ea typeface="微软雅黑"/>
                           <a:cs typeface="微软雅黑"/>
@@ -9992,14 +9986,11 @@
                       <a:pPr algn="l"/>
                       <a:r>
                         <a:rPr sz="1100">
-                          <a:solidFill>
-                            <a:srgbClr val="222222"/>
-                          </a:solidFill>
                           <a:latin typeface="微软雅黑"/>
                           <a:ea typeface="微软雅黑"/>
                           <a:cs typeface="微软雅黑"/>
                         </a:rPr>
-                        <a:t>F3 自动出题与判题：出题提示词与 JSON 解析重试、客观题与简答题判分、文件大小校验</a:t>
+                        <a:t>系统全部功能代码实现：分层架构、双库接入、文档入库、RAG 问答、出题判题、错题本、复习计划、前端</a:t>
                       </a:r>
                     </a:p>
                   </a:txBody>
@@ -10019,9 +10010,6 @@
                       <a:pPr algn="ctr"/>
                       <a:r>
                         <a:rPr sz="1100">
-                          <a:solidFill>
-                            <a:srgbClr val="222222"/>
-                          </a:solidFill>
                           <a:latin typeface="微软雅黑"/>
                           <a:ea typeface="微软雅黑"/>
                           <a:cs typeface="微软雅黑"/>
@@ -10044,9 +10032,6 @@
                       <a:pPr algn="ctr"/>
                       <a:r>
                         <a:rPr sz="1100">
-                          <a:solidFill>
-                            <a:srgbClr val="222222"/>
-                          </a:solidFill>
                           <a:latin typeface="微软雅黑"/>
                           <a:ea typeface="微软雅黑"/>
                           <a:cs typeface="微软雅黑"/>
@@ -10069,9 +10054,6 @@
                       <a:pPr algn="ctr"/>
                       <a:r>
                         <a:rPr sz="1100">
-                          <a:solidFill>
-                            <a:srgbClr val="222222"/>
-                          </a:solidFill>
                           <a:latin typeface="微软雅黑"/>
                           <a:ea typeface="微软雅黑"/>
                           <a:cs typeface="微软雅黑"/>
@@ -10094,14 +10076,11 @@
                       <a:pPr algn="l"/>
                       <a:r>
                         <a:rPr sz="1100">
-                          <a:solidFill>
-                            <a:srgbClr val="222222"/>
-                          </a:solidFill>
                           <a:latin typeface="微软雅黑"/>
                           <a:ea typeface="微软雅黑"/>
                           <a:cs typeface="微软雅黑"/>
                         </a:rPr>
-                        <a:t>F4 错题本与 F5 复习计划：错题沉淀与掌握管理、七天复习计划生成与日期计算；报告统稿</a:t>
+                        <a:t>系统测试与数据整理：测试用例设计与执行、记录结果数据、整理结果分析指标</a:t>
                       </a:r>
                     </a:p>
                   </a:txBody>
@@ -10121,9 +10100,6 @@
                       <a:pPr algn="ctr"/>
                       <a:r>
                         <a:rPr sz="1100">
-                          <a:solidFill>
-                            <a:srgbClr val="222222"/>
-                          </a:solidFill>
                           <a:latin typeface="微软雅黑"/>
                           <a:ea typeface="微软雅黑"/>
                           <a:cs typeface="微软雅黑"/>
@@ -10146,9 +10122,6 @@
                       <a:pPr algn="ctr"/>
                       <a:r>
                         <a:rPr sz="1100">
-                          <a:solidFill>
-                            <a:srgbClr val="222222"/>
-                          </a:solidFill>
                           <a:latin typeface="微软雅黑"/>
                           <a:ea typeface="微软雅黑"/>
                           <a:cs typeface="微软雅黑"/>
@@ -10171,9 +10144,6 @@
                       <a:pPr algn="ctr"/>
                       <a:r>
                         <a:rPr sz="1100">
-                          <a:solidFill>
-                            <a:srgbClr val="222222"/>
-                          </a:solidFill>
                           <a:latin typeface="微软雅黑"/>
                           <a:ea typeface="微软雅黑"/>
                           <a:cs typeface="微软雅黑"/>
@@ -10196,14 +10166,11 @@
                       <a:pPr algn="l"/>
                       <a:r>
                         <a:rPr sz="1100">
-                          <a:solidFill>
-                            <a:srgbClr val="222222"/>
-                          </a:solidFill>
                           <a:latin typeface="微软雅黑"/>
                           <a:ea typeface="微软雅黑"/>
                           <a:cs typeface="微软雅黑"/>
                         </a:rPr>
-                        <a:t>前端页面与系统测试：五个功能标签页交互实现；功能测试与结构测试用例设计与执行</a:t>
+                        <a:t>界面验证与使用文档：五页面操作验证、界面截图采集、使用说明与部署手册</a:t>
                       </a:r>
                     </a:p>
                   </a:txBody>
@@ -10223,9 +10190,6 @@
                       <a:pPr algn="ctr"/>
                       <a:r>
                         <a:rPr sz="1100">
-                          <a:solidFill>
-                            <a:srgbClr val="222222"/>
-                          </a:solidFill>
                           <a:latin typeface="微软雅黑"/>
                           <a:ea typeface="微软雅黑"/>
                           <a:cs typeface="微软雅黑"/>
@@ -10248,9 +10212,6 @@
                       <a:pPr algn="ctr"/>
                       <a:r>
                         <a:rPr sz="1100">
-                          <a:solidFill>
-                            <a:srgbClr val="222222"/>
-                          </a:solidFill>
                           <a:latin typeface="微软雅黑"/>
                           <a:ea typeface="微软雅黑"/>
                           <a:cs typeface="微软雅黑"/>
@@ -10273,9 +10234,6 @@
                       <a:pPr algn="ctr"/>
                       <a:r>
                         <a:rPr sz="1100">
-                          <a:solidFill>
-                            <a:srgbClr val="222222"/>
-                          </a:solidFill>
                           <a:latin typeface="微软雅黑"/>
                           <a:ea typeface="微软雅黑"/>
                           <a:cs typeface="微软雅黑"/>
@@ -10298,14 +10256,11 @@
                       <a:pPr algn="l"/>
                       <a:r>
                         <a:rPr sz="1100">
-                          <a:solidFill>
-                            <a:srgbClr val="222222"/>
-                          </a:solidFill>
                           <a:latin typeface="微软雅黑"/>
                           <a:ea typeface="微软雅黑"/>
                           <a:cs typeface="微软雅黑"/>
                         </a:rPr>
-                        <a:t>数据库设计与数据契约：七张表三层建模（E-R/CDM/PDM）、完整性与级联删除、ORM 与 Schema</a:t>
+                        <a:t>报告撰写与统稿：数据库三层建模设计、过程论述与结果分析撰写、全文统稿</a:t>
                       </a:r>
                     </a:p>
                   </a:txBody>
@@ -11400,6 +11355,43 @@
                 <a:cs typeface="微软雅黑"/>
               </a:rPr>
               <a:t>以检索增强生成（RAG）为主线技术，将课程资料向量化构建专属知识库，使回答与题目均“有据可依”；围绕“学、问、练、测、复”五个环节构建完整学习闭环，把资料检索、知识问答、自动出题、错题沉淀与复习规划串成连续链路。</a:t>
+            </a:r>
+          </a:p>
+        </p:txBody>
+      </p:sp>
+      <p:sp>
+        <p:nvSpPr>
+          <p:cNvPr id="8" name="TextBox 7"/>
+          <p:cNvSpPr txBox="1"/>
+          <p:nvPr/>
+        </p:nvSpPr>
+        <p:spPr>
+          <a:xfrm>
+            <a:off x="8321040" y="274320"/>
+            <a:ext cx="3383280" cy="457200"/>
+          </a:xfrm>
+          <a:prstGeom prst="rect">
+            <a:avLst/>
+          </a:prstGeom>
+          <a:noFill/>
+        </p:spPr>
+        <p:txBody>
+          <a:bodyPr wrap="square">
+            <a:spAutoFit/>
+          </a:bodyPr>
+          <a:lstStyle/>
+          <a:p>
+            <a:pPr algn="r"/>
+            <a:r>
+              <a:rPr sz="1300">
+                <a:solidFill>
+                  <a:srgbClr val="BDD7EE"/>
+                </a:solidFill>
+                <a:latin typeface="微软雅黑"/>
+                <a:ea typeface="微软雅黑"/>
+                <a:cs typeface="微软雅黑"/>
+              </a:rPr>
+              <a:t>负责人：袁钟其</a:t>
             </a:r>
           </a:p>
         </p:txBody>
@@ -12306,6 +12298,43 @@
           </a:graphicData>
         </a:graphic>
       </p:graphicFrame>
+      <p:sp>
+        <p:nvSpPr>
+          <p:cNvPr id="9" name="TextBox 8"/>
+          <p:cNvSpPr txBox="1"/>
+          <p:nvPr/>
+        </p:nvSpPr>
+        <p:spPr>
+          <a:xfrm>
+            <a:off x="8321040" y="274320"/>
+            <a:ext cx="3383280" cy="457200"/>
+          </a:xfrm>
+          <a:prstGeom prst="rect">
+            <a:avLst/>
+          </a:prstGeom>
+          <a:noFill/>
+        </p:spPr>
+        <p:txBody>
+          <a:bodyPr wrap="square">
+            <a:spAutoFit/>
+          </a:bodyPr>
+          <a:lstStyle/>
+          <a:p>
+            <a:pPr algn="r"/>
+            <a:r>
+              <a:rPr sz="1300">
+                <a:solidFill>
+                  <a:srgbClr val="BDD7EE"/>
+                </a:solidFill>
+                <a:latin typeface="微软雅黑"/>
+                <a:ea typeface="微软雅黑"/>
+                <a:cs typeface="微软雅黑"/>
+              </a:rPr>
+              <a:t>负责人：周承锦</a:t>
+            </a:r>
+          </a:p>
+        </p:txBody>
+      </p:sp>
     </p:spTree>
   </p:cSld>
   <p:clrMapOvr>
@@ -12578,6 +12607,43 @@
           </a:p>
         </p:txBody>
       </p:sp>
+      <p:sp>
+        <p:nvSpPr>
+          <p:cNvPr id="8" name="TextBox 7"/>
+          <p:cNvSpPr txBox="1"/>
+          <p:nvPr/>
+        </p:nvSpPr>
+        <p:spPr>
+          <a:xfrm>
+            <a:off x="8321040" y="274320"/>
+            <a:ext cx="3383280" cy="457200"/>
+          </a:xfrm>
+          <a:prstGeom prst="rect">
+            <a:avLst/>
+          </a:prstGeom>
+          <a:noFill/>
+        </p:spPr>
+        <p:txBody>
+          <a:bodyPr wrap="square">
+            <a:spAutoFit/>
+          </a:bodyPr>
+          <a:lstStyle/>
+          <a:p>
+            <a:pPr algn="r"/>
+            <a:r>
+              <a:rPr sz="1300">
+                <a:solidFill>
+                  <a:srgbClr val="BDD7EE"/>
+                </a:solidFill>
+                <a:latin typeface="微软雅黑"/>
+                <a:ea typeface="微软雅黑"/>
+                <a:cs typeface="微软雅黑"/>
+              </a:rPr>
+              <a:t>负责人：周承锦</a:t>
+            </a:r>
+          </a:p>
+        </p:txBody>
+      </p:sp>
     </p:spTree>
   </p:cSld>
   <p:clrMapOvr>
@@ -12803,6 +12869,43 @@
           </a:p>
         </p:txBody>
       </p:sp>
+      <p:sp>
+        <p:nvSpPr>
+          <p:cNvPr id="7" name="TextBox 6"/>
+          <p:cNvSpPr txBox="1"/>
+          <p:nvPr/>
+        </p:nvSpPr>
+        <p:spPr>
+          <a:xfrm>
+            <a:off x="8321040" y="274320"/>
+            <a:ext cx="3383280" cy="457200"/>
+          </a:xfrm>
+          <a:prstGeom prst="rect">
+            <a:avLst/>
+          </a:prstGeom>
+          <a:noFill/>
+        </p:spPr>
+        <p:txBody>
+          <a:bodyPr wrap="square">
+            <a:spAutoFit/>
+          </a:bodyPr>
+          <a:lstStyle/>
+          <a:p>
+            <a:pPr algn="r"/>
+            <a:r>
+              <a:rPr sz="1300">
+                <a:solidFill>
+                  <a:srgbClr val="BDD7EE"/>
+                </a:solidFill>
+                <a:latin typeface="微软雅黑"/>
+                <a:ea typeface="微软雅黑"/>
+                <a:cs typeface="微软雅黑"/>
+              </a:rPr>
+              <a:t>负责人：刘纲正</a:t>
+            </a:r>
+          </a:p>
+        </p:txBody>
+      </p:sp>
     </p:spTree>
   </p:cSld>
   <p:clrMapOvr>
@@ -13024,6 +13127,43 @@
                 <a:cs typeface="微软雅黑"/>
               </a:rPr>
               <a:t>图 3　智学助手系统概念数据模型（CDM）图</a:t>
+            </a:r>
+          </a:p>
+        </p:txBody>
+      </p:sp>
+      <p:sp>
+        <p:nvSpPr>
+          <p:cNvPr id="7" name="TextBox 6"/>
+          <p:cNvSpPr txBox="1"/>
+          <p:nvPr/>
+        </p:nvSpPr>
+        <p:spPr>
+          <a:xfrm>
+            <a:off x="8321040" y="274320"/>
+            <a:ext cx="3383280" cy="457200"/>
+          </a:xfrm>
+          <a:prstGeom prst="rect">
+            <a:avLst/>
+          </a:prstGeom>
+          <a:noFill/>
+        </p:spPr>
+        <p:txBody>
+          <a:bodyPr wrap="square">
+            <a:spAutoFit/>
+          </a:bodyPr>
+          <a:lstStyle/>
+          <a:p>
+            <a:pPr algn="r"/>
+            <a:r>
+              <a:rPr sz="1300">
+                <a:solidFill>
+                  <a:srgbClr val="BDD7EE"/>
+                </a:solidFill>
+                <a:latin typeface="微软雅黑"/>
+                <a:ea typeface="微软雅黑"/>
+                <a:cs typeface="微软雅黑"/>
+              </a:rPr>
+              <a:t>负责人：刘纲正</a:t>
             </a:r>
           </a:p>
         </p:txBody>
@@ -14097,6 +14237,43 @@
           </a:p>
         </p:txBody>
       </p:sp>
+      <p:sp>
+        <p:nvSpPr>
+          <p:cNvPr id="7" name="TextBox 6"/>
+          <p:cNvSpPr txBox="1"/>
+          <p:nvPr/>
+        </p:nvSpPr>
+        <p:spPr>
+          <a:xfrm>
+            <a:off x="8321040" y="274320"/>
+            <a:ext cx="3383280" cy="457200"/>
+          </a:xfrm>
+          <a:prstGeom prst="rect">
+            <a:avLst/>
+          </a:prstGeom>
+          <a:noFill/>
+        </p:spPr>
+        <p:txBody>
+          <a:bodyPr wrap="square">
+            <a:spAutoFit/>
+          </a:bodyPr>
+          <a:lstStyle/>
+          <a:p>
+            <a:pPr algn="r"/>
+            <a:r>
+              <a:rPr sz="1300">
+                <a:solidFill>
+                  <a:srgbClr val="BDD7EE"/>
+                </a:solidFill>
+                <a:latin typeface="微软雅黑"/>
+                <a:ea typeface="微软雅黑"/>
+                <a:cs typeface="微软雅黑"/>
+              </a:rPr>
+              <a:t>负责人：刘纲正</a:t>
+            </a:r>
+          </a:p>
+        </p:txBody>
+      </p:sp>
     </p:spTree>
   </p:cSld>
   <p:clrMapOvr>
@@ -15051,6 +15228,43 @@
           </a:p>
         </p:txBody>
       </p:sp>
+      <p:sp>
+        <p:nvSpPr>
+          <p:cNvPr id="7" name="TextBox 6"/>
+          <p:cNvSpPr txBox="1"/>
+          <p:nvPr/>
+        </p:nvSpPr>
+        <p:spPr>
+          <a:xfrm>
+            <a:off x="8321040" y="274320"/>
+            <a:ext cx="3383280" cy="457200"/>
+          </a:xfrm>
+          <a:prstGeom prst="rect">
+            <a:avLst/>
+          </a:prstGeom>
+          <a:noFill/>
+        </p:spPr>
+        <p:txBody>
+          <a:bodyPr wrap="square">
+            <a:spAutoFit/>
+          </a:bodyPr>
+          <a:lstStyle/>
+          <a:p>
+            <a:pPr algn="r"/>
+            <a:r>
+              <a:rPr sz="1300">
+                <a:solidFill>
+                  <a:srgbClr val="BDD7EE"/>
+                </a:solidFill>
+                <a:latin typeface="微软雅黑"/>
+                <a:ea typeface="微软雅黑"/>
+                <a:cs typeface="微软雅黑"/>
+              </a:rPr>
+              <a:t>负责人：周承锦</a:t>
+            </a:r>
+          </a:p>
+        </p:txBody>
+      </p:sp>
     </p:spTree>
   </p:cSld>
   <p:clrMapOvr>

</xml_diff>

<commit_message>
docs: user-refined defense PPT
finalize defense PPT with functional demo pages
</commit_message>
<xml_diff>
--- a/defense/智学助手-课程设计答辩.pptx
+++ b/defense/智学助手-课程设计答辩.pptx
@@ -17,14 +17,16 @@
     <p:sldId id="262" r:id="rId10"/>
     <p:sldId id="263" r:id="rId11"/>
     <p:sldId id="264" r:id="rId12"/>
-    <p:sldId id="265" r:id="rId13"/>
-    <p:sldId id="266" r:id="rId14"/>
-    <p:sldId id="267" r:id="rId15"/>
-    <p:sldId id="272" r:id="rId16"/>
-    <p:sldId id="268" r:id="rId17"/>
-    <p:sldId id="269" r:id="rId18"/>
-    <p:sldId id="270" r:id="rId19"/>
-    <p:sldId id="271" r:id="rId20"/>
+    <p:sldId id="273" r:id="rId13"/>
+    <p:sldId id="274" r:id="rId14"/>
+    <p:sldId id="265" r:id="rId15"/>
+    <p:sldId id="266" r:id="rId16"/>
+    <p:sldId id="267" r:id="rId17"/>
+    <p:sldId id="275" r:id="rId18"/>
+    <p:sldId id="268" r:id="rId19"/>
+    <p:sldId id="269" r:id="rId20"/>
+    <p:sldId id="270" r:id="rId21"/>
+    <p:sldId id="271" r:id="rId22"/>
   </p:sldIdLst>
   <p:sldSz cx="12191365" cy="6858000" type="screen4x3"/>
   <p:notesSz cx="6858000" cy="9144000"/>
@@ -864,42 +866,22 @@
           <a:lstStyle/>
           <a:p>
             <a:r>
-              <a:t>【主讲：陈果】</a:t>
-            </a:r>
-          </a:p>
-          <a:p>
-            <a:r>
-              <a:t>本页需补充五张界面截图，截图要求与报告第三节“11．实现的界面”一致：</a:t>
-            </a:r>
-          </a:p>
-          <a:p>
-            <a:r>
-              <a:t>1. 文档管理页（已选课程 + 文档列表，能看到切分块数）</a:t>
-            </a:r>
-          </a:p>
-          <a:p>
-            <a:r>
-              <a:t>2. 智能问答页（提问与回答，下方显示引用来源卡片）</a:t>
-            </a:r>
-          </a:p>
-          <a:p>
-            <a:r>
-              <a:t>3. 自动出题页（参数表单 + 题目卡片，含判分结果）</a:t>
-            </a:r>
-          </a:p>
-          <a:p>
-            <a:r>
-              <a:t>4. 错题本页（错题卡片，用户答案与正确答案对比）</a:t>
-            </a:r>
-          </a:p>
-          <a:p>
-            <a:r>
-              <a:t>5. 复习计划页（按日期分组的条目，含完成勾选）</a:t>
-            </a:r>
-          </a:p>
-          <a:p>
-            <a:r>
-              <a:t>讲的时候按“选课程 → 传文档 → 提问 → 出题 → 判错 → 排复习”的顺序讲，完整演示一遍学习闭环。</a:t>
+              <a:t>【主讲：袁钟其】</a:t>
+            </a:r>
+          </a:p>
+          <a:p>
+            <a:r>
+              <a:t>四点：MySQL 走 Docker Compose（端口 3307）、后端 Uvicorn 启动、Chroma 进程内本地持久化、敏感信息走 .env。</a:t>
+            </a:r>
+          </a:p>
+          <a:p>
+            <a:r>
+              <a:t>⚠ 注意：后端不在 Docker 里跑，别口误说成“Docker 一键启动整个系统”。</a:t>
+            </a:r>
+          </a:p>
+          <a:p>
+            <a:r>
+              <a:t>末尾的“运行截图”位置需补全。</a:t>
             </a:r>
           </a:p>
         </p:txBody>
@@ -974,17 +956,22 @@
           </a:p>
           <a:p>
             <a:r>
-              <a:t>四点：MySQL 走 Docker Compose（端口 3307）、后端 Uvicorn 启动、Chroma 进程内本地持久化、敏感信息走 .env。</a:t>
-            </a:r>
-          </a:p>
-          <a:p>
-            <a:r>
-              <a:t>⚠ 注意：后端不在 Docker 里跑，别口误说成“Docker 一键启动整个系统”。</a:t>
-            </a:r>
-          </a:p>
-          <a:p>
-            <a:r>
-              <a:t>末尾的“运行截图”位置需补全。</a:t>
+              <a:t>【收尾】</a:t>
+            </a:r>
+          </a:p>
+          <a:p>
+            <a:r>
+              <a:t>成果三条、展望三条。</a:t>
+            </a:r>
+          </a:p>
+          <a:p>
+            <a:r>
+              <a:t>展望部分可以提：多用户隔离、学习统计可视化、混合检索（向量+关键词）、Chroma 迁移 Milvus（requirements.txt 里已预留依赖）。</a:t>
+            </a:r>
+          </a:p>
+          <a:p>
+            <a:r>
+              <a:t>提到“已预留 Milvus 依赖”会显得有前瞻性。</a:t>
             </a:r>
           </a:p>
         </p:txBody>
@@ -1059,22 +1046,22 @@
           </a:p>
           <a:p>
             <a:r>
-              <a:t>【收尾】</a:t>
-            </a:r>
-          </a:p>
-          <a:p>
-            <a:r>
-              <a:t>成果三条、展望三条。</a:t>
-            </a:r>
-          </a:p>
-          <a:p>
-            <a:r>
-              <a:t>展望部分可以提：多用户隔离、学习统计可视化、混合检索（向量+关键词）、Chroma 迁移 Milvus（requirements.txt 里已预留依赖）。</a:t>
-            </a:r>
-          </a:p>
-          <a:p>
-            <a:r>
-              <a:t>提到“已预留 Milvus 依赖”会显得有前瞻性。</a:t>
+              <a:t>你负责：数据库设计（E-R / CDM / PDM）、课程设计报告撰写与统稿。</a:t>
+            </a:r>
+          </a:p>
+          <a:p>
+            <a:r>
+              <a:t>⚠ 答辩前务必把姓名、学号补全。</a:t>
+            </a:r>
+          </a:p>
+          <a:p>
+            <a:r>
+              <a:t>预计提问：你设计的表和别人的模块怎么对接？——答：我先把 ORM 模型和 Pydantic Schema 定好，其他同学服务层直接引用这些模型读写，保证字段统一。</a:t>
+            </a:r>
+          </a:p>
+          <a:p>
+            <a:r>
+              <a:t>预计提问：你这部分工作量体现在哪？——答：7 张表三层建模、完整性设计、级联删除顺序设计，以及报告全文统稿。</a:t>
             </a:r>
           </a:p>
         </p:txBody>
@@ -1100,96 +1087,6 @@
 </file>
 
 <file path=ppt/notesSlides/notesSlide16.xml><?xml version="1.0" encoding="utf-8"?>
-<p:notes xmlns:a="http://schemas.openxmlformats.org/drawingml/2006/main" xmlns:r="http://schemas.openxmlformats.org/officeDocument/2006/relationships" xmlns:p="http://schemas.openxmlformats.org/presentationml/2006/main">
-  <p:cSld>
-    <p:spTree>
-      <p:nvGrpSpPr>
-        <p:cNvPr id="1" name=""/>
-        <p:cNvGrpSpPr/>
-        <p:nvPr/>
-      </p:nvGrpSpPr>
-      <p:grpSpPr>
-        <a:xfrm>
-          <a:off x="0" y="0"/>
-          <a:ext cx="0" cy="0"/>
-          <a:chOff x="0" y="0"/>
-          <a:chExt cx="0" cy="0"/>
-        </a:xfrm>
-      </p:grpSpPr>
-      <p:sp>
-        <p:nvSpPr>
-          <p:cNvPr id="2" name="Slide Image Placeholder 1"/>
-          <p:cNvSpPr>
-            <a:spLocks noGrp="1"/>
-          </p:cNvSpPr>
-          <p:nvPr>
-            <p:ph type="sldImg" idx="2"/>
-          </p:nvPr>
-        </p:nvSpPr>
-        <p:spPr/>
-      </p:sp>
-      <p:sp>
-        <p:nvSpPr>
-          <p:cNvPr id="3" name="Notes Placeholder 2"/>
-          <p:cNvSpPr>
-            <a:spLocks noGrp="1"/>
-          </p:cNvSpPr>
-          <p:nvPr>
-            <p:ph type="body" sz="quarter" idx="3"/>
-          </p:nvPr>
-        </p:nvSpPr>
-        <p:spPr/>
-        <p:txBody>
-          <a:bodyPr/>
-          <a:lstStyle/>
-          <a:p>
-            <a:r>
-              <a:t>【主讲：袁钟其】</a:t>
-            </a:r>
-          </a:p>
-          <a:p>
-            <a:r>
-              <a:t>你负责：数据库设计（E-R / CDM / PDM）、课程设计报告撰写与统稿。</a:t>
-            </a:r>
-          </a:p>
-          <a:p>
-            <a:r>
-              <a:t>⚠ 答辩前务必把姓名、学号补全。</a:t>
-            </a:r>
-          </a:p>
-          <a:p>
-            <a:r>
-              <a:t>预计提问：你设计的表和别人的模块怎么对接？——答：我先把 ORM 模型和 Pydantic Schema 定好，其他同学服务层直接引用这些模型读写，保证字段统一。</a:t>
-            </a:r>
-          </a:p>
-          <a:p>
-            <a:r>
-              <a:t>预计提问：你这部分工作量体现在哪？——答：7 张表三层建模、完整性设计、级联删除顺序设计，以及报告全文统稿。</a:t>
-            </a:r>
-          </a:p>
-        </p:txBody>
-      </p:sp>
-      <p:sp>
-        <p:nvSpPr>
-          <p:cNvPr id="4" name="Slide Number Placeholder 3"/>
-          <p:cNvSpPr>
-            <a:spLocks noGrp="1"/>
-          </p:cNvSpPr>
-          <p:nvPr>
-            <p:ph type="sldNum" sz="quarter" idx="5"/>
-          </p:nvPr>
-        </p:nvSpPr>
-        <p:spPr/>
-      </p:sp>
-    </p:spTree>
-  </p:cSld>
-  <p:clrMapOvr>
-    <a:masterClrMapping/>
-  </p:clrMapOvr>
-</p:notes>
-</file>
-
-<file path=ppt/notesSlides/notesSlide17.xml><?xml version="1.0" encoding="utf-8"?>
 <p:notes xmlns:a="http://schemas.openxmlformats.org/drawingml/2006/main" xmlns:r="http://schemas.openxmlformats.org/officeDocument/2006/relationships" xmlns:p="http://schemas.openxmlformats.org/presentationml/2006/main">
   <p:cSld>
     <p:spTree>
@@ -5190,7 +5087,7 @@
         </p:nvSpPr>
         <p:spPr>
           <a:xfrm>
-            <a:off x="822960" y="4526280"/>
+            <a:off x="838200" y="4526280"/>
             <a:ext cx="10515600" cy="628015"/>
           </a:xfrm>
           <a:prstGeom prst="rect">
@@ -5343,6 +5240,1946 @@
           <a:lstStyle/>
           <a:p>
             <a:pPr algn="l">
+              <a:spcAft>
+                <a:spcPts val="600"/>
+              </a:spcAft>
+            </a:pPr>
+            <a:r>
+              <a:rPr sz="2600">
+                <a:solidFill>
+                  <a:srgbClr val="FFFFFF"/>
+                </a:solidFill>
+                <a:latin typeface="微软雅黑" panose="020B0503020204020204" charset="-122"/>
+                <a:ea typeface="微软雅黑" panose="020B0503020204020204" charset="-122"/>
+                <a:cs typeface="微软雅黑" panose="020B0503020204020204" charset="-122"/>
+              </a:rPr>
+              <a:t>5.1　功能演示（一）：文档入库</a:t>
+            </a:r>
+            <a:endParaRPr sz="2600">
+              <a:solidFill>
+                <a:srgbClr val="FFFFFF"/>
+              </a:solidFill>
+              <a:latin typeface="微软雅黑" panose="020B0503020204020204" charset="-122"/>
+              <a:ea typeface="微软雅黑" panose="020B0503020204020204" charset="-122"/>
+              <a:cs typeface="微软雅黑" panose="020B0503020204020204" charset="-122"/>
+            </a:endParaRPr>
+          </a:p>
+        </p:txBody>
+      </p:sp>
+      <p:sp>
+        <p:nvSpPr>
+          <p:cNvPr id="4" name="TextBox 3"/>
+          <p:cNvSpPr txBox="1"/>
+          <p:nvPr/>
+        </p:nvSpPr>
+        <p:spPr>
+          <a:xfrm>
+            <a:off x="8321040" y="274320"/>
+            <a:ext cx="3383280" cy="457200"/>
+          </a:xfrm>
+          <a:prstGeom prst="rect">
+            <a:avLst/>
+          </a:prstGeom>
+          <a:noFill/>
+        </p:spPr>
+        <p:txBody>
+          <a:bodyPr wrap="square" lIns="0" tIns="0" rIns="0" bIns="0" anchor="ctr">
+            <a:spAutoFit/>
+          </a:bodyPr>
+          <a:lstStyle/>
+          <a:p>
+            <a:pPr algn="r">
+              <a:spcAft>
+                <a:spcPts val="600"/>
+              </a:spcAft>
+            </a:pPr>
+            <a:r>
+              <a:rPr sz="1300">
+                <a:solidFill>
+                  <a:srgbClr val="BDD7EE"/>
+                </a:solidFill>
+                <a:latin typeface="微软雅黑" panose="020B0503020204020204" charset="-122"/>
+                <a:ea typeface="微软雅黑" panose="020B0503020204020204" charset="-122"/>
+                <a:cs typeface="微软雅黑" panose="020B0503020204020204" charset="-122"/>
+              </a:rPr>
+              <a:t>负责人：周承锦</a:t>
+            </a:r>
+            <a:endParaRPr sz="1300">
+              <a:solidFill>
+                <a:srgbClr val="BDD7EE"/>
+              </a:solidFill>
+              <a:latin typeface="微软雅黑" panose="020B0503020204020204" charset="-122"/>
+              <a:ea typeface="微软雅黑" panose="020B0503020204020204" charset="-122"/>
+              <a:cs typeface="微软雅黑" panose="020B0503020204020204" charset="-122"/>
+            </a:endParaRPr>
+          </a:p>
+        </p:txBody>
+      </p:sp>
+      <p:sp>
+        <p:nvSpPr>
+          <p:cNvPr id="5" name="TextBox 4"/>
+          <p:cNvSpPr txBox="1"/>
+          <p:nvPr/>
+        </p:nvSpPr>
+        <p:spPr>
+          <a:xfrm>
+            <a:off x="502920" y="1115568"/>
+            <a:ext cx="5120640" cy="365760"/>
+          </a:xfrm>
+          <a:prstGeom prst="rect">
+            <a:avLst/>
+          </a:prstGeom>
+          <a:noFill/>
+        </p:spPr>
+        <p:txBody>
+          <a:bodyPr wrap="square" lIns="0" tIns="0" rIns="0" bIns="0" anchor="t">
+            <a:spAutoFit/>
+          </a:bodyPr>
+          <a:lstStyle/>
+          <a:p>
+            <a:pPr algn="l">
+              <a:spcAft>
+                <a:spcPts val="600"/>
+              </a:spcAft>
+            </a:pPr>
+            <a:r>
+              <a:rPr sz="1800">
+                <a:solidFill>
+                  <a:srgbClr val="2E75B6"/>
+                </a:solidFill>
+                <a:latin typeface="微软雅黑" panose="020B0503020204020204" charset="-122"/>
+                <a:ea typeface="微软雅黑" panose="020B0503020204020204" charset="-122"/>
+                <a:cs typeface="微软雅黑" panose="020B0503020204020204" charset="-122"/>
+              </a:rPr>
+              <a:t>操作流程</a:t>
+            </a:r>
+            <a:endParaRPr sz="1800">
+              <a:solidFill>
+                <a:srgbClr val="2E75B6"/>
+              </a:solidFill>
+              <a:latin typeface="微软雅黑" panose="020B0503020204020204" charset="-122"/>
+              <a:ea typeface="微软雅黑" panose="020B0503020204020204" charset="-122"/>
+              <a:cs typeface="微软雅黑" panose="020B0503020204020204" charset="-122"/>
+            </a:endParaRPr>
+          </a:p>
+        </p:txBody>
+      </p:sp>
+      <p:sp>
+        <p:nvSpPr>
+          <p:cNvPr id="6" name="Rounded Rectangle 5"/>
+          <p:cNvSpPr/>
+          <p:nvPr/>
+        </p:nvSpPr>
+        <p:spPr>
+          <a:xfrm>
+            <a:off x="502920" y="1572768"/>
+            <a:ext cx="4480560" cy="658368"/>
+          </a:xfrm>
+          <a:prstGeom prst="roundRect">
+            <a:avLst/>
+          </a:prstGeom>
+          <a:solidFill>
+            <a:srgbClr val="EAF3FB"/>
+          </a:solidFill>
+          <a:ln w="16510">
+            <a:solidFill>
+              <a:srgbClr val="1F4E79"/>
+            </a:solidFill>
+          </a:ln>
+          <a:effectLst/>
+        </p:spPr>
+        <p:style>
+          <a:lnRef idx="1">
+            <a:schemeClr val="accent1"/>
+          </a:lnRef>
+          <a:fillRef idx="3">
+            <a:schemeClr val="accent1"/>
+          </a:fillRef>
+          <a:effectRef idx="2">
+            <a:schemeClr val="accent1"/>
+          </a:effectRef>
+          <a:fontRef idx="minor">
+            <a:schemeClr val="lt1"/>
+          </a:fontRef>
+        </p:style>
+        <p:txBody>
+          <a:bodyPr wrap="square" rtlCol="0" anchor="ctr"/>
+          <a:lstStyle/>
+          <a:p>
+            <a:pPr algn="ctr"/>
+            <a:r>
+              <a:rPr sz="1200">
+                <a:solidFill>
+                  <a:srgbClr val="1F4E79"/>
+                </a:solidFill>
+                <a:latin typeface="微软雅黑" panose="020B0503020204020204" charset="-122"/>
+                <a:ea typeface="微软雅黑" panose="020B0503020204020204" charset="-122"/>
+                <a:cs typeface="微软雅黑" panose="020B0503020204020204" charset="-122"/>
+              </a:rPr>
+              <a:t>① 新建课程</a:t>
+            </a:r>
+            <a:endParaRPr sz="1200">
+              <a:solidFill>
+                <a:srgbClr val="1F4E79"/>
+              </a:solidFill>
+              <a:latin typeface="微软雅黑" panose="020B0503020204020204" charset="-122"/>
+              <a:ea typeface="微软雅黑" panose="020B0503020204020204" charset="-122"/>
+              <a:cs typeface="微软雅黑" panose="020B0503020204020204" charset="-122"/>
+            </a:endParaRPr>
+          </a:p>
+        </p:txBody>
+      </p:sp>
+      <p:sp>
+        <p:nvSpPr>
+          <p:cNvPr id="7" name="Down Arrow 6"/>
+          <p:cNvSpPr/>
+          <p:nvPr/>
+        </p:nvSpPr>
+        <p:spPr>
+          <a:xfrm>
+            <a:off x="2697480" y="2231136"/>
+            <a:ext cx="182880" cy="256032"/>
+          </a:xfrm>
+          <a:prstGeom prst="downArrow">
+            <a:avLst/>
+          </a:prstGeom>
+          <a:solidFill>
+            <a:srgbClr val="2E75B6"/>
+          </a:solidFill>
+          <a:ln>
+            <a:noFill/>
+          </a:ln>
+          <a:effectLst/>
+        </p:spPr>
+        <p:style>
+          <a:lnRef idx="1">
+            <a:schemeClr val="accent1"/>
+          </a:lnRef>
+          <a:fillRef idx="3">
+            <a:schemeClr val="accent1"/>
+          </a:fillRef>
+          <a:effectRef idx="2">
+            <a:schemeClr val="accent1"/>
+          </a:effectRef>
+          <a:fontRef idx="minor">
+            <a:schemeClr val="lt1"/>
+          </a:fontRef>
+        </p:style>
+        <p:txBody>
+          <a:bodyPr rtlCol="0" anchor="ctr"/>
+          <a:lstStyle/>
+          <a:p>
+            <a:pPr algn="ctr"/>
+          </a:p>
+        </p:txBody>
+      </p:sp>
+      <p:sp>
+        <p:nvSpPr>
+          <p:cNvPr id="8" name="Rounded Rectangle 7"/>
+          <p:cNvSpPr/>
+          <p:nvPr/>
+        </p:nvSpPr>
+        <p:spPr>
+          <a:xfrm>
+            <a:off x="502920" y="2487168"/>
+            <a:ext cx="4480560" cy="658368"/>
+          </a:xfrm>
+          <a:prstGeom prst="roundRect">
+            <a:avLst/>
+          </a:prstGeom>
+          <a:solidFill>
+            <a:srgbClr val="EAF3FB"/>
+          </a:solidFill>
+          <a:ln w="16510">
+            <a:solidFill>
+              <a:srgbClr val="1F4E79"/>
+            </a:solidFill>
+          </a:ln>
+          <a:effectLst/>
+        </p:spPr>
+        <p:style>
+          <a:lnRef idx="1">
+            <a:schemeClr val="accent1"/>
+          </a:lnRef>
+          <a:fillRef idx="3">
+            <a:schemeClr val="accent1"/>
+          </a:fillRef>
+          <a:effectRef idx="2">
+            <a:schemeClr val="accent1"/>
+          </a:effectRef>
+          <a:fontRef idx="minor">
+            <a:schemeClr val="lt1"/>
+          </a:fontRef>
+        </p:style>
+        <p:txBody>
+          <a:bodyPr wrap="square" rtlCol="0" anchor="ctr"/>
+          <a:lstStyle/>
+          <a:p>
+            <a:pPr algn="ctr"/>
+            <a:r>
+              <a:rPr sz="1200">
+                <a:solidFill>
+                  <a:srgbClr val="1F4E79"/>
+                </a:solidFill>
+                <a:latin typeface="微软雅黑" panose="020B0503020204020204" charset="-122"/>
+                <a:ea typeface="微软雅黑" panose="020B0503020204020204" charset="-122"/>
+                <a:cs typeface="微软雅黑" panose="020B0503020204020204" charset="-122"/>
+              </a:rPr>
+              <a:t>② 上传文档
+(PDF/Word/MD/TXT)</a:t>
+            </a:r>
+            <a:endParaRPr sz="1200">
+              <a:solidFill>
+                <a:srgbClr val="1F4E79"/>
+              </a:solidFill>
+              <a:latin typeface="微软雅黑" panose="020B0503020204020204" charset="-122"/>
+              <a:ea typeface="微软雅黑" panose="020B0503020204020204" charset="-122"/>
+              <a:cs typeface="微软雅黑" panose="020B0503020204020204" charset="-122"/>
+            </a:endParaRPr>
+          </a:p>
+        </p:txBody>
+      </p:sp>
+      <p:sp>
+        <p:nvSpPr>
+          <p:cNvPr id="9" name="Down Arrow 8"/>
+          <p:cNvSpPr/>
+          <p:nvPr/>
+        </p:nvSpPr>
+        <p:spPr>
+          <a:xfrm>
+            <a:off x="2697480" y="3145535"/>
+            <a:ext cx="182880" cy="256032"/>
+          </a:xfrm>
+          <a:prstGeom prst="downArrow">
+            <a:avLst/>
+          </a:prstGeom>
+          <a:solidFill>
+            <a:srgbClr val="2E75B6"/>
+          </a:solidFill>
+          <a:ln>
+            <a:noFill/>
+          </a:ln>
+          <a:effectLst/>
+        </p:spPr>
+        <p:style>
+          <a:lnRef idx="1">
+            <a:schemeClr val="accent1"/>
+          </a:lnRef>
+          <a:fillRef idx="3">
+            <a:schemeClr val="accent1"/>
+          </a:fillRef>
+          <a:effectRef idx="2">
+            <a:schemeClr val="accent1"/>
+          </a:effectRef>
+          <a:fontRef idx="minor">
+            <a:schemeClr val="lt1"/>
+          </a:fontRef>
+        </p:style>
+        <p:txBody>
+          <a:bodyPr rtlCol="0" anchor="ctr"/>
+          <a:lstStyle/>
+          <a:p>
+            <a:pPr algn="ctr"/>
+          </a:p>
+        </p:txBody>
+      </p:sp>
+      <p:sp>
+        <p:nvSpPr>
+          <p:cNvPr id="10" name="Rounded Rectangle 9"/>
+          <p:cNvSpPr/>
+          <p:nvPr/>
+        </p:nvSpPr>
+        <p:spPr>
+          <a:xfrm>
+            <a:off x="502920" y="3401568"/>
+            <a:ext cx="4480560" cy="658368"/>
+          </a:xfrm>
+          <a:prstGeom prst="roundRect">
+            <a:avLst/>
+          </a:prstGeom>
+          <a:solidFill>
+            <a:srgbClr val="EAF3FB"/>
+          </a:solidFill>
+          <a:ln w="16510">
+            <a:solidFill>
+              <a:srgbClr val="1F4E79"/>
+            </a:solidFill>
+          </a:ln>
+          <a:effectLst/>
+        </p:spPr>
+        <p:style>
+          <a:lnRef idx="1">
+            <a:schemeClr val="accent1"/>
+          </a:lnRef>
+          <a:fillRef idx="3">
+            <a:schemeClr val="accent1"/>
+          </a:fillRef>
+          <a:effectRef idx="2">
+            <a:schemeClr val="accent1"/>
+          </a:effectRef>
+          <a:fontRef idx="minor">
+            <a:schemeClr val="lt1"/>
+          </a:fontRef>
+        </p:style>
+        <p:txBody>
+          <a:bodyPr wrap="square" rtlCol="0" anchor="ctr"/>
+          <a:lstStyle/>
+          <a:p>
+            <a:pPr algn="ctr"/>
+            <a:r>
+              <a:rPr sz="1200">
+                <a:solidFill>
+                  <a:srgbClr val="1F4E79"/>
+                </a:solidFill>
+                <a:latin typeface="微软雅黑" panose="020B0503020204020204" charset="-122"/>
+                <a:ea typeface="微软雅黑" panose="020B0503020204020204" charset="-122"/>
+                <a:cs typeface="微软雅黑" panose="020B0503020204020204" charset="-122"/>
+              </a:rPr>
+              <a:t>③ 自动解析切分
+(500字符/重叠50)</a:t>
+            </a:r>
+            <a:endParaRPr sz="1200">
+              <a:solidFill>
+                <a:srgbClr val="1F4E79"/>
+              </a:solidFill>
+              <a:latin typeface="微软雅黑" panose="020B0503020204020204" charset="-122"/>
+              <a:ea typeface="微软雅黑" panose="020B0503020204020204" charset="-122"/>
+              <a:cs typeface="微软雅黑" panose="020B0503020204020204" charset="-122"/>
+            </a:endParaRPr>
+          </a:p>
+        </p:txBody>
+      </p:sp>
+      <p:sp>
+        <p:nvSpPr>
+          <p:cNvPr id="11" name="Down Arrow 10"/>
+          <p:cNvSpPr/>
+          <p:nvPr/>
+        </p:nvSpPr>
+        <p:spPr>
+          <a:xfrm>
+            <a:off x="2697480" y="4059935"/>
+            <a:ext cx="182880" cy="256032"/>
+          </a:xfrm>
+          <a:prstGeom prst="downArrow">
+            <a:avLst/>
+          </a:prstGeom>
+          <a:solidFill>
+            <a:srgbClr val="2E75B6"/>
+          </a:solidFill>
+          <a:ln>
+            <a:noFill/>
+          </a:ln>
+          <a:effectLst/>
+        </p:spPr>
+        <p:style>
+          <a:lnRef idx="1">
+            <a:schemeClr val="accent1"/>
+          </a:lnRef>
+          <a:fillRef idx="3">
+            <a:schemeClr val="accent1"/>
+          </a:fillRef>
+          <a:effectRef idx="2">
+            <a:schemeClr val="accent1"/>
+          </a:effectRef>
+          <a:fontRef idx="minor">
+            <a:schemeClr val="lt1"/>
+          </a:fontRef>
+        </p:style>
+        <p:txBody>
+          <a:bodyPr rtlCol="0" anchor="ctr"/>
+          <a:lstStyle/>
+          <a:p>
+            <a:pPr algn="ctr"/>
+          </a:p>
+        </p:txBody>
+      </p:sp>
+      <p:sp>
+        <p:nvSpPr>
+          <p:cNvPr id="12" name="Rounded Rectangle 11"/>
+          <p:cNvSpPr/>
+          <p:nvPr/>
+        </p:nvSpPr>
+        <p:spPr>
+          <a:xfrm>
+            <a:off x="502920" y="4315968"/>
+            <a:ext cx="4480560" cy="658368"/>
+          </a:xfrm>
+          <a:prstGeom prst="roundRect">
+            <a:avLst/>
+          </a:prstGeom>
+          <a:solidFill>
+            <a:srgbClr val="EAF3FB"/>
+          </a:solidFill>
+          <a:ln w="16510">
+            <a:solidFill>
+              <a:srgbClr val="1F4E79"/>
+            </a:solidFill>
+          </a:ln>
+          <a:effectLst/>
+        </p:spPr>
+        <p:style>
+          <a:lnRef idx="1">
+            <a:schemeClr val="accent1"/>
+          </a:lnRef>
+          <a:fillRef idx="3">
+            <a:schemeClr val="accent1"/>
+          </a:fillRef>
+          <a:effectRef idx="2">
+            <a:schemeClr val="accent1"/>
+          </a:effectRef>
+          <a:fontRef idx="minor">
+            <a:schemeClr val="lt1"/>
+          </a:fontRef>
+        </p:style>
+        <p:txBody>
+          <a:bodyPr wrap="square" rtlCol="0" anchor="ctr"/>
+          <a:lstStyle/>
+          <a:p>
+            <a:pPr algn="ctr"/>
+            <a:r>
+              <a:rPr sz="1200">
+                <a:solidFill>
+                  <a:srgbClr val="1F4E79"/>
+                </a:solidFill>
+                <a:latin typeface="微软雅黑" panose="020B0503020204020204" charset="-122"/>
+                <a:ea typeface="微软雅黑" panose="020B0503020204020204" charset="-122"/>
+                <a:cs typeface="微软雅黑" panose="020B0503020204020204" charset="-122"/>
+              </a:rPr>
+              <a:t>④ 向量化入库
+(BGE-M3)</a:t>
+            </a:r>
+            <a:endParaRPr sz="1200">
+              <a:solidFill>
+                <a:srgbClr val="1F4E79"/>
+              </a:solidFill>
+              <a:latin typeface="微软雅黑" panose="020B0503020204020204" charset="-122"/>
+              <a:ea typeface="微软雅黑" panose="020B0503020204020204" charset="-122"/>
+              <a:cs typeface="微软雅黑" panose="020B0503020204020204" charset="-122"/>
+            </a:endParaRPr>
+          </a:p>
+        </p:txBody>
+      </p:sp>
+      <p:sp>
+        <p:nvSpPr>
+          <p:cNvPr id="13" name="Down Arrow 12"/>
+          <p:cNvSpPr/>
+          <p:nvPr/>
+        </p:nvSpPr>
+        <p:spPr>
+          <a:xfrm>
+            <a:off x="2697480" y="4974336"/>
+            <a:ext cx="182880" cy="256032"/>
+          </a:xfrm>
+          <a:prstGeom prst="downArrow">
+            <a:avLst/>
+          </a:prstGeom>
+          <a:solidFill>
+            <a:srgbClr val="2E75B6"/>
+          </a:solidFill>
+          <a:ln>
+            <a:noFill/>
+          </a:ln>
+          <a:effectLst/>
+        </p:spPr>
+        <p:style>
+          <a:lnRef idx="1">
+            <a:schemeClr val="accent1"/>
+          </a:lnRef>
+          <a:fillRef idx="3">
+            <a:schemeClr val="accent1"/>
+          </a:fillRef>
+          <a:effectRef idx="2">
+            <a:schemeClr val="accent1"/>
+          </a:effectRef>
+          <a:fontRef idx="minor">
+            <a:schemeClr val="lt1"/>
+          </a:fontRef>
+        </p:style>
+        <p:txBody>
+          <a:bodyPr rtlCol="0" anchor="ctr"/>
+          <a:lstStyle/>
+          <a:p>
+            <a:pPr algn="ctr"/>
+          </a:p>
+        </p:txBody>
+      </p:sp>
+      <p:sp>
+        <p:nvSpPr>
+          <p:cNvPr id="14" name="Rounded Rectangle 13"/>
+          <p:cNvSpPr/>
+          <p:nvPr/>
+        </p:nvSpPr>
+        <p:spPr>
+          <a:xfrm>
+            <a:off x="502920" y="5230368"/>
+            <a:ext cx="4480560" cy="658368"/>
+          </a:xfrm>
+          <a:prstGeom prst="roundRect">
+            <a:avLst/>
+          </a:prstGeom>
+          <a:solidFill>
+            <a:srgbClr val="EAF3FB"/>
+          </a:solidFill>
+          <a:ln w="16510">
+            <a:solidFill>
+              <a:srgbClr val="1F4E79"/>
+            </a:solidFill>
+          </a:ln>
+          <a:effectLst/>
+        </p:spPr>
+        <p:style>
+          <a:lnRef idx="1">
+            <a:schemeClr val="accent1"/>
+          </a:lnRef>
+          <a:fillRef idx="3">
+            <a:schemeClr val="accent1"/>
+          </a:fillRef>
+          <a:effectRef idx="2">
+            <a:schemeClr val="accent1"/>
+          </a:effectRef>
+          <a:fontRef idx="minor">
+            <a:schemeClr val="lt1"/>
+          </a:fontRef>
+        </p:style>
+        <p:txBody>
+          <a:bodyPr wrap="square" rtlCol="0" anchor="ctr"/>
+          <a:lstStyle/>
+          <a:p>
+            <a:pPr algn="ctr"/>
+            <a:r>
+              <a:rPr sz="1200">
+                <a:solidFill>
+                  <a:srgbClr val="1F4E79"/>
+                </a:solidFill>
+                <a:latin typeface="微软雅黑" panose="020B0503020204020204" charset="-122"/>
+                <a:ea typeface="微软雅黑" panose="020B0503020204020204" charset="-122"/>
+                <a:cs typeface="微软雅黑" panose="020B0503020204020204" charset="-122"/>
+              </a:rPr>
+              <a:t>⑤ 状态变 completed</a:t>
+            </a:r>
+            <a:endParaRPr sz="1200">
+              <a:solidFill>
+                <a:srgbClr val="1F4E79"/>
+              </a:solidFill>
+              <a:latin typeface="微软雅黑" panose="020B0503020204020204" charset="-122"/>
+              <a:ea typeface="微软雅黑" panose="020B0503020204020204" charset="-122"/>
+              <a:cs typeface="微软雅黑" panose="020B0503020204020204" charset="-122"/>
+            </a:endParaRPr>
+          </a:p>
+        </p:txBody>
+      </p:sp>
+      <p:sp>
+        <p:nvSpPr>
+          <p:cNvPr id="15" name="TextBox 14"/>
+          <p:cNvSpPr txBox="1"/>
+          <p:nvPr/>
+        </p:nvSpPr>
+        <p:spPr>
+          <a:xfrm>
+            <a:off x="502920" y="6144768"/>
+            <a:ext cx="4572000" cy="457200"/>
+          </a:xfrm>
+          <a:prstGeom prst="rect">
+            <a:avLst/>
+          </a:prstGeom>
+          <a:noFill/>
+        </p:spPr>
+        <p:txBody>
+          <a:bodyPr wrap="square" lIns="0" tIns="0" rIns="0" bIns="0" anchor="t">
+            <a:spAutoFit/>
+          </a:bodyPr>
+          <a:lstStyle/>
+          <a:p>
+            <a:pPr algn="l">
+              <a:spcAft>
+                <a:spcPts val="600"/>
+              </a:spcAft>
+            </a:pPr>
+            <a:r>
+              <a:rPr sz="1200">
+                <a:solidFill>
+                  <a:srgbClr val="808080"/>
+                </a:solidFill>
+                <a:latin typeface="微软雅黑" panose="020B0503020204020204" charset="-122"/>
+                <a:ea typeface="微软雅黑" panose="020B0503020204020204" charset="-122"/>
+                <a:cs typeface="微软雅黑" panose="020B0503020204020204" charset="-122"/>
+              </a:rPr>
+              <a:t>支持 5 类格式 · 单文件 ≤10MB · 入库 &lt;30 秒</a:t>
+            </a:r>
+            <a:endParaRPr sz="1200">
+              <a:solidFill>
+                <a:srgbClr val="808080"/>
+              </a:solidFill>
+              <a:latin typeface="微软雅黑" panose="020B0503020204020204" charset="-122"/>
+              <a:ea typeface="微软雅黑" panose="020B0503020204020204" charset="-122"/>
+              <a:cs typeface="微软雅黑" panose="020B0503020204020204" charset="-122"/>
+            </a:endParaRPr>
+          </a:p>
+        </p:txBody>
+      </p:sp>
+      <p:sp>
+        <p:nvSpPr>
+          <p:cNvPr id="16" name="Rectangle 15"/>
+          <p:cNvSpPr/>
+          <p:nvPr/>
+        </p:nvSpPr>
+        <p:spPr>
+          <a:xfrm>
+            <a:off x="5577840" y="1280160"/>
+            <a:ext cx="5943600" cy="3931920"/>
+          </a:xfrm>
+          <a:prstGeom prst="rect">
+            <a:avLst/>
+          </a:prstGeom>
+          <a:solidFill>
+            <a:srgbClr val="F2F2F2"/>
+          </a:solidFill>
+          <a:ln w="15240">
+            <a:solidFill>
+              <a:srgbClr val="C00000"/>
+            </a:solidFill>
+            <a:prstDash val="dash"/>
+          </a:ln>
+          <a:effectLst/>
+        </p:spPr>
+        <p:style>
+          <a:lnRef idx="1">
+            <a:schemeClr val="accent1"/>
+          </a:lnRef>
+          <a:fillRef idx="3">
+            <a:schemeClr val="accent1"/>
+          </a:fillRef>
+          <a:effectRef idx="2">
+            <a:schemeClr val="accent1"/>
+          </a:effectRef>
+          <a:fontRef idx="minor">
+            <a:schemeClr val="lt1"/>
+          </a:fontRef>
+        </p:style>
+        <p:txBody>
+          <a:bodyPr wrap="square" rtlCol="0" anchor="ctr"/>
+          <a:lstStyle/>
+          <a:p>
+            <a:pPr algn="ctr"/>
+            <a:r>
+              <a:rPr sz="1300">
+                <a:solidFill>
+                  <a:srgbClr val="C00000"/>
+                </a:solidFill>
+                <a:latin typeface="微软雅黑" panose="020B0503020204020204" charset="-122"/>
+                <a:ea typeface="微软雅黑" panose="020B0503020204020204" charset="-122"/>
+                <a:cs typeface="微软雅黑" panose="020B0503020204020204" charset="-122"/>
+              </a:rPr>
+              <a:t>【截图 A】
+文档管理页演示</a:t>
+            </a:r>
+            <a:endParaRPr sz="1300">
+              <a:solidFill>
+                <a:srgbClr val="C00000"/>
+              </a:solidFill>
+              <a:latin typeface="微软雅黑" panose="020B0503020204020204" charset="-122"/>
+              <a:ea typeface="微软雅黑" panose="020B0503020204020204" charset="-122"/>
+              <a:cs typeface="微软雅黑" panose="020B0503020204020204" charset="-122"/>
+            </a:endParaRPr>
+          </a:p>
+          <a:p>
+            <a:pPr algn="ctr"/>
+            <a:r>
+              <a:rPr sz="1000">
+                <a:solidFill>
+                  <a:srgbClr val="808080"/>
+                </a:solidFill>
+                <a:latin typeface="微软雅黑" panose="020B0503020204020204" charset="-122"/>
+                <a:ea typeface="微软雅黑" panose="020B0503020204020204" charset="-122"/>
+                <a:cs typeface="微软雅黑" panose="020B0503020204020204" charset="-122"/>
+              </a:rPr>
+              <a:t>已选课程 + 上传中的加载提示
++ 完成后的文档列表（含切分块数与状态）</a:t>
+            </a:r>
+            <a:endParaRPr sz="1000">
+              <a:solidFill>
+                <a:srgbClr val="808080"/>
+              </a:solidFill>
+              <a:latin typeface="微软雅黑" panose="020B0503020204020204" charset="-122"/>
+              <a:ea typeface="微软雅黑" panose="020B0503020204020204" charset="-122"/>
+              <a:cs typeface="微软雅黑" panose="020B0503020204020204" charset="-122"/>
+            </a:endParaRPr>
+          </a:p>
+        </p:txBody>
+      </p:sp>
+      <p:sp>
+        <p:nvSpPr>
+          <p:cNvPr id="17" name="TextBox 16"/>
+          <p:cNvSpPr txBox="1"/>
+          <p:nvPr/>
+        </p:nvSpPr>
+        <p:spPr>
+          <a:xfrm>
+            <a:off x="5577840" y="5321808"/>
+            <a:ext cx="5943600" cy="168910"/>
+          </a:xfrm>
+          <a:prstGeom prst="rect">
+            <a:avLst/>
+          </a:prstGeom>
+          <a:noFill/>
+        </p:spPr>
+        <p:txBody>
+          <a:bodyPr wrap="square" lIns="0" tIns="0" rIns="0" bIns="0" anchor="t">
+            <a:spAutoFit/>
+          </a:bodyPr>
+          <a:lstStyle/>
+          <a:p>
+            <a:pPr algn="ctr">
+              <a:spcAft>
+                <a:spcPts val="600"/>
+              </a:spcAft>
+            </a:pPr>
+            <a:r>
+              <a:rPr sz="1100">
+                <a:solidFill>
+                  <a:srgbClr val="808080"/>
+                </a:solidFill>
+                <a:latin typeface="微软雅黑" panose="020B0503020204020204" charset="-122"/>
+                <a:ea typeface="微软雅黑" panose="020B0503020204020204" charset="-122"/>
+                <a:cs typeface="微软雅黑" panose="020B0503020204020204" charset="-122"/>
+              </a:rPr>
+              <a:t>演示截图</a:t>
+            </a:r>
+            <a:endParaRPr sz="1100">
+              <a:solidFill>
+                <a:srgbClr val="808080"/>
+              </a:solidFill>
+              <a:latin typeface="微软雅黑" panose="020B0503020204020204" charset="-122"/>
+              <a:ea typeface="微软雅黑" panose="020B0503020204020204" charset="-122"/>
+              <a:cs typeface="微软雅黑" panose="020B0503020204020204" charset="-122"/>
+            </a:endParaRPr>
+          </a:p>
+        </p:txBody>
+      </p:sp>
+      <p:sp>
+        <p:nvSpPr>
+          <p:cNvPr id="18" name="TextBox 17"/>
+          <p:cNvSpPr txBox="1"/>
+          <p:nvPr/>
+        </p:nvSpPr>
+        <p:spPr>
+          <a:xfrm>
+            <a:off x="11247120" y="6473952"/>
+            <a:ext cx="640080" cy="274320"/>
+          </a:xfrm>
+          <a:prstGeom prst="rect">
+            <a:avLst/>
+          </a:prstGeom>
+          <a:noFill/>
+        </p:spPr>
+        <p:txBody>
+          <a:bodyPr wrap="none">
+            <a:spAutoFit/>
+          </a:bodyPr>
+          <a:lstStyle/>
+          <a:p>
+            <a:pPr algn="r"/>
+            <a:r>
+              <a:rPr sz="1000">
+                <a:solidFill>
+                  <a:srgbClr val="808080"/>
+                </a:solidFill>
+                <a:latin typeface="微软雅黑" panose="020B0503020204020204" charset="-122"/>
+                <a:ea typeface="微软雅黑" panose="020B0503020204020204" charset="-122"/>
+                <a:cs typeface="微软雅黑" panose="020B0503020204020204" charset="-122"/>
+              </a:rPr>
+              <a:t>10</a:t>
+            </a:r>
+            <a:endParaRPr sz="1000">
+              <a:solidFill>
+                <a:srgbClr val="808080"/>
+              </a:solidFill>
+              <a:latin typeface="微软雅黑" panose="020B0503020204020204" charset="-122"/>
+              <a:ea typeface="微软雅黑" panose="020B0503020204020204" charset="-122"/>
+              <a:cs typeface="微软雅黑" panose="020B0503020204020204" charset="-122"/>
+            </a:endParaRPr>
+          </a:p>
+        </p:txBody>
+      </p:sp>
+      <p:pic>
+        <p:nvPicPr>
+          <p:cNvPr id="20" name="图片 19" descr="bfb5efee686c257c6dd3f16ee3f716c2"/>
+          <p:cNvPicPr>
+            <a:picLocks noChangeAspect="1"/>
+          </p:cNvPicPr>
+          <p:nvPr/>
+        </p:nvPicPr>
+        <p:blipFill>
+          <a:blip r:embed="rId1"/>
+          <a:stretch>
+            <a:fillRect/>
+          </a:stretch>
+        </p:blipFill>
+        <p:spPr>
+          <a:xfrm>
+            <a:off x="5369560" y="1251585"/>
+            <a:ext cx="6289040" cy="4070350"/>
+          </a:xfrm>
+          <a:prstGeom prst="rect">
+            <a:avLst/>
+          </a:prstGeom>
+        </p:spPr>
+      </p:pic>
+    </p:spTree>
+  </p:cSld>
+  <p:clrMapOvr>
+    <a:masterClrMapping/>
+  </p:clrMapOvr>
+</p:sld>
+</file>
+
+<file path=ppt/slides/slide11.xml><?xml version="1.0" encoding="utf-8"?>
+<p:sld xmlns:a="http://schemas.openxmlformats.org/drawingml/2006/main" xmlns:r="http://schemas.openxmlformats.org/officeDocument/2006/relationships" xmlns:p="http://schemas.openxmlformats.org/presentationml/2006/main">
+  <p:cSld>
+    <p:spTree>
+      <p:nvGrpSpPr>
+        <p:cNvPr id="1" name=""/>
+        <p:cNvGrpSpPr/>
+        <p:nvPr/>
+      </p:nvGrpSpPr>
+      <p:grpSpPr/>
+      <p:sp>
+        <p:nvSpPr>
+          <p:cNvPr id="2" name="Rectangle 1"/>
+          <p:cNvSpPr/>
+          <p:nvPr/>
+        </p:nvSpPr>
+        <p:spPr>
+          <a:xfrm>
+            <a:off x="0" y="0"/>
+            <a:ext cx="12191695" cy="960120"/>
+          </a:xfrm>
+          <a:prstGeom prst="rect">
+            <a:avLst/>
+          </a:prstGeom>
+          <a:solidFill>
+            <a:srgbClr val="1F4E79"/>
+          </a:solidFill>
+          <a:ln>
+            <a:noFill/>
+          </a:ln>
+          <a:effectLst/>
+        </p:spPr>
+        <p:style>
+          <a:lnRef idx="1">
+            <a:schemeClr val="accent1"/>
+          </a:lnRef>
+          <a:fillRef idx="3">
+            <a:schemeClr val="accent1"/>
+          </a:fillRef>
+          <a:effectRef idx="2">
+            <a:schemeClr val="accent1"/>
+          </a:effectRef>
+          <a:fontRef idx="minor">
+            <a:schemeClr val="lt1"/>
+          </a:fontRef>
+        </p:style>
+        <p:txBody>
+          <a:bodyPr rtlCol="0" anchor="ctr"/>
+          <a:lstStyle/>
+          <a:p>
+            <a:pPr algn="ctr"/>
+          </a:p>
+        </p:txBody>
+      </p:sp>
+      <p:sp>
+        <p:nvSpPr>
+          <p:cNvPr id="3" name="TextBox 2"/>
+          <p:cNvSpPr txBox="1"/>
+          <p:nvPr/>
+        </p:nvSpPr>
+        <p:spPr>
+          <a:xfrm>
+            <a:off x="502920" y="182880"/>
+            <a:ext cx="11155680" cy="621792"/>
+          </a:xfrm>
+          <a:prstGeom prst="rect">
+            <a:avLst/>
+          </a:prstGeom>
+          <a:noFill/>
+        </p:spPr>
+        <p:txBody>
+          <a:bodyPr wrap="square" lIns="0" tIns="0" rIns="0" bIns="0" anchor="ctr">
+            <a:spAutoFit/>
+          </a:bodyPr>
+          <a:lstStyle/>
+          <a:p>
+            <a:pPr algn="l">
+              <a:spcAft>
+                <a:spcPts val="600"/>
+              </a:spcAft>
+            </a:pPr>
+            <a:r>
+              <a:rPr sz="2600">
+                <a:solidFill>
+                  <a:srgbClr val="FFFFFF"/>
+                </a:solidFill>
+                <a:latin typeface="微软雅黑" panose="020B0503020204020204" charset="-122"/>
+                <a:ea typeface="微软雅黑" panose="020B0503020204020204" charset="-122"/>
+                <a:cs typeface="微软雅黑" panose="020B0503020204020204" charset="-122"/>
+              </a:rPr>
+              <a:t>5.2　功能演示（二）：智能问答</a:t>
+            </a:r>
+            <a:endParaRPr sz="2600">
+              <a:solidFill>
+                <a:srgbClr val="FFFFFF"/>
+              </a:solidFill>
+              <a:latin typeface="微软雅黑" panose="020B0503020204020204" charset="-122"/>
+              <a:ea typeface="微软雅黑" panose="020B0503020204020204" charset="-122"/>
+              <a:cs typeface="微软雅黑" panose="020B0503020204020204" charset="-122"/>
+            </a:endParaRPr>
+          </a:p>
+        </p:txBody>
+      </p:sp>
+      <p:sp>
+        <p:nvSpPr>
+          <p:cNvPr id="4" name="TextBox 3"/>
+          <p:cNvSpPr txBox="1"/>
+          <p:nvPr/>
+        </p:nvSpPr>
+        <p:spPr>
+          <a:xfrm>
+            <a:off x="8321040" y="274320"/>
+            <a:ext cx="3383280" cy="457200"/>
+          </a:xfrm>
+          <a:prstGeom prst="rect">
+            <a:avLst/>
+          </a:prstGeom>
+          <a:noFill/>
+        </p:spPr>
+        <p:txBody>
+          <a:bodyPr wrap="square" lIns="0" tIns="0" rIns="0" bIns="0" anchor="ctr">
+            <a:spAutoFit/>
+          </a:bodyPr>
+          <a:lstStyle/>
+          <a:p>
+            <a:pPr algn="r">
+              <a:spcAft>
+                <a:spcPts val="600"/>
+              </a:spcAft>
+            </a:pPr>
+            <a:r>
+              <a:rPr sz="1300">
+                <a:solidFill>
+                  <a:srgbClr val="BDD7EE"/>
+                </a:solidFill>
+                <a:latin typeface="微软雅黑" panose="020B0503020204020204" charset="-122"/>
+                <a:ea typeface="微软雅黑" panose="020B0503020204020204" charset="-122"/>
+                <a:cs typeface="微软雅黑" panose="020B0503020204020204" charset="-122"/>
+              </a:rPr>
+              <a:t>负责人：周承锦</a:t>
+            </a:r>
+            <a:endParaRPr sz="1300">
+              <a:solidFill>
+                <a:srgbClr val="BDD7EE"/>
+              </a:solidFill>
+              <a:latin typeface="微软雅黑" panose="020B0503020204020204" charset="-122"/>
+              <a:ea typeface="微软雅黑" panose="020B0503020204020204" charset="-122"/>
+              <a:cs typeface="微软雅黑" panose="020B0503020204020204" charset="-122"/>
+            </a:endParaRPr>
+          </a:p>
+        </p:txBody>
+      </p:sp>
+      <p:sp>
+        <p:nvSpPr>
+          <p:cNvPr id="5" name="TextBox 4"/>
+          <p:cNvSpPr txBox="1"/>
+          <p:nvPr/>
+        </p:nvSpPr>
+        <p:spPr>
+          <a:xfrm>
+            <a:off x="502920" y="1115568"/>
+            <a:ext cx="5120640" cy="365760"/>
+          </a:xfrm>
+          <a:prstGeom prst="rect">
+            <a:avLst/>
+          </a:prstGeom>
+          <a:noFill/>
+        </p:spPr>
+        <p:txBody>
+          <a:bodyPr wrap="square" lIns="0" tIns="0" rIns="0" bIns="0" anchor="t">
+            <a:spAutoFit/>
+          </a:bodyPr>
+          <a:lstStyle/>
+          <a:p>
+            <a:pPr algn="l">
+              <a:spcAft>
+                <a:spcPts val="600"/>
+              </a:spcAft>
+            </a:pPr>
+            <a:r>
+              <a:rPr sz="1800">
+                <a:solidFill>
+                  <a:srgbClr val="2E75B6"/>
+                </a:solidFill>
+                <a:latin typeface="微软雅黑" panose="020B0503020204020204" charset="-122"/>
+                <a:ea typeface="微软雅黑" panose="020B0503020204020204" charset="-122"/>
+                <a:cs typeface="微软雅黑" panose="020B0503020204020204" charset="-122"/>
+              </a:rPr>
+              <a:t>问答过程</a:t>
+            </a:r>
+            <a:endParaRPr sz="1800">
+              <a:solidFill>
+                <a:srgbClr val="2E75B6"/>
+              </a:solidFill>
+              <a:latin typeface="微软雅黑" panose="020B0503020204020204" charset="-122"/>
+              <a:ea typeface="微软雅黑" panose="020B0503020204020204" charset="-122"/>
+              <a:cs typeface="微软雅黑" panose="020B0503020204020204" charset="-122"/>
+            </a:endParaRPr>
+          </a:p>
+        </p:txBody>
+      </p:sp>
+      <p:sp>
+        <p:nvSpPr>
+          <p:cNvPr id="6" name="Rounded Rectangle 5"/>
+          <p:cNvSpPr/>
+          <p:nvPr/>
+        </p:nvSpPr>
+        <p:spPr>
+          <a:xfrm>
+            <a:off x="502920" y="1572768"/>
+            <a:ext cx="4480560" cy="658368"/>
+          </a:xfrm>
+          <a:prstGeom prst="roundRect">
+            <a:avLst/>
+          </a:prstGeom>
+          <a:solidFill>
+            <a:srgbClr val="EAF3FB"/>
+          </a:solidFill>
+          <a:ln w="16510">
+            <a:solidFill>
+              <a:srgbClr val="1F4E79"/>
+            </a:solidFill>
+          </a:ln>
+          <a:effectLst/>
+        </p:spPr>
+        <p:style>
+          <a:lnRef idx="1">
+            <a:schemeClr val="accent1"/>
+          </a:lnRef>
+          <a:fillRef idx="3">
+            <a:schemeClr val="accent1"/>
+          </a:fillRef>
+          <a:effectRef idx="2">
+            <a:schemeClr val="accent1"/>
+          </a:effectRef>
+          <a:fontRef idx="minor">
+            <a:schemeClr val="lt1"/>
+          </a:fontRef>
+        </p:style>
+        <p:txBody>
+          <a:bodyPr wrap="square" rtlCol="0" anchor="ctr"/>
+          <a:lstStyle/>
+          <a:p>
+            <a:pPr algn="ctr"/>
+            <a:r>
+              <a:rPr sz="1200">
+                <a:solidFill>
+                  <a:srgbClr val="1F4E79"/>
+                </a:solidFill>
+                <a:latin typeface="微软雅黑" panose="020B0503020204020204" charset="-122"/>
+                <a:ea typeface="微软雅黑" panose="020B0503020204020204" charset="-122"/>
+                <a:cs typeface="微软雅黑" panose="020B0503020204020204" charset="-122"/>
+              </a:rPr>
+              <a:t>① 选择课程</a:t>
+            </a:r>
+            <a:endParaRPr sz="1200">
+              <a:solidFill>
+                <a:srgbClr val="1F4E79"/>
+              </a:solidFill>
+              <a:latin typeface="微软雅黑" panose="020B0503020204020204" charset="-122"/>
+              <a:ea typeface="微软雅黑" panose="020B0503020204020204" charset="-122"/>
+              <a:cs typeface="微软雅黑" panose="020B0503020204020204" charset="-122"/>
+            </a:endParaRPr>
+          </a:p>
+        </p:txBody>
+      </p:sp>
+      <p:sp>
+        <p:nvSpPr>
+          <p:cNvPr id="7" name="Down Arrow 6"/>
+          <p:cNvSpPr/>
+          <p:nvPr/>
+        </p:nvSpPr>
+        <p:spPr>
+          <a:xfrm>
+            <a:off x="2697480" y="2231136"/>
+            <a:ext cx="182880" cy="256032"/>
+          </a:xfrm>
+          <a:prstGeom prst="downArrow">
+            <a:avLst/>
+          </a:prstGeom>
+          <a:solidFill>
+            <a:srgbClr val="2E75B6"/>
+          </a:solidFill>
+          <a:ln>
+            <a:noFill/>
+          </a:ln>
+          <a:effectLst/>
+        </p:spPr>
+        <p:style>
+          <a:lnRef idx="1">
+            <a:schemeClr val="accent1"/>
+          </a:lnRef>
+          <a:fillRef idx="3">
+            <a:schemeClr val="accent1"/>
+          </a:fillRef>
+          <a:effectRef idx="2">
+            <a:schemeClr val="accent1"/>
+          </a:effectRef>
+          <a:fontRef idx="minor">
+            <a:schemeClr val="lt1"/>
+          </a:fontRef>
+        </p:style>
+        <p:txBody>
+          <a:bodyPr rtlCol="0" anchor="ctr"/>
+          <a:lstStyle/>
+          <a:p>
+            <a:pPr algn="ctr"/>
+          </a:p>
+        </p:txBody>
+      </p:sp>
+      <p:sp>
+        <p:nvSpPr>
+          <p:cNvPr id="8" name="Rounded Rectangle 7"/>
+          <p:cNvSpPr/>
+          <p:nvPr/>
+        </p:nvSpPr>
+        <p:spPr>
+          <a:xfrm>
+            <a:off x="502920" y="2487168"/>
+            <a:ext cx="4480560" cy="658368"/>
+          </a:xfrm>
+          <a:prstGeom prst="roundRect">
+            <a:avLst/>
+          </a:prstGeom>
+          <a:solidFill>
+            <a:srgbClr val="EAF3FB"/>
+          </a:solidFill>
+          <a:ln w="16510">
+            <a:solidFill>
+              <a:srgbClr val="1F4E79"/>
+            </a:solidFill>
+          </a:ln>
+          <a:effectLst/>
+        </p:spPr>
+        <p:style>
+          <a:lnRef idx="1">
+            <a:schemeClr val="accent1"/>
+          </a:lnRef>
+          <a:fillRef idx="3">
+            <a:schemeClr val="accent1"/>
+          </a:fillRef>
+          <a:effectRef idx="2">
+            <a:schemeClr val="accent1"/>
+          </a:effectRef>
+          <a:fontRef idx="minor">
+            <a:schemeClr val="lt1"/>
+          </a:fontRef>
+        </p:style>
+        <p:txBody>
+          <a:bodyPr wrap="square" rtlCol="0" anchor="ctr"/>
+          <a:lstStyle/>
+          <a:p>
+            <a:pPr algn="ctr"/>
+            <a:r>
+              <a:rPr sz="1200">
+                <a:solidFill>
+                  <a:srgbClr val="1F4E79"/>
+                </a:solidFill>
+                <a:latin typeface="微软雅黑" panose="020B0503020204020204" charset="-122"/>
+                <a:ea typeface="微软雅黑" panose="020B0503020204020204" charset="-122"/>
+                <a:cs typeface="微软雅黑" panose="020B0503020204020204" charset="-122"/>
+              </a:rPr>
+              <a:t>② 输入问题</a:t>
+            </a:r>
+            <a:endParaRPr sz="1200">
+              <a:solidFill>
+                <a:srgbClr val="1F4E79"/>
+              </a:solidFill>
+              <a:latin typeface="微软雅黑" panose="020B0503020204020204" charset="-122"/>
+              <a:ea typeface="微软雅黑" panose="020B0503020204020204" charset="-122"/>
+              <a:cs typeface="微软雅黑" panose="020B0503020204020204" charset="-122"/>
+            </a:endParaRPr>
+          </a:p>
+        </p:txBody>
+      </p:sp>
+      <p:sp>
+        <p:nvSpPr>
+          <p:cNvPr id="9" name="Down Arrow 8"/>
+          <p:cNvSpPr/>
+          <p:nvPr/>
+        </p:nvSpPr>
+        <p:spPr>
+          <a:xfrm>
+            <a:off x="2697480" y="3145535"/>
+            <a:ext cx="182880" cy="256032"/>
+          </a:xfrm>
+          <a:prstGeom prst="downArrow">
+            <a:avLst/>
+          </a:prstGeom>
+          <a:solidFill>
+            <a:srgbClr val="2E75B6"/>
+          </a:solidFill>
+          <a:ln>
+            <a:noFill/>
+          </a:ln>
+          <a:effectLst/>
+        </p:spPr>
+        <p:style>
+          <a:lnRef idx="1">
+            <a:schemeClr val="accent1"/>
+          </a:lnRef>
+          <a:fillRef idx="3">
+            <a:schemeClr val="accent1"/>
+          </a:fillRef>
+          <a:effectRef idx="2">
+            <a:schemeClr val="accent1"/>
+          </a:effectRef>
+          <a:fontRef idx="minor">
+            <a:schemeClr val="lt1"/>
+          </a:fontRef>
+        </p:style>
+        <p:txBody>
+          <a:bodyPr rtlCol="0" anchor="ctr"/>
+          <a:lstStyle/>
+          <a:p>
+            <a:pPr algn="ctr"/>
+          </a:p>
+        </p:txBody>
+      </p:sp>
+      <p:sp>
+        <p:nvSpPr>
+          <p:cNvPr id="10" name="Rounded Rectangle 9"/>
+          <p:cNvSpPr/>
+          <p:nvPr/>
+        </p:nvSpPr>
+        <p:spPr>
+          <a:xfrm>
+            <a:off x="502920" y="3401568"/>
+            <a:ext cx="4480560" cy="658368"/>
+          </a:xfrm>
+          <a:prstGeom prst="roundRect">
+            <a:avLst/>
+          </a:prstGeom>
+          <a:solidFill>
+            <a:srgbClr val="EAF3FB"/>
+          </a:solidFill>
+          <a:ln w="16510">
+            <a:solidFill>
+              <a:srgbClr val="1F4E79"/>
+            </a:solidFill>
+          </a:ln>
+          <a:effectLst/>
+        </p:spPr>
+        <p:style>
+          <a:lnRef idx="1">
+            <a:schemeClr val="accent1"/>
+          </a:lnRef>
+          <a:fillRef idx="3">
+            <a:schemeClr val="accent1"/>
+          </a:fillRef>
+          <a:effectRef idx="2">
+            <a:schemeClr val="accent1"/>
+          </a:effectRef>
+          <a:fontRef idx="minor">
+            <a:schemeClr val="lt1"/>
+          </a:fontRef>
+        </p:style>
+        <p:txBody>
+          <a:bodyPr wrap="square" rtlCol="0" anchor="ctr"/>
+          <a:lstStyle/>
+          <a:p>
+            <a:pPr algn="ctr"/>
+            <a:r>
+              <a:rPr sz="1200">
+                <a:solidFill>
+                  <a:srgbClr val="1F4E79"/>
+                </a:solidFill>
+                <a:latin typeface="微软雅黑" panose="020B0503020204020204" charset="-122"/>
+                <a:ea typeface="微软雅黑" panose="020B0503020204020204" charset="-122"/>
+                <a:cs typeface="微软雅黑" panose="020B0503020204020204" charset="-122"/>
+              </a:rPr>
+              <a:t>③ 向量化并
+检索 top_k 片段</a:t>
+            </a:r>
+            <a:endParaRPr sz="1200">
+              <a:solidFill>
+                <a:srgbClr val="1F4E79"/>
+              </a:solidFill>
+              <a:latin typeface="微软雅黑" panose="020B0503020204020204" charset="-122"/>
+              <a:ea typeface="微软雅黑" panose="020B0503020204020204" charset="-122"/>
+              <a:cs typeface="微软雅黑" panose="020B0503020204020204" charset="-122"/>
+            </a:endParaRPr>
+          </a:p>
+        </p:txBody>
+      </p:sp>
+      <p:sp>
+        <p:nvSpPr>
+          <p:cNvPr id="11" name="Down Arrow 10"/>
+          <p:cNvSpPr/>
+          <p:nvPr/>
+        </p:nvSpPr>
+        <p:spPr>
+          <a:xfrm>
+            <a:off x="2697480" y="4059935"/>
+            <a:ext cx="182880" cy="256032"/>
+          </a:xfrm>
+          <a:prstGeom prst="downArrow">
+            <a:avLst/>
+          </a:prstGeom>
+          <a:solidFill>
+            <a:srgbClr val="2E75B6"/>
+          </a:solidFill>
+          <a:ln>
+            <a:noFill/>
+          </a:ln>
+          <a:effectLst/>
+        </p:spPr>
+        <p:style>
+          <a:lnRef idx="1">
+            <a:schemeClr val="accent1"/>
+          </a:lnRef>
+          <a:fillRef idx="3">
+            <a:schemeClr val="accent1"/>
+          </a:fillRef>
+          <a:effectRef idx="2">
+            <a:schemeClr val="accent1"/>
+          </a:effectRef>
+          <a:fontRef idx="minor">
+            <a:schemeClr val="lt1"/>
+          </a:fontRef>
+        </p:style>
+        <p:txBody>
+          <a:bodyPr rtlCol="0" anchor="ctr"/>
+          <a:lstStyle/>
+          <a:p>
+            <a:pPr algn="ctr"/>
+          </a:p>
+        </p:txBody>
+      </p:sp>
+      <p:sp>
+        <p:nvSpPr>
+          <p:cNvPr id="12" name="Rounded Rectangle 11"/>
+          <p:cNvSpPr/>
+          <p:nvPr/>
+        </p:nvSpPr>
+        <p:spPr>
+          <a:xfrm>
+            <a:off x="502920" y="4315968"/>
+            <a:ext cx="4480560" cy="658368"/>
+          </a:xfrm>
+          <a:prstGeom prst="roundRect">
+            <a:avLst/>
+          </a:prstGeom>
+          <a:solidFill>
+            <a:srgbClr val="EAF3FB"/>
+          </a:solidFill>
+          <a:ln w="16510">
+            <a:solidFill>
+              <a:srgbClr val="1F4E79"/>
+            </a:solidFill>
+          </a:ln>
+          <a:effectLst/>
+        </p:spPr>
+        <p:style>
+          <a:lnRef idx="1">
+            <a:schemeClr val="accent1"/>
+          </a:lnRef>
+          <a:fillRef idx="3">
+            <a:schemeClr val="accent1"/>
+          </a:fillRef>
+          <a:effectRef idx="2">
+            <a:schemeClr val="accent1"/>
+          </a:effectRef>
+          <a:fontRef idx="minor">
+            <a:schemeClr val="lt1"/>
+          </a:fontRef>
+        </p:style>
+        <p:txBody>
+          <a:bodyPr wrap="square" rtlCol="0" anchor="ctr"/>
+          <a:lstStyle/>
+          <a:p>
+            <a:pPr algn="ctr"/>
+            <a:r>
+              <a:rPr sz="1200">
+                <a:solidFill>
+                  <a:srgbClr val="1F4E79"/>
+                </a:solidFill>
+                <a:latin typeface="微软雅黑" panose="020B0503020204020204" charset="-122"/>
+                <a:ea typeface="微软雅黑" panose="020B0503020204020204" charset="-122"/>
+                <a:cs typeface="微软雅黑" panose="020B0503020204020204" charset="-122"/>
+              </a:rPr>
+              <a:t>④ 拼接上下文
+大模型生成</a:t>
+            </a:r>
+            <a:endParaRPr sz="1200">
+              <a:solidFill>
+                <a:srgbClr val="1F4E79"/>
+              </a:solidFill>
+              <a:latin typeface="微软雅黑" panose="020B0503020204020204" charset="-122"/>
+              <a:ea typeface="微软雅黑" panose="020B0503020204020204" charset="-122"/>
+              <a:cs typeface="微软雅黑" panose="020B0503020204020204" charset="-122"/>
+            </a:endParaRPr>
+          </a:p>
+        </p:txBody>
+      </p:sp>
+      <p:sp>
+        <p:nvSpPr>
+          <p:cNvPr id="13" name="Down Arrow 12"/>
+          <p:cNvSpPr/>
+          <p:nvPr/>
+        </p:nvSpPr>
+        <p:spPr>
+          <a:xfrm>
+            <a:off x="2697480" y="4974336"/>
+            <a:ext cx="182880" cy="256032"/>
+          </a:xfrm>
+          <a:prstGeom prst="downArrow">
+            <a:avLst/>
+          </a:prstGeom>
+          <a:solidFill>
+            <a:srgbClr val="2E75B6"/>
+          </a:solidFill>
+          <a:ln>
+            <a:noFill/>
+          </a:ln>
+          <a:effectLst/>
+        </p:spPr>
+        <p:style>
+          <a:lnRef idx="1">
+            <a:schemeClr val="accent1"/>
+          </a:lnRef>
+          <a:fillRef idx="3">
+            <a:schemeClr val="accent1"/>
+          </a:fillRef>
+          <a:effectRef idx="2">
+            <a:schemeClr val="accent1"/>
+          </a:effectRef>
+          <a:fontRef idx="minor">
+            <a:schemeClr val="lt1"/>
+          </a:fontRef>
+        </p:style>
+        <p:txBody>
+          <a:bodyPr rtlCol="0" anchor="ctr"/>
+          <a:lstStyle/>
+          <a:p>
+            <a:pPr algn="ctr"/>
+          </a:p>
+        </p:txBody>
+      </p:sp>
+      <p:sp>
+        <p:nvSpPr>
+          <p:cNvPr id="14" name="Rounded Rectangle 13"/>
+          <p:cNvSpPr/>
+          <p:nvPr/>
+        </p:nvSpPr>
+        <p:spPr>
+          <a:xfrm>
+            <a:off x="502920" y="5230368"/>
+            <a:ext cx="4480560" cy="658368"/>
+          </a:xfrm>
+          <a:prstGeom prst="roundRect">
+            <a:avLst/>
+          </a:prstGeom>
+          <a:solidFill>
+            <a:srgbClr val="EAF3FB"/>
+          </a:solidFill>
+          <a:ln w="16510">
+            <a:solidFill>
+              <a:srgbClr val="1F4E79"/>
+            </a:solidFill>
+          </a:ln>
+          <a:effectLst/>
+        </p:spPr>
+        <p:style>
+          <a:lnRef idx="1">
+            <a:schemeClr val="accent1"/>
+          </a:lnRef>
+          <a:fillRef idx="3">
+            <a:schemeClr val="accent1"/>
+          </a:fillRef>
+          <a:effectRef idx="2">
+            <a:schemeClr val="accent1"/>
+          </a:effectRef>
+          <a:fontRef idx="minor">
+            <a:schemeClr val="lt1"/>
+          </a:fontRef>
+        </p:style>
+        <p:txBody>
+          <a:bodyPr wrap="square" rtlCol="0" anchor="ctr"/>
+          <a:lstStyle/>
+          <a:p>
+            <a:pPr algn="ctr"/>
+            <a:r>
+              <a:rPr sz="1200">
+                <a:solidFill>
+                  <a:srgbClr val="1F4E79"/>
+                </a:solidFill>
+                <a:latin typeface="微软雅黑" panose="020B0503020204020204" charset="-122"/>
+                <a:ea typeface="微软雅黑" panose="020B0503020204020204" charset="-122"/>
+                <a:cs typeface="微软雅黑" panose="020B0503020204020204" charset="-122"/>
+              </a:rPr>
+              <a:t>⑤ 返回回答
++ 引用来源</a:t>
+            </a:r>
+            <a:endParaRPr sz="1200">
+              <a:solidFill>
+                <a:srgbClr val="1F4E79"/>
+              </a:solidFill>
+              <a:latin typeface="微软雅黑" panose="020B0503020204020204" charset="-122"/>
+              <a:ea typeface="微软雅黑" panose="020B0503020204020204" charset="-122"/>
+              <a:cs typeface="微软雅黑" panose="020B0503020204020204" charset="-122"/>
+            </a:endParaRPr>
+          </a:p>
+        </p:txBody>
+      </p:sp>
+      <p:sp>
+        <p:nvSpPr>
+          <p:cNvPr id="15" name="TextBox 14"/>
+          <p:cNvSpPr txBox="1"/>
+          <p:nvPr/>
+        </p:nvSpPr>
+        <p:spPr>
+          <a:xfrm>
+            <a:off x="502920" y="6144768"/>
+            <a:ext cx="4572000" cy="457200"/>
+          </a:xfrm>
+          <a:prstGeom prst="rect">
+            <a:avLst/>
+          </a:prstGeom>
+          <a:noFill/>
+        </p:spPr>
+        <p:txBody>
+          <a:bodyPr wrap="square" lIns="0" tIns="0" rIns="0" bIns="0" anchor="t">
+            <a:spAutoFit/>
+          </a:bodyPr>
+          <a:lstStyle/>
+          <a:p>
+            <a:pPr algn="l">
+              <a:spcAft>
+                <a:spcPts val="600"/>
+              </a:spcAft>
+            </a:pPr>
+            <a:r>
+              <a:rPr sz="1200">
+                <a:solidFill>
+                  <a:srgbClr val="808080"/>
+                </a:solidFill>
+                <a:latin typeface="微软雅黑" panose="020B0503020204020204" charset="-122"/>
+                <a:ea typeface="微软雅黑" panose="020B0503020204020204" charset="-122"/>
+                <a:cs typeface="微软雅黑" panose="020B0503020204020204" charset="-122"/>
+              </a:rPr>
+              <a:t>亮点：答案可溯源，附文件名与原文片段摘要</a:t>
+            </a:r>
+            <a:endParaRPr sz="1200">
+              <a:solidFill>
+                <a:srgbClr val="808080"/>
+              </a:solidFill>
+              <a:latin typeface="微软雅黑" panose="020B0503020204020204" charset="-122"/>
+              <a:ea typeface="微软雅黑" panose="020B0503020204020204" charset="-122"/>
+              <a:cs typeface="微软雅黑" panose="020B0503020204020204" charset="-122"/>
+            </a:endParaRPr>
+          </a:p>
+        </p:txBody>
+      </p:sp>
+      <p:sp>
+        <p:nvSpPr>
+          <p:cNvPr id="16" name="Rectangle 15"/>
+          <p:cNvSpPr/>
+          <p:nvPr/>
+        </p:nvSpPr>
+        <p:spPr>
+          <a:xfrm>
+            <a:off x="5577840" y="1280160"/>
+            <a:ext cx="5943600" cy="3931920"/>
+          </a:xfrm>
+          <a:prstGeom prst="rect">
+            <a:avLst/>
+          </a:prstGeom>
+          <a:solidFill>
+            <a:srgbClr val="F2F2F2"/>
+          </a:solidFill>
+          <a:ln w="15240">
+            <a:solidFill>
+              <a:srgbClr val="C00000"/>
+            </a:solidFill>
+            <a:prstDash val="dash"/>
+          </a:ln>
+          <a:effectLst/>
+        </p:spPr>
+        <p:style>
+          <a:lnRef idx="1">
+            <a:schemeClr val="accent1"/>
+          </a:lnRef>
+          <a:fillRef idx="3">
+            <a:schemeClr val="accent1"/>
+          </a:fillRef>
+          <a:effectRef idx="2">
+            <a:schemeClr val="accent1"/>
+          </a:effectRef>
+          <a:fontRef idx="minor">
+            <a:schemeClr val="lt1"/>
+          </a:fontRef>
+        </p:style>
+        <p:txBody>
+          <a:bodyPr wrap="square" rtlCol="0" anchor="ctr"/>
+          <a:lstStyle/>
+          <a:p>
+            <a:pPr algn="ctr"/>
+            <a:r>
+              <a:rPr sz="1300">
+                <a:solidFill>
+                  <a:srgbClr val="C00000"/>
+                </a:solidFill>
+                <a:latin typeface="微软雅黑" panose="020B0503020204020204" charset="-122"/>
+                <a:ea typeface="微软雅黑" panose="020B0503020204020204" charset="-122"/>
+                <a:cs typeface="微软雅黑" panose="020B0503020204020204" charset="-122"/>
+              </a:rPr>
+              <a:t>【截图 B】
+智能问答页演示</a:t>
+            </a:r>
+            <a:endParaRPr sz="1300">
+              <a:solidFill>
+                <a:srgbClr val="C00000"/>
+              </a:solidFill>
+              <a:latin typeface="微软雅黑" panose="020B0503020204020204" charset="-122"/>
+              <a:ea typeface="微软雅黑" panose="020B0503020204020204" charset="-122"/>
+              <a:cs typeface="微软雅黑" panose="020B0503020204020204" charset="-122"/>
+            </a:endParaRPr>
+          </a:p>
+          <a:p>
+            <a:pPr algn="ctr"/>
+            <a:r>
+              <a:rPr sz="1000">
+                <a:solidFill>
+                  <a:srgbClr val="808080"/>
+                </a:solidFill>
+                <a:latin typeface="微软雅黑" panose="020B0503020204020204" charset="-122"/>
+                <a:ea typeface="微软雅黑" panose="020B0503020204020204" charset="-122"/>
+                <a:cs typeface="微软雅黑" panose="020B0503020204020204" charset="-122"/>
+              </a:rPr>
+              <a:t>聊天式布局 + AI 回答
++ 回答下方的引用来源卡片（文件名/原文摘要）</a:t>
+            </a:r>
+            <a:endParaRPr sz="1000">
+              <a:solidFill>
+                <a:srgbClr val="808080"/>
+              </a:solidFill>
+              <a:latin typeface="微软雅黑" panose="020B0503020204020204" charset="-122"/>
+              <a:ea typeface="微软雅黑" panose="020B0503020204020204" charset="-122"/>
+              <a:cs typeface="微软雅黑" panose="020B0503020204020204" charset="-122"/>
+            </a:endParaRPr>
+          </a:p>
+        </p:txBody>
+      </p:sp>
+      <p:sp>
+        <p:nvSpPr>
+          <p:cNvPr id="17" name="TextBox 16"/>
+          <p:cNvSpPr txBox="1"/>
+          <p:nvPr/>
+        </p:nvSpPr>
+        <p:spPr>
+          <a:xfrm>
+            <a:off x="5577840" y="5321808"/>
+            <a:ext cx="5943600" cy="168910"/>
+          </a:xfrm>
+          <a:prstGeom prst="rect">
+            <a:avLst/>
+          </a:prstGeom>
+          <a:noFill/>
+        </p:spPr>
+        <p:txBody>
+          <a:bodyPr wrap="square" lIns="0" tIns="0" rIns="0" bIns="0" anchor="t">
+            <a:spAutoFit/>
+          </a:bodyPr>
+          <a:lstStyle/>
+          <a:p>
+            <a:pPr algn="ctr">
+              <a:spcAft>
+                <a:spcPts val="600"/>
+              </a:spcAft>
+            </a:pPr>
+            <a:r>
+              <a:rPr sz="1100">
+                <a:solidFill>
+                  <a:srgbClr val="808080"/>
+                </a:solidFill>
+                <a:latin typeface="微软雅黑" panose="020B0503020204020204" charset="-122"/>
+                <a:ea typeface="微软雅黑" panose="020B0503020204020204" charset="-122"/>
+                <a:cs typeface="微软雅黑" panose="020B0503020204020204" charset="-122"/>
+              </a:rPr>
+              <a:t>演示截图</a:t>
+            </a:r>
+            <a:endParaRPr sz="1100">
+              <a:solidFill>
+                <a:srgbClr val="808080"/>
+              </a:solidFill>
+              <a:latin typeface="微软雅黑" panose="020B0503020204020204" charset="-122"/>
+              <a:ea typeface="微软雅黑" panose="020B0503020204020204" charset="-122"/>
+              <a:cs typeface="微软雅黑" panose="020B0503020204020204" charset="-122"/>
+            </a:endParaRPr>
+          </a:p>
+        </p:txBody>
+      </p:sp>
+      <p:sp>
+        <p:nvSpPr>
+          <p:cNvPr id="18" name="TextBox 17"/>
+          <p:cNvSpPr txBox="1"/>
+          <p:nvPr/>
+        </p:nvSpPr>
+        <p:spPr>
+          <a:xfrm>
+            <a:off x="11247120" y="6473952"/>
+            <a:ext cx="640080" cy="274320"/>
+          </a:xfrm>
+          <a:prstGeom prst="rect">
+            <a:avLst/>
+          </a:prstGeom>
+          <a:noFill/>
+        </p:spPr>
+        <p:txBody>
+          <a:bodyPr wrap="none">
+            <a:spAutoFit/>
+          </a:bodyPr>
+          <a:lstStyle/>
+          <a:p>
+            <a:pPr algn="r"/>
+            <a:r>
+              <a:rPr sz="1000">
+                <a:solidFill>
+                  <a:srgbClr val="808080"/>
+                </a:solidFill>
+                <a:latin typeface="微软雅黑" panose="020B0503020204020204" charset="-122"/>
+                <a:ea typeface="微软雅黑" panose="020B0503020204020204" charset="-122"/>
+                <a:cs typeface="微软雅黑" panose="020B0503020204020204" charset="-122"/>
+              </a:rPr>
+              <a:t>11</a:t>
+            </a:r>
+            <a:endParaRPr sz="1000">
+              <a:solidFill>
+                <a:srgbClr val="808080"/>
+              </a:solidFill>
+              <a:latin typeface="微软雅黑" panose="020B0503020204020204" charset="-122"/>
+              <a:ea typeface="微软雅黑" panose="020B0503020204020204" charset="-122"/>
+              <a:cs typeface="微软雅黑" panose="020B0503020204020204" charset="-122"/>
+            </a:endParaRPr>
+          </a:p>
+        </p:txBody>
+      </p:sp>
+      <p:pic>
+        <p:nvPicPr>
+          <p:cNvPr id="19" name="图片 18" descr="ca5a6761a4240cfa9514e9ef41757ecc"/>
+          <p:cNvPicPr>
+            <a:picLocks noChangeAspect="1"/>
+          </p:cNvPicPr>
+          <p:nvPr/>
+        </p:nvPicPr>
+        <p:blipFill>
+          <a:blip r:embed="rId1"/>
+          <a:stretch>
+            <a:fillRect/>
+          </a:stretch>
+        </p:blipFill>
+        <p:spPr>
+          <a:xfrm>
+            <a:off x="5346700" y="1219835"/>
+            <a:ext cx="6360795" cy="4102100"/>
+          </a:xfrm>
+          <a:prstGeom prst="rect">
+            <a:avLst/>
+          </a:prstGeom>
+        </p:spPr>
+      </p:pic>
+    </p:spTree>
+  </p:cSld>
+  <p:clrMapOvr>
+    <a:masterClrMapping/>
+  </p:clrMapOvr>
+</p:sld>
+</file>
+
+<file path=ppt/slides/slide12.xml><?xml version="1.0" encoding="utf-8"?>
+<p:sld xmlns:a="http://schemas.openxmlformats.org/drawingml/2006/main" xmlns:r="http://schemas.openxmlformats.org/officeDocument/2006/relationships" xmlns:p="http://schemas.openxmlformats.org/presentationml/2006/main">
+  <p:cSld>
+    <p:spTree>
+      <p:nvGrpSpPr>
+        <p:cNvPr id="1" name=""/>
+        <p:cNvGrpSpPr/>
+        <p:nvPr/>
+      </p:nvGrpSpPr>
+      <p:grpSpPr/>
+      <p:sp>
+        <p:nvSpPr>
+          <p:cNvPr id="2" name="Rectangle 1"/>
+          <p:cNvSpPr/>
+          <p:nvPr/>
+        </p:nvSpPr>
+        <p:spPr>
+          <a:xfrm>
+            <a:off x="0" y="0"/>
+            <a:ext cx="12191695" cy="960120"/>
+          </a:xfrm>
+          <a:prstGeom prst="rect">
+            <a:avLst/>
+          </a:prstGeom>
+          <a:solidFill>
+            <a:srgbClr val="1F4E79"/>
+          </a:solidFill>
+          <a:ln>
+            <a:noFill/>
+          </a:ln>
+          <a:effectLst/>
+        </p:spPr>
+        <p:style>
+          <a:lnRef idx="1">
+            <a:schemeClr val="accent1"/>
+          </a:lnRef>
+          <a:fillRef idx="3">
+            <a:schemeClr val="accent1"/>
+          </a:fillRef>
+          <a:effectRef idx="2">
+            <a:schemeClr val="accent1"/>
+          </a:effectRef>
+          <a:fontRef idx="minor">
+            <a:schemeClr val="lt1"/>
+          </a:fontRef>
+        </p:style>
+        <p:txBody>
+          <a:bodyPr rtlCol="0" anchor="ctr"/>
+          <a:lstStyle/>
+          <a:p>
+            <a:pPr algn="ctr"/>
+          </a:p>
+        </p:txBody>
+      </p:sp>
+      <p:sp>
+        <p:nvSpPr>
+          <p:cNvPr id="3" name="TextBox 2"/>
+          <p:cNvSpPr txBox="1"/>
+          <p:nvPr/>
+        </p:nvSpPr>
+        <p:spPr>
+          <a:xfrm>
+            <a:off x="502920" y="182880"/>
+            <a:ext cx="11155680" cy="621792"/>
+          </a:xfrm>
+          <a:prstGeom prst="rect">
+            <a:avLst/>
+          </a:prstGeom>
+          <a:noFill/>
+        </p:spPr>
+        <p:txBody>
+          <a:bodyPr wrap="square" lIns="0" tIns="0" rIns="0" bIns="0" anchor="ctr">
+            <a:spAutoFit/>
+          </a:bodyPr>
+          <a:lstStyle/>
+          <a:p>
+            <a:pPr algn="l">
               <a:lnSpc>
                 <a:spcPct val="125000"/>
               </a:lnSpc>
@@ -5354,7 +7191,7 @@
               </a:spcAft>
             </a:pPr>
             <a:r>
-              <a:rPr sz="2600" b="1">
+              <a:rPr sz="2600">
                 <a:solidFill>
                   <a:srgbClr val="FFFFFF"/>
                 </a:solidFill>
@@ -5362,9 +7199,9 @@
                 <a:ea typeface="微软雅黑" panose="020B0503020204020204" charset="-122"/>
                 <a:cs typeface="微软雅黑" panose="020B0503020204020204" charset="-122"/>
               </a:rPr>
-              <a:t>5.1　F3 自动出题与判题模块</a:t>
-            </a:r>
-            <a:endParaRPr sz="2600" b="1">
+              <a:t>5.3　F3 自动出题与判题模块</a:t>
+            </a:r>
+            <a:endParaRPr sz="2600">
               <a:solidFill>
                 <a:srgbClr val="FFFFFF"/>
               </a:solidFill>
@@ -5465,14 +7302,18 @@
                   <a:srgbClr val="808080"/>
                 </a:solidFill>
                 <a:latin typeface="微软雅黑" panose="020B0503020204020204" charset="-122"/>
+                <a:ea typeface="微软雅黑" panose="020B0503020204020204" charset="-122"/>
+                <a:cs typeface="微软雅黑" panose="020B0503020204020204" charset="-122"/>
               </a:rPr>
-              <a:t>10</a:t>
+              <a:t>12</a:t>
             </a:r>
             <a:endParaRPr sz="1000">
               <a:solidFill>
                 <a:srgbClr val="808080"/>
               </a:solidFill>
               <a:latin typeface="微软雅黑" panose="020B0503020204020204" charset="-122"/>
+              <a:ea typeface="微软雅黑" panose="020B0503020204020204" charset="-122"/>
+              <a:cs typeface="微软雅黑" panose="020B0503020204020204" charset="-122"/>
             </a:endParaRPr>
           </a:p>
         </p:txBody>
@@ -5541,8 +7382,8 @@
           <p:nvPr/>
         </p:nvGraphicFramePr>
         <p:xfrm>
-          <a:off x="548640" y="1572768"/>
-          <a:ext cx="11091672" cy="2103120"/>
+          <a:off x="548640" y="1572895"/>
+          <a:ext cx="6242050" cy="2103120"/>
         </p:xfrm>
         <a:graphic>
           <a:graphicData uri="http://schemas.openxmlformats.org/drawingml/2006/table">
@@ -5551,8 +7392,8 @@
                 <a:tableStyleId>{5C22544A-7EE6-4342-B048-85BDC9FD1C3A}</a:tableStyleId>
               </a:tblPr>
               <a:tblGrid>
-                <a:gridCol w="1232408"/>
-                <a:gridCol w="9859264"/>
+                <a:gridCol w="694055"/>
+                <a:gridCol w="5547995"/>
               </a:tblGrid>
               <a:tr h="420624">
                 <a:tc>
@@ -5961,8 +7802,8 @@
         </p:nvSpPr>
         <p:spPr>
           <a:xfrm>
-            <a:off x="548640" y="4133087"/>
-            <a:ext cx="11091672" cy="2103120"/>
+            <a:off x="548640" y="4133215"/>
+            <a:ext cx="4796155" cy="1499870"/>
           </a:xfrm>
           <a:prstGeom prst="rect">
             <a:avLst/>
@@ -6105,6 +7946,30 @@
           </a:p>
         </p:txBody>
       </p:sp>
+      <p:pic>
+        <p:nvPicPr>
+          <p:cNvPr id="10" name="图片 9" descr="616d32327babf71b30e6beb8c57db5f6"/>
+          <p:cNvPicPr>
+            <a:picLocks noChangeAspect="1"/>
+          </p:cNvPicPr>
+          <p:nvPr/>
+        </p:nvPicPr>
+        <p:blipFill>
+          <a:blip r:embed="rId1"/>
+          <a:stretch>
+            <a:fillRect/>
+          </a:stretch>
+        </p:blipFill>
+        <p:spPr>
+          <a:xfrm>
+            <a:off x="6112510" y="1508760"/>
+            <a:ext cx="5788025" cy="3320415"/>
+          </a:xfrm>
+          <a:prstGeom prst="rect">
+            <a:avLst/>
+          </a:prstGeom>
+        </p:spPr>
+      </p:pic>
     </p:spTree>
   </p:cSld>
   <p:clrMapOvr>
@@ -6113,7 +7978,7 @@
 </p:sld>
 </file>
 
-<file path=ppt/slides/slide11.xml><?xml version="1.0" encoding="utf-8"?>
+<file path=ppt/slides/slide13.xml><?xml version="1.0" encoding="utf-8"?>
 <p:sld xmlns:a="http://schemas.openxmlformats.org/drawingml/2006/main" xmlns:r="http://schemas.openxmlformats.org/officeDocument/2006/relationships" xmlns:p="http://schemas.openxmlformats.org/presentationml/2006/main">
   <p:cSld>
     <p:spTree>
@@ -6201,7 +8066,7 @@
               </a:spcAft>
             </a:pPr>
             <a:r>
-              <a:rPr sz="2600" b="1">
+              <a:rPr sz="2600">
                 <a:solidFill>
                   <a:srgbClr val="FFFFFF"/>
                 </a:solidFill>
@@ -6209,9 +8074,9 @@
                 <a:ea typeface="微软雅黑" panose="020B0503020204020204" charset="-122"/>
                 <a:cs typeface="微软雅黑" panose="020B0503020204020204" charset="-122"/>
               </a:rPr>
-              <a:t>5.2　F4 错题本与 F5 复习计划模块</a:t>
-            </a:r>
-            <a:endParaRPr sz="2600" b="1">
+              <a:t>5.4　F4 错题本与 F5 复习计划模块</a:t>
+            </a:r>
+            <a:endParaRPr sz="2600">
               <a:solidFill>
                 <a:srgbClr val="FFFFFF"/>
               </a:solidFill>
@@ -6312,14 +8177,18 @@
                   <a:srgbClr val="808080"/>
                 </a:solidFill>
                 <a:latin typeface="微软雅黑" panose="020B0503020204020204" charset="-122"/>
+                <a:ea typeface="微软雅黑" panose="020B0503020204020204" charset="-122"/>
+                <a:cs typeface="微软雅黑" panose="020B0503020204020204" charset="-122"/>
               </a:rPr>
-              <a:t>11</a:t>
+              <a:t>13</a:t>
             </a:r>
             <a:endParaRPr sz="1000">
               <a:solidFill>
                 <a:srgbClr val="808080"/>
               </a:solidFill>
               <a:latin typeface="微软雅黑" panose="020B0503020204020204" charset="-122"/>
+              <a:ea typeface="微软雅黑" panose="020B0503020204020204" charset="-122"/>
+              <a:cs typeface="微软雅黑" panose="020B0503020204020204" charset="-122"/>
             </a:endParaRPr>
           </a:p>
         </p:txBody>
@@ -6387,8 +8256,8 @@
         </p:nvSpPr>
         <p:spPr>
           <a:xfrm>
-            <a:off x="548640" y="1572768"/>
-            <a:ext cx="11091672" cy="1234440"/>
+            <a:off x="548640" y="1572895"/>
+            <a:ext cx="5084445" cy="1230630"/>
           </a:xfrm>
           <a:prstGeom prst="rect">
             <a:avLst/>
@@ -6595,8 +8464,8 @@
           <p:nvPr/>
         </p:nvGraphicFramePr>
         <p:xfrm>
-          <a:off x="548640" y="3218688"/>
-          <a:ext cx="11091672" cy="2103120"/>
+          <a:off x="548640" y="3218815"/>
+          <a:ext cx="4276090" cy="3413760"/>
         </p:xfrm>
         <a:graphic>
           <a:graphicData uri="http://schemas.openxmlformats.org/drawingml/2006/table">
@@ -6605,10 +8474,10 @@
                 <a:tableStyleId>{5C22544A-7EE6-4342-B048-85BDC9FD1C3A}</a:tableStyleId>
               </a:tblPr>
               <a:tblGrid>
-                <a:gridCol w="1232408"/>
-                <a:gridCol w="9859264"/>
+                <a:gridCol w="474980"/>
+                <a:gridCol w="3801110"/>
               </a:tblGrid>
-              <a:tr h="420624">
+              <a:tr h="487680">
                 <a:tc>
                   <a:txBody>
                     <a:bodyPr/>
@@ -6676,7 +8545,7 @@
                   </a:tcPr>
                 </a:tc>
               </a:tr>
-              <a:tr h="420624">
+              <a:tr h="822960">
                 <a:tc>
                   <a:txBody>
                     <a:bodyPr/>
@@ -6744,7 +8613,7 @@
                   </a:tcPr>
                 </a:tc>
               </a:tr>
-              <a:tr h="420624">
+              <a:tr h="640080">
                 <a:tc>
                   <a:txBody>
                     <a:bodyPr/>
@@ -6812,7 +8681,7 @@
                   </a:tcPr>
                 </a:tc>
               </a:tr>
-              <a:tr h="420624">
+              <a:tr h="822960">
                 <a:tc>
                   <a:txBody>
                     <a:bodyPr/>
@@ -6880,7 +8749,7 @@
                   </a:tcPr>
                 </a:tc>
               </a:tr>
-              <a:tr h="420624">
+              <a:tr h="640080">
                 <a:tc>
                   <a:txBody>
                     <a:bodyPr/>
@@ -6952,6 +8821,54 @@
           </a:graphicData>
         </a:graphic>
       </p:graphicFrame>
+      <p:pic>
+        <p:nvPicPr>
+          <p:cNvPr id="10" name="图片 9" descr="58cb55beb300f6cca056702bbbcf823d"/>
+          <p:cNvPicPr>
+            <a:picLocks noChangeAspect="1"/>
+          </p:cNvPicPr>
+          <p:nvPr/>
+        </p:nvPicPr>
+        <p:blipFill>
+          <a:blip r:embed="rId1"/>
+          <a:stretch>
+            <a:fillRect/>
+          </a:stretch>
+        </p:blipFill>
+        <p:spPr>
+          <a:xfrm>
+            <a:off x="6117590" y="1214120"/>
+            <a:ext cx="4565015" cy="2525395"/>
+          </a:xfrm>
+          <a:prstGeom prst="rect">
+            <a:avLst/>
+          </a:prstGeom>
+        </p:spPr>
+      </p:pic>
+      <p:pic>
+        <p:nvPicPr>
+          <p:cNvPr id="11" name="图片 10" descr="1ea2b7f88a7f4e965704607efe77f8a5"/>
+          <p:cNvPicPr>
+            <a:picLocks noChangeAspect="1"/>
+          </p:cNvPicPr>
+          <p:nvPr/>
+        </p:nvPicPr>
+        <p:blipFill>
+          <a:blip r:embed="rId2"/>
+          <a:stretch>
+            <a:fillRect/>
+          </a:stretch>
+        </p:blipFill>
+        <p:spPr>
+          <a:xfrm>
+            <a:off x="6099810" y="3899535"/>
+            <a:ext cx="4582795" cy="2536190"/>
+          </a:xfrm>
+          <a:prstGeom prst="rect">
+            <a:avLst/>
+          </a:prstGeom>
+        </p:spPr>
+      </p:pic>
     </p:spTree>
   </p:cSld>
   <p:clrMapOvr>
@@ -6960,7 +8877,7 @@
 </p:sld>
 </file>
 
-<file path=ppt/slides/slide12.xml><?xml version="1.0" encoding="utf-8"?>
+<file path=ppt/slides/slide14.xml><?xml version="1.0" encoding="utf-8"?>
 <p:sld xmlns:a="http://schemas.openxmlformats.org/drawingml/2006/main" xmlns:r="http://schemas.openxmlformats.org/officeDocument/2006/relationships" xmlns:p="http://schemas.openxmlformats.org/presentationml/2006/main">
   <p:cSld>
     <p:spTree>
@@ -7048,7 +8965,7 @@
               </a:spcAft>
             </a:pPr>
             <a:r>
-              <a:rPr sz="2600" b="1">
+              <a:rPr sz="2600">
                 <a:solidFill>
                   <a:srgbClr val="FFFFFF"/>
                 </a:solidFill>
@@ -7056,9 +8973,9 @@
                 <a:ea typeface="微软雅黑" panose="020B0503020204020204" charset="-122"/>
                 <a:cs typeface="微软雅黑" panose="020B0503020204020204" charset="-122"/>
               </a:rPr>
-              <a:t>5.3　前端界面与系统测试</a:t>
-            </a:r>
-            <a:endParaRPr sz="2600" b="1">
+              <a:t>5.5　前端界面与系统测试</a:t>
+            </a:r>
+            <a:endParaRPr sz="2600">
               <a:solidFill>
                 <a:srgbClr val="FFFFFF"/>
               </a:solidFill>
@@ -7159,14 +9076,18 @@
                   <a:srgbClr val="808080"/>
                 </a:solidFill>
                 <a:latin typeface="微软雅黑" panose="020B0503020204020204" charset="-122"/>
+                <a:ea typeface="微软雅黑" panose="020B0503020204020204" charset="-122"/>
+                <a:cs typeface="微软雅黑" panose="020B0503020204020204" charset="-122"/>
               </a:rPr>
-              <a:t>12</a:t>
+              <a:t>14</a:t>
             </a:r>
             <a:endParaRPr sz="1000">
               <a:solidFill>
                 <a:srgbClr val="808080"/>
               </a:solidFill>
               <a:latin typeface="微软雅黑" panose="020B0503020204020204" charset="-122"/>
+              <a:ea typeface="微软雅黑" panose="020B0503020204020204" charset="-122"/>
+              <a:cs typeface="微软雅黑" panose="020B0503020204020204" charset="-122"/>
             </a:endParaRPr>
           </a:p>
         </p:txBody>
@@ -8335,7 +10256,7 @@
 </p:sld>
 </file>
 
-<file path=ppt/slides/slide13.xml><?xml version="1.0" encoding="utf-8"?>
+<file path=ppt/slides/slide15.xml><?xml version="1.0" encoding="utf-8"?>
 <p:sld xmlns:a="http://schemas.openxmlformats.org/drawingml/2006/main" xmlns:r="http://schemas.openxmlformats.org/officeDocument/2006/relationships" xmlns:p="http://schemas.openxmlformats.org/presentationml/2006/main">
   <p:cSld>
     <p:spTree>
@@ -8397,8 +10318,8 @@
         </p:nvSpPr>
         <p:spPr>
           <a:xfrm>
-            <a:off x="502920" y="182880"/>
-            <a:ext cx="11155680" cy="621792"/>
+            <a:off x="502920" y="293751"/>
+            <a:ext cx="11155680" cy="400050"/>
           </a:xfrm>
           <a:prstGeom prst="rect">
             <a:avLst/>
@@ -8425,7 +10346,29 @@
                 <a:ea typeface="微软雅黑" panose="020B0503020204020204" charset="-122"/>
                 <a:cs typeface="微软雅黑" panose="020B0503020204020204" charset="-122"/>
               </a:rPr>
-              <a:t>5.4　系统界面展示（需补充截图）</a:t>
+              <a:t>5.</a:t>
+            </a:r>
+            <a:r>
+              <a:rPr lang="en-US" sz="2600">
+                <a:solidFill>
+                  <a:srgbClr val="FFFFFF"/>
+                </a:solidFill>
+                <a:latin typeface="微软雅黑" panose="020B0503020204020204" charset="-122"/>
+                <a:ea typeface="微软雅黑" panose="020B0503020204020204" charset="-122"/>
+                <a:cs typeface="微软雅黑" panose="020B0503020204020204" charset="-122"/>
+              </a:rPr>
+              <a:t>6</a:t>
+            </a:r>
+            <a:r>
+              <a:rPr sz="2600">
+                <a:solidFill>
+                  <a:srgbClr val="FFFFFF"/>
+                </a:solidFill>
+                <a:latin typeface="微软雅黑" panose="020B0503020204020204" charset="-122"/>
+                <a:ea typeface="微软雅黑" panose="020B0503020204020204" charset="-122"/>
+                <a:cs typeface="微软雅黑" panose="020B0503020204020204" charset="-122"/>
+              </a:rPr>
+              <a:t>　功能演示（五）：端到端学习闭环</a:t>
             </a:r>
             <a:endParaRPr sz="2600">
               <a:solidFill>
@@ -8471,40 +10414,92 @@
                   <a:srgbClr val="BDD7EE"/>
                 </a:solidFill>
                 <a:latin typeface="微软雅黑" panose="020B0503020204020204" charset="-122"/>
+                <a:ea typeface="微软雅黑" panose="020B0503020204020204" charset="-122"/>
+                <a:cs typeface="微软雅黑" panose="020B0503020204020204" charset="-122"/>
               </a:rPr>
-              <a:t>负责人：陈果</a:t>
+              <a:t>负责人：周承锦</a:t>
             </a:r>
             <a:endParaRPr sz="1300">
               <a:solidFill>
                 <a:srgbClr val="BDD7EE"/>
               </a:solidFill>
               <a:latin typeface="微软雅黑" panose="020B0503020204020204" charset="-122"/>
+              <a:ea typeface="微软雅黑" panose="020B0503020204020204" charset="-122"/>
+              <a:cs typeface="微软雅黑" panose="020B0503020204020204" charset="-122"/>
             </a:endParaRPr>
           </a:p>
         </p:txBody>
       </p:sp>
       <p:sp>
         <p:nvSpPr>
-          <p:cNvPr id="5" name="Rectangle 4"/>
-          <p:cNvSpPr/>
+          <p:cNvPr id="5" name="TextBox 4"/>
+          <p:cNvSpPr txBox="1"/>
           <p:nvPr/>
         </p:nvSpPr>
         <p:spPr>
           <a:xfrm>
-            <a:off x="548640" y="3566160"/>
-            <a:ext cx="3566160" cy="1417320"/>
+            <a:off x="502920" y="1078992"/>
+            <a:ext cx="11155680" cy="365760"/>
           </a:xfrm>
           <a:prstGeom prst="rect">
             <a:avLst/>
           </a:prstGeom>
+          <a:noFill/>
+        </p:spPr>
+        <p:txBody>
+          <a:bodyPr wrap="square" lIns="0" tIns="0" rIns="0" bIns="0" anchor="t">
+            <a:spAutoFit/>
+          </a:bodyPr>
+          <a:lstStyle/>
+          <a:p>
+            <a:pPr algn="l">
+              <a:spcAft>
+                <a:spcPts val="600"/>
+              </a:spcAft>
+            </a:pPr>
+            <a:r>
+              <a:rPr sz="1800">
+                <a:solidFill>
+                  <a:srgbClr val="2E75B6"/>
+                </a:solidFill>
+                <a:latin typeface="微软雅黑" panose="020B0503020204020204" charset="-122"/>
+                <a:ea typeface="微软雅黑" panose="020B0503020204020204" charset="-122"/>
+                <a:cs typeface="微软雅黑" panose="020B0503020204020204" charset="-122"/>
+              </a:rPr>
+              <a:t>一条完整的学习闭环（演示脚本）</a:t>
+            </a:r>
+            <a:endParaRPr sz="1800">
+              <a:solidFill>
+                <a:srgbClr val="2E75B6"/>
+              </a:solidFill>
+              <a:latin typeface="微软雅黑" panose="020B0503020204020204" charset="-122"/>
+              <a:ea typeface="微软雅黑" panose="020B0503020204020204" charset="-122"/>
+              <a:cs typeface="微软雅黑" panose="020B0503020204020204" charset="-122"/>
+            </a:endParaRPr>
+          </a:p>
+        </p:txBody>
+      </p:sp>
+      <p:sp>
+        <p:nvSpPr>
+          <p:cNvPr id="6" name="Rounded Rectangle 5"/>
+          <p:cNvSpPr/>
+          <p:nvPr/>
+        </p:nvSpPr>
+        <p:spPr>
+          <a:xfrm>
+            <a:off x="502920" y="1627632"/>
+            <a:ext cx="1874519" cy="914400"/>
+          </a:xfrm>
+          <a:prstGeom prst="roundRect">
+            <a:avLst/>
+          </a:prstGeom>
           <a:solidFill>
-            <a:srgbClr val="F2F2F2"/>
+            <a:srgbClr val="EAF3FB"/>
           </a:solidFill>
-          <a:ln w="15240">
+          <a:ln w="16510">
             <a:solidFill>
-              <a:srgbClr val="C00000"/>
+              <a:srgbClr val="1F4E79"/>
             </a:solidFill>
-            <a:prstDash val="dash"/>
           </a:ln>
           <a:effectLst/>
         </p:spPr>
@@ -8528,122 +10523,47 @@
           <a:p>
             <a:pPr algn="ctr"/>
             <a:r>
-              <a:rPr sz="1300">
+              <a:rPr sz="1200">
                 <a:solidFill>
-                  <a:srgbClr val="C00000"/>
+                  <a:srgbClr val="1F4E79"/>
                 </a:solidFill>
                 <a:latin typeface="微软雅黑" panose="020B0503020204020204" charset="-122"/>
                 <a:ea typeface="微软雅黑" panose="020B0503020204020204" charset="-122"/>
                 <a:cs typeface="微软雅黑" panose="020B0503020204020204" charset="-122"/>
               </a:rPr>
-              <a:t>【截图 1】
-文档管理页</a:t>
-            </a:r>
-            <a:endParaRPr sz="1300">
+              <a:t>上传课件
+建知识库</a:t>
+            </a:r>
+            <a:endParaRPr sz="1200">
               <a:solidFill>
-                <a:srgbClr val="C00000"/>
+                <a:srgbClr val="1F4E79"/>
               </a:solidFill>
               <a:latin typeface="微软雅黑" panose="020B0503020204020204" charset="-122"/>
               <a:ea typeface="微软雅黑" panose="020B0503020204020204" charset="-122"/>
               <a:cs typeface="微软雅黑" panose="020B0503020204020204" charset="-122"/>
             </a:endParaRPr>
           </a:p>
-          <a:p>
-            <a:pPr algn="ctr"/>
-            <a:r>
-              <a:rPr sz="1000">
-                <a:solidFill>
-                  <a:srgbClr val="808080"/>
-                </a:solidFill>
-                <a:latin typeface="微软雅黑" panose="020B0503020204020204" charset="-122"/>
-                <a:ea typeface="微软雅黑" panose="020B0503020204020204" charset="-122"/>
-                <a:cs typeface="微软雅黑" panose="020B0503020204020204" charset="-122"/>
-              </a:rPr>
-              <a:t>已选课程 + 文档列表
-含文件名与切分块数</a:t>
-            </a:r>
-            <a:endParaRPr sz="1000">
-              <a:solidFill>
-                <a:srgbClr val="808080"/>
-              </a:solidFill>
-              <a:latin typeface="微软雅黑" panose="020B0503020204020204" charset="-122"/>
-              <a:ea typeface="微软雅黑" panose="020B0503020204020204" charset="-122"/>
-              <a:cs typeface="微软雅黑" panose="020B0503020204020204" charset="-122"/>
-            </a:endParaRPr>
-          </a:p>
-        </p:txBody>
-      </p:sp>
-      <p:sp>
-        <p:nvSpPr>
-          <p:cNvPr id="6" name="TextBox 5"/>
-          <p:cNvSpPr txBox="1"/>
+        </p:txBody>
+      </p:sp>
+      <p:sp>
+        <p:nvSpPr>
+          <p:cNvPr id="7" name="Right Arrow 6"/>
+          <p:cNvSpPr/>
           <p:nvPr/>
         </p:nvSpPr>
         <p:spPr>
           <a:xfrm>
-            <a:off x="548640" y="5038344"/>
-            <a:ext cx="3566160" cy="310896"/>
+            <a:off x="2377439" y="1975104"/>
+            <a:ext cx="274320" cy="219456"/>
           </a:xfrm>
-          <a:prstGeom prst="rect">
-            <a:avLst/>
-          </a:prstGeom>
-          <a:noFill/>
-        </p:spPr>
-        <p:txBody>
-          <a:bodyPr wrap="square" lIns="0" tIns="0" rIns="0" bIns="0" anchor="t">
-            <a:spAutoFit/>
-          </a:bodyPr>
-          <a:lstStyle/>
-          <a:p>
-            <a:pPr algn="ctr">
-              <a:spcAft>
-                <a:spcPts val="600"/>
-              </a:spcAft>
-            </a:pPr>
-            <a:r>
-              <a:rPr sz="1050">
-                <a:solidFill>
-                  <a:srgbClr val="808080"/>
-                </a:solidFill>
-                <a:latin typeface="微软雅黑" panose="020B0503020204020204" charset="-122"/>
-                <a:ea typeface="微软雅黑" panose="020B0503020204020204" charset="-122"/>
-                <a:cs typeface="微软雅黑" panose="020B0503020204020204" charset="-122"/>
-              </a:rPr>
-              <a:t>图 1  文档管理页</a:t>
-            </a:r>
-            <a:endParaRPr sz="1050">
-              <a:solidFill>
-                <a:srgbClr val="808080"/>
-              </a:solidFill>
-              <a:latin typeface="微软雅黑" panose="020B0503020204020204" charset="-122"/>
-              <a:ea typeface="微软雅黑" panose="020B0503020204020204" charset="-122"/>
-              <a:cs typeface="微软雅黑" panose="020B0503020204020204" charset="-122"/>
-            </a:endParaRPr>
-          </a:p>
-        </p:txBody>
-      </p:sp>
-      <p:sp>
-        <p:nvSpPr>
-          <p:cNvPr id="7" name="Rectangle 6"/>
-          <p:cNvSpPr/>
-          <p:nvPr/>
-        </p:nvSpPr>
-        <p:spPr>
-          <a:xfrm>
-            <a:off x="4206240" y="3566160"/>
-            <a:ext cx="3566160" cy="1417320"/>
-          </a:xfrm>
-          <a:prstGeom prst="rect">
+          <a:prstGeom prst="rightArrow">
             <a:avLst/>
           </a:prstGeom>
           <a:solidFill>
-            <a:srgbClr val="F2F2F2"/>
+            <a:srgbClr val="2E75B6"/>
           </a:solidFill>
-          <a:ln w="15240">
-            <a:solidFill>
-              <a:srgbClr val="C00000"/>
-            </a:solidFill>
-            <a:prstDash val="dash"/>
+          <a:ln>
+            <a:noFill/>
           </a:ln>
           <a:effectLst/>
         </p:spPr>
@@ -8662,127 +10582,34 @@
           </a:fontRef>
         </p:style>
         <p:txBody>
-          <a:bodyPr wrap="square" rtlCol="0" anchor="ctr"/>
+          <a:bodyPr rtlCol="0" anchor="ctr"/>
           <a:lstStyle/>
           <a:p>
             <a:pPr algn="ctr"/>
-            <a:r>
-              <a:rPr sz="1300">
-                <a:solidFill>
-                  <a:srgbClr val="C00000"/>
-                </a:solidFill>
-                <a:latin typeface="微软雅黑" panose="020B0503020204020204" charset="-122"/>
-                <a:ea typeface="微软雅黑" panose="020B0503020204020204" charset="-122"/>
-                <a:cs typeface="微软雅黑" panose="020B0503020204020204" charset="-122"/>
-              </a:rPr>
-              <a:t>【截图 2】
-智能问答页</a:t>
-            </a:r>
-            <a:endParaRPr sz="1300">
-              <a:solidFill>
-                <a:srgbClr val="C00000"/>
-              </a:solidFill>
-              <a:latin typeface="微软雅黑" panose="020B0503020204020204" charset="-122"/>
-              <a:ea typeface="微软雅黑" panose="020B0503020204020204" charset="-122"/>
-              <a:cs typeface="微软雅黑" panose="020B0503020204020204" charset="-122"/>
-            </a:endParaRPr>
-          </a:p>
-          <a:p>
-            <a:pPr algn="ctr"/>
-            <a:r>
-              <a:rPr sz="1000">
-                <a:solidFill>
-                  <a:srgbClr val="808080"/>
-                </a:solidFill>
-                <a:latin typeface="微软雅黑" panose="020B0503020204020204" charset="-122"/>
-                <a:ea typeface="微软雅黑" panose="020B0503020204020204" charset="-122"/>
-                <a:cs typeface="微软雅黑" panose="020B0503020204020204" charset="-122"/>
-              </a:rPr>
-              <a:t>提问与 AI 回答
-下方显示引用来源卡片</a:t>
-            </a:r>
-            <a:endParaRPr sz="1000">
-              <a:solidFill>
-                <a:srgbClr val="808080"/>
-              </a:solidFill>
-              <a:latin typeface="微软雅黑" panose="020B0503020204020204" charset="-122"/>
-              <a:ea typeface="微软雅黑" panose="020B0503020204020204" charset="-122"/>
-              <a:cs typeface="微软雅黑" panose="020B0503020204020204" charset="-122"/>
-            </a:endParaRPr>
-          </a:p>
-        </p:txBody>
-      </p:sp>
-      <p:sp>
-        <p:nvSpPr>
-          <p:cNvPr id="8" name="TextBox 7"/>
-          <p:cNvSpPr txBox="1"/>
+          </a:p>
+        </p:txBody>
+      </p:sp>
+      <p:sp>
+        <p:nvSpPr>
+          <p:cNvPr id="8" name="Rounded Rectangle 7"/>
+          <p:cNvSpPr/>
           <p:nvPr/>
         </p:nvSpPr>
         <p:spPr>
           <a:xfrm>
-            <a:off x="4206240" y="5038344"/>
-            <a:ext cx="3566160" cy="310896"/>
+            <a:off x="2697480" y="1627632"/>
+            <a:ext cx="1874519" cy="914400"/>
           </a:xfrm>
-          <a:prstGeom prst="rect">
-            <a:avLst/>
-          </a:prstGeom>
-          <a:noFill/>
-        </p:spPr>
-        <p:txBody>
-          <a:bodyPr wrap="square" lIns="0" tIns="0" rIns="0" bIns="0" anchor="t">
-            <a:spAutoFit/>
-          </a:bodyPr>
-          <a:lstStyle/>
-          <a:p>
-            <a:pPr algn="ctr">
-              <a:spcAft>
-                <a:spcPts val="600"/>
-              </a:spcAft>
-            </a:pPr>
-            <a:r>
-              <a:rPr sz="1050">
-                <a:solidFill>
-                  <a:srgbClr val="808080"/>
-                </a:solidFill>
-                <a:latin typeface="微软雅黑" panose="020B0503020204020204" charset="-122"/>
-                <a:ea typeface="微软雅黑" panose="020B0503020204020204" charset="-122"/>
-                <a:cs typeface="微软雅黑" panose="020B0503020204020204" charset="-122"/>
-              </a:rPr>
-              <a:t>图 2  智能问答页</a:t>
-            </a:r>
-            <a:endParaRPr sz="1050">
-              <a:solidFill>
-                <a:srgbClr val="808080"/>
-              </a:solidFill>
-              <a:latin typeface="微软雅黑" panose="020B0503020204020204" charset="-122"/>
-              <a:ea typeface="微软雅黑" panose="020B0503020204020204" charset="-122"/>
-              <a:cs typeface="微软雅黑" panose="020B0503020204020204" charset="-122"/>
-            </a:endParaRPr>
-          </a:p>
-        </p:txBody>
-      </p:sp>
-      <p:sp>
-        <p:nvSpPr>
-          <p:cNvPr id="9" name="Rectangle 8"/>
-          <p:cNvSpPr/>
-          <p:nvPr/>
-        </p:nvSpPr>
-        <p:spPr>
-          <a:xfrm>
-            <a:off x="7863840" y="3566160"/>
-            <a:ext cx="3566160" cy="1417320"/>
-          </a:xfrm>
-          <a:prstGeom prst="rect">
+          <a:prstGeom prst="roundRect">
             <a:avLst/>
           </a:prstGeom>
           <a:solidFill>
-            <a:srgbClr val="F2F2F2"/>
+            <a:srgbClr val="EAF3FB"/>
           </a:solidFill>
-          <a:ln w="15240">
+          <a:ln w="16510">
             <a:solidFill>
-              <a:srgbClr val="C00000"/>
+              <a:srgbClr val="2E75B6"/>
             </a:solidFill>
-            <a:prstDash val="dash"/>
           </a:ln>
           <a:effectLst/>
         </p:spPr>
@@ -8806,122 +10633,47 @@
           <a:p>
             <a:pPr algn="ctr"/>
             <a:r>
-              <a:rPr sz="1300">
+              <a:rPr sz="1200">
                 <a:solidFill>
-                  <a:srgbClr val="C00000"/>
+                  <a:srgbClr val="1F4E79"/>
                 </a:solidFill>
                 <a:latin typeface="微软雅黑" panose="020B0503020204020204" charset="-122"/>
                 <a:ea typeface="微软雅黑" panose="020B0503020204020204" charset="-122"/>
                 <a:cs typeface="微软雅黑" panose="020B0503020204020204" charset="-122"/>
               </a:rPr>
-              <a:t>【截图 3】
-自动出题页</a:t>
-            </a:r>
-            <a:endParaRPr sz="1300">
+              <a:t>针对课件
+智能问答</a:t>
+            </a:r>
+            <a:endParaRPr sz="1200">
               <a:solidFill>
-                <a:srgbClr val="C00000"/>
+                <a:srgbClr val="1F4E79"/>
               </a:solidFill>
               <a:latin typeface="微软雅黑" panose="020B0503020204020204" charset="-122"/>
               <a:ea typeface="微软雅黑" panose="020B0503020204020204" charset="-122"/>
               <a:cs typeface="微软雅黑" panose="020B0503020204020204" charset="-122"/>
             </a:endParaRPr>
           </a:p>
-          <a:p>
-            <a:pPr algn="ctr"/>
-            <a:r>
-              <a:rPr sz="1000">
-                <a:solidFill>
-                  <a:srgbClr val="808080"/>
-                </a:solidFill>
-                <a:latin typeface="微软雅黑" panose="020B0503020204020204" charset="-122"/>
-                <a:ea typeface="微软雅黑" panose="020B0503020204020204" charset="-122"/>
-                <a:cs typeface="微软雅黑" panose="020B0503020204020204" charset="-122"/>
-              </a:rPr>
-              <a:t>参数表单 + 题目卡片
-含判分结果</a:t>
-            </a:r>
-            <a:endParaRPr sz="1000">
-              <a:solidFill>
-                <a:srgbClr val="808080"/>
-              </a:solidFill>
-              <a:latin typeface="微软雅黑" panose="020B0503020204020204" charset="-122"/>
-              <a:ea typeface="微软雅黑" panose="020B0503020204020204" charset="-122"/>
-              <a:cs typeface="微软雅黑" panose="020B0503020204020204" charset="-122"/>
-            </a:endParaRPr>
-          </a:p>
-        </p:txBody>
-      </p:sp>
-      <p:sp>
-        <p:nvSpPr>
-          <p:cNvPr id="10" name="TextBox 9"/>
-          <p:cNvSpPr txBox="1"/>
+        </p:txBody>
+      </p:sp>
+      <p:sp>
+        <p:nvSpPr>
+          <p:cNvPr id="9" name="Right Arrow 8"/>
+          <p:cNvSpPr/>
           <p:nvPr/>
         </p:nvSpPr>
         <p:spPr>
           <a:xfrm>
-            <a:off x="7863840" y="5038344"/>
-            <a:ext cx="3566160" cy="310896"/>
+            <a:off x="4572000" y="1975104"/>
+            <a:ext cx="274320" cy="219456"/>
           </a:xfrm>
-          <a:prstGeom prst="rect">
-            <a:avLst/>
-          </a:prstGeom>
-          <a:noFill/>
-        </p:spPr>
-        <p:txBody>
-          <a:bodyPr wrap="square" lIns="0" tIns="0" rIns="0" bIns="0" anchor="t">
-            <a:spAutoFit/>
-          </a:bodyPr>
-          <a:lstStyle/>
-          <a:p>
-            <a:pPr algn="ctr">
-              <a:spcAft>
-                <a:spcPts val="600"/>
-              </a:spcAft>
-            </a:pPr>
-            <a:r>
-              <a:rPr sz="1050">
-                <a:solidFill>
-                  <a:srgbClr val="808080"/>
-                </a:solidFill>
-                <a:latin typeface="微软雅黑" panose="020B0503020204020204" charset="-122"/>
-                <a:ea typeface="微软雅黑" panose="020B0503020204020204" charset="-122"/>
-                <a:cs typeface="微软雅黑" panose="020B0503020204020204" charset="-122"/>
-              </a:rPr>
-              <a:t>图 3  自动出题页</a:t>
-            </a:r>
-            <a:endParaRPr sz="1050">
-              <a:solidFill>
-                <a:srgbClr val="808080"/>
-              </a:solidFill>
-              <a:latin typeface="微软雅黑" panose="020B0503020204020204" charset="-122"/>
-              <a:ea typeface="微软雅黑" panose="020B0503020204020204" charset="-122"/>
-              <a:cs typeface="微软雅黑" panose="020B0503020204020204" charset="-122"/>
-            </a:endParaRPr>
-          </a:p>
-        </p:txBody>
-      </p:sp>
-      <p:sp>
-        <p:nvSpPr>
-          <p:cNvPr id="11" name="Rectangle 10"/>
-          <p:cNvSpPr/>
-          <p:nvPr/>
-        </p:nvSpPr>
-        <p:spPr>
-          <a:xfrm>
-            <a:off x="1417320" y="1828800"/>
-            <a:ext cx="3566160" cy="1417320"/>
-          </a:xfrm>
-          <a:prstGeom prst="rect">
+          <a:prstGeom prst="rightArrow">
             <a:avLst/>
           </a:prstGeom>
           <a:solidFill>
-            <a:srgbClr val="F2F2F2"/>
+            <a:srgbClr val="2E75B6"/>
           </a:solidFill>
-          <a:ln w="15240">
-            <a:solidFill>
-              <a:srgbClr val="C00000"/>
-            </a:solidFill>
-            <a:prstDash val="dash"/>
+          <a:ln>
+            <a:noFill/>
           </a:ln>
           <a:effectLst/>
         </p:spPr>
@@ -8940,127 +10692,34 @@
           </a:fontRef>
         </p:style>
         <p:txBody>
-          <a:bodyPr wrap="square" rtlCol="0" anchor="ctr"/>
+          <a:bodyPr rtlCol="0" anchor="ctr"/>
           <a:lstStyle/>
           <a:p>
             <a:pPr algn="ctr"/>
-            <a:r>
-              <a:rPr sz="1300">
-                <a:solidFill>
-                  <a:srgbClr val="C00000"/>
-                </a:solidFill>
-                <a:latin typeface="微软雅黑" panose="020B0503020204020204" charset="-122"/>
-                <a:ea typeface="微软雅黑" panose="020B0503020204020204" charset="-122"/>
-                <a:cs typeface="微软雅黑" panose="020B0503020204020204" charset="-122"/>
-              </a:rPr>
-              <a:t>【截图 4】
-错题本页</a:t>
-            </a:r>
-            <a:endParaRPr sz="1300">
-              <a:solidFill>
-                <a:srgbClr val="C00000"/>
-              </a:solidFill>
-              <a:latin typeface="微软雅黑" panose="020B0503020204020204" charset="-122"/>
-              <a:ea typeface="微软雅黑" panose="020B0503020204020204" charset="-122"/>
-              <a:cs typeface="微软雅黑" panose="020B0503020204020204" charset="-122"/>
-            </a:endParaRPr>
-          </a:p>
-          <a:p>
-            <a:pPr algn="ctr"/>
-            <a:r>
-              <a:rPr sz="1000">
-                <a:solidFill>
-                  <a:srgbClr val="808080"/>
-                </a:solidFill>
-                <a:latin typeface="微软雅黑" panose="020B0503020204020204" charset="-122"/>
-                <a:ea typeface="微软雅黑" panose="020B0503020204020204" charset="-122"/>
-                <a:cs typeface="微软雅黑" panose="020B0503020204020204" charset="-122"/>
-              </a:rPr>
-              <a:t>错题卡片
-用户答案与正确答案对比</a:t>
-            </a:r>
-            <a:endParaRPr sz="1000">
-              <a:solidFill>
-                <a:srgbClr val="808080"/>
-              </a:solidFill>
-              <a:latin typeface="微软雅黑" panose="020B0503020204020204" charset="-122"/>
-              <a:ea typeface="微软雅黑" panose="020B0503020204020204" charset="-122"/>
-              <a:cs typeface="微软雅黑" panose="020B0503020204020204" charset="-122"/>
-            </a:endParaRPr>
-          </a:p>
-        </p:txBody>
-      </p:sp>
-      <p:sp>
-        <p:nvSpPr>
-          <p:cNvPr id="12" name="TextBox 11"/>
-          <p:cNvSpPr txBox="1"/>
+          </a:p>
+        </p:txBody>
+      </p:sp>
+      <p:sp>
+        <p:nvSpPr>
+          <p:cNvPr id="10" name="Rounded Rectangle 9"/>
+          <p:cNvSpPr/>
           <p:nvPr/>
         </p:nvSpPr>
         <p:spPr>
           <a:xfrm>
-            <a:off x="1417320" y="3300984"/>
-            <a:ext cx="3566160" cy="310896"/>
+            <a:off x="4892040" y="1627632"/>
+            <a:ext cx="1874519" cy="914400"/>
           </a:xfrm>
-          <a:prstGeom prst="rect">
-            <a:avLst/>
-          </a:prstGeom>
-          <a:noFill/>
-        </p:spPr>
-        <p:txBody>
-          <a:bodyPr wrap="square" lIns="0" tIns="0" rIns="0" bIns="0" anchor="t">
-            <a:spAutoFit/>
-          </a:bodyPr>
-          <a:lstStyle/>
-          <a:p>
-            <a:pPr algn="ctr">
-              <a:spcAft>
-                <a:spcPts val="600"/>
-              </a:spcAft>
-            </a:pPr>
-            <a:r>
-              <a:rPr sz="1050">
-                <a:solidFill>
-                  <a:srgbClr val="808080"/>
-                </a:solidFill>
-                <a:latin typeface="微软雅黑" panose="020B0503020204020204" charset="-122"/>
-                <a:ea typeface="微软雅黑" panose="020B0503020204020204" charset="-122"/>
-                <a:cs typeface="微软雅黑" panose="020B0503020204020204" charset="-122"/>
-              </a:rPr>
-              <a:t>图 4  错题本页</a:t>
-            </a:r>
-            <a:endParaRPr sz="1050">
-              <a:solidFill>
-                <a:srgbClr val="808080"/>
-              </a:solidFill>
-              <a:latin typeface="微软雅黑" panose="020B0503020204020204" charset="-122"/>
-              <a:ea typeface="微软雅黑" panose="020B0503020204020204" charset="-122"/>
-              <a:cs typeface="微软雅黑" panose="020B0503020204020204" charset="-122"/>
-            </a:endParaRPr>
-          </a:p>
-        </p:txBody>
-      </p:sp>
-      <p:sp>
-        <p:nvSpPr>
-          <p:cNvPr id="13" name="Rectangle 12"/>
-          <p:cNvSpPr/>
-          <p:nvPr/>
-        </p:nvSpPr>
-        <p:spPr>
-          <a:xfrm>
-            <a:off x="5074920" y="1828800"/>
-            <a:ext cx="3566160" cy="1417320"/>
-          </a:xfrm>
-          <a:prstGeom prst="rect">
+          <a:prstGeom prst="roundRect">
             <a:avLst/>
           </a:prstGeom>
           <a:solidFill>
-            <a:srgbClr val="F2F2F2"/>
+            <a:srgbClr val="EAF3FB"/>
           </a:solidFill>
-          <a:ln w="15240">
+          <a:ln w="16510">
             <a:solidFill>
-              <a:srgbClr val="C00000"/>
+              <a:srgbClr val="1F4E79"/>
             </a:solidFill>
-            <a:prstDash val="dash"/>
           </a:ln>
           <a:effectLst/>
         </p:spPr>
@@ -9084,43 +10743,130 @@
           <a:p>
             <a:pPr algn="ctr"/>
             <a:r>
-              <a:rPr sz="1300">
+              <a:rPr sz="1200">
                 <a:solidFill>
-                  <a:srgbClr val="C00000"/>
+                  <a:srgbClr val="1F4E79"/>
                 </a:solidFill>
                 <a:latin typeface="微软雅黑" panose="020B0503020204020204" charset="-122"/>
                 <a:ea typeface="微软雅黑" panose="020B0503020204020204" charset="-122"/>
                 <a:cs typeface="微软雅黑" panose="020B0503020204020204" charset="-122"/>
               </a:rPr>
-              <a:t>【截图 5】
-复习计划页</a:t>
-            </a:r>
-            <a:endParaRPr sz="1300">
+              <a:t>生成题目
+在线作答</a:t>
+            </a:r>
+            <a:endParaRPr sz="1200">
               <a:solidFill>
-                <a:srgbClr val="C00000"/>
+                <a:srgbClr val="1F4E79"/>
               </a:solidFill>
               <a:latin typeface="微软雅黑" panose="020B0503020204020204" charset="-122"/>
               <a:ea typeface="微软雅黑" panose="020B0503020204020204" charset="-122"/>
               <a:cs typeface="微软雅黑" panose="020B0503020204020204" charset="-122"/>
             </a:endParaRPr>
           </a:p>
+        </p:txBody>
+      </p:sp>
+      <p:sp>
+        <p:nvSpPr>
+          <p:cNvPr id="11" name="Right Arrow 10"/>
+          <p:cNvSpPr/>
+          <p:nvPr/>
+        </p:nvSpPr>
+        <p:spPr>
+          <a:xfrm>
+            <a:off x="6766559" y="1975104"/>
+            <a:ext cx="274320" cy="219456"/>
+          </a:xfrm>
+          <a:prstGeom prst="rightArrow">
+            <a:avLst/>
+          </a:prstGeom>
+          <a:solidFill>
+            <a:srgbClr val="2E75B6"/>
+          </a:solidFill>
+          <a:ln>
+            <a:noFill/>
+          </a:ln>
+          <a:effectLst/>
+        </p:spPr>
+        <p:style>
+          <a:lnRef idx="1">
+            <a:schemeClr val="accent1"/>
+          </a:lnRef>
+          <a:fillRef idx="3">
+            <a:schemeClr val="accent1"/>
+          </a:fillRef>
+          <a:effectRef idx="2">
+            <a:schemeClr val="accent1"/>
+          </a:effectRef>
+          <a:fontRef idx="minor">
+            <a:schemeClr val="lt1"/>
+          </a:fontRef>
+        </p:style>
+        <p:txBody>
+          <a:bodyPr rtlCol="0" anchor="ctr"/>
+          <a:lstStyle/>
           <a:p>
             <a:pPr algn="ctr"/>
-            <a:r>
-              <a:rPr sz="1000">
+          </a:p>
+        </p:txBody>
+      </p:sp>
+      <p:sp>
+        <p:nvSpPr>
+          <p:cNvPr id="12" name="Rounded Rectangle 11"/>
+          <p:cNvSpPr/>
+          <p:nvPr/>
+        </p:nvSpPr>
+        <p:spPr>
+          <a:xfrm>
+            <a:off x="7086600" y="1627632"/>
+            <a:ext cx="1874519" cy="914400"/>
+          </a:xfrm>
+          <a:prstGeom prst="roundRect">
+            <a:avLst/>
+          </a:prstGeom>
+          <a:solidFill>
+            <a:srgbClr val="EAF3FB"/>
+          </a:solidFill>
+          <a:ln w="16510">
+            <a:solidFill>
+              <a:srgbClr val="2E75B6"/>
+            </a:solidFill>
+          </a:ln>
+          <a:effectLst/>
+        </p:spPr>
+        <p:style>
+          <a:lnRef idx="1">
+            <a:schemeClr val="accent1"/>
+          </a:lnRef>
+          <a:fillRef idx="3">
+            <a:schemeClr val="accent1"/>
+          </a:fillRef>
+          <a:effectRef idx="2">
+            <a:schemeClr val="accent1"/>
+          </a:effectRef>
+          <a:fontRef idx="minor">
+            <a:schemeClr val="lt1"/>
+          </a:fontRef>
+        </p:style>
+        <p:txBody>
+          <a:bodyPr wrap="square" rtlCol="0" anchor="ctr"/>
+          <a:lstStyle/>
+          <a:p>
+            <a:pPr algn="ctr"/>
+            <a:r>
+              <a:rPr sz="1200">
                 <a:solidFill>
-                  <a:srgbClr val="808080"/>
+                  <a:srgbClr val="1F4E79"/>
                 </a:solidFill>
                 <a:latin typeface="微软雅黑" panose="020B0503020204020204" charset="-122"/>
                 <a:ea typeface="微软雅黑" panose="020B0503020204020204" charset="-122"/>
                 <a:cs typeface="微软雅黑" panose="020B0503020204020204" charset="-122"/>
               </a:rPr>
-              <a:t>按日期分组的复习条目
-含完成勾选</a:t>
-            </a:r>
-            <a:endParaRPr sz="1000">
+              <a:t>答错自动
+进错题本</a:t>
+            </a:r>
+            <a:endParaRPr sz="1200">
               <a:solidFill>
-                <a:srgbClr val="808080"/>
+                <a:srgbClr val="1F4E79"/>
               </a:solidFill>
               <a:latin typeface="微软雅黑" panose="020B0503020204020204" charset="-122"/>
               <a:ea typeface="微软雅黑" panose="020B0503020204020204" charset="-122"/>
@@ -9131,14 +10877,124 @@
       </p:sp>
       <p:sp>
         <p:nvSpPr>
-          <p:cNvPr id="14" name="TextBox 13"/>
+          <p:cNvPr id="13" name="Right Arrow 12"/>
+          <p:cNvSpPr/>
+          <p:nvPr/>
+        </p:nvSpPr>
+        <p:spPr>
+          <a:xfrm>
+            <a:off x="8961120" y="1975104"/>
+            <a:ext cx="274320" cy="219456"/>
+          </a:xfrm>
+          <a:prstGeom prst="rightArrow">
+            <a:avLst/>
+          </a:prstGeom>
+          <a:solidFill>
+            <a:srgbClr val="2E75B6"/>
+          </a:solidFill>
+          <a:ln>
+            <a:noFill/>
+          </a:ln>
+          <a:effectLst/>
+        </p:spPr>
+        <p:style>
+          <a:lnRef idx="1">
+            <a:schemeClr val="accent1"/>
+          </a:lnRef>
+          <a:fillRef idx="3">
+            <a:schemeClr val="accent1"/>
+          </a:fillRef>
+          <a:effectRef idx="2">
+            <a:schemeClr val="accent1"/>
+          </a:effectRef>
+          <a:fontRef idx="minor">
+            <a:schemeClr val="lt1"/>
+          </a:fontRef>
+        </p:style>
+        <p:txBody>
+          <a:bodyPr rtlCol="0" anchor="ctr"/>
+          <a:lstStyle/>
+          <a:p>
+            <a:pPr algn="ctr"/>
+          </a:p>
+        </p:txBody>
+      </p:sp>
+      <p:sp>
+        <p:nvSpPr>
+          <p:cNvPr id="14" name="Rounded Rectangle 13"/>
+          <p:cNvSpPr/>
+          <p:nvPr/>
+        </p:nvSpPr>
+        <p:spPr>
+          <a:xfrm>
+            <a:off x="9281160" y="1627632"/>
+            <a:ext cx="1874519" cy="914400"/>
+          </a:xfrm>
+          <a:prstGeom prst="roundRect">
+            <a:avLst/>
+          </a:prstGeom>
+          <a:solidFill>
+            <a:srgbClr val="EAF3FB"/>
+          </a:solidFill>
+          <a:ln w="16510">
+            <a:solidFill>
+              <a:srgbClr val="1F4E79"/>
+            </a:solidFill>
+          </a:ln>
+          <a:effectLst/>
+        </p:spPr>
+        <p:style>
+          <a:lnRef idx="1">
+            <a:schemeClr val="accent1"/>
+          </a:lnRef>
+          <a:fillRef idx="3">
+            <a:schemeClr val="accent1"/>
+          </a:fillRef>
+          <a:effectRef idx="2">
+            <a:schemeClr val="accent1"/>
+          </a:effectRef>
+          <a:fontRef idx="minor">
+            <a:schemeClr val="lt1"/>
+          </a:fontRef>
+        </p:style>
+        <p:txBody>
+          <a:bodyPr wrap="square" rtlCol="0" anchor="ctr"/>
+          <a:lstStyle/>
+          <a:p>
+            <a:pPr algn="ctr"/>
+            <a:r>
+              <a:rPr sz="1200">
+                <a:solidFill>
+                  <a:srgbClr val="1F4E79"/>
+                </a:solidFill>
+                <a:latin typeface="微软雅黑" panose="020B0503020204020204" charset="-122"/>
+                <a:ea typeface="微软雅黑" panose="020B0503020204020204" charset="-122"/>
+                <a:cs typeface="微软雅黑" panose="020B0503020204020204" charset="-122"/>
+              </a:rPr>
+              <a:t>一键生成
+7天复习计划</a:t>
+            </a:r>
+            <a:endParaRPr sz="1200">
+              <a:solidFill>
+                <a:srgbClr val="1F4E79"/>
+              </a:solidFill>
+              <a:latin typeface="微软雅黑" panose="020B0503020204020204" charset="-122"/>
+              <a:ea typeface="微软雅黑" panose="020B0503020204020204" charset="-122"/>
+              <a:cs typeface="微软雅黑" panose="020B0503020204020204" charset="-122"/>
+            </a:endParaRPr>
+          </a:p>
+        </p:txBody>
+      </p:sp>
+      <p:sp>
+        <p:nvSpPr>
+          <p:cNvPr id="16" name="TextBox 15"/>
           <p:cNvSpPr txBox="1"/>
           <p:nvPr/>
         </p:nvSpPr>
         <p:spPr>
           <a:xfrm>
-            <a:off x="5074920" y="3300984"/>
-            <a:ext cx="3566160" cy="310896"/>
+            <a:off x="502920" y="3200400"/>
+            <a:ext cx="11155680" cy="3017520"/>
           </a:xfrm>
           <a:prstGeom prst="rect">
             <a:avLst/>
@@ -9151,85 +11007,140 @@
           </a:bodyPr>
           <a:lstStyle/>
           <a:p>
-            <a:pPr algn="ctr">
+            <a:pPr algn="l">
               <a:spcAft>
-                <a:spcPts val="600"/>
+                <a:spcPts val="800"/>
               </a:spcAft>
             </a:pPr>
             <a:r>
-              <a:rPr sz="1050">
+              <a:rPr sz="1400">
                 <a:solidFill>
-                  <a:srgbClr val="808080"/>
+                  <a:srgbClr val="222222"/>
                 </a:solidFill>
                 <a:latin typeface="微软雅黑" panose="020B0503020204020204" charset="-122"/>
                 <a:ea typeface="微软雅黑" panose="020B0503020204020204" charset="-122"/>
                 <a:cs typeface="微软雅黑" panose="020B0503020204020204" charset="-122"/>
               </a:rPr>
-              <a:t>图 5  复习计划页</a:t>
-            </a:r>
-            <a:endParaRPr sz="1050">
+              <a:t>① “先上传一份课程讲义，系统自动切分成知识块并向量化入库。”</a:t>
+            </a:r>
+            <a:endParaRPr sz="1400">
               <a:solidFill>
-                <a:srgbClr val="808080"/>
+                <a:srgbClr val="222222"/>
               </a:solidFill>
               <a:latin typeface="微软雅黑" panose="020B0503020204020204" charset="-122"/>
               <a:ea typeface="微软雅黑" panose="020B0503020204020204" charset="-122"/>
               <a:cs typeface="微软雅黑" panose="020B0503020204020204" charset="-122"/>
             </a:endParaRPr>
           </a:p>
-        </p:txBody>
-      </p:sp>
-      <p:sp>
-        <p:nvSpPr>
-          <p:cNvPr id="15" name="TextBox 14"/>
-          <p:cNvSpPr txBox="1"/>
-          <p:nvPr/>
-        </p:nvSpPr>
-        <p:spPr>
-          <a:xfrm>
-            <a:off x="548640" y="6053328"/>
-            <a:ext cx="11091672" cy="640080"/>
-          </a:xfrm>
-          <a:prstGeom prst="rect">
-            <a:avLst/>
-          </a:prstGeom>
-          <a:noFill/>
-        </p:spPr>
-        <p:txBody>
-          <a:bodyPr wrap="square" lIns="0" tIns="0" rIns="0" bIns="0" anchor="t">
-            <a:spAutoFit/>
-          </a:bodyPr>
-          <a:lstStyle/>
-          <a:p>
-            <a:pPr algn="ctr">
+          <a:p>
+            <a:pPr algn="l">
               <a:spcAft>
-                <a:spcPts val="600"/>
+                <a:spcPts val="800"/>
               </a:spcAft>
             </a:pPr>
             <a:r>
-              <a:rPr sz="1200">
+              <a:rPr sz="1400">
                 <a:solidFill>
-                  <a:srgbClr val="C00000"/>
+                  <a:srgbClr val="222222"/>
                 </a:solidFill>
                 <a:latin typeface="微软雅黑" panose="020B0503020204020204" charset="-122"/>
                 <a:ea typeface="微软雅黑" panose="020B0503020204020204" charset="-122"/>
                 <a:cs typeface="微软雅黑" panose="020B0503020204020204" charset="-122"/>
               </a:rPr>
-              <a:t>说明：本页五张截图需在系统实际运行后补充；截图要求与报告第三节“11．实现的界面”一致。</a:t>
-            </a:r>
-            <a:endParaRPr sz="1200">
+              <a:t>② “切换到智能问答，问一个课件里的问题，注意回答下方带引用来源。”</a:t>
+            </a:r>
+            <a:endParaRPr sz="1400">
               <a:solidFill>
-                <a:srgbClr val="C00000"/>
+                <a:srgbClr val="222222"/>
               </a:solidFill>
               <a:latin typeface="微软雅黑" panose="020B0503020204020204" charset="-122"/>
               <a:ea typeface="微软雅黑" panose="020B0503020204020204" charset="-122"/>
               <a:cs typeface="微软雅黑" panose="020B0503020204020204" charset="-122"/>
             </a:endParaRPr>
           </a:p>
-        </p:txBody>
-      </p:sp>
-      <p:sp>
-        <p:nvSpPr>
-          <p:cNvPr id="16" name="TextBox 15"/>
+          <a:p>
+            <a:pPr algn="l">
+              <a:spcAft>
+                <a:spcPts val="800"/>
+              </a:spcAft>
+            </a:pPr>
+            <a:r>
+              <a:rPr sz="1400">
+                <a:solidFill>
+                  <a:srgbClr val="222222"/>
+                </a:solidFill>
+                <a:latin typeface="微软雅黑" panose="020B0503020204020204" charset="-122"/>
+                <a:ea typeface="微软雅黑" panose="020B0503020204020204" charset="-122"/>
+                <a:cs typeface="微软雅黑" panose="020B0503020204020204" charset="-122"/>
+              </a:rPr>
+              <a:t>③ “用自动出题生成 5 道单选题，现场点一道作答，答错后立即判分。”</a:t>
+            </a:r>
+            <a:endParaRPr sz="1400">
+              <a:solidFill>
+                <a:srgbClr val="222222"/>
+              </a:solidFill>
+              <a:latin typeface="微软雅黑" panose="020B0503020204020204" charset="-122"/>
+              <a:ea typeface="微软雅黑" panose="020B0503020204020204" charset="-122"/>
+              <a:cs typeface="微软雅黑" panose="020B0503020204020204" charset="-122"/>
+            </a:endParaRPr>
+          </a:p>
+          <a:p>
+            <a:pPr algn="l">
+              <a:spcAft>
+                <a:spcPts val="800"/>
+              </a:spcAft>
+            </a:pPr>
+            <a:r>
+              <a:rPr sz="1400">
+                <a:solidFill>
+                  <a:srgbClr val="222222"/>
+                </a:solidFill>
+                <a:latin typeface="微软雅黑" panose="020B0503020204020204" charset="-122"/>
+                <a:ea typeface="微软雅黑" panose="020B0503020204020204" charset="-122"/>
+                <a:cs typeface="微软雅黑" panose="020B0503020204020204" charset="-122"/>
+              </a:rPr>
+              <a:t>④ “切到错题本，看到刚才答错的题已自动沉淀，含答案对比与解析。”</a:t>
+            </a:r>
+            <a:endParaRPr sz="1400">
+              <a:solidFill>
+                <a:srgbClr val="222222"/>
+              </a:solidFill>
+              <a:latin typeface="微软雅黑" panose="020B0503020204020204" charset="-122"/>
+              <a:ea typeface="微软雅黑" panose="020B0503020204020204" charset="-122"/>
+              <a:cs typeface="微软雅黑" panose="020B0503020204020204" charset="-122"/>
+            </a:endParaRPr>
+          </a:p>
+          <a:p>
+            <a:pPr algn="l">
+              <a:spcAft>
+                <a:spcPts val="800"/>
+              </a:spcAft>
+            </a:pPr>
+            <a:r>
+              <a:rPr sz="1400">
+                <a:solidFill>
+                  <a:srgbClr val="222222"/>
+                </a:solidFill>
+                <a:latin typeface="微软雅黑" panose="020B0503020204020204" charset="-122"/>
+                <a:ea typeface="微软雅黑" panose="020B0503020204020204" charset="-122"/>
+                <a:cs typeface="微软雅黑" panose="020B0503020204020204" charset="-122"/>
+              </a:rPr>
+              <a:t>⑤ “生成复习计划，系统按错题把知识点排到 7 天，日期从今天起算。”</a:t>
+            </a:r>
+            <a:endParaRPr sz="1400">
+              <a:solidFill>
+                <a:srgbClr val="222222"/>
+              </a:solidFill>
+              <a:latin typeface="微软雅黑" panose="020B0503020204020204" charset="-122"/>
+              <a:ea typeface="微软雅黑" panose="020B0503020204020204" charset="-122"/>
+              <a:cs typeface="微软雅黑" panose="020B0503020204020204" charset="-122"/>
+            </a:endParaRPr>
+          </a:p>
+        </p:txBody>
+      </p:sp>
+      <p:sp>
+        <p:nvSpPr>
+          <p:cNvPr id="17" name="TextBox 16"/>
           <p:cNvSpPr txBox="1"/>
           <p:nvPr/>
         </p:nvSpPr>
@@ -9244,30 +11155,30 @@
           <a:noFill/>
         </p:spPr>
         <p:txBody>
-          <a:bodyPr wrap="square" lIns="0" tIns="0" rIns="0" bIns="0" anchor="t">
+          <a:bodyPr wrap="none">
             <a:spAutoFit/>
           </a:bodyPr>
           <a:lstStyle/>
           <a:p>
-            <a:pPr algn="r">
-              <a:spcAft>
-                <a:spcPts val="600"/>
-              </a:spcAft>
-            </a:pPr>
+            <a:pPr algn="r"/>
             <a:r>
               <a:rPr sz="1000">
                 <a:solidFill>
                   <a:srgbClr val="808080"/>
                 </a:solidFill>
                 <a:latin typeface="微软雅黑" panose="020B0503020204020204" charset="-122"/>
+                <a:ea typeface="微软雅黑" panose="020B0503020204020204" charset="-122"/>
+                <a:cs typeface="微软雅黑" panose="020B0503020204020204" charset="-122"/>
               </a:rPr>
-              <a:t>13</a:t>
+              <a:t>16</a:t>
             </a:r>
             <a:endParaRPr sz="1000">
               <a:solidFill>
                 <a:srgbClr val="808080"/>
               </a:solidFill>
               <a:latin typeface="微软雅黑" panose="020B0503020204020204" charset="-122"/>
+              <a:ea typeface="微软雅黑" panose="020B0503020204020204" charset="-122"/>
+              <a:cs typeface="微软雅黑" panose="020B0503020204020204" charset="-122"/>
             </a:endParaRPr>
           </a:p>
         </p:txBody>
@@ -9280,7 +11191,7 @@
 </p:sld>
 </file>
 
-<file path=ppt/slides/slide14.xml><?xml version="1.0" encoding="utf-8"?>
+<file path=ppt/slides/slide16.xml><?xml version="1.0" encoding="utf-8"?>
 <p:sld xmlns:a="http://schemas.openxmlformats.org/drawingml/2006/main" xmlns:r="http://schemas.openxmlformats.org/officeDocument/2006/relationships" xmlns:p="http://schemas.openxmlformats.org/presentationml/2006/main">
   <p:cSld>
     <p:spTree>
@@ -9342,8 +11253,8 @@
         </p:nvSpPr>
         <p:spPr>
           <a:xfrm>
-            <a:off x="502920" y="182880"/>
-            <a:ext cx="11185855" cy="621792"/>
+            <a:off x="502920" y="243903"/>
+            <a:ext cx="11185855" cy="499745"/>
           </a:xfrm>
           <a:prstGeom prst="rect">
             <a:avLst/>
@@ -9376,7 +11287,29 @@
                 <a:ea typeface="微软雅黑" panose="020B0503020204020204" charset="-122"/>
                 <a:cs typeface="微软雅黑" panose="020B0503020204020204" charset="-122"/>
               </a:rPr>
-              <a:t>5.5　系统部署与运行</a:t>
+              <a:t>5.</a:t>
+            </a:r>
+            <a:r>
+              <a:rPr lang="en-US" sz="2600">
+                <a:solidFill>
+                  <a:srgbClr val="FFFFFF"/>
+                </a:solidFill>
+                <a:latin typeface="微软雅黑" panose="020B0503020204020204" charset="-122"/>
+                <a:ea typeface="微软雅黑" panose="020B0503020204020204" charset="-122"/>
+                <a:cs typeface="微软雅黑" panose="020B0503020204020204" charset="-122"/>
+              </a:rPr>
+              <a:t>7</a:t>
+            </a:r>
+            <a:r>
+              <a:rPr sz="2600">
+                <a:solidFill>
+                  <a:srgbClr val="FFFFFF"/>
+                </a:solidFill>
+                <a:latin typeface="微软雅黑" panose="020B0503020204020204" charset="-122"/>
+                <a:ea typeface="微软雅黑" panose="020B0503020204020204" charset="-122"/>
+                <a:cs typeface="微软雅黑" panose="020B0503020204020204" charset="-122"/>
+              </a:rPr>
+              <a:t>　系统部署与运行</a:t>
             </a:r>
             <a:endParaRPr sz="2600">
               <a:solidFill>
@@ -9479,14 +11412,18 @@
                   <a:srgbClr val="808080"/>
                 </a:solidFill>
                 <a:latin typeface="微软雅黑" panose="020B0503020204020204" charset="-122"/>
+                <a:ea typeface="微软雅黑" panose="020B0503020204020204" charset="-122"/>
+                <a:cs typeface="微软雅黑" panose="020B0503020204020204" charset="-122"/>
               </a:rPr>
-              <a:t>14</a:t>
+              <a:t>17</a:t>
             </a:r>
             <a:endParaRPr sz="1000">
               <a:solidFill>
                 <a:srgbClr val="808080"/>
               </a:solidFill>
               <a:latin typeface="微软雅黑" panose="020B0503020204020204" charset="-122"/>
+              <a:ea typeface="微软雅黑" panose="020B0503020204020204" charset="-122"/>
+              <a:cs typeface="微软雅黑" panose="020B0503020204020204" charset="-122"/>
             </a:endParaRPr>
           </a:p>
         </p:txBody>
@@ -9813,7 +11750,7 @@
 </p:sld>
 </file>
 
-<file path=ppt/slides/slide15.xml><?xml version="1.0" encoding="utf-8"?>
+<file path=ppt/slides/slide17.xml><?xml version="1.0" encoding="utf-8"?>
 <p:sld xmlns:a="http://schemas.openxmlformats.org/drawingml/2006/main" xmlns:r="http://schemas.openxmlformats.org/officeDocument/2006/relationships" xmlns:p="http://schemas.openxmlformats.org/presentationml/2006/main">
   <p:cSld>
     <p:spTree>
@@ -9961,14 +11898,18 @@
                   <a:srgbClr val="808080"/>
                 </a:solidFill>
                 <a:latin typeface="微软雅黑" panose="020B0503020204020204" charset="-122"/>
+                <a:ea typeface="微软雅黑" panose="020B0503020204020204" charset="-122"/>
+                <a:cs typeface="微软雅黑" panose="020B0503020204020204" charset="-122"/>
               </a:rPr>
-              <a:t>15</a:t>
+              <a:t>18</a:t>
             </a:r>
             <a:endParaRPr sz="1000">
               <a:solidFill>
                 <a:srgbClr val="808080"/>
               </a:solidFill>
               <a:latin typeface="微软雅黑" panose="020B0503020204020204" charset="-122"/>
+              <a:ea typeface="微软雅黑" panose="020B0503020204020204" charset="-122"/>
+              <a:cs typeface="微软雅黑" panose="020B0503020204020204" charset="-122"/>
             </a:endParaRPr>
           </a:p>
         </p:txBody>
@@ -10329,7 +12270,7 @@
 </p:sld>
 </file>
 
-<file path=ppt/slides/slide16.xml><?xml version="1.0" encoding="utf-8"?>
+<file path=ppt/slides/slide18.xml><?xml version="1.0" encoding="utf-8"?>
 <p:sld xmlns:a="http://schemas.openxmlformats.org/drawingml/2006/main" xmlns:r="http://schemas.openxmlformats.org/officeDocument/2006/relationships" xmlns:p="http://schemas.openxmlformats.org/presentationml/2006/main">
   <p:cSld>
     <p:spTree>
@@ -10477,14 +12418,18 @@
                   <a:srgbClr val="808080"/>
                 </a:solidFill>
                 <a:latin typeface="微软雅黑" panose="020B0503020204020204" charset="-122"/>
+                <a:ea typeface="微软雅黑" panose="020B0503020204020204" charset="-122"/>
+                <a:cs typeface="微软雅黑" panose="020B0503020204020204" charset="-122"/>
               </a:rPr>
-              <a:t>16</a:t>
+              <a:t>19</a:t>
             </a:r>
             <a:endParaRPr sz="1000">
               <a:solidFill>
                 <a:srgbClr val="808080"/>
               </a:solidFill>
               <a:latin typeface="微软雅黑" panose="020B0503020204020204" charset="-122"/>
+              <a:ea typeface="微软雅黑" panose="020B0503020204020204" charset="-122"/>
+              <a:cs typeface="微软雅黑" panose="020B0503020204020204" charset="-122"/>
             </a:endParaRPr>
           </a:p>
         </p:txBody>
@@ -11201,61 +13146,6 @@
           </a:graphicData>
         </a:graphic>
       </p:graphicFrame>
-      <p:sp>
-        <p:nvSpPr>
-          <p:cNvPr id="6" name="TextBox 5"/>
-          <p:cNvSpPr txBox="1"/>
-          <p:nvPr/>
-        </p:nvSpPr>
-        <p:spPr>
-          <a:xfrm>
-            <a:off x="548640" y="5120640"/>
-            <a:ext cx="11091672" cy="1097280"/>
-          </a:xfrm>
-          <a:prstGeom prst="rect">
-            <a:avLst/>
-          </a:prstGeom>
-          <a:noFill/>
-        </p:spPr>
-        <p:txBody>
-          <a:bodyPr wrap="square" lIns="0" tIns="0" rIns="0" bIns="0" anchor="t">
-            <a:spAutoFit/>
-          </a:bodyPr>
-          <a:lstStyle/>
-          <a:p>
-            <a:pPr algn="l">
-              <a:lnSpc>
-                <a:spcPct val="125000"/>
-              </a:lnSpc>
-              <a:spcBef>
-                <a:spcPts val="0"/>
-              </a:spcBef>
-              <a:spcAft>
-                <a:spcPts val="600"/>
-              </a:spcAft>
-            </a:pPr>
-            <a:r>
-              <a:rPr sz="1300" b="0">
-                <a:solidFill>
-                  <a:srgbClr val="808080"/>
-                </a:solidFill>
-                <a:latin typeface="微软雅黑" panose="020B0503020204020204" charset="-122"/>
-                <a:ea typeface="微软雅黑" panose="020B0503020204020204" charset="-122"/>
-                <a:cs typeface="微软雅黑" panose="020B0503020204020204" charset="-122"/>
-              </a:rPr>
-              <a:t>注：表格中标注“【姓名】”“【学号】”的位置需补全；各成员的功能模块建议对应独立的 Git 提交记录，便于体现贡献度。</a:t>
-            </a:r>
-            <a:endParaRPr sz="1300" b="0">
-              <a:solidFill>
-                <a:srgbClr val="808080"/>
-              </a:solidFill>
-              <a:latin typeface="微软雅黑" panose="020B0503020204020204" charset="-122"/>
-              <a:ea typeface="微软雅黑" panose="020B0503020204020204" charset="-122"/>
-              <a:cs typeface="微软雅黑" panose="020B0503020204020204" charset="-122"/>
-            </a:endParaRPr>
-          </a:p>
-        </p:txBody>
-      </p:sp>
     </p:spTree>
   </p:cSld>
   <p:clrMapOvr>
@@ -11264,7 +13154,7 @@
 </p:sld>
 </file>
 
-<file path=ppt/slides/slide17.xml><?xml version="1.0" encoding="utf-8"?>
+<file path=ppt/slides/slide19.xml><?xml version="1.0" encoding="utf-8"?>
 <p:sld xmlns:a="http://schemas.openxmlformats.org/drawingml/2006/main" xmlns:r="http://schemas.openxmlformats.org/officeDocument/2006/relationships" xmlns:p="http://schemas.openxmlformats.org/presentationml/2006/main">
   <p:cSld>
     <p:spTree>
@@ -11313,14 +13203,18 @@
                   <a:srgbClr val="808080"/>
                 </a:solidFill>
                 <a:latin typeface="微软雅黑" panose="020B0503020204020204" charset="-122"/>
+                <a:ea typeface="微软雅黑" panose="020B0503020204020204" charset="-122"/>
+                <a:cs typeface="微软雅黑" panose="020B0503020204020204" charset="-122"/>
               </a:rPr>
-              <a:t>17</a:t>
+              <a:t>20</a:t>
             </a:r>
             <a:endParaRPr sz="1000">
               <a:solidFill>
                 <a:srgbClr val="808080"/>
               </a:solidFill>
               <a:latin typeface="微软雅黑" panose="020B0503020204020204" charset="-122"/>
+              <a:ea typeface="微软雅黑" panose="020B0503020204020204" charset="-122"/>
+              <a:cs typeface="微软雅黑" panose="020B0503020204020204" charset="-122"/>
             </a:endParaRPr>
           </a:p>
         </p:txBody>
@@ -11722,6 +13616,8 @@
                   <a:srgbClr val="808080"/>
                 </a:solidFill>
                 <a:latin typeface="微软雅黑" panose="020B0503020204020204" charset="-122"/>
+                <a:ea typeface="微软雅黑" panose="020B0503020204020204" charset="-122"/>
+                <a:cs typeface="微软雅黑" panose="020B0503020204020204" charset="-122"/>
               </a:rPr>
               <a:t>2</a:t>
             </a:r>
@@ -11730,6 +13626,8 @@
                 <a:srgbClr val="808080"/>
               </a:solidFill>
               <a:latin typeface="微软雅黑" panose="020B0503020204020204" charset="-122"/>
+              <a:ea typeface="微软雅黑" panose="020B0503020204020204" charset="-122"/>
+              <a:cs typeface="微软雅黑" panose="020B0503020204020204" charset="-122"/>
             </a:endParaRPr>
           </a:p>
         </p:txBody>
@@ -12193,6 +14091,8 @@
                   <a:srgbClr val="808080"/>
                 </a:solidFill>
                 <a:latin typeface="微软雅黑" panose="020B0503020204020204" charset="-122"/>
+                <a:ea typeface="微软雅黑" panose="020B0503020204020204" charset="-122"/>
+                <a:cs typeface="微软雅黑" panose="020B0503020204020204" charset="-122"/>
               </a:rPr>
               <a:t>3</a:t>
             </a:r>
@@ -12201,6 +14101,8 @@
                 <a:srgbClr val="808080"/>
               </a:solidFill>
               <a:latin typeface="微软雅黑" panose="020B0503020204020204" charset="-122"/>
+              <a:ea typeface="微软雅黑" panose="020B0503020204020204" charset="-122"/>
+              <a:cs typeface="微软雅黑" panose="020B0503020204020204" charset="-122"/>
             </a:endParaRPr>
           </a:p>
         </p:txBody>
@@ -12656,6 +14558,8 @@
                   <a:srgbClr val="808080"/>
                 </a:solidFill>
                 <a:latin typeface="微软雅黑" panose="020B0503020204020204" charset="-122"/>
+                <a:ea typeface="微软雅黑" panose="020B0503020204020204" charset="-122"/>
+                <a:cs typeface="微软雅黑" panose="020B0503020204020204" charset="-122"/>
               </a:rPr>
               <a:t>4</a:t>
             </a:r>
@@ -12664,6 +14568,8 @@
                 <a:srgbClr val="808080"/>
               </a:solidFill>
               <a:latin typeface="微软雅黑" panose="020B0503020204020204" charset="-122"/>
+              <a:ea typeface="微软雅黑" panose="020B0503020204020204" charset="-122"/>
+              <a:cs typeface="微软雅黑" panose="020B0503020204020204" charset="-122"/>
             </a:endParaRPr>
           </a:p>
         </p:txBody>
@@ -13817,6 +15723,8 @@
                   <a:srgbClr val="808080"/>
                 </a:solidFill>
                 <a:latin typeface="微软雅黑" panose="020B0503020204020204" charset="-122"/>
+                <a:ea typeface="微软雅黑" panose="020B0503020204020204" charset="-122"/>
+                <a:cs typeface="微软雅黑" panose="020B0503020204020204" charset="-122"/>
               </a:rPr>
               <a:t>5</a:t>
             </a:r>
@@ -13825,6 +15733,8 @@
                 <a:srgbClr val="808080"/>
               </a:solidFill>
               <a:latin typeface="微软雅黑" panose="020B0503020204020204" charset="-122"/>
+              <a:ea typeface="微软雅黑" panose="020B0503020204020204" charset="-122"/>
+              <a:cs typeface="微软雅黑" panose="020B0503020204020204" charset="-122"/>
             </a:endParaRPr>
           </a:p>
         </p:txBody>
@@ -14164,6 +16074,8 @@
                   <a:srgbClr val="808080"/>
                 </a:solidFill>
                 <a:latin typeface="微软雅黑" panose="020B0503020204020204" charset="-122"/>
+                <a:ea typeface="微软雅黑" panose="020B0503020204020204" charset="-122"/>
+                <a:cs typeface="微软雅黑" panose="020B0503020204020204" charset="-122"/>
               </a:rPr>
               <a:t>6</a:t>
             </a:r>
@@ -14172,6 +16084,8 @@
                 <a:srgbClr val="808080"/>
               </a:solidFill>
               <a:latin typeface="微软雅黑" panose="020B0503020204020204" charset="-122"/>
+              <a:ea typeface="微软雅黑" panose="020B0503020204020204" charset="-122"/>
+              <a:cs typeface="微软雅黑" panose="020B0503020204020204" charset="-122"/>
             </a:endParaRPr>
           </a:p>
         </p:txBody>
@@ -14456,6 +16370,8 @@
                   <a:srgbClr val="808080"/>
                 </a:solidFill>
                 <a:latin typeface="微软雅黑" panose="020B0503020204020204" charset="-122"/>
+                <a:ea typeface="微软雅黑" panose="020B0503020204020204" charset="-122"/>
+                <a:cs typeface="微软雅黑" panose="020B0503020204020204" charset="-122"/>
               </a:rPr>
               <a:t>7</a:t>
             </a:r>
@@ -14464,6 +16380,8 @@
                 <a:srgbClr val="808080"/>
               </a:solidFill>
               <a:latin typeface="微软雅黑" panose="020B0503020204020204" charset="-122"/>
+              <a:ea typeface="微软雅黑" panose="020B0503020204020204" charset="-122"/>
+              <a:cs typeface="微软雅黑" panose="020B0503020204020204" charset="-122"/>
             </a:endParaRPr>
           </a:p>
         </p:txBody>
@@ -14748,6 +16666,8 @@
                   <a:srgbClr val="808080"/>
                 </a:solidFill>
                 <a:latin typeface="微软雅黑" panose="020B0503020204020204" charset="-122"/>
+                <a:ea typeface="微软雅黑" panose="020B0503020204020204" charset="-122"/>
+                <a:cs typeface="微软雅黑" panose="020B0503020204020204" charset="-122"/>
               </a:rPr>
               <a:t>8</a:t>
             </a:r>
@@ -14756,6 +16676,8 @@
                 <a:srgbClr val="808080"/>
               </a:solidFill>
               <a:latin typeface="微软雅黑" panose="020B0503020204020204" charset="-122"/>
+              <a:ea typeface="微软雅黑" panose="020B0503020204020204" charset="-122"/>
+              <a:cs typeface="微软雅黑" panose="020B0503020204020204" charset="-122"/>
             </a:endParaRPr>
           </a:p>
         </p:txBody>
@@ -16148,6 +18070,8 @@
                   <a:srgbClr val="808080"/>
                 </a:solidFill>
                 <a:latin typeface="微软雅黑" panose="020B0503020204020204" charset="-122"/>
+                <a:ea typeface="微软雅黑" panose="020B0503020204020204" charset="-122"/>
+                <a:cs typeface="微软雅黑" panose="020B0503020204020204" charset="-122"/>
               </a:rPr>
               <a:t>9</a:t>
             </a:r>
@@ -16156,6 +18080,8 @@
                 <a:srgbClr val="808080"/>
               </a:solidFill>
               <a:latin typeface="微软雅黑" panose="020B0503020204020204" charset="-122"/>
+              <a:ea typeface="微软雅黑" panose="020B0503020204020204" charset="-122"/>
+              <a:cs typeface="微软雅黑" panose="020B0503020204020204" charset="-122"/>
             </a:endParaRPr>
           </a:p>
         </p:txBody>

</xml_diff>